<commit_message>
docs: drop the explanation lines from the guide's traps slide
Co-Authored-By: Claude Opus 5.5 <noreply@anthropic.com>
Claude-Session: https://claude.ai/code/session_014udSfWkctWaSTKdEZUW1Gh
</commit_message>
<xml_diff>
--- a/docs/TAG_IVT_Report_Update_Guide.pptx
+++ b/docs/TAG_IVT_Report_Update_Guide.pptx
@@ -121,7 +121,7 @@
   <p:extLst>
     <p:ext uri="{521415D9-36F7-43E2-AB2F-B90AF26B5E84}">
       <p14:sectionLst xmlns:p14="http://schemas.microsoft.com/office/powerpoint/2010/main">
-        <p14:section name="Overview" id="{8989161d-f979-cc43-5a51-7a667d5f9ca6}">
+        <p14:section name="Overview" id="{7eaa1433-e3bc-fe37-db88-c521fc30ec1b}">
           <p14:sldIdLst>
             <p14:sldId id="256"/>
             <p14:sldId id="257"/>
@@ -129,7 +129,7 @@
             <p14:sldId id="259"/>
           </p14:sldIdLst>
         </p14:section>
-        <p14:section name="1 · GAM" id="{c1151be3-0f9b-cd45-c301-48965a800c81}">
+        <p14:section name="1 · GAM" id="{ac4b858e-1c3f-21ec-3c36-5ad5e4a8eb3e}">
           <p14:sldIdLst>
             <p14:sldId id="260"/>
             <p14:sldId id="261"/>
@@ -137,14 +137,14 @@
             <p14:sldId id="263"/>
           </p14:sldIdLst>
         </p14:section>
-        <p14:section name="2–3 · DV and GA4" id="{77d57dc9-de35-cabc-d058-9a2d298fcbc6}">
+        <p14:section name="2–3 · DV and GA4" id="{5f70419a-f049-6c94-74c4-802d7b684d1d}">
           <p14:sldIdLst>
             <p14:sldId id="264"/>
             <p14:sldId id="265"/>
             <p14:sldId id="266"/>
           </p14:sldIdLst>
         </p14:section>
-        <p14:section name="4–5 · Math and deck" id="{a97eb2d3-f661-4c9b-680e-cf17c6b97292}">
+        <p14:section name="4–5 · Math and deck" id="{1e181954-8f66-6119-a798-153f5f28e333}">
           <p14:sldIdLst>
             <p14:sldId id="267"/>
             <p14:sldId id="268"/>
@@ -12351,16 +12351,16 @@
         <p:spPr>
           <a:xfrm>
             <a:off x="1463040" y="2194560"/>
-            <a:ext cx="4937760" cy="365760"/>
-          </a:xfrm>
-          <a:prstGeom prst="rect">
-            <a:avLst/>
-          </a:prstGeom>
-          <a:noFill/>
-          <a:ln/>
-        </p:spPr>
-        <p:txBody>
-          <a:bodyPr wrap="square" lIns="0" tIns="0" rIns="0" bIns="0" rtlCol="0" anchor="t"/>
+            <a:ext cx="4937760" cy="731520"/>
+          </a:xfrm>
+          <a:prstGeom prst="rect">
+            <a:avLst/>
+          </a:prstGeom>
+          <a:noFill/>
+          <a:ln/>
+        </p:spPr>
+        <p:txBody>
+          <a:bodyPr wrap="square" lIns="0" tIns="0" rIns="0" bIns="0" rtlCol="0" anchor="ctr"/>
           <a:lstStyle/>
           <a:p>
             <a:pPr indent="0" marL="0">
@@ -12372,7 +12372,7 @@
                   <a:schemeClr val="tx1"/>
                 </a:solidFill>
               </a:rPr>
-              <a:t>Ad unit (top level), not Ad unit</a:t>
+              <a:t>Use Ad unit (top level), not Ad unit</a:t>
             </a:r>
             <a:endParaRPr lang="en-US" sz="1600" dirty="0"/>
           </a:p>
@@ -12380,43 +12380,7 @@
       </p:sp>
       <p:sp>
         <p:nvSpPr>
-          <p:cNvPr id="8" name="Text 6"/>
-          <p:cNvSpPr txBox="1"/>
-          <p:nvPr/>
-        </p:nvSpPr>
-        <p:spPr>
-          <a:xfrm>
-            <a:off x="1463040" y="2560320"/>
-            <a:ext cx="4937760" cy="411480"/>
-          </a:xfrm>
-          <a:prstGeom prst="rect">
-            <a:avLst/>
-          </a:prstGeom>
-          <a:noFill/>
-          <a:ln/>
-        </p:spPr>
-        <p:txBody>
-          <a:bodyPr wrap="square" lIns="0" tIns="0" rIns="0" bIns="0" rtlCol="0" anchor="t"/>
-          <a:lstStyle/>
-          <a:p>
-            <a:pPr indent="0" marL="0">
-              <a:buNone/>
-            </a:pPr>
-            <a:r>
-              <a:rPr lang="en-US" sz="1300" dirty="0">
-                <a:solidFill>
-                  <a:schemeClr val="tx2"/>
-                </a:solidFill>
-              </a:rPr>
-              <a:t>The leaf ad unit called newsweek is the bare parent: ~173 impressions a month</a:t>
-            </a:r>
-            <a:endParaRPr lang="en-US" sz="1300" dirty="0"/>
-          </a:p>
-        </p:txBody>
-      </p:sp>
-      <p:sp>
-        <p:nvSpPr>
-          <p:cNvPr id="9" name="trap 2"/>
+          <p:cNvPr id="8" name="trap 2"/>
           <p:cNvSpPr/>
           <p:nvPr/>
         </p:nvSpPr>
@@ -12441,7 +12405,7 @@
       </p:sp>
       <p:sp>
         <p:nvSpPr>
-          <p:cNvPr id="10" name="trap icon 2"/>
+          <p:cNvPr id="9" name="trap icon 2"/>
           <p:cNvSpPr/>
           <p:nvPr/>
         </p:nvSpPr>
@@ -12466,14 +12430,50 @@
       </p:sp>
       <p:sp>
         <p:nvSpPr>
+          <p:cNvPr id="10" name="Text 8"/>
+          <p:cNvSpPr txBox="1"/>
+          <p:nvPr/>
+        </p:nvSpPr>
+        <p:spPr>
+          <a:xfrm>
+            <a:off x="777240" y="3520440"/>
+            <a:ext cx="457200" cy="457200"/>
+          </a:xfrm>
+          <a:prstGeom prst="rect">
+            <a:avLst/>
+          </a:prstGeom>
+          <a:noFill/>
+          <a:ln/>
+        </p:spPr>
+        <p:txBody>
+          <a:bodyPr wrap="square" lIns="0" tIns="0" rIns="0" bIns="0" rtlCol="0" anchor="ctr"/>
+          <a:lstStyle/>
+          <a:p>
+            <a:pPr algn="ctr" indent="0" marL="0">
+              <a:buNone/>
+            </a:pPr>
+            <a:r>
+              <a:rPr lang="en-US" sz="1600" b="1" dirty="0">
+                <a:solidFill>
+                  <a:schemeClr val="tx2"/>
+                </a:solidFill>
+              </a:rPr>
+              <a:t>!</a:t>
+            </a:r>
+            <a:endParaRPr lang="en-US" sz="1600" dirty="0"/>
+          </a:p>
+        </p:txBody>
+      </p:sp>
+      <p:sp>
+        <p:nvSpPr>
           <p:cNvPr id="11" name="Text 9"/>
           <p:cNvSpPr txBox="1"/>
           <p:nvPr/>
         </p:nvSpPr>
         <p:spPr>
           <a:xfrm>
-            <a:off x="777240" y="3520440"/>
-            <a:ext cx="457200" cy="457200"/>
+            <a:off x="1463040" y="3383280"/>
+            <a:ext cx="4937760" cy="731520"/>
           </a:xfrm>
           <a:prstGeom prst="rect">
             <a:avLst/>
@@ -12485,16 +12485,16 @@
           <a:bodyPr wrap="square" lIns="0" tIns="0" rIns="0" bIns="0" rtlCol="0" anchor="ctr"/>
           <a:lstStyle/>
           <a:p>
-            <a:pPr algn="ctr" indent="0" marL="0">
+            <a:pPr indent="0" marL="0">
               <a:buNone/>
             </a:pPr>
             <a:r>
               <a:rPr lang="en-US" sz="1600" b="1" dirty="0">
                 <a:solidFill>
-                  <a:schemeClr val="tx2"/>
-                </a:solidFill>
-              </a:rPr>
-              <a:t>!</a:t>
+                  <a:schemeClr val="tx1"/>
+                </a:solidFill>
+              </a:rPr>
+              <a:t>Video Ad Exchange: In-stream video + In-stream video or audio</a:t>
             </a:r>
             <a:endParaRPr lang="en-US" sz="1600" dirty="0"/>
           </a:p>
@@ -12502,79 +12502,7 @@
       </p:sp>
       <p:sp>
         <p:nvSpPr>
-          <p:cNvPr id="12" name="Text 10"/>
-          <p:cNvSpPr txBox="1"/>
-          <p:nvPr/>
-        </p:nvSpPr>
-        <p:spPr>
-          <a:xfrm>
-            <a:off x="1463040" y="3383280"/>
-            <a:ext cx="4937760" cy="365760"/>
-          </a:xfrm>
-          <a:prstGeom prst="rect">
-            <a:avLst/>
-          </a:prstGeom>
-          <a:noFill/>
-          <a:ln/>
-        </p:spPr>
-        <p:txBody>
-          <a:bodyPr wrap="square" lIns="0" tIns="0" rIns="0" bIns="0" rtlCol="0" anchor="t"/>
-          <a:lstStyle/>
-          <a:p>
-            <a:pPr indent="0" marL="0">
-              <a:buNone/>
-            </a:pPr>
-            <a:r>
-              <a:rPr lang="en-US" sz="1600" b="1" dirty="0">
-                <a:solidFill>
-                  <a:schemeClr val="tx1"/>
-                </a:solidFill>
-              </a:rPr>
-              <a:t>Video Ad Exchange: both in-stream formats</a:t>
-            </a:r>
-            <a:endParaRPr lang="en-US" sz="1600" dirty="0"/>
-          </a:p>
-        </p:txBody>
-      </p:sp>
-      <p:sp>
-        <p:nvSpPr>
-          <p:cNvPr id="13" name="Text 11"/>
-          <p:cNvSpPr txBox="1"/>
-          <p:nvPr/>
-        </p:nvSpPr>
-        <p:spPr>
-          <a:xfrm>
-            <a:off x="1463040" y="3749040"/>
-            <a:ext cx="4937760" cy="411480"/>
-          </a:xfrm>
-          <a:prstGeom prst="rect">
-            <a:avLst/>
-          </a:prstGeom>
-          <a:noFill/>
-          <a:ln/>
-        </p:spPr>
-        <p:txBody>
-          <a:bodyPr wrap="square" lIns="0" tIns="0" rIns="0" bIns="0" rtlCol="0" anchor="t"/>
-          <a:lstStyle/>
-          <a:p>
-            <a:pPr indent="0" marL="0">
-              <a:buNone/>
-            </a:pPr>
-            <a:r>
-              <a:rPr lang="en-US" sz="1300" dirty="0">
-                <a:solidFill>
-                  <a:schemeClr val="tx2"/>
-                </a:solidFill>
-              </a:rPr>
-              <a:t>Inventory format also has In-stream video or audio; always add it to In-stream video</a:t>
-            </a:r>
-            <a:endParaRPr lang="en-US" sz="1300" dirty="0"/>
-          </a:p>
-        </p:txBody>
-      </p:sp>
-      <p:sp>
-        <p:nvSpPr>
-          <p:cNvPr id="14" name="trap 3"/>
+          <p:cNvPr id="12" name="trap 3"/>
           <p:cNvSpPr/>
           <p:nvPr/>
         </p:nvSpPr>
@@ -12599,7 +12527,7 @@
       </p:sp>
       <p:sp>
         <p:nvSpPr>
-          <p:cNvPr id="15" name="trap icon 3"/>
+          <p:cNvPr id="13" name="trap icon 3"/>
           <p:cNvSpPr/>
           <p:nvPr/>
         </p:nvSpPr>
@@ -12624,7 +12552,7 @@
       </p:sp>
       <p:sp>
         <p:nvSpPr>
-          <p:cNvPr id="16" name="Text 14"/>
+          <p:cNvPr id="14" name="Text 12"/>
           <p:cNvSpPr txBox="1"/>
           <p:nvPr/>
         </p:nvSpPr>
@@ -12660,23 +12588,23 @@
       </p:sp>
       <p:sp>
         <p:nvSpPr>
-          <p:cNvPr id="17" name="Text 15"/>
+          <p:cNvPr id="15" name="Text 13"/>
           <p:cNvSpPr txBox="1"/>
           <p:nvPr/>
         </p:nvSpPr>
         <p:spPr>
           <a:xfrm>
             <a:off x="1463040" y="4572000"/>
-            <a:ext cx="4937760" cy="365760"/>
-          </a:xfrm>
-          <a:prstGeom prst="rect">
-            <a:avLst/>
-          </a:prstGeom>
-          <a:noFill/>
-          <a:ln/>
-        </p:spPr>
-        <p:txBody>
-          <a:bodyPr wrap="square" lIns="0" tIns="0" rIns="0" bIns="0" rtlCol="0" anchor="t"/>
+            <a:ext cx="4937760" cy="731520"/>
+          </a:xfrm>
+          <a:prstGeom prst="rect">
+            <a:avLst/>
+          </a:prstGeom>
+          <a:noFill/>
+          <a:ln/>
+        </p:spPr>
+        <p:txBody>
+          <a:bodyPr wrap="square" lIns="0" tIns="0" rIns="0" bIns="0" rtlCol="0" anchor="ctr"/>
           <a:lstStyle/>
           <a:p>
             <a:pPr indent="0" marL="0">
@@ -12688,7 +12616,7 @@
                   <a:schemeClr val="tx1"/>
                 </a:solidFill>
               </a:rPr>
-              <a:t>Never Programmatic channel = Open Auction</a:t>
+              <a:t>Never filter Programmatic channel = Open Auction</a:t>
             </a:r>
             <a:endParaRPr lang="en-US" sz="1600" dirty="0"/>
           </a:p>
@@ -12696,43 +12624,7 @@
       </p:sp>
       <p:sp>
         <p:nvSpPr>
-          <p:cNvPr id="18" name="Text 16"/>
-          <p:cNvSpPr txBox="1"/>
-          <p:nvPr/>
-        </p:nvSpPr>
-        <p:spPr>
-          <a:xfrm>
-            <a:off x="1463040" y="4937760"/>
-            <a:ext cx="4937760" cy="411480"/>
-          </a:xfrm>
-          <a:prstGeom prst="rect">
-            <a:avLst/>
-          </a:prstGeom>
-          <a:noFill/>
-          <a:ln/>
-        </p:spPr>
-        <p:txBody>
-          <a:bodyPr wrap="square" lIns="0" tIns="0" rIns="0" bIns="0" rtlCol="0" anchor="t"/>
-          <a:lstStyle/>
-          <a:p>
-            <a:pPr indent="0" marL="0">
-              <a:buNone/>
-            </a:pPr>
-            <a:r>
-              <a:rPr lang="en-US" sz="1300" dirty="0">
-                <a:solidFill>
-                  <a:schemeClr val="tx2"/>
-                </a:solidFill>
-              </a:rPr>
-              <a:t>That is Ad Exchange minus PA; it caused the January Ad Exchange error</a:t>
-            </a:r>
-            <a:endParaRPr lang="en-US" sz="1300" dirty="0"/>
-          </a:p>
-        </p:txBody>
-      </p:sp>
-      <p:sp>
-        <p:nvSpPr>
-          <p:cNvPr id="19" name="fact card"/>
+          <p:cNvPr id="16" name="fact card"/>
           <p:cNvSpPr/>
           <p:nvPr/>
         </p:nvSpPr>
@@ -12757,7 +12649,7 @@
       </p:sp>
       <p:sp>
         <p:nvSpPr>
-          <p:cNvPr id="20" name="Text 18"/>
+          <p:cNvPr id="17" name="Text 15"/>
           <p:cNvSpPr txBox="1"/>
           <p:nvPr/>
         </p:nvSpPr>
@@ -12793,7 +12685,7 @@
       </p:sp>
       <p:sp>
         <p:nvSpPr>
-          <p:cNvPr id="21" name="Text 19"/>
+          <p:cNvPr id="18" name="Text 16"/>
           <p:cNvSpPr txBox="1"/>
           <p:nvPr/>
         </p:nvSpPr>
@@ -12849,7 +12741,7 @@
       </p:sp>
       <p:sp>
         <p:nvSpPr>
-          <p:cNvPr id="22" name="Text 20"/>
+          <p:cNvPr id="19" name="Text 17"/>
           <p:cNvSpPr txBox="1"/>
           <p:nvPr/>
         </p:nvSpPr>

</xml_diff>

<commit_message>
docs: remove the open-fixes slide from the TAG IVT guide
Co-Authored-By: Claude Opus 5.5 <noreply@anthropic.com>
Claude-Session: https://claude.ai/code/session_014udSfWkctWaSTKdEZUW1Gh
</commit_message>
<xml_diff>
--- a/docs/TAG_IVT_Report_Update_Guide.pptx
+++ b/docs/TAG_IVT_Report_Update_Guide.pptx
@@ -19,10 +19,9 @@
     <p:sldId id="267" r:id="rId13"/>
     <p:sldId id="268" r:id="rId14"/>
     <p:sldId id="269" r:id="rId15"/>
-    <p:sldId id="270" r:id="rId16"/>
   </p:sldIdLst>
   <p:notesMasterIdLst>
-    <p:notesMasterId r:id="rId17"/>
+    <p:notesMasterId r:id="rId16"/>
   </p:notesMasterIdLst>
   <p:sldSz cx="12192000" cy="6858000"/>
   <p:notesSz cx="6858000" cy="12192000"/>
@@ -121,7 +120,7 @@
   <p:extLst>
     <p:ext uri="{521415D9-36F7-43E2-AB2F-B90AF26B5E84}">
       <p14:sectionLst xmlns:p14="http://schemas.microsoft.com/office/powerpoint/2010/main">
-        <p14:section name="Overview" id="{7eaa1433-e3bc-fe37-db88-c521fc30ec1b}">
+        <p14:section name="Overview" id="{282ee278-5aad-aa45-c3ad-3e2399f1faa3}">
           <p14:sldIdLst>
             <p14:sldId id="256"/>
             <p14:sldId id="257"/>
@@ -129,7 +128,7 @@
             <p14:sldId id="259"/>
           </p14:sldIdLst>
         </p14:section>
-        <p14:section name="1 · GAM" id="{ac4b858e-1c3f-21ec-3c36-5ad5e4a8eb3e}">
+        <p14:section name="1 · GAM" id="{f454723d-edb9-eeb1-ef10-d82bb6847779}">
           <p14:sldIdLst>
             <p14:sldId id="260"/>
             <p14:sldId id="261"/>
@@ -137,19 +136,18 @@
             <p14:sldId id="263"/>
           </p14:sldIdLst>
         </p14:section>
-        <p14:section name="2–3 · DV and GA4" id="{5f70419a-f049-6c94-74c4-802d7b684d1d}">
+        <p14:section name="2–3 · DV and GA4" id="{8e79f2f1-faae-2b07-cb5e-496d06a44a21}">
           <p14:sldIdLst>
             <p14:sldId id="264"/>
             <p14:sldId id="265"/>
             <p14:sldId id="266"/>
           </p14:sldIdLst>
         </p14:section>
-        <p14:section name="4–5 · Math and deck" id="{1e181954-8f66-6119-a798-153f5f28e333}">
+        <p14:section name="4–5 · Math and deck" id="{19a81982-3a01-cf00-fff6-594cde8f6400}">
           <p14:sldIdLst>
             <p14:sldId id="267"/>
             <p14:sldId id="268"/>
             <p14:sldId id="269"/>
-            <p14:sldId id="270"/>
           </p14:sldIdLst>
         </p14:section>
       </p14:sectionLst>
@@ -1286,94 +1284,6 @@
             <a:fld id="{F7021451-1387-4CA6-816F-3879F97B5CBC}" type="slidenum">
               <a:rPr lang="en-US"/>
               <a:t>14</a:t>
-            </a:fld>
-            <a:endParaRPr lang="en-US"/>
-          </a:p>
-        </p:txBody>
-      </p:sp>
-    </p:spTree>
-    <p:extLst>
-      <p:ext uri="{BB962C8B-B14F-4D97-AF65-F5344CB8AC3E}">
-        <p14:creationId xmlns:p14="http://schemas.microsoft.com/office/powerpoint/2010/main" val="1024086991"/>
-      </p:ext>
-    </p:extLst>
-  </p:cSld>
-  <p:clrMapOvr>
-    <a:masterClrMapping/>
-  </p:clrMapOvr>
-</p:notes>
-</file>
-
-<file path=ppt/notesSlides/notesSlide15.xml><?xml version="1.0" encoding="utf-8"?>
-<p:notes xmlns:a="http://schemas.openxmlformats.org/drawingml/2006/main" xmlns:r="http://schemas.openxmlformats.org/officeDocument/2006/relationships" xmlns:p="http://schemas.openxmlformats.org/presentationml/2006/main">
-  <p:cSld>
-    <p:spTree>
-      <p:nvGrpSpPr>
-        <p:cNvPr id="1" name=""/>
-        <p:cNvGrpSpPr/>
-        <p:nvPr/>
-      </p:nvGrpSpPr>
-      <p:grpSpPr>
-        <a:xfrm>
-          <a:off x="0" y="0"/>
-          <a:ext cx="0" cy="0"/>
-          <a:chOff x="0" y="0"/>
-          <a:chExt cx="0" cy="0"/>
-        </a:xfrm>
-      </p:grpSpPr>
-      <p:sp>
-        <p:nvSpPr>
-          <p:cNvPr id="2" name="Slide Image Placeholder 1"/>
-          <p:cNvSpPr>
-            <a:spLocks noGrp="1" noRot="1" noChangeAspect="1"/>
-          </p:cNvSpPr>
-          <p:nvPr>
-            <p:ph type="sldImg"/>
-          </p:nvPr>
-        </p:nvSpPr>
-        <p:spPr/>
-      </p:sp>
-      <p:sp>
-        <p:nvSpPr>
-          <p:cNvPr id="3" name="Notes Placeholder 2"/>
-          <p:cNvSpPr>
-            <a:spLocks noGrp="1"/>
-          </p:cNvSpPr>
-          <p:nvPr>
-            <p:ph type="body" idx="1"/>
-          </p:nvPr>
-        </p:nvSpPr>
-        <p:spPr/>
-        <p:txBody>
-          <a:bodyPr/>
-          <a:lstStyle/>
-          <a:p>
-            <a:r>
-              <a:rPr lang="en-US" dirty="0"/>
-              <a:t/>
-            </a:r>
-            <a:endParaRPr lang="en-US" dirty="0"/>
-          </a:p>
-        </p:txBody>
-      </p:sp>
-      <p:sp>
-        <p:nvSpPr>
-          <p:cNvPr id="4" name="Slide Number Placeholder 3"/>
-          <p:cNvSpPr>
-            <a:spLocks noGrp="1"/>
-          </p:cNvSpPr>
-          <p:nvPr>
-            <p:ph type="sldNum" sz="quarter" idx="10"/>
-          </p:nvPr>
-        </p:nvSpPr>
-        <p:spPr/>
-        <p:txBody>
-          <a:bodyPr/>
-          <a:lstStyle/>
-          <a:p>
-            <a:fld id="{F7021451-1387-4CA6-816F-3879F97B5CBC}" type="slidenum">
-              <a:rPr lang="en-US"/>
-              <a:t>15</a:t>
             </a:fld>
             <a:endParaRPr lang="en-US"/>
           </a:p>
@@ -5917,1076 +5827,6 @@
             <a:fld id="{F7021451-1387-4CA6-816F-3879F97B5CBC}" type="slidenum">
               <a:rPr b="0" lang="en-US"/>
               <a:t>14</a:t>
-            </a:fld>
-            <a:endParaRPr lang="en-US"/>
-          </a:p>
-        </p:txBody>
-      </p:sp>
-    </p:spTree>
-  </p:cSld>
-  <p:clrMapOvr>
-    <a:masterClrMapping/>
-  </p:clrMapOvr>
-</p:sld>
-</file>
-
-<file path=ppt/slides/slide15.xml><?xml version="1.0" encoding="utf-8"?>
-<p:sld xmlns:a="http://schemas.openxmlformats.org/drawingml/2006/main" xmlns:r="http://schemas.openxmlformats.org/officeDocument/2006/relationships" xmlns:p="http://schemas.openxmlformats.org/presentationml/2006/main">
-  <p:cSld name="Slide 15">
-    <p:spTree>
-      <p:nvGrpSpPr>
-        <p:cNvPr id="1" name=""/>
-        <p:cNvGrpSpPr/>
-        <p:nvPr/>
-      </p:nvGrpSpPr>
-      <p:grpSpPr>
-        <a:xfrm>
-          <a:off x="0" y="0"/>
-          <a:ext cx="0" cy="0"/>
-          <a:chOff x="0" y="0"/>
-          <a:chExt cx="0" cy="0"/>
-        </a:xfrm>
-      </p:grpSpPr>
-      <p:sp>
-        <p:nvSpPr>
-          <p:cNvPr id="2" name="Text 1"/>
-          <p:cNvSpPr/>
-          <p:nvPr>
-            <p:ph idx="101" type="body" hasCustomPrompt="1"/>
-          </p:nvPr>
-        </p:nvSpPr>
-        <p:spPr>
-          <a:xfrm>
-            <a:off x="749808" y="457200"/>
-            <a:ext cx="8229600" cy="329184"/>
-          </a:xfrm>
-          <a:prstGeom prst="rect">
-            <a:avLst/>
-          </a:prstGeom>
-          <a:noFill/>
-          <a:ln/>
-        </p:spPr>
-        <p:txBody>
-          <a:bodyPr wrap="square" lIns="0" tIns="0" rIns="0" bIns="0" rtlCol="0" anchor="ctr"/>
-          <a:lstStyle/>
-          <a:p>
-            <a:pPr indent="0" marL="0">
-              <a:buNone/>
-            </a:pPr>
-            <a:r>
-              <a:rPr lang="en-US" sz="1200" b="1" spc="300" kern="0" dirty="0">
-                <a:solidFill>
-                  <a:schemeClr val="tx2"/>
-                </a:solidFill>
-              </a:rPr>
-              <a:t>BEFORE THE NEXT SEND</a:t>
-            </a:r>
-            <a:endParaRPr lang="en-US" sz="1200" dirty="0"/>
-          </a:p>
-        </p:txBody>
-      </p:sp>
-      <p:sp>
-        <p:nvSpPr>
-          <p:cNvPr id="3" name="Text 1"/>
-          <p:cNvSpPr/>
-          <p:nvPr>
-            <p:ph idx="102" type="title" hasCustomPrompt="1"/>
-          </p:nvPr>
-        </p:nvSpPr>
-        <p:spPr>
-          <a:xfrm>
-            <a:off x="548640" y="868680"/>
-            <a:ext cx="11094415" cy="868680"/>
-          </a:xfrm>
-          <a:prstGeom prst="rect">
-            <a:avLst/>
-          </a:prstGeom>
-          <a:noFill/>
-          <a:ln/>
-        </p:spPr>
-        <p:txBody>
-          <a:bodyPr wrap="square" lIns="0" tIns="0" rIns="0" bIns="0" rtlCol="0" anchor="t"/>
-          <a:lstStyle/>
-          <a:p>
-            <a:pPr algn="l" indent="0" marL="0">
-              <a:buNone/>
-            </a:pPr>
-            <a:r>
-              <a:rPr lang="en-US" sz="3400" dirty="0">
-                <a:solidFill>
-                  <a:schemeClr val="tx1"/>
-                </a:solidFill>
-                <a:latin typeface="Georgia" pitchFamily="34" charset="0"/>
-                <a:ea typeface="Georgia" pitchFamily="34" charset="-122"/>
-                <a:cs typeface="Georgia" pitchFamily="34" charset="-120"/>
-              </a:rPr>
-              <a:t>Open fixes in the current files</a:t>
-            </a:r>
-            <a:endParaRPr lang="en-US" sz="3400" dirty="0"/>
-          </a:p>
-        </p:txBody>
-      </p:sp>
-      <p:sp>
-        <p:nvSpPr>
-          <p:cNvPr id="4" name="fix 1"/>
-          <p:cNvSpPr/>
-          <p:nvPr/>
-        </p:nvSpPr>
-        <p:spPr>
-          <a:xfrm>
-            <a:off x="548640" y="1874520"/>
-            <a:ext cx="11094415" cy="603504"/>
-          </a:xfrm>
-          <a:prstGeom prst="rect">
-            <a:avLst/>
-          </a:prstGeom>
-          <a:solidFill>
-            <a:schemeClr val="bg1"/>
-          </a:solidFill>
-          <a:ln w="9525">
-            <a:solidFill>
-              <a:srgbClr val="E7E0C9"/>
-            </a:solidFill>
-            <a:prstDash val="solid"/>
-          </a:ln>
-        </p:spPr>
-      </p:sp>
-      <p:sp>
-        <p:nvSpPr>
-          <p:cNvPr id="5" name="fix dot 1"/>
-          <p:cNvSpPr/>
-          <p:nvPr/>
-        </p:nvSpPr>
-        <p:spPr>
-          <a:xfrm>
-            <a:off x="777240" y="2057400"/>
-            <a:ext cx="237744" cy="237744"/>
-          </a:xfrm>
-          <a:prstGeom prst="ellipse">
-            <a:avLst/>
-          </a:prstGeom>
-          <a:solidFill>
-            <a:schemeClr val="accent2"/>
-          </a:solidFill>
-          <a:ln/>
-        </p:spPr>
-      </p:sp>
-      <p:sp>
-        <p:nvSpPr>
-          <p:cNvPr id="6" name="Text 4"/>
-          <p:cNvSpPr txBox="1"/>
-          <p:nvPr/>
-        </p:nvSpPr>
-        <p:spPr>
-          <a:xfrm>
-            <a:off x="1234440" y="2011680"/>
-            <a:ext cx="3108960" cy="329184"/>
-          </a:xfrm>
-          <a:prstGeom prst="rect">
-            <a:avLst/>
-          </a:prstGeom>
-          <a:noFill/>
-          <a:ln/>
-        </p:spPr>
-        <p:txBody>
-          <a:bodyPr wrap="square" lIns="0" tIns="0" rIns="0" bIns="0" rtlCol="0" anchor="t"/>
-          <a:lstStyle/>
-          <a:p>
-            <a:pPr indent="0" marL="0">
-              <a:buNone/>
-            </a:pPr>
-            <a:r>
-              <a:rPr lang="en-US" sz="1400" b="1" dirty="0">
-                <a:solidFill>
-                  <a:schemeClr val="tx1"/>
-                </a:solidFill>
-              </a:rPr>
-              <a:t>Display Jan, Ad Exchange</a:t>
-            </a:r>
-            <a:endParaRPr lang="en-US" sz="1400" dirty="0"/>
-          </a:p>
-        </p:txBody>
-      </p:sp>
-      <p:sp>
-        <p:nvSpPr>
-          <p:cNvPr id="7" name="Text 5"/>
-          <p:cNvSpPr txBox="1"/>
-          <p:nvPr/>
-        </p:nvSpPr>
-        <p:spPr>
-          <a:xfrm>
-            <a:off x="4389120" y="2011680"/>
-            <a:ext cx="3520440" cy="329184"/>
-          </a:xfrm>
-          <a:prstGeom prst="rect">
-            <a:avLst/>
-          </a:prstGeom>
-          <a:noFill/>
-          <a:ln/>
-        </p:spPr>
-        <p:txBody>
-          <a:bodyPr wrap="square" lIns="0" tIns="0" rIns="0" bIns="0" rtlCol="0" anchor="t"/>
-          <a:lstStyle/>
-          <a:p>
-            <a:pPr indent="0" marL="0">
-              <a:buNone/>
-            </a:pPr>
-            <a:r>
-              <a:rPr lang="en-US" sz="1400" dirty="0">
-                <a:solidFill>
-                  <a:schemeClr val="accent2"/>
-                </a:solidFill>
-              </a:rPr>
-              <a:t>59,562,722 → 59,956,722</a:t>
-            </a:r>
-            <a:endParaRPr lang="en-US" sz="1400" dirty="0"/>
-          </a:p>
-        </p:txBody>
-      </p:sp>
-      <p:sp>
-        <p:nvSpPr>
-          <p:cNvPr id="8" name="Text 6"/>
-          <p:cNvSpPr txBox="1"/>
-          <p:nvPr/>
-        </p:nvSpPr>
-        <p:spPr>
-          <a:xfrm>
-            <a:off x="8001000" y="1929384"/>
-            <a:ext cx="3566160" cy="502920"/>
-          </a:xfrm>
-          <a:prstGeom prst="rect">
-            <a:avLst/>
-          </a:prstGeom>
-          <a:noFill/>
-          <a:ln/>
-        </p:spPr>
-        <p:txBody>
-          <a:bodyPr wrap="square" lIns="0" tIns="0" rIns="0" bIns="0" rtlCol="0" anchor="ctr"/>
-          <a:lstStyle/>
-          <a:p>
-            <a:pPr indent="0" marL="0">
-              <a:buNone/>
-            </a:pPr>
-            <a:r>
-              <a:rPr lang="en-US" sz="1200" dirty="0">
-                <a:solidFill>
-                  <a:schemeClr val="tx2"/>
-                </a:solidFill>
-              </a:rPr>
-              <a:t>Taken as Open Auction only; short by January's PA (394,000)</a:t>
-            </a:r>
-            <a:endParaRPr lang="en-US" sz="1200" dirty="0"/>
-          </a:p>
-        </p:txBody>
-      </p:sp>
-      <p:sp>
-        <p:nvSpPr>
-          <p:cNvPr id="9" name="fix 2"/>
-          <p:cNvSpPr/>
-          <p:nvPr/>
-        </p:nvSpPr>
-        <p:spPr>
-          <a:xfrm>
-            <a:off x="548640" y="2578608"/>
-            <a:ext cx="11094415" cy="603504"/>
-          </a:xfrm>
-          <a:prstGeom prst="rect">
-            <a:avLst/>
-          </a:prstGeom>
-          <a:solidFill>
-            <a:schemeClr val="bg1"/>
-          </a:solidFill>
-          <a:ln w="9525">
-            <a:solidFill>
-              <a:srgbClr val="E7E0C9"/>
-            </a:solidFill>
-            <a:prstDash val="solid"/>
-          </a:ln>
-        </p:spPr>
-      </p:sp>
-      <p:sp>
-        <p:nvSpPr>
-          <p:cNvPr id="10" name="fix dot 2"/>
-          <p:cNvSpPr/>
-          <p:nvPr/>
-        </p:nvSpPr>
-        <p:spPr>
-          <a:xfrm>
-            <a:off x="777240" y="2761488"/>
-            <a:ext cx="237744" cy="237744"/>
-          </a:xfrm>
-          <a:prstGeom prst="ellipse">
-            <a:avLst/>
-          </a:prstGeom>
-          <a:solidFill>
-            <a:schemeClr val="accent2"/>
-          </a:solidFill>
-          <a:ln/>
-        </p:spPr>
-      </p:sp>
-      <p:sp>
-        <p:nvSpPr>
-          <p:cNvPr id="11" name="Text 9"/>
-          <p:cNvSpPr txBox="1"/>
-          <p:nvPr/>
-        </p:nvSpPr>
-        <p:spPr>
-          <a:xfrm>
-            <a:off x="1234440" y="2715768"/>
-            <a:ext cx="3108960" cy="329184"/>
-          </a:xfrm>
-          <a:prstGeom prst="rect">
-            <a:avLst/>
-          </a:prstGeom>
-          <a:noFill/>
-          <a:ln/>
-        </p:spPr>
-        <p:txBody>
-          <a:bodyPr wrap="square" lIns="0" tIns="0" rIns="0" bIns="0" rtlCol="0" anchor="t"/>
-          <a:lstStyle/>
-          <a:p>
-            <a:pPr indent="0" marL="0">
-              <a:buNone/>
-            </a:pPr>
-            <a:r>
-              <a:rPr lang="en-US" sz="1400" b="1" dirty="0">
-                <a:solidFill>
-                  <a:schemeClr val="tx1"/>
-                </a:solidFill>
-              </a:rPr>
-              <a:t>Video Ad Exchange, Jan + Jul–Sep</a:t>
-            </a:r>
-            <a:endParaRPr lang="en-US" sz="1400" dirty="0"/>
-          </a:p>
-        </p:txBody>
-      </p:sp>
-      <p:sp>
-        <p:nvSpPr>
-          <p:cNvPr id="12" name="Text 10"/>
-          <p:cNvSpPr txBox="1"/>
-          <p:nvPr/>
-        </p:nvSpPr>
-        <p:spPr>
-          <a:xfrm>
-            <a:off x="4389120" y="2715768"/>
-            <a:ext cx="3520440" cy="329184"/>
-          </a:xfrm>
-          <a:prstGeom prst="rect">
-            <a:avLst/>
-          </a:prstGeom>
-          <a:noFill/>
-          <a:ln/>
-        </p:spPr>
-        <p:txBody>
-          <a:bodyPr wrap="square" lIns="0" tIns="0" rIns="0" bIns="0" rtlCol="0" anchor="t"/>
-          <a:lstStyle/>
-          <a:p>
-            <a:pPr indent="0" marL="0">
-              <a:buNone/>
-            </a:pPr>
-            <a:r>
-              <a:rPr lang="en-US" sz="1400" dirty="0">
-                <a:solidFill>
-                  <a:schemeClr val="accent2"/>
-                </a:solidFill>
-              </a:rPr>
-              <a:t>Add In-stream video or audio</a:t>
-            </a:r>
-            <a:endParaRPr lang="en-US" sz="1400" dirty="0"/>
-          </a:p>
-        </p:txBody>
-      </p:sp>
-      <p:sp>
-        <p:nvSpPr>
-          <p:cNvPr id="13" name="Text 11"/>
-          <p:cNvSpPr txBox="1"/>
-          <p:nvPr/>
-        </p:nvSpPr>
-        <p:spPr>
-          <a:xfrm>
-            <a:off x="8001000" y="2633472"/>
-            <a:ext cx="3566160" cy="502920"/>
-          </a:xfrm>
-          <a:prstGeom prst="rect">
-            <a:avLst/>
-          </a:prstGeom>
-          <a:noFill/>
-          <a:ln/>
-        </p:spPr>
-        <p:txBody>
-          <a:bodyPr wrap="square" lIns="0" tIns="0" rIns="0" bIns="0" rtlCol="0" anchor="ctr"/>
-          <a:lstStyle/>
-          <a:p>
-            <a:pPr indent="0" marL="0">
-              <a:buNone/>
-            </a:pPr>
-            <a:r>
-              <a:rPr lang="en-US" sz="1200" dirty="0">
-                <a:solidFill>
-                  <a:schemeClr val="tx2"/>
-                </a:solidFill>
-              </a:rPr>
-              <a:t>Aug +82,199 · Sep +42,531 · Jul +83 · Jan +1. Video GAM total moves the same</a:t>
-            </a:r>
-            <a:endParaRPr lang="en-US" sz="1200" dirty="0"/>
-          </a:p>
-        </p:txBody>
-      </p:sp>
-      <p:sp>
-        <p:nvSpPr>
-          <p:cNvPr id="14" name="fix 3"/>
-          <p:cNvSpPr/>
-          <p:nvPr/>
-        </p:nvSpPr>
-        <p:spPr>
-          <a:xfrm>
-            <a:off x="548640" y="3282696"/>
-            <a:ext cx="11094415" cy="603504"/>
-          </a:xfrm>
-          <a:prstGeom prst="rect">
-            <a:avLst/>
-          </a:prstGeom>
-          <a:solidFill>
-            <a:schemeClr val="bg1"/>
-          </a:solidFill>
-          <a:ln w="9525">
-            <a:solidFill>
-              <a:srgbClr val="E7E0C9"/>
-            </a:solidFill>
-            <a:prstDash val="solid"/>
-          </a:ln>
-        </p:spPr>
-      </p:sp>
-      <p:sp>
-        <p:nvSpPr>
-          <p:cNvPr id="15" name="fix dot 3"/>
-          <p:cNvSpPr/>
-          <p:nvPr/>
-        </p:nvSpPr>
-        <p:spPr>
-          <a:xfrm>
-            <a:off x="777240" y="3465576"/>
-            <a:ext cx="237744" cy="237744"/>
-          </a:xfrm>
-          <a:prstGeom prst="ellipse">
-            <a:avLst/>
-          </a:prstGeom>
-          <a:solidFill>
-            <a:schemeClr val="accent2"/>
-          </a:solidFill>
-          <a:ln/>
-        </p:spPr>
-      </p:sp>
-      <p:sp>
-        <p:nvSpPr>
-          <p:cNvPr id="16" name="Text 14"/>
-          <p:cNvSpPr txBox="1"/>
-          <p:nvPr/>
-        </p:nvSpPr>
-        <p:spPr>
-          <a:xfrm>
-            <a:off x="1234440" y="3419856"/>
-            <a:ext cx="3108960" cy="329184"/>
-          </a:xfrm>
-          <a:prstGeom prst="rect">
-            <a:avLst/>
-          </a:prstGeom>
-          <a:noFill/>
-          <a:ln/>
-        </p:spPr>
-        <p:txBody>
-          <a:bodyPr wrap="square" lIns="0" tIns="0" rIns="0" bIns="0" rtlCol="0" anchor="t"/>
-          <a:lstStyle/>
-          <a:p>
-            <a:pPr indent="0" marL="0">
-              <a:buNone/>
-            </a:pPr>
-            <a:r>
-              <a:rPr lang="en-US" sz="1400" b="1" dirty="0">
-                <a:solidFill>
-                  <a:schemeClr val="tx1"/>
-                </a:solidFill>
-              </a:rPr>
-              <a:t>Slide 4 discrepancies</a:t>
-            </a:r>
-            <a:endParaRPr lang="en-US" sz="1400" dirty="0"/>
-          </a:p>
-        </p:txBody>
-      </p:sp>
-      <p:sp>
-        <p:nvSpPr>
-          <p:cNvPr id="17" name="Text 15"/>
-          <p:cNvSpPr txBox="1"/>
-          <p:nvPr/>
-        </p:nvSpPr>
-        <p:spPr>
-          <a:xfrm>
-            <a:off x="4389120" y="3419856"/>
-            <a:ext cx="3520440" cy="329184"/>
-          </a:xfrm>
-          <a:prstGeom prst="rect">
-            <a:avLst/>
-          </a:prstGeom>
-          <a:noFill/>
-          <a:ln/>
-        </p:spPr>
-        <p:txBody>
-          <a:bodyPr wrap="square" lIns="0" tIns="0" rIns="0" bIns="0" rtlCol="0" anchor="t"/>
-          <a:lstStyle/>
-          <a:p>
-            <a:pPr indent="0" marL="0">
-              <a:buNone/>
-            </a:pPr>
-            <a:r>
-              <a:rPr lang="en-US" sz="1400" dirty="0">
-                <a:solidFill>
-                  <a:schemeClr val="accent2"/>
-                </a:solidFill>
-              </a:rPr>
-              <a:t>3.21 / 4.41 / 3.61% → 3.11 / 4.22 / 3.48%</a:t>
-            </a:r>
-            <a:endParaRPr lang="en-US" sz="1400" dirty="0"/>
-          </a:p>
-        </p:txBody>
-      </p:sp>
-      <p:sp>
-        <p:nvSpPr>
-          <p:cNvPr id="18" name="Text 16"/>
-          <p:cNvSpPr txBox="1"/>
-          <p:nvPr/>
-        </p:nvSpPr>
-        <p:spPr>
-          <a:xfrm>
-            <a:off x="8001000" y="3337560"/>
-            <a:ext cx="3566160" cy="502920"/>
-          </a:xfrm>
-          <a:prstGeom prst="rect">
-            <a:avLst/>
-          </a:prstGeom>
-          <a:noFill/>
-          <a:ln/>
-        </p:spPr>
-        <p:txBody>
-          <a:bodyPr wrap="square" lIns="0" tIns="0" rIns="0" bIns="0" rtlCol="0" anchor="ctr"/>
-          <a:lstStyle/>
-          <a:p>
-            <a:pPr indent="0" marL="0">
-              <a:buNone/>
-            </a:pPr>
-            <a:r>
-              <a:rPr lang="en-US" sz="1200" dirty="0">
-                <a:solidFill>
-                  <a:schemeClr val="tx2"/>
-                </a:solidFill>
-              </a:rPr>
-              <a:t>Restate with the workbook's formula (÷ pageviews)</a:t>
-            </a:r>
-            <a:endParaRPr lang="en-US" sz="1200" dirty="0"/>
-          </a:p>
-        </p:txBody>
-      </p:sp>
-      <p:sp>
-        <p:nvSpPr>
-          <p:cNvPr id="19" name="fix 4"/>
-          <p:cNvSpPr/>
-          <p:nvPr/>
-        </p:nvSpPr>
-        <p:spPr>
-          <a:xfrm>
-            <a:off x="548640" y="3986784"/>
-            <a:ext cx="11094415" cy="603504"/>
-          </a:xfrm>
-          <a:prstGeom prst="rect">
-            <a:avLst/>
-          </a:prstGeom>
-          <a:solidFill>
-            <a:schemeClr val="bg1"/>
-          </a:solidFill>
-          <a:ln w="9525">
-            <a:solidFill>
-              <a:srgbClr val="E7E0C9"/>
-            </a:solidFill>
-            <a:prstDash val="solid"/>
-          </a:ln>
-        </p:spPr>
-      </p:sp>
-      <p:sp>
-        <p:nvSpPr>
-          <p:cNvPr id="20" name="fix dot 4"/>
-          <p:cNvSpPr/>
-          <p:nvPr/>
-        </p:nvSpPr>
-        <p:spPr>
-          <a:xfrm>
-            <a:off x="777240" y="4169664"/>
-            <a:ext cx="237744" cy="237744"/>
-          </a:xfrm>
-          <a:prstGeom prst="ellipse">
-            <a:avLst/>
-          </a:prstGeom>
-          <a:solidFill>
-            <a:schemeClr val="accent5"/>
-          </a:solidFill>
-          <a:ln/>
-        </p:spPr>
-      </p:sp>
-      <p:sp>
-        <p:nvSpPr>
-          <p:cNvPr id="21" name="Text 19"/>
-          <p:cNvSpPr txBox="1"/>
-          <p:nvPr/>
-        </p:nvSpPr>
-        <p:spPr>
-          <a:xfrm>
-            <a:off x="1234440" y="4123944"/>
-            <a:ext cx="3108960" cy="329184"/>
-          </a:xfrm>
-          <a:prstGeom prst="rect">
-            <a:avLst/>
-          </a:prstGeom>
-          <a:noFill/>
-          <a:ln/>
-        </p:spPr>
-        <p:txBody>
-          <a:bodyPr wrap="square" lIns="0" tIns="0" rIns="0" bIns="0" rtlCol="0" anchor="t"/>
-          <a:lstStyle/>
-          <a:p>
-            <a:pPr indent="0" marL="0">
-              <a:buNone/>
-            </a:pPr>
-            <a:r>
-              <a:rPr lang="en-US" sz="1400" b="1" dirty="0">
-                <a:solidFill>
-                  <a:schemeClr val="tx1"/>
-                </a:solidFill>
-              </a:rPr>
-              <a:t>PMP – PD+PG header</a:t>
-            </a:r>
-            <a:endParaRPr lang="en-US" sz="1400" dirty="0"/>
-          </a:p>
-        </p:txBody>
-      </p:sp>
-      <p:sp>
-        <p:nvSpPr>
-          <p:cNvPr id="22" name="Text 20"/>
-          <p:cNvSpPr txBox="1"/>
-          <p:nvPr/>
-        </p:nvSpPr>
-        <p:spPr>
-          <a:xfrm>
-            <a:off x="4389120" y="4123944"/>
-            <a:ext cx="3520440" cy="329184"/>
-          </a:xfrm>
-          <a:prstGeom prst="rect">
-            <a:avLst/>
-          </a:prstGeom>
-          <a:noFill/>
-          <a:ln/>
-        </p:spPr>
-        <p:txBody>
-          <a:bodyPr wrap="square" lIns="0" tIns="0" rIns="0" bIns="0" rtlCol="0" anchor="t"/>
-          <a:lstStyle/>
-          <a:p>
-            <a:pPr indent="0" marL="0">
-              <a:buNone/>
-            </a:pPr>
-            <a:r>
-              <a:rPr lang="en-US" sz="1400" dirty="0">
-                <a:solidFill>
-                  <a:schemeClr val="tx1"/>
-                </a:solidFill>
-              </a:rPr>
-              <a:t>→ "Total impressions"</a:t>
-            </a:r>
-            <a:endParaRPr lang="en-US" sz="1400" dirty="0"/>
-          </a:p>
-        </p:txBody>
-      </p:sp>
-      <p:sp>
-        <p:nvSpPr>
-          <p:cNvPr id="23" name="Text 21"/>
-          <p:cNvSpPr txBox="1"/>
-          <p:nvPr/>
-        </p:nvSpPr>
-        <p:spPr>
-          <a:xfrm>
-            <a:off x="8001000" y="4041648"/>
-            <a:ext cx="3566160" cy="502920"/>
-          </a:xfrm>
-          <a:prstGeom prst="rect">
-            <a:avLst/>
-          </a:prstGeom>
-          <a:noFill/>
-          <a:ln/>
-        </p:spPr>
-        <p:txBody>
-          <a:bodyPr wrap="square" lIns="0" tIns="0" rIns="0" bIns="0" rtlCol="0" anchor="ctr"/>
-          <a:lstStyle/>
-          <a:p>
-            <a:pPr indent="0" marL="0">
-              <a:buNone/>
-            </a:pPr>
-            <a:r>
-              <a:rPr lang="en-US" sz="1200" dirty="0">
-                <a:solidFill>
-                  <a:schemeClr val="tx2"/>
-                </a:solidFill>
-              </a:rPr>
-              <a:t>The numbers are total impressions, not unfiltered downloaded</a:t>
-            </a:r>
-            <a:endParaRPr lang="en-US" sz="1200" dirty="0"/>
-          </a:p>
-        </p:txBody>
-      </p:sp>
-      <p:sp>
-        <p:nvSpPr>
-          <p:cNvPr id="24" name="fix 5"/>
-          <p:cNvSpPr/>
-          <p:nvPr/>
-        </p:nvSpPr>
-        <p:spPr>
-          <a:xfrm>
-            <a:off x="548640" y="4690872"/>
-            <a:ext cx="11094415" cy="603504"/>
-          </a:xfrm>
-          <a:prstGeom prst="rect">
-            <a:avLst/>
-          </a:prstGeom>
-          <a:solidFill>
-            <a:schemeClr val="bg1"/>
-          </a:solidFill>
-          <a:ln w="9525">
-            <a:solidFill>
-              <a:srgbClr val="E7E0C9"/>
-            </a:solidFill>
-            <a:prstDash val="solid"/>
-          </a:ln>
-        </p:spPr>
-      </p:sp>
-      <p:sp>
-        <p:nvSpPr>
-          <p:cNvPr id="25" name="fix dot 5"/>
-          <p:cNvSpPr/>
-          <p:nvPr/>
-        </p:nvSpPr>
-        <p:spPr>
-          <a:xfrm>
-            <a:off x="777240" y="4873752"/>
-            <a:ext cx="237744" cy="237744"/>
-          </a:xfrm>
-          <a:prstGeom prst="ellipse">
-            <a:avLst/>
-          </a:prstGeom>
-          <a:solidFill>
-            <a:schemeClr val="accent5"/>
-          </a:solidFill>
-          <a:ln/>
-        </p:spPr>
-      </p:sp>
-      <p:sp>
-        <p:nvSpPr>
-          <p:cNvPr id="26" name="Text 24"/>
-          <p:cNvSpPr txBox="1"/>
-          <p:nvPr/>
-        </p:nvSpPr>
-        <p:spPr>
-          <a:xfrm>
-            <a:off x="1234440" y="4828032"/>
-            <a:ext cx="3108960" cy="329184"/>
-          </a:xfrm>
-          <a:prstGeom prst="rect">
-            <a:avLst/>
-          </a:prstGeom>
-          <a:noFill/>
-          <a:ln/>
-        </p:spPr>
-        <p:txBody>
-          <a:bodyPr wrap="square" lIns="0" tIns="0" rIns="0" bIns="0" rtlCol="0" anchor="t"/>
-          <a:lstStyle/>
-          <a:p>
-            <a:pPr indent="0" marL="0">
-              <a:buNone/>
-            </a:pPr>
-            <a:r>
-              <a:rPr lang="en-US" sz="1400" b="1" dirty="0">
-                <a:solidFill>
-                  <a:schemeClr val="tx1"/>
-                </a:solidFill>
-              </a:rPr>
-              <a:t>DV post-bid impressions</a:t>
-            </a:r>
-            <a:endParaRPr lang="en-US" sz="1400" dirty="0"/>
-          </a:p>
-        </p:txBody>
-      </p:sp>
-      <p:sp>
-        <p:nvSpPr>
-          <p:cNvPr id="27" name="Text 25"/>
-          <p:cNvSpPr txBox="1"/>
-          <p:nvPr/>
-        </p:nvSpPr>
-        <p:spPr>
-          <a:xfrm>
-            <a:off x="4389120" y="4828032"/>
-            <a:ext cx="3520440" cy="329184"/>
-          </a:xfrm>
-          <a:prstGeom prst="rect">
-            <a:avLst/>
-          </a:prstGeom>
-          <a:noFill/>
-          <a:ln/>
-        </p:spPr>
-        <p:txBody>
-          <a:bodyPr wrap="square" lIns="0" tIns="0" rIns="0" bIns="0" rtlCol="0" anchor="t"/>
-          <a:lstStyle/>
-          <a:p>
-            <a:pPr indent="0" marL="0">
-              <a:buNone/>
-            </a:pPr>
-            <a:r>
-              <a:rPr lang="en-US" sz="1400" dirty="0">
-                <a:solidFill>
-                  <a:schemeClr val="tx1"/>
-                </a:solidFill>
-              </a:rPr>
-              <a:t>Rounded → exact export</a:t>
-            </a:r>
-            <a:endParaRPr lang="en-US" sz="1400" dirty="0"/>
-          </a:p>
-        </p:txBody>
-      </p:sp>
-      <p:sp>
-        <p:nvSpPr>
-          <p:cNvPr id="28" name="Text 26"/>
-          <p:cNvSpPr txBox="1"/>
-          <p:nvPr/>
-        </p:nvSpPr>
-        <p:spPr>
-          <a:xfrm>
-            <a:off x="8001000" y="4745736"/>
-            <a:ext cx="3566160" cy="502920"/>
-          </a:xfrm>
-          <a:prstGeom prst="rect">
-            <a:avLst/>
-          </a:prstGeom>
-          <a:noFill/>
-          <a:ln/>
-        </p:spPr>
-        <p:txBody>
-          <a:bodyPr wrap="square" lIns="0" tIns="0" rIns="0" bIns="0" rtlCol="0" anchor="ctr"/>
-          <a:lstStyle/>
-          <a:p>
-            <a:pPr indent="0" marL="0">
-              <a:buNone/>
-            </a:pPr>
-            <a:r>
-              <a:rPr lang="en-US" sz="1200" dirty="0">
-                <a:solidFill>
-                  <a:schemeClr val="tx2"/>
-                </a:solidFill>
-              </a:rPr>
-              <a:t>Rounding moves the DV↔GAM gap by up to ~0.03pp a month</a:t>
-            </a:r>
-            <a:endParaRPr lang="en-US" sz="1200" dirty="0"/>
-          </a:p>
-        </p:txBody>
-      </p:sp>
-      <p:sp>
-        <p:nvSpPr>
-          <p:cNvPr id="29" name="fix 6"/>
-          <p:cNvSpPr/>
-          <p:nvPr/>
-        </p:nvSpPr>
-        <p:spPr>
-          <a:xfrm>
-            <a:off x="548640" y="5394960"/>
-            <a:ext cx="11094415" cy="603504"/>
-          </a:xfrm>
-          <a:prstGeom prst="rect">
-            <a:avLst/>
-          </a:prstGeom>
-          <a:solidFill>
-            <a:schemeClr val="bg1"/>
-          </a:solidFill>
-          <a:ln w="9525">
-            <a:solidFill>
-              <a:srgbClr val="E7E0C9"/>
-            </a:solidFill>
-            <a:prstDash val="solid"/>
-          </a:ln>
-        </p:spPr>
-      </p:sp>
-      <p:sp>
-        <p:nvSpPr>
-          <p:cNvPr id="30" name="fix dot 6"/>
-          <p:cNvSpPr/>
-          <p:nvPr/>
-        </p:nvSpPr>
-        <p:spPr>
-          <a:xfrm>
-            <a:off x="777240" y="5577840"/>
-            <a:ext cx="237744" cy="237744"/>
-          </a:xfrm>
-          <a:prstGeom prst="ellipse">
-            <a:avLst/>
-          </a:prstGeom>
-          <a:solidFill>
-            <a:schemeClr val="accent5"/>
-          </a:solidFill>
-          <a:ln/>
-        </p:spPr>
-      </p:sp>
-      <p:sp>
-        <p:nvSpPr>
-          <p:cNvPr id="31" name="Text 29"/>
-          <p:cNvSpPr txBox="1"/>
-          <p:nvPr/>
-        </p:nvSpPr>
-        <p:spPr>
-          <a:xfrm>
-            <a:off x="1234440" y="5532120"/>
-            <a:ext cx="3108960" cy="329184"/>
-          </a:xfrm>
-          <a:prstGeom prst="rect">
-            <a:avLst/>
-          </a:prstGeom>
-          <a:noFill/>
-          <a:ln/>
-        </p:spPr>
-        <p:txBody>
-          <a:bodyPr wrap="square" lIns="0" tIns="0" rIns="0" bIns="0" rtlCol="0" anchor="t"/>
-          <a:lstStyle/>
-          <a:p>
-            <a:pPr indent="0" marL="0">
-              <a:buNone/>
-            </a:pPr>
-            <a:r>
-              <a:rPr lang="en-US" sz="1400" b="1" dirty="0">
-                <a:solidFill>
-                  <a:schemeClr val="tx1"/>
-                </a:solidFill>
-              </a:rPr>
-              <a:t>DV pre-bid menu path</a:t>
-            </a:r>
-            <a:endParaRPr lang="en-US" sz="1400" dirty="0"/>
-          </a:p>
-        </p:txBody>
-      </p:sp>
-      <p:sp>
-        <p:nvSpPr>
-          <p:cNvPr id="32" name="Text 30"/>
-          <p:cNvSpPr txBox="1"/>
-          <p:nvPr/>
-        </p:nvSpPr>
-        <p:spPr>
-          <a:xfrm>
-            <a:off x="4389120" y="5532120"/>
-            <a:ext cx="3520440" cy="329184"/>
-          </a:xfrm>
-          <a:prstGeom prst="rect">
-            <a:avLst/>
-          </a:prstGeom>
-          <a:noFill/>
-          <a:ln/>
-        </p:spPr>
-        <p:txBody>
-          <a:bodyPr wrap="square" lIns="0" tIns="0" rIns="0" bIns="0" rtlCol="0" anchor="t"/>
-          <a:lstStyle/>
-          <a:p>
-            <a:pPr indent="0" marL="0">
-              <a:buNone/>
-            </a:pPr>
-            <a:r>
-              <a:rPr lang="en-US" sz="1400" dirty="0">
-                <a:solidFill>
-                  <a:schemeClr val="tx1"/>
-                </a:solidFill>
-              </a:rPr>
-              <a:t>Write it down</a:t>
-            </a:r>
-            <a:endParaRPr lang="en-US" sz="1400" dirty="0"/>
-          </a:p>
-        </p:txBody>
-      </p:sp>
-      <p:sp>
-        <p:nvSpPr>
-          <p:cNvPr id="33" name="Text 31"/>
-          <p:cNvSpPr txBox="1"/>
-          <p:nvPr/>
-        </p:nvSpPr>
-        <p:spPr>
-          <a:xfrm>
-            <a:off x="8001000" y="5449824"/>
-            <a:ext cx="3566160" cy="502920"/>
-          </a:xfrm>
-          <a:prstGeom prst="rect">
-            <a:avLst/>
-          </a:prstGeom>
-          <a:noFill/>
-          <a:ln/>
-        </p:spPr>
-        <p:txBody>
-          <a:bodyPr wrap="square" lIns="0" tIns="0" rIns="0" bIns="0" rtlCol="0" anchor="ctr"/>
-          <a:lstStyle/>
-          <a:p>
-            <a:pPr indent="0" marL="0">
-              <a:buNone/>
-            </a:pPr>
-            <a:r>
-              <a:rPr lang="en-US" sz="1200" dirty="0">
-                <a:solidFill>
-                  <a:schemeClr val="tx2"/>
-                </a:solidFill>
-              </a:rPr>
-              <a:t>Whoever runs Q4 should add it to this guide</a:t>
-            </a:r>
-            <a:endParaRPr lang="en-US" sz="1200" dirty="0"/>
-          </a:p>
-        </p:txBody>
-      </p:sp>
-      <p:sp>
-        <p:nvSpPr>
-          <p:cNvPr id="25" name="Slide Number Placeholder 0"/>
-          <p:cNvSpPr>
-            <a:spLocks noGrp="1"/>
-          </p:cNvSpPr>
-          <p:nvPr>
-            <p:ph type="sldNum" sz="quarter" idx="4294967295"/>
-          </p:nvPr>
-        </p:nvSpPr>
-        <p:spPr>
-          <a:xfrm>
-            <a:off x="548640" y="6400800"/>
-            <a:ext cx="914400" cy="274320"/>
-          </a:xfrm>
-          <a:prstGeom prst="rect">
-            <a:avLst/>
-          </a:prstGeom>
-          <a:extLst>
-            <a:ext uri="{C572A759-6A51-4108-AA02-DFA0A04FC94B}">
-              <ma14:wrappingTextBoxFlag xmlns:ma14="http://schemas.microsoft.com/office/mac/drawingml/2011/main" val="0"/>
-            </a:ext>
-          </a:extLst>
-        </p:spPr>
-        <p:txBody>
-          <a:bodyPr/>
-          <a:lstStyle>
-            <a:lvl1pPr>
-              <a:defRPr sz="1000">
-                <a:solidFill>
-                  <a:srgbClr val="8C887B"/>
-                </a:solidFill>
-                <a:latin typeface="Arial"/>
-                <a:ea typeface="Arial"/>
-                <a:cs typeface="Arial"/>
-              </a:defRPr>
-            </a:lvl1pPr>
-          </a:lstStyle>
-          <a:p>
-            <a:pPr algn="l"/>
-            <a:fld id="{F7021451-1387-4CA6-816F-3879F97B5CBC}" type="slidenum">
-              <a:rPr b="0" lang="en-US"/>
-              <a:t>15</a:t>
             </a:fld>
             <a:endParaRPr lang="en-US"/>
           </a:p>

</xml_diff>

<commit_message>
docs: label the TAG IVT workbooks pre-bid / post-bid monitoring
Co-Authored-By: Claude Opus 5.5 <noreply@anthropic.com>
Claude-Session: https://claude.ai/code/session_014udSfWkctWaSTKdEZUW1Gh
</commit_message>
<xml_diff>
--- a/docs/TAG_IVT_Report_Update_Guide.pptx
+++ b/docs/TAG_IVT_Report_Update_Guide.pptx
@@ -122,7 +122,7 @@
   <p:extLst>
     <p:ext uri="{521415D9-36F7-43E2-AB2F-B90AF26B5E84}">
       <p14:sectionLst xmlns:p14="http://schemas.microsoft.com/office/powerpoint/2010/main">
-        <p14:section name="Overview" id="{debe3961-d5e5-615f-2be4-6e594c394959}">
+        <p14:section name="Overview" id="{ce8bb97a-38d1-7927-0d6b-2ef63a89015b}">
           <p14:sldIdLst>
             <p14:sldId id="256"/>
             <p14:sldId id="257"/>
@@ -132,7 +132,7 @@
             <p14:sldId id="261"/>
           </p14:sldIdLst>
         </p14:section>
-        <p14:section name="1 · GAM" id="{d27b2fb6-4c94-2d09-471c-38e30b78d6af}">
+        <p14:section name="1 · GAM" id="{c3066be5-18c2-d117-b017-21c32f4c7a8b}">
           <p14:sldIdLst>
             <p14:sldId id="262"/>
             <p14:sldId id="263"/>
@@ -140,14 +140,14 @@
             <p14:sldId id="265"/>
           </p14:sldIdLst>
         </p14:section>
-        <p14:section name="2–3 · DV and GA4" id="{5c6e57fb-fe0a-8c6f-5bba-116372805886}">
+        <p14:section name="2–3 · DV and GA4" id="{ad64ef4f-f381-7283-c3d9-9c66af9cf302}">
           <p14:sldIdLst>
             <p14:sldId id="266"/>
             <p14:sldId id="267"/>
             <p14:sldId id="268"/>
           </p14:sldIdLst>
         </p14:section>
-        <p14:section name="4–5 · Math and deck" id="{51047359-d835-6be4-f15f-b42bbb193ad6}">
+        <p14:section name="4–5 · Math and deck" id="{cf976f7d-1345-1685-239e-1ed4a69f18eb}">
           <p14:sldIdLst>
             <p14:sldId id="269"/>
             <p14:sldId id="270"/>
@@ -7082,7 +7082,7 @@
                   <a:schemeClr val="tx2"/>
                 </a:solidFill>
               </a:rPr>
-              <a:t>GA4 web pageviews vs DV pre-bid requests, by month</a:t>
+              <a:t>Pre-bid monitoring: GA4 web pageviews vs pages DV's pre-bid check evaluated, by month</a:t>
             </a:r>
             <a:endParaRPr lang="en-US" sz="1400" dirty="0"/>
           </a:p>
@@ -7274,7 +7274,7 @@
                   <a:schemeClr val="tx2"/>
                 </a:solidFill>
               </a:rPr>
-              <a:t>GAM impressions by channel, DV post-bid impressions and SIVT rate, display and video sheets</a:t>
+              <a:t>Post-bid monitoring: GAM impressions vs DV post-bid impressions, plus SIVT rate</a:t>
             </a:r>
             <a:endParaRPr lang="en-US" sz="1400" dirty="0"/>
           </a:p>
@@ -7613,7 +7613,7 @@
                   <a:schemeClr val="tx2"/>
                 </a:solidFill>
               </a:rPr>
-              <a:t>WORKBOOK 1 · DV-GA DISCREPANCY</a:t>
+              <a:t>WORKBOOK 1 · DV-GA DISCREPANCY · PRE-BID MONITORING</a:t>
             </a:r>
             <a:endParaRPr lang="en-US" sz="1200" dirty="0"/>
           </a:p>
@@ -7698,7 +7698,7 @@
       </p:sp>
       <p:graphicFrame>
         <p:nvGraphicFramePr>
-          <p:cNvPr id="4" name="Workbook 1 · DV-GA discrepancy columns"/>
+          <p:cNvPr id="4" name="Workbook 1 · DV-GA discrepancy · pre-bid monitoring columns"/>
           <p:cNvGraphicFramePr>
             <a:graphicFrameLocks noGrp="1"/>
           </p:cNvGraphicFramePr>
@@ -9068,7 +9068,7 @@
                   <a:schemeClr val="tx2"/>
                 </a:solidFill>
               </a:rPr>
-              <a:t>WORKBOOK 2 · DV-GAM DISCREPANCY</a:t>
+              <a:t>WORKBOOK 2 · DV-GAM DISCREPANCY · POST-BID MONITORING</a:t>
             </a:r>
             <a:endParaRPr lang="en-US" sz="1200" dirty="0"/>
           </a:p>
@@ -9153,7 +9153,7 @@
       </p:sp>
       <p:graphicFrame>
         <p:nvGraphicFramePr>
-          <p:cNvPr id="5" name="Workbook 2 · DV-GAM discrepancy columns"/>
+          <p:cNvPr id="5" name="Workbook 2 · DV-GAM discrepancy · post-bid monitoring columns"/>
           <p:cNvGraphicFramePr>
             <a:graphicFrameLocks noGrp="1"/>
           </p:cNvGraphicFramePr>

</xml_diff>

<commit_message>
docs: state the pre-bid workbook's goal (every pageview monitored by DV)
Co-Authored-By: Claude Opus 5.5 <noreply@anthropic.com>
Claude-Session: https://claude.ai/code/session_014udSfWkctWaSTKdEZUW1Gh
</commit_message>
<xml_diff>
--- a/docs/TAG_IVT_Report_Update_Guide.pptx
+++ b/docs/TAG_IVT_Report_Update_Guide.pptx
@@ -122,7 +122,7 @@
   <p:extLst>
     <p:ext uri="{521415D9-36F7-43E2-AB2F-B90AF26B5E84}">
       <p14:sectionLst xmlns:p14="http://schemas.microsoft.com/office/powerpoint/2010/main">
-        <p14:section name="Overview" id="{ce8bb97a-38d1-7927-0d6b-2ef63a89015b}">
+        <p14:section name="Overview" id="{2a7c6280-e8b7-53b2-a384-01d75b478c89}">
           <p14:sldIdLst>
             <p14:sldId id="256"/>
             <p14:sldId id="257"/>
@@ -132,7 +132,7 @@
             <p14:sldId id="261"/>
           </p14:sldIdLst>
         </p14:section>
-        <p14:section name="1 · GAM" id="{c3066be5-18c2-d117-b017-21c32f4c7a8b}">
+        <p14:section name="1 · GAM" id="{f8995b00-d1ce-2bd4-e019-a376ccf8c79e}">
           <p14:sldIdLst>
             <p14:sldId id="262"/>
             <p14:sldId id="263"/>
@@ -140,14 +140,14 @@
             <p14:sldId id="265"/>
           </p14:sldIdLst>
         </p14:section>
-        <p14:section name="2–3 · DV and GA4" id="{ad64ef4f-f381-7283-c3d9-9c66af9cf302}">
+        <p14:section name="2–3 · DV and GA4" id="{0c262811-0448-3d33-ea02-c2be4cf57032}">
           <p14:sldIdLst>
             <p14:sldId id="266"/>
             <p14:sldId id="267"/>
             <p14:sldId id="268"/>
           </p14:sldIdLst>
         </p14:section>
-        <p14:section name="4–5 · Math and deck" id="{cf976f7d-1345-1685-239e-1ed4a69f18eb}">
+        <p14:section name="4–5 · Math and deck" id="{7502effa-890c-d388-2c6a-0017745aedca}">
           <p14:sldIdLst>
             <p14:sldId id="269"/>
             <p14:sldId id="270"/>
@@ -6941,7 +6941,7 @@
         <p:spPr>
           <a:xfrm>
             <a:off x="548640" y="2148840"/>
-            <a:ext cx="3454298" cy="3566160"/>
+            <a:ext cx="3454298" cy="4023360"/>
           </a:xfrm>
           <a:prstGeom prst="rect">
             <a:avLst/>
@@ -7061,7 +7061,7 @@
         <p:spPr>
           <a:xfrm>
             <a:off x="868680" y="4343400"/>
-            <a:ext cx="2814218" cy="777240"/>
+            <a:ext cx="2814218" cy="1280160"/>
           </a:xfrm>
           <a:prstGeom prst="rect">
             <a:avLst/>
@@ -7082,7 +7082,7 @@
                   <a:schemeClr val="tx2"/>
                 </a:solidFill>
               </a:rPr>
-              <a:t>Pre-bid monitoring: GA4 web pageviews vs pages DV's pre-bid check evaluated, by month</a:t>
+              <a:t>Pre-bid monitoring. Comparing GA4 web pageviews with DV pre-bid requests, month by month, shows TAG and its auditors that DV monitors every pageview.</a:t>
             </a:r>
             <a:endParaRPr lang="en-US" sz="1400" dirty="0"/>
           </a:p>
@@ -7096,7 +7096,7 @@
         </p:nvSpPr>
         <p:spPr>
           <a:xfrm>
-            <a:off x="868680" y="5166360"/>
+            <a:off x="868680" y="5669280"/>
             <a:ext cx="2814218" cy="320040"/>
           </a:xfrm>
           <a:prstGeom prst="rect">
@@ -7133,7 +7133,7 @@
         <p:spPr>
           <a:xfrm>
             <a:off x="4368698" y="2148840"/>
-            <a:ext cx="3454298" cy="3566160"/>
+            <a:ext cx="3454298" cy="4023360"/>
           </a:xfrm>
           <a:prstGeom prst="rect">
             <a:avLst/>
@@ -7253,7 +7253,7 @@
         <p:spPr>
           <a:xfrm>
             <a:off x="4688738" y="4343400"/>
-            <a:ext cx="2814218" cy="777240"/>
+            <a:ext cx="2814218" cy="1280160"/>
           </a:xfrm>
           <a:prstGeom prst="rect">
             <a:avLst/>
@@ -7288,7 +7288,7 @@
         </p:nvSpPr>
         <p:spPr>
           <a:xfrm>
-            <a:off x="4688738" y="5166360"/>
+            <a:off x="4688738" y="5669280"/>
             <a:ext cx="2814218" cy="320040"/>
           </a:xfrm>
           <a:prstGeom prst="rect">
@@ -7325,7 +7325,7 @@
         <p:spPr>
           <a:xfrm>
             <a:off x="8188757" y="2148840"/>
-            <a:ext cx="3454298" cy="3566160"/>
+            <a:ext cx="3454298" cy="4023360"/>
           </a:xfrm>
           <a:prstGeom prst="rect">
             <a:avLst/>
@@ -7445,7 +7445,7 @@
         <p:spPr>
           <a:xfrm>
             <a:off x="8508797" y="4343400"/>
-            <a:ext cx="2814218" cy="777240"/>
+            <a:ext cx="2814218" cy="1280160"/>
           </a:xfrm>
           <a:prstGeom prst="rect">
             <a:avLst/>
@@ -7480,7 +7480,7 @@
         </p:nvSpPr>
         <p:spPr>
           <a:xfrm>
-            <a:off x="8508797" y="5166360"/>
+            <a:off x="8508797" y="5669280"/>
             <a:ext cx="2814218" cy="320040"/>
           </a:xfrm>
           <a:prstGeom prst="rect">
@@ -7669,6 +7669,42 @@
         <p:spPr>
           <a:xfrm>
             <a:off x="548640" y="1783080"/>
+            <a:ext cx="11094415" cy="640080"/>
+          </a:xfrm>
+          <a:prstGeom prst="rect">
+            <a:avLst/>
+          </a:prstGeom>
+          <a:noFill/>
+          <a:ln/>
+        </p:spPr>
+        <p:txBody>
+          <a:bodyPr wrap="square" lIns="0" tIns="0" rIns="0" bIns="0" rtlCol="0" anchor="t"/>
+          <a:lstStyle/>
+          <a:p>
+            <a:pPr indent="0" marL="0">
+              <a:buNone/>
+            </a:pPr>
+            <a:r>
+              <a:rPr lang="en-US" sz="1600" b="1" dirty="0">
+                <a:solidFill>
+                  <a:schemeClr val="tx1"/>
+                </a:solidFill>
+              </a:rPr>
+              <a:t>Our goal: by comparing GA4 pageviews with DV pre-bid requests, show TAG and TAG auditors that every pageview is monitored by DoubleVerify.</a:t>
+            </a:r>
+            <a:endParaRPr lang="en-US" sz="1600" dirty="0"/>
+          </a:p>
+        </p:txBody>
+      </p:sp>
+      <p:sp>
+        <p:nvSpPr>
+          <p:cNvPr id="5" name="Text 3"/>
+          <p:cNvSpPr txBox="1"/>
+          <p:nvPr/>
+        </p:nvSpPr>
+        <p:spPr>
+          <a:xfrm>
+            <a:off x="548640" y="2468880"/>
             <a:ext cx="11094415" cy="457200"/>
           </a:xfrm>
           <a:prstGeom prst="rect">
@@ -7711,7 +7747,7 @@
           </p:nvPr>
         </p:nvGraphicFramePr>
         <p:xfrm>
-          <a:off x="548640" y="2377440"/>
+          <a:off x="548640" y="3063240"/>
           <a:ext cx="11094415" cy="914400"/>
         </p:xfrm>
         <a:graphic>

</xml_diff>

<commit_message>
docs: state the post-bid workbook's goal (every impression measured by DV)
Co-Authored-By: Claude Opus 5.5 <noreply@anthropic.com>
Claude-Session: https://claude.ai/code/session_014udSfWkctWaSTKdEZUW1Gh
</commit_message>
<xml_diff>
--- a/docs/TAG_IVT_Report_Update_Guide.pptx
+++ b/docs/TAG_IVT_Report_Update_Guide.pptx
@@ -122,7 +122,7 @@
   <p:extLst>
     <p:ext uri="{521415D9-36F7-43E2-AB2F-B90AF26B5E84}">
       <p14:sectionLst xmlns:p14="http://schemas.microsoft.com/office/powerpoint/2010/main">
-        <p14:section name="Overview" id="{2a7c6280-e8b7-53b2-a384-01d75b478c89}">
+        <p14:section name="Overview" id="{13756354-8fd1-9618-5ae3-4761ed61e025}">
           <p14:sldIdLst>
             <p14:sldId id="256"/>
             <p14:sldId id="257"/>
@@ -132,7 +132,7 @@
             <p14:sldId id="261"/>
           </p14:sldIdLst>
         </p14:section>
-        <p14:section name="1 · GAM" id="{f8995b00-d1ce-2bd4-e019-a376ccf8c79e}">
+        <p14:section name="1 · GAM" id="{1d7deb49-4882-7de2-f181-a0e02ec03774}">
           <p14:sldIdLst>
             <p14:sldId id="262"/>
             <p14:sldId id="263"/>
@@ -140,14 +140,14 @@
             <p14:sldId id="265"/>
           </p14:sldIdLst>
         </p14:section>
-        <p14:section name="2–3 · DV and GA4" id="{0c262811-0448-3d33-ea02-c2be4cf57032}">
+        <p14:section name="2–3 · DV and GA4" id="{c819f5c8-5f90-dbfd-a06d-f40e09b45ad3}">
           <p14:sldIdLst>
             <p14:sldId id="266"/>
             <p14:sldId id="267"/>
             <p14:sldId id="268"/>
           </p14:sldIdLst>
         </p14:section>
-        <p14:section name="4–5 · Math and deck" id="{7502effa-890c-d388-2c6a-0017745aedca}">
+        <p14:section name="4–5 · Math and deck" id="{0193d94d-5ece-d199-4a8c-05e372b9bb4f}">
           <p14:sldIdLst>
             <p14:sldId id="269"/>
             <p14:sldId id="270"/>
@@ -7274,7 +7274,7 @@
                   <a:schemeClr val="tx2"/>
                 </a:solidFill>
               </a:rPr>
-              <a:t>Post-bid monitoring: GAM impressions vs DV post-bid impressions, plus SIVT rate</a:t>
+              <a:t>Post-bid monitoring. Comparing every impression GAM records with what DV records shows we also measure all post-bid impressions. Plus SIVT rate.</a:t>
             </a:r>
             <a:endParaRPr lang="en-US" sz="1400" dirty="0"/>
           </a:p>
@@ -7747,7 +7747,7 @@
           </p:nvPr>
         </p:nvGraphicFramePr>
         <p:xfrm>
-          <a:off x="548640" y="3063240"/>
+          <a:off x="548640" y="2999232"/>
           <a:ext cx="11094415" cy="914400"/>
         </p:xfrm>
         <a:graphic>
@@ -7759,7 +7759,7 @@
                 <a:gridCol w="6217920"/>
                 <a:gridCol w="2496312"/>
               </a:tblGrid>
-              <a:tr h="320040">
+              <a:tr h="283464">
                 <a:tc>
                   <a:txBody>
                     <a:bodyPr/>
@@ -7965,7 +7965,7 @@
                   </a:tcPr>
                 </a:tc>
               </a:tr>
-              <a:tr h="320040">
+              <a:tr h="283464">
                 <a:tc>
                   <a:txBody>
                     <a:bodyPr/>
@@ -8171,7 +8171,7 @@
                   </a:tcPr>
                 </a:tc>
               </a:tr>
-              <a:tr h="320040">
+              <a:tr h="283464">
                 <a:tc>
                   <a:txBody>
                     <a:bodyPr/>
@@ -8377,7 +8377,7 @@
                   </a:tcPr>
                 </a:tc>
               </a:tr>
-              <a:tr h="320040">
+              <a:tr h="283464">
                 <a:tc>
                   <a:txBody>
                     <a:bodyPr/>
@@ -8583,7 +8583,7 @@
                   </a:tcPr>
                 </a:tc>
               </a:tr>
-              <a:tr h="320040">
+              <a:tr h="283464">
                 <a:tc>
                   <a:txBody>
                     <a:bodyPr/>
@@ -8789,7 +8789,7 @@
                   </a:tcPr>
                 </a:tc>
               </a:tr>
-              <a:tr h="320040">
+              <a:tr h="283464">
                 <a:tc>
                   <a:txBody>
                     <a:bodyPr/>
@@ -9160,6 +9160,42 @@
         <p:spPr>
           <a:xfrm>
             <a:off x="548640" y="1783080"/>
+            <a:ext cx="11094415" cy="640080"/>
+          </a:xfrm>
+          <a:prstGeom prst="rect">
+            <a:avLst/>
+          </a:prstGeom>
+          <a:noFill/>
+          <a:ln/>
+        </p:spPr>
+        <p:txBody>
+          <a:bodyPr wrap="square" lIns="0" tIns="0" rIns="0" bIns="0" rtlCol="0" anchor="t"/>
+          <a:lstStyle/>
+          <a:p>
+            <a:pPr indent="0" marL="0">
+              <a:buNone/>
+            </a:pPr>
+            <a:r>
+              <a:rPr lang="en-US" sz="1600" b="1" dirty="0">
+                <a:solidFill>
+                  <a:schemeClr val="tx1"/>
+                </a:solidFill>
+              </a:rPr>
+              <a:t>Our goal: by comparing all impressions GAM records with what DV records, show TAG and TAG auditors that every post-bid impression is measured.</a:t>
+            </a:r>
+            <a:endParaRPr lang="en-US" sz="1600" dirty="0"/>
+          </a:p>
+        </p:txBody>
+      </p:sp>
+      <p:sp>
+        <p:nvSpPr>
+          <p:cNvPr id="5" name="Text 3"/>
+          <p:cNvSpPr txBox="1"/>
+          <p:nvPr/>
+        </p:nvSpPr>
+        <p:spPr>
+          <a:xfrm>
+            <a:off x="548640" y="2468880"/>
             <a:ext cx="11094415" cy="457200"/>
           </a:xfrm>
           <a:prstGeom prst="rect">
@@ -9202,7 +9238,7 @@
           </p:nvPr>
         </p:nvGraphicFramePr>
         <p:xfrm>
-          <a:off x="548640" y="2377440"/>
+          <a:off x="548640" y="2999232"/>
           <a:ext cx="11094415" cy="914400"/>
         </p:xfrm>
         <a:graphic>
@@ -9214,7 +9250,7 @@
                 <a:gridCol w="6217920"/>
                 <a:gridCol w="2496312"/>
               </a:tblGrid>
-              <a:tr h="320040">
+              <a:tr h="283464">
                 <a:tc>
                   <a:txBody>
                     <a:bodyPr/>
@@ -9420,7 +9456,7 @@
                   </a:tcPr>
                 </a:tc>
               </a:tr>
-              <a:tr h="320040">
+              <a:tr h="283464">
                 <a:tc>
                   <a:txBody>
                     <a:bodyPr/>
@@ -9626,7 +9662,7 @@
                   </a:tcPr>
                 </a:tc>
               </a:tr>
-              <a:tr h="320040">
+              <a:tr h="283464">
                 <a:tc>
                   <a:txBody>
                     <a:bodyPr/>
@@ -9832,7 +9868,7 @@
                   </a:tcPr>
                 </a:tc>
               </a:tr>
-              <a:tr h="320040">
+              <a:tr h="283464">
                 <a:tc>
                   <a:txBody>
                     <a:bodyPr/>
@@ -10038,7 +10074,7 @@
                   </a:tcPr>
                 </a:tc>
               </a:tr>
-              <a:tr h="320040">
+              <a:tr h="283464">
                 <a:tc>
                   <a:txBody>
                     <a:bodyPr/>
@@ -10244,7 +10280,7 @@
                   </a:tcPr>
                 </a:tc>
               </a:tr>
-              <a:tr h="320040">
+              <a:tr h="283464">
                 <a:tc>
                   <a:txBody>
                     <a:bodyPr/>
@@ -10450,7 +10486,7 @@
                   </a:tcPr>
                 </a:tc>
               </a:tr>
-              <a:tr h="320040">
+              <a:tr h="283464">
                 <a:tc>
                   <a:txBody>
                     <a:bodyPr/>
@@ -10656,7 +10692,7 @@
                   </a:tcPr>
                 </a:tc>
               </a:tr>
-              <a:tr h="320040">
+              <a:tr h="283464">
                 <a:tc>
                   <a:txBody>
                     <a:bodyPr/>
@@ -10862,7 +10898,7 @@
                   </a:tcPr>
                 </a:tc>
               </a:tr>
-              <a:tr h="320040">
+              <a:tr h="283464">
                 <a:tc>
                   <a:txBody>
                     <a:bodyPr/>
@@ -11068,7 +11104,7 @@
                   </a:tcPr>
                 </a:tc>
               </a:tr>
-              <a:tr h="320040">
+              <a:tr h="283464">
                 <a:tc>
                   <a:txBody>
                     <a:bodyPr/>
@@ -11274,7 +11310,7 @@
                   </a:tcPr>
                 </a:tc>
               </a:tr>
-              <a:tr h="320040">
+              <a:tr h="283464">
                 <a:tc>
                   <a:txBody>
                     <a:bodyPr/>

</xml_diff>

<commit_message>
docs: show the monthly discrepancy rate on the guide's pre/post-bid charts
Co-Authored-By: Claude Opus 5.5 <noreply@anthropic.com>
Claude-Session: https://claude.ai/code/session_014udSfWkctWaSTKdEZUW1Gh
</commit_message>
<xml_diff>
--- a/docs/TAG_IVT_Report_Update_Guide.pptx
+++ b/docs/TAG_IVT_Report_Update_Guide.pptx
@@ -124,7 +124,7 @@
   <p:extLst>
     <p:ext uri="{521415D9-36F7-43E2-AB2F-B90AF26B5E84}">
       <p14:sectionLst xmlns:p14="http://schemas.microsoft.com/office/powerpoint/2010/main">
-        <p14:section name="Overview" id="{2ebdabf3-4d25-3823-fc5f-43277175d1cc}">
+        <p14:section name="Overview" id="{5f0be8cb-3a0c-432c-84e4-bab24de197c0}">
           <p14:sldIdLst>
             <p14:sldId id="256"/>
             <p14:sldId id="257"/>
@@ -136,7 +136,7 @@
             <p14:sldId id="263"/>
           </p14:sldIdLst>
         </p14:section>
-        <p14:section name="1 · GAM" id="{000b8540-b19f-b41f-4d5f-28af275c47bc}">
+        <p14:section name="1 · GAM" id="{07d86376-7bd1-5dbd-de7d-64dc48dc9686}">
           <p14:sldIdLst>
             <p14:sldId id="264"/>
             <p14:sldId id="265"/>
@@ -144,14 +144,14 @@
             <p14:sldId id="267"/>
           </p14:sldIdLst>
         </p14:section>
-        <p14:section name="2–3 · DV and GA4" id="{06898039-e368-0d64-a420-c5ff4849fb0d}">
+        <p14:section name="2–3 · DV and GA4" id="{9f7f6d8b-8403-588a-cf38-38462b4bc743}">
           <p14:sldIdLst>
             <p14:sldId id="268"/>
             <p14:sldId id="269"/>
             <p14:sldId id="270"/>
           </p14:sldIdLst>
         </p14:section>
-        <p14:section name="4–5 · Math and deck" id="{b2e4ca87-68d5-5e76-798a-2f7f39b03737}">
+        <p14:section name="4–5 · Math and deck" id="{c5b29312-b4c8-ea56-fb87-17b0d5cbfe8d}">
           <p14:sldIdLst>
             <p14:sldId id="271"/>
             <p14:sldId id="272"/>
@@ -181,7 +181,7 @@
             <a:pPr>
               <a:defRPr sz="1200" b="0" i="0" u="none" strike="noStrike">
                 <a:solidFill>
-                  <a:srgbClr val="57564F"/>
+                  <a:srgbClr val="1F1E19"/>
                 </a:solidFill>
                 <a:latin typeface="+mn-lt"/>
               </a:defRPr>
@@ -189,11 +189,327 @@
             <a:r>
               <a:rPr sz="1200" b="0" i="0" u="none" strike="noStrike">
                 <a:solidFill>
-                  <a:srgbClr val="57564F"/>
+                  <a:srgbClr val="1F1E19"/>
                 </a:solidFill>
                 <a:latin typeface="+mn-lt"/>
               </a:rPr>
-              <a:t>2026 YTD (Jan–Sep, October excluded), millions</a:t>
+              <a:t>Discrepancy rate by month, 2026 YTD (Jan–Sep, October excluded)</a:t>
+            </a:r>
+          </a:p>
+        </c:rich>
+      </c:tx>
+      <c:layout/>
+      <c:overlay val="0"/>
+    </c:title>
+    <c:autoTitleDeleted val="0"/>
+    <c:plotArea>
+      <c:layout/>
+      <c:lineChart>
+        <c:varyColors val="0"/>
+        <c:ser>
+          <c:idx val="0"/>
+          <c:order val="0"/>
+          <c:tx>
+            <c:strRef>
+              <c:f>Sheet1!$B$1</c:f>
+              <c:strCache>
+                <c:ptCount val="1"/>
+                <c:pt idx="0">
+                  <c:v>Discrepancy %</c:v>
+                </c:pt>
+              </c:strCache>
+            </c:strRef>
+          </c:tx>
+          <c:spPr>
+            <a:solidFill>
+              <a:srgbClr val="1F1E19"/>
+            </a:solidFill>
+            <a:ln w="31750" cap="flat">
+              <a:solidFill>
+                <a:srgbClr val="1F1E19"/>
+              </a:solidFill>
+              <a:prstDash val="solid"/>
+              <a:round/>
+            </a:ln>
+            <a:effectLst/>
+          </c:spPr>
+          <c:invertIfNegative val="0"/>
+          <c:dLbls>
+            <c:numFmt formatCode="0.0&quot;%&quot;" sourceLinked="0"/>
+            <c:txPr>
+              <a:bodyPr/>
+              <a:lstStyle/>
+              <a:p>
+                <a:pPr>
+                  <a:defRPr b="1" i="0" strike="noStrike" sz="1100" u="none">
+                    <a:solidFill>
+                      <a:srgbClr val="1F1E19"/>
+                    </a:solidFill>
+                    <a:latin typeface="+mn-lt"/>
+                  </a:defRPr>
+                </a:pPr>
+              </a:p>
+            </c:txPr>
+            <c:dLblPos val="t"/>
+            <c:showLegendKey val="0"/>
+            <c:showVal val="1"/>
+            <c:showCatName val="0"/>
+            <c:showSerName val="0"/>
+            <c:showPercent val="0"/>
+            <c:showBubbleSize val="0"/>
+            <c:showLeaderLines val="0"/>
+          </c:dLbls>
+          <c:marker>
+            <c:symbol val="circle"/>
+            <c:size val="7"/>
+            <c:spPr>
+              <a:solidFill>
+                <a:srgbClr val="1F1E19"/>
+              </a:solidFill>
+              <a:ln w="9525" cap="flat">
+                <a:solidFill>
+                  <a:srgbClr val="1F1E19"/>
+                </a:solidFill>
+                <a:prstDash val="solid"/>
+                <a:round/>
+              </a:ln>
+              <a:effectLst/>
+            </c:spPr>
+          </c:marker>
+          <c:cat>
+            <c:multiLvlStrRef>
+              <c:f>Sheet1!$A$2:$A$10</c:f>
+              <c:multiLvlStrCache>
+                <c:ptCount val="9"/>
+                <c:lvl>
+                  <c:pt idx="0">
+                    <c:v>Jan</c:v>
+                  </c:pt>
+                  <c:pt idx="1">
+                    <c:v>Feb</c:v>
+                  </c:pt>
+                  <c:pt idx="2">
+                    <c:v>Mar</c:v>
+                  </c:pt>
+                  <c:pt idx="3">
+                    <c:v>Apr</c:v>
+                  </c:pt>
+                  <c:pt idx="4">
+                    <c:v>May</c:v>
+                  </c:pt>
+                  <c:pt idx="5">
+                    <c:v>Jun</c:v>
+                  </c:pt>
+                  <c:pt idx="6">
+                    <c:v>Jul</c:v>
+                  </c:pt>
+                  <c:pt idx="7">
+                    <c:v>Aug</c:v>
+                  </c:pt>
+                  <c:pt idx="8">
+                    <c:v>Sep</c:v>
+                  </c:pt>
+                </c:lvl>
+              </c:multiLvlStrCache>
+            </c:multiLvlStrRef>
+          </c:cat>
+          <c:val>
+            <c:numRef>
+              <c:f>Sheet1!$B$2:$B$10</c:f>
+              <c:numCache>
+                <c:formatCode>General</c:formatCode>
+                <c:ptCount val="9"/>
+                <c:pt idx="0">
+                  <c:v>3.1</c:v>
+                </c:pt>
+                <c:pt idx="1">
+                  <c:v>3.2</c:v>
+                </c:pt>
+                <c:pt idx="2">
+                  <c:v>3</c:v>
+                </c:pt>
+                <c:pt idx="3">
+                  <c:v>1.9</c:v>
+                </c:pt>
+                <c:pt idx="4">
+                  <c:v>8.6</c:v>
+                </c:pt>
+                <c:pt idx="5">
+                  <c:v>2.4</c:v>
+                </c:pt>
+                <c:pt idx="6">
+                  <c:v>5.4</c:v>
+                </c:pt>
+                <c:pt idx="7">
+                  <c:v>5.8</c:v>
+                </c:pt>
+                <c:pt idx="8">
+                  <c:v>4</c:v>
+                </c:pt>
+              </c:numCache>
+            </c:numRef>
+          </c:val>
+          <c:smooth val="0"/>
+        </c:ser>
+        <c:dLbls>
+          <c:numFmt formatCode="0.0&quot;%&quot;" sourceLinked="0"/>
+          <c:txPr>
+            <a:bodyPr/>
+            <a:lstStyle/>
+            <a:p>
+              <a:pPr>
+                <a:defRPr b="1" i="0" strike="noStrike" sz="1100" u="none">
+                  <a:solidFill>
+                    <a:srgbClr val="1F1E19"/>
+                  </a:solidFill>
+                  <a:latin typeface="+mn-lt"/>
+                </a:defRPr>
+              </a:pPr>
+            </a:p>
+          </c:txPr>
+          <c:dLblPos val="t"/>
+          <c:showLegendKey val="0"/>
+          <c:showVal val="1"/>
+          <c:showCatName val="0"/>
+          <c:showSerName val="0"/>
+          <c:showPercent val="0"/>
+          <c:showBubbleSize val="0"/>
+          <c:showLeaderLines val="0"/>
+        </c:dLbls>
+        <c:marker val="1"/>
+        <c:axId val="2094734554"/>
+        <c:axId val="2094734552"/>
+        <c:axId val="2094734556"/>
+      </c:lineChart>
+      <c:catAx>
+        <c:axId val="2094734554"/>
+        <c:scaling>
+          <c:orientation val="minMax"/>
+        </c:scaling>
+        <c:delete val="0"/>
+        <c:axPos val="b"/>
+        <c:numFmt formatCode="General" sourceLinked="1"/>
+        <c:majorTickMark val="out"/>
+        <c:minorTickMark val="none"/>
+        <c:tickLblPos val="low"/>
+        <c:spPr>
+          <a:ln w="12700" cap="flat">
+            <a:noFill/>
+            <a:prstDash val="solid"/>
+            <a:round/>
+          </a:ln>
+        </c:spPr>
+        <c:txPr>
+          <a:bodyPr/>
+          <a:lstStyle/>
+          <a:p>
+            <a:pPr>
+              <a:defRPr sz="1100" b="0" i="0" u="none" strike="noStrike">
+                <a:solidFill>
+                  <a:srgbClr val="57564F"/>
+                </a:solidFill>
+                <a:latin typeface="+mn-lt"/>
+              </a:defRPr>
+            </a:pPr>
+            <a:endParaRPr lang="en-US"/>
+          </a:p>
+        </c:txPr>
+        <c:crossAx val="2094734552"/>
+        <c:crosses val="autoZero"/>
+        <c:auto val="1"/>
+        <c:lblAlgn val="ctr"/>
+        <c:noMultiLvlLbl val="1"/>
+      </c:catAx>
+      <c:valAx>
+        <c:axId val="2094734552"/>
+        <c:scaling>
+          <c:orientation val="minMax"/>
+          <c:max val="11"/>
+          <c:min val="0"/>
+        </c:scaling>
+        <c:delete val="1"/>
+        <c:axPos val="l"/>
+        <c:numFmt formatCode="General" sourceLinked="0"/>
+        <c:majorTickMark val="out"/>
+        <c:minorTickMark val="none"/>
+        <c:tickLblPos val="nextTo"/>
+        <c:spPr>
+          <a:ln w="12700" cap="flat">
+            <a:noFill/>
+            <a:prstDash val="solid"/>
+            <a:round/>
+          </a:ln>
+        </c:spPr>
+        <c:txPr>
+          <a:bodyPr/>
+          <a:lstStyle/>
+          <a:p>
+            <a:pPr>
+              <a:defRPr sz="1000" b="0" i="0" u="none" strike="noStrike">
+                <a:solidFill>
+                  <a:srgbClr val="57564F"/>
+                </a:solidFill>
+                <a:latin typeface="+mn-lt"/>
+              </a:defRPr>
+            </a:pPr>
+            <a:endParaRPr lang="en-US"/>
+          </a:p>
+        </c:txPr>
+        <c:crossAx val="2094734554"/>
+        <c:crosses val="autoZero"/>
+        <c:crossBetween val="between"/>
+      </c:valAx>
+      <c:spPr>
+        <a:noFill/>
+        <a:ln>
+          <a:noFill/>
+        </a:ln>
+        <a:effectLst/>
+      </c:spPr>
+    </c:plotArea>
+    <c:plotVisOnly val="1"/>
+    <c:dispBlanksAs val="span"/>
+  </c:chart>
+  <c:spPr>
+    <a:noFill/>
+    <a:ln>
+      <a:noFill/>
+    </a:ln>
+    <a:effectLst/>
+  </c:spPr>
+  <c:externalData r:id="rId1">
+    <c:autoUpdate val="0"/>
+  </c:externalData>
+</c:chartSpace>
+</file>
+
+<file path=ppt/charts/chart2.xml><?xml version="1.0" encoding="utf-8"?>
+<c:chartSpace xmlns:c="http://schemas.openxmlformats.org/drawingml/2006/chart" xmlns:a="http://schemas.openxmlformats.org/drawingml/2006/main" xmlns:r="http://schemas.openxmlformats.org/officeDocument/2006/relationships">
+  <c:date1904 val="0"/>
+  <c:roundedCorners val="1"/>
+  <c:chart>
+    <c:title>
+      <c:tx>
+        <c:rich>
+          <a:bodyPr/>
+          <a:lstStyle/>
+          <a:p>
+            <a:pPr>
+              <a:defRPr sz="1200" b="0" i="0" u="none" strike="noStrike">
+                <a:solidFill>
+                  <a:srgbClr val="57564F"/>
+                </a:solidFill>
+                <a:latin typeface="+mn-lt"/>
+              </a:defRPr>
+            </a:pPr>
+            <a:r>
+              <a:rPr sz="1200" b="0" i="0" u="none" strike="noStrike">
+                <a:solidFill>
+                  <a:srgbClr val="57564F"/>
+                </a:solidFill>
+                <a:latin typeface="+mn-lt"/>
+              </a:rPr>
+              <a:t>Volumes, millions</a:t>
             </a:r>
           </a:p>
         </c:rich>
@@ -499,7 +815,7 @@
           <a:lstStyle/>
           <a:p>
             <a:pPr>
-              <a:defRPr sz="1200" b="0" i="0" u="none" strike="noStrike">
+              <a:defRPr sz="1100" b="0" i="0" u="none" strike="noStrike">
                 <a:solidFill>
                   <a:srgbClr val="57564F"/>
                 </a:solidFill>
@@ -549,7 +865,7 @@
           <a:lstStyle/>
           <a:p>
             <a:pPr>
-              <a:defRPr sz="1100" b="0" i="0" u="none" strike="noStrike">
+              <a:defRPr sz="1000" b="0" i="0" u="none" strike="noStrike">
                 <a:solidFill>
                   <a:srgbClr val="57564F"/>
                 </a:solidFill>
@@ -579,7 +895,7 @@
         <a:lstStyle/>
         <a:p>
           <a:pPr>
-            <a:defRPr sz="1200">
+            <a:defRPr sz="1100">
               <a:solidFill>
                 <a:srgbClr val="1F1E19"/>
               </a:solidFill>
@@ -607,7 +923,7 @@
 </c:chartSpace>
 </file>
 
-<file path=ppt/charts/chart2.xml><?xml version="1.0" encoding="utf-8"?>
+<file path=ppt/charts/chart3.xml><?xml version="1.0" encoding="utf-8"?>
 <c:chartSpace xmlns:c="http://schemas.openxmlformats.org/drawingml/2006/chart" xmlns:a="http://schemas.openxmlformats.org/drawingml/2006/main" xmlns:r="http://schemas.openxmlformats.org/officeDocument/2006/relationships">
   <c:date1904 val="0"/>
   <c:roundedCorners val="1"/>
@@ -621,7 +937,7 @@
             <a:pPr>
               <a:defRPr sz="1200" b="0" i="0" u="none" strike="noStrike">
                 <a:solidFill>
-                  <a:srgbClr val="57564F"/>
+                  <a:srgbClr val="1F1E19"/>
                 </a:solidFill>
                 <a:latin typeface="+mn-lt"/>
               </a:defRPr>
@@ -629,11 +945,327 @@
             <a:r>
               <a:rPr sz="1200" b="0" i="0" u="none" strike="noStrike">
                 <a:solidFill>
-                  <a:srgbClr val="57564F"/>
+                  <a:srgbClr val="1F1E19"/>
                 </a:solidFill>
                 <a:latin typeface="+mn-lt"/>
               </a:rPr>
-              <a:t>2026 YTD (Jan–Sep, October excluded), millions</a:t>
+              <a:t>Discrepancy rate by month, 2026 YTD (Jan–Sep, October excluded)</a:t>
+            </a:r>
+          </a:p>
+        </c:rich>
+      </c:tx>
+      <c:layout/>
+      <c:overlay val="0"/>
+    </c:title>
+    <c:autoTitleDeleted val="0"/>
+    <c:plotArea>
+      <c:layout/>
+      <c:lineChart>
+        <c:varyColors val="0"/>
+        <c:ser>
+          <c:idx val="0"/>
+          <c:order val="0"/>
+          <c:tx>
+            <c:strRef>
+              <c:f>Sheet1!$B$1</c:f>
+              <c:strCache>
+                <c:ptCount val="1"/>
+                <c:pt idx="0">
+                  <c:v>Discrepancy %</c:v>
+                </c:pt>
+              </c:strCache>
+            </c:strRef>
+          </c:tx>
+          <c:spPr>
+            <a:solidFill>
+              <a:srgbClr val="1F1E19"/>
+            </a:solidFill>
+            <a:ln w="31750" cap="flat">
+              <a:solidFill>
+                <a:srgbClr val="1F1E19"/>
+              </a:solidFill>
+              <a:prstDash val="solid"/>
+              <a:round/>
+            </a:ln>
+            <a:effectLst/>
+          </c:spPr>
+          <c:invertIfNegative val="0"/>
+          <c:dLbls>
+            <c:numFmt formatCode="0.0&quot;%&quot;" sourceLinked="0"/>
+            <c:txPr>
+              <a:bodyPr/>
+              <a:lstStyle/>
+              <a:p>
+                <a:pPr>
+                  <a:defRPr b="1" i="0" strike="noStrike" sz="1100" u="none">
+                    <a:solidFill>
+                      <a:srgbClr val="1F1E19"/>
+                    </a:solidFill>
+                    <a:latin typeface="+mn-lt"/>
+                  </a:defRPr>
+                </a:pPr>
+              </a:p>
+            </c:txPr>
+            <c:dLblPos val="t"/>
+            <c:showLegendKey val="0"/>
+            <c:showVal val="1"/>
+            <c:showCatName val="0"/>
+            <c:showSerName val="0"/>
+            <c:showPercent val="0"/>
+            <c:showBubbleSize val="0"/>
+            <c:showLeaderLines val="0"/>
+          </c:dLbls>
+          <c:marker>
+            <c:symbol val="circle"/>
+            <c:size val="7"/>
+            <c:spPr>
+              <a:solidFill>
+                <a:srgbClr val="1F1E19"/>
+              </a:solidFill>
+              <a:ln w="9525" cap="flat">
+                <a:solidFill>
+                  <a:srgbClr val="1F1E19"/>
+                </a:solidFill>
+                <a:prstDash val="solid"/>
+                <a:round/>
+              </a:ln>
+              <a:effectLst/>
+            </c:spPr>
+          </c:marker>
+          <c:cat>
+            <c:multiLvlStrRef>
+              <c:f>Sheet1!$A$2:$A$10</c:f>
+              <c:multiLvlStrCache>
+                <c:ptCount val="9"/>
+                <c:lvl>
+                  <c:pt idx="0">
+                    <c:v>Jan</c:v>
+                  </c:pt>
+                  <c:pt idx="1">
+                    <c:v>Feb</c:v>
+                  </c:pt>
+                  <c:pt idx="2">
+                    <c:v>Mar</c:v>
+                  </c:pt>
+                  <c:pt idx="3">
+                    <c:v>Apr</c:v>
+                  </c:pt>
+                  <c:pt idx="4">
+                    <c:v>May</c:v>
+                  </c:pt>
+                  <c:pt idx="5">
+                    <c:v>Jun</c:v>
+                  </c:pt>
+                  <c:pt idx="6">
+                    <c:v>Jul</c:v>
+                  </c:pt>
+                  <c:pt idx="7">
+                    <c:v>Aug</c:v>
+                  </c:pt>
+                  <c:pt idx="8">
+                    <c:v>Sep</c:v>
+                  </c:pt>
+                </c:lvl>
+              </c:multiLvlStrCache>
+            </c:multiLvlStrRef>
+          </c:cat>
+          <c:val>
+            <c:numRef>
+              <c:f>Sheet1!$B$2:$B$10</c:f>
+              <c:numCache>
+                <c:formatCode>General</c:formatCode>
+                <c:ptCount val="9"/>
+                <c:pt idx="0">
+                  <c:v>7.8</c:v>
+                </c:pt>
+                <c:pt idx="1">
+                  <c:v>8</c:v>
+                </c:pt>
+                <c:pt idx="2">
+                  <c:v>10.5</c:v>
+                </c:pt>
+                <c:pt idx="3">
+                  <c:v>10.6</c:v>
+                </c:pt>
+                <c:pt idx="4">
+                  <c:v>8.6</c:v>
+                </c:pt>
+                <c:pt idx="5">
+                  <c:v>7.6</c:v>
+                </c:pt>
+                <c:pt idx="6">
+                  <c:v>7.8</c:v>
+                </c:pt>
+                <c:pt idx="7">
+                  <c:v>7.3</c:v>
+                </c:pt>
+                <c:pt idx="8">
+                  <c:v>7.1</c:v>
+                </c:pt>
+              </c:numCache>
+            </c:numRef>
+          </c:val>
+          <c:smooth val="0"/>
+        </c:ser>
+        <c:dLbls>
+          <c:numFmt formatCode="0.0&quot;%&quot;" sourceLinked="0"/>
+          <c:txPr>
+            <a:bodyPr/>
+            <a:lstStyle/>
+            <a:p>
+              <a:pPr>
+                <a:defRPr b="1" i="0" strike="noStrike" sz="1100" u="none">
+                  <a:solidFill>
+                    <a:srgbClr val="1F1E19"/>
+                  </a:solidFill>
+                  <a:latin typeface="+mn-lt"/>
+                </a:defRPr>
+              </a:pPr>
+            </a:p>
+          </c:txPr>
+          <c:dLblPos val="t"/>
+          <c:showLegendKey val="0"/>
+          <c:showVal val="1"/>
+          <c:showCatName val="0"/>
+          <c:showSerName val="0"/>
+          <c:showPercent val="0"/>
+          <c:showBubbleSize val="0"/>
+          <c:showLeaderLines val="0"/>
+        </c:dLbls>
+        <c:marker val="1"/>
+        <c:axId val="2094734554"/>
+        <c:axId val="2094734552"/>
+        <c:axId val="2094734556"/>
+      </c:lineChart>
+      <c:catAx>
+        <c:axId val="2094734554"/>
+        <c:scaling>
+          <c:orientation val="minMax"/>
+        </c:scaling>
+        <c:delete val="0"/>
+        <c:axPos val="b"/>
+        <c:numFmt formatCode="General" sourceLinked="1"/>
+        <c:majorTickMark val="out"/>
+        <c:minorTickMark val="none"/>
+        <c:tickLblPos val="low"/>
+        <c:spPr>
+          <a:ln w="12700" cap="flat">
+            <a:noFill/>
+            <a:prstDash val="solid"/>
+            <a:round/>
+          </a:ln>
+        </c:spPr>
+        <c:txPr>
+          <a:bodyPr/>
+          <a:lstStyle/>
+          <a:p>
+            <a:pPr>
+              <a:defRPr sz="1100" b="0" i="0" u="none" strike="noStrike">
+                <a:solidFill>
+                  <a:srgbClr val="57564F"/>
+                </a:solidFill>
+                <a:latin typeface="+mn-lt"/>
+              </a:defRPr>
+            </a:pPr>
+            <a:endParaRPr lang="en-US"/>
+          </a:p>
+        </c:txPr>
+        <c:crossAx val="2094734552"/>
+        <c:crosses val="autoZero"/>
+        <c:auto val="1"/>
+        <c:lblAlgn val="ctr"/>
+        <c:noMultiLvlLbl val="1"/>
+      </c:catAx>
+      <c:valAx>
+        <c:axId val="2094734552"/>
+        <c:scaling>
+          <c:orientation val="minMax"/>
+          <c:max val="13"/>
+          <c:min val="0"/>
+        </c:scaling>
+        <c:delete val="1"/>
+        <c:axPos val="l"/>
+        <c:numFmt formatCode="General" sourceLinked="0"/>
+        <c:majorTickMark val="out"/>
+        <c:minorTickMark val="none"/>
+        <c:tickLblPos val="nextTo"/>
+        <c:spPr>
+          <a:ln w="12700" cap="flat">
+            <a:noFill/>
+            <a:prstDash val="solid"/>
+            <a:round/>
+          </a:ln>
+        </c:spPr>
+        <c:txPr>
+          <a:bodyPr/>
+          <a:lstStyle/>
+          <a:p>
+            <a:pPr>
+              <a:defRPr sz="1000" b="0" i="0" u="none" strike="noStrike">
+                <a:solidFill>
+                  <a:srgbClr val="57564F"/>
+                </a:solidFill>
+                <a:latin typeface="+mn-lt"/>
+              </a:defRPr>
+            </a:pPr>
+            <a:endParaRPr lang="en-US"/>
+          </a:p>
+        </c:txPr>
+        <c:crossAx val="2094734554"/>
+        <c:crosses val="autoZero"/>
+        <c:crossBetween val="between"/>
+      </c:valAx>
+      <c:spPr>
+        <a:noFill/>
+        <a:ln>
+          <a:noFill/>
+        </a:ln>
+        <a:effectLst/>
+      </c:spPr>
+    </c:plotArea>
+    <c:plotVisOnly val="1"/>
+    <c:dispBlanksAs val="span"/>
+  </c:chart>
+  <c:spPr>
+    <a:noFill/>
+    <a:ln>
+      <a:noFill/>
+    </a:ln>
+    <a:effectLst/>
+  </c:spPr>
+  <c:externalData r:id="rId1">
+    <c:autoUpdate val="0"/>
+  </c:externalData>
+</c:chartSpace>
+</file>
+
+<file path=ppt/charts/chart4.xml><?xml version="1.0" encoding="utf-8"?>
+<c:chartSpace xmlns:c="http://schemas.openxmlformats.org/drawingml/2006/chart" xmlns:a="http://schemas.openxmlformats.org/drawingml/2006/main" xmlns:r="http://schemas.openxmlformats.org/officeDocument/2006/relationships">
+  <c:date1904 val="0"/>
+  <c:roundedCorners val="1"/>
+  <c:chart>
+    <c:title>
+      <c:tx>
+        <c:rich>
+          <a:bodyPr/>
+          <a:lstStyle/>
+          <a:p>
+            <a:pPr>
+              <a:defRPr sz="1200" b="0" i="0" u="none" strike="noStrike">
+                <a:solidFill>
+                  <a:srgbClr val="57564F"/>
+                </a:solidFill>
+                <a:latin typeface="+mn-lt"/>
+              </a:defRPr>
+            </a:pPr>
+            <a:r>
+              <a:rPr sz="1200" b="0" i="0" u="none" strike="noStrike">
+                <a:solidFill>
+                  <a:srgbClr val="57564F"/>
+                </a:solidFill>
+                <a:latin typeface="+mn-lt"/>
+              </a:rPr>
+              <a:t>Volumes, millions</a:t>
             </a:r>
           </a:p>
         </c:rich>
@@ -939,7 +1571,7 @@
           <a:lstStyle/>
           <a:p>
             <a:pPr>
-              <a:defRPr sz="1200" b="0" i="0" u="none" strike="noStrike">
+              <a:defRPr sz="1100" b="0" i="0" u="none" strike="noStrike">
                 <a:solidFill>
                   <a:srgbClr val="57564F"/>
                 </a:solidFill>
@@ -989,7 +1621,7 @@
           <a:lstStyle/>
           <a:p>
             <a:pPr>
-              <a:defRPr sz="1100" b="0" i="0" u="none" strike="noStrike">
+              <a:defRPr sz="1000" b="0" i="0" u="none" strike="noStrike">
                 <a:solidFill>
                   <a:srgbClr val="57564F"/>
                 </a:solidFill>
@@ -1019,7 +1651,7 @@
         <a:lstStyle/>
         <a:p>
           <a:pPr>
-            <a:defRPr sz="1200">
+            <a:defRPr sz="1100">
               <a:solidFill>
                 <a:srgbClr val="1F1E19"/>
               </a:solidFill>
@@ -1047,7 +1679,7 @@
 </c:chartSpace>
 </file>
 
-<file path=ppt/charts/chart3.xml><?xml version="1.0" encoding="utf-8"?>
+<file path=ppt/charts/chart5.xml><?xml version="1.0" encoding="utf-8"?>
 <c:chartSpace xmlns:c="http://schemas.openxmlformats.org/drawingml/2006/chart" xmlns:a="http://schemas.openxmlformats.org/drawingml/2006/main" xmlns:r="http://schemas.openxmlformats.org/officeDocument/2006/relationships">
   <c:date1904 val="0"/>
   <c:roundedCorners val="1"/>
@@ -12760,7 +13392,7 @@
                 <a:ea typeface="Georgia" pitchFamily="34" charset="-122"/>
                 <a:cs typeface="Georgia" pitchFamily="34" charset="-120"/>
               </a:rPr>
-              <a:t>DV's pre-bid check sees 96% of pageviews</a:t>
+              <a:t>Pre-bid discrepancy: 3.9% YTD</a:t>
             </a:r>
             <a:endParaRPr lang="en-US" sz="3400" dirty="0"/>
           </a:p>
@@ -12768,13 +13400,13 @@
       </p:sp>
       <p:graphicFrame>
         <p:nvGraphicFramePr>
-          <p:cNvPr id="4" name="Pre-bid monitoring · what it shows chart" descr=""/>
+          <p:cNvPr id="4" name="Pre-bid monitoring · what it shows discrepancy chart" descr=""/>
           <p:cNvGraphicFramePr/>
           <p:nvPr/>
         </p:nvGraphicFramePr>
         <p:xfrm>
-          <a:off x="548640" y="1874520"/>
-          <a:ext cx="7406640" cy="4160520"/>
+          <a:off x="548640" y="1828800"/>
+          <a:ext cx="7406640" cy="1600200"/>
         </p:xfrm>
         <a:graphic xmlns:a="http://schemas.openxmlformats.org/drawingml/2006/main">
           <a:graphicData uri="http://schemas.openxmlformats.org/drawingml/2006/chart">
@@ -12782,9 +13414,25 @@
           </a:graphicData>
         </a:graphic>
       </p:graphicFrame>
-      <p:sp>
-        <p:nvSpPr>
-          <p:cNvPr id="5" name="stat 1"/>
+      <p:graphicFrame>
+        <p:nvGraphicFramePr>
+          <p:cNvPr id="5" name="Pre-bid monitoring · what it shows volume chart" descr=""/>
+          <p:cNvGraphicFramePr/>
+          <p:nvPr/>
+        </p:nvGraphicFramePr>
+        <p:xfrm>
+          <a:off x="548640" y="3474720"/>
+          <a:ext cx="7406640" cy="2606040"/>
+        </p:xfrm>
+        <a:graphic xmlns:a="http://schemas.openxmlformats.org/drawingml/2006/main">
+          <a:graphicData uri="http://schemas.openxmlformats.org/drawingml/2006/chart">
+            <c:chart xmlns:c="http://schemas.openxmlformats.org/drawingml/2006/chart" r:id="rId2"/>
+          </a:graphicData>
+        </a:graphic>
+      </p:graphicFrame>
+      <p:sp>
+        <p:nvSpPr>
+          <p:cNvPr id="6" name="stat 1"/>
           <p:cNvSpPr/>
           <p:nvPr/>
         </p:nvSpPr>
@@ -12809,7 +13457,7 @@
       </p:sp>
       <p:sp>
         <p:nvSpPr>
-          <p:cNvPr id="6" name="Text 3"/>
+          <p:cNvPr id="7" name="Text 3"/>
           <p:cNvSpPr txBox="1"/>
           <p:nvPr/>
         </p:nvSpPr>
@@ -12837,7 +13485,7 @@
                   <a:schemeClr val="bg2"/>
                 </a:solidFill>
               </a:rPr>
-              <a:t>MONITORED, YTD JAN–SEP</a:t>
+              <a:t>DISCREPANCY, YTD JAN–SEP</a:t>
             </a:r>
             <a:endParaRPr lang="en-US" sz="1100" dirty="0"/>
           </a:p>
@@ -12845,7 +13493,7 @@
       </p:sp>
       <p:sp>
         <p:nvSpPr>
-          <p:cNvPr id="7" name="Text 4"/>
+          <p:cNvPr id="8" name="Text 4"/>
           <p:cNvSpPr txBox="1"/>
           <p:nvPr/>
         </p:nvSpPr>
@@ -12876,7 +13524,7 @@
                 <a:ea typeface="Georgia" pitchFamily="34" charset="-122"/>
                 <a:cs typeface="Georgia" pitchFamily="34" charset="-120"/>
               </a:rPr>
-              <a:t>96.1%</a:t>
+              <a:t>3.9%</a:t>
             </a:r>
             <a:endParaRPr lang="en-US" sz="4400" dirty="0"/>
           </a:p>
@@ -12884,7 +13532,7 @@
       </p:sp>
       <p:sp>
         <p:nvSpPr>
-          <p:cNvPr id="8" name="Text 5"/>
+          <p:cNvPr id="9" name="Text 5"/>
           <p:cNvSpPr txBox="1"/>
           <p:nvPr/>
         </p:nvSpPr>
@@ -12912,7 +13560,7 @@
                   <a:schemeClr val="bg2"/>
                 </a:solidFill>
               </a:rPr>
-              <a:t>485.97M DV pre-bid requests against 505.70M GA4 web pageviews. Monthly range 91.4%–98.1%.</a:t>
+              <a:t>So 96.1% of pageviews were monitored by DV pre-bid: 485.97M requests against 505.70M GA4 pageviews. Highest month: May, 8.6%.</a:t>
             </a:r>
             <a:endParaRPr lang="en-US" sz="1300" dirty="0"/>
           </a:p>
@@ -12920,7 +13568,7 @@
       </p:sp>
       <p:sp>
         <p:nvSpPr>
-          <p:cNvPr id="9" name="Text 6"/>
+          <p:cNvPr id="10" name="Text 6"/>
           <p:cNvSpPr txBox="1"/>
           <p:nvPr/>
         </p:nvSpPr>
@@ -12948,7 +13596,7 @@
                   <a:schemeClr val="tx2"/>
                 </a:solidFill>
               </a:rPr>
-              <a:t>Source: DV-GA discrepancy workbook, 2026. Coverage = Prebid Reqs ÷ Pageviews.</a:t>
+              <a:t>Source: DV-GA workbook 2026. Discrepancy = (Pageviews − Prebid Reqs) ÷ Pageviews.</a:t>
             </a:r>
             <a:endParaRPr lang="en-US" sz="1100" dirty="0"/>
           </a:p>
@@ -15621,7 +16269,7 @@
                 <a:ea typeface="Georgia" pitchFamily="34" charset="-122"/>
                 <a:cs typeface="Georgia" pitchFamily="34" charset="-120"/>
               </a:rPr>
-              <a:t>DV measures about 9 in 10 GAM impressions</a:t>
+              <a:t>Post-bid discrepancy: 8.4% display, 13.3% video</a:t>
             </a:r>
             <a:endParaRPr lang="en-US" sz="3400" dirty="0"/>
           </a:p>
@@ -15629,13 +16277,13 @@
       </p:sp>
       <p:graphicFrame>
         <p:nvGraphicFramePr>
-          <p:cNvPr id="4" name="Post-bid monitoring · what it shows chart" descr=""/>
+          <p:cNvPr id="4" name="Post-bid monitoring · what it shows discrepancy chart" descr=""/>
           <p:cNvGraphicFramePr/>
           <p:nvPr/>
         </p:nvGraphicFramePr>
         <p:xfrm>
-          <a:off x="548640" y="1874520"/>
-          <a:ext cx="7406640" cy="4160520"/>
+          <a:off x="548640" y="1828800"/>
+          <a:ext cx="7406640" cy="1600200"/>
         </p:xfrm>
         <a:graphic xmlns:a="http://schemas.openxmlformats.org/drawingml/2006/main">
           <a:graphicData uri="http://schemas.openxmlformats.org/drawingml/2006/chart">
@@ -15643,9 +16291,25 @@
           </a:graphicData>
         </a:graphic>
       </p:graphicFrame>
-      <p:sp>
-        <p:nvSpPr>
-          <p:cNvPr id="5" name="stat 1"/>
+      <p:graphicFrame>
+        <p:nvGraphicFramePr>
+          <p:cNvPr id="5" name="Post-bid monitoring · what it shows volume chart" descr=""/>
+          <p:cNvGraphicFramePr/>
+          <p:nvPr/>
+        </p:nvGraphicFramePr>
+        <p:xfrm>
+          <a:off x="548640" y="3474720"/>
+          <a:ext cx="7406640" cy="2606040"/>
+        </p:xfrm>
+        <a:graphic xmlns:a="http://schemas.openxmlformats.org/drawingml/2006/main">
+          <a:graphicData uri="http://schemas.openxmlformats.org/drawingml/2006/chart">
+            <c:chart xmlns:c="http://schemas.openxmlformats.org/drawingml/2006/chart" r:id="rId2"/>
+          </a:graphicData>
+        </a:graphic>
+      </p:graphicFrame>
+      <p:sp>
+        <p:nvSpPr>
+          <p:cNvPr id="6" name="stat 1"/>
           <p:cNvSpPr/>
           <p:nvPr/>
         </p:nvSpPr>
@@ -15670,7 +16334,7 @@
       </p:sp>
       <p:sp>
         <p:nvSpPr>
-          <p:cNvPr id="6" name="Text 3"/>
+          <p:cNvPr id="7" name="Text 3"/>
           <p:cNvSpPr txBox="1"/>
           <p:nvPr/>
         </p:nvSpPr>
@@ -15698,7 +16362,7 @@
                   <a:schemeClr val="bg2"/>
                 </a:solidFill>
               </a:rPr>
-              <a:t>DISPLAY, YTD JAN–SEP</a:t>
+              <a:t>DISPLAY DISCREPANCY, YTD</a:t>
             </a:r>
             <a:endParaRPr lang="en-US" sz="1100" dirty="0"/>
           </a:p>
@@ -15706,7 +16370,7 @@
       </p:sp>
       <p:sp>
         <p:nvSpPr>
-          <p:cNvPr id="7" name="Text 4"/>
+          <p:cNvPr id="8" name="Text 4"/>
           <p:cNvSpPr txBox="1"/>
           <p:nvPr/>
         </p:nvSpPr>
@@ -15737,7 +16401,7 @@
                 <a:ea typeface="Georgia" pitchFamily="34" charset="-122"/>
                 <a:cs typeface="Georgia" pitchFamily="34" charset="-120"/>
               </a:rPr>
-              <a:t>91.6%</a:t>
+              <a:t>8.4%</a:t>
             </a:r>
             <a:endParaRPr lang="en-US" sz="4400" dirty="0"/>
           </a:p>
@@ -15745,7 +16409,7 @@
       </p:sp>
       <p:sp>
         <p:nvSpPr>
-          <p:cNvPr id="8" name="Text 5"/>
+          <p:cNvPr id="9" name="Text 5"/>
           <p:cNvSpPr txBox="1"/>
           <p:nvPr/>
         </p:nvSpPr>
@@ -15773,7 +16437,7 @@
                   <a:schemeClr val="bg2"/>
                 </a:solidFill>
               </a:rPr>
-              <a:t>DV post-bid impressions ÷ GAM total, inpage display sheet.</a:t>
+              <a:t>91.6% of display impressions measured by DV post-bid.</a:t>
             </a:r>
             <a:endParaRPr lang="en-US" sz="1300" dirty="0"/>
           </a:p>
@@ -15781,7 +16445,7 @@
       </p:sp>
       <p:sp>
         <p:nvSpPr>
-          <p:cNvPr id="9" name="stat 2"/>
+          <p:cNvPr id="10" name="stat 2"/>
           <p:cNvSpPr/>
           <p:nvPr/>
         </p:nvSpPr>
@@ -15806,7 +16470,7 @@
       </p:sp>
       <p:sp>
         <p:nvSpPr>
-          <p:cNvPr id="10" name="Text 7"/>
+          <p:cNvPr id="11" name="Text 7"/>
           <p:cNvSpPr txBox="1"/>
           <p:nvPr/>
         </p:nvSpPr>
@@ -15834,7 +16498,7 @@
                   <a:schemeClr val="tx2"/>
                 </a:solidFill>
               </a:rPr>
-              <a:t>VIDEO, YTD JAN–SEP</a:t>
+              <a:t>VIDEO DISCREPANCY, YTD</a:t>
             </a:r>
             <a:endParaRPr lang="en-US" sz="1100" dirty="0"/>
           </a:p>
@@ -15842,7 +16506,7 @@
       </p:sp>
       <p:sp>
         <p:nvSpPr>
-          <p:cNvPr id="11" name="Text 8"/>
+          <p:cNvPr id="12" name="Text 8"/>
           <p:cNvSpPr txBox="1"/>
           <p:nvPr/>
         </p:nvSpPr>
@@ -15873,7 +16537,7 @@
                 <a:ea typeface="Georgia" pitchFamily="34" charset="-122"/>
                 <a:cs typeface="Georgia" pitchFamily="34" charset="-120"/>
               </a:rPr>
-              <a:t>86.7%</a:t>
+              <a:t>13.3%</a:t>
             </a:r>
             <a:endParaRPr lang="en-US" sz="4400" dirty="0"/>
           </a:p>
@@ -15881,7 +16545,7 @@
       </p:sp>
       <p:sp>
         <p:nvSpPr>
-          <p:cNvPr id="12" name="Text 9"/>
+          <p:cNvPr id="13" name="Text 9"/>
           <p:cNvSpPr txBox="1"/>
           <p:nvPr/>
         </p:nvSpPr>
@@ -15909,7 +16573,7 @@
                   <a:schemeClr val="tx2"/>
                 </a:solidFill>
               </a:rPr>
-              <a:t>Same ratio on the instream video sheet.</a:t>
+              <a:t>86.7% measured. Gap = impressions DV can't tag (e.g. Google demand).</a:t>
             </a:r>
             <a:endParaRPr lang="en-US" sz="1300" dirty="0"/>
           </a:p>
@@ -15917,7 +16581,7 @@
       </p:sp>
       <p:sp>
         <p:nvSpPr>
-          <p:cNvPr id="13" name="Text 10"/>
+          <p:cNvPr id="14" name="Text 10"/>
           <p:cNvSpPr txBox="1"/>
           <p:nvPr/>
         </p:nvSpPr>
@@ -15945,7 +16609,7 @@
                   <a:schemeClr val="tx2"/>
                 </a:solidFill>
               </a:rPr>
-              <a:t>Source: DV-GAM workbook 2026, display sheet. Gap = impressions DV can't tag (e.g. Google demand).</a:t>
+              <a:t>Source: DV-GAM workbook 2026, display sheet. Discrepancy = 1 − DV ÷ GAM total.</a:t>
             </a:r>
             <a:endParaRPr lang="en-US" sz="1100" dirty="0"/>
           </a:p>

</xml_diff>

<commit_message>
docs: split the guide's post-bid charts into display and video
Co-Authored-By: Claude Opus 5.5 <noreply@anthropic.com>
Claude-Session: https://claude.ai/code/session_014udSfWkctWaSTKdEZUW1Gh
</commit_message>
<xml_diff>
--- a/docs/TAG_IVT_Report_Update_Guide.pptx
+++ b/docs/TAG_IVT_Report_Update_Guide.pptx
@@ -124,7 +124,7 @@
   <p:extLst>
     <p:ext uri="{521415D9-36F7-43E2-AB2F-B90AF26B5E84}">
       <p14:sectionLst xmlns:p14="http://schemas.microsoft.com/office/powerpoint/2010/main">
-        <p14:section name="Overview" id="{5f0be8cb-3a0c-432c-84e4-bab24de197c0}">
+        <p14:section name="Overview" id="{7d277a4a-cd42-b00b-1821-e782447ff6e0}">
           <p14:sldIdLst>
             <p14:sldId id="256"/>
             <p14:sldId id="257"/>
@@ -136,7 +136,7 @@
             <p14:sldId id="263"/>
           </p14:sldIdLst>
         </p14:section>
-        <p14:section name="1 · GAM" id="{07d86376-7bd1-5dbd-de7d-64dc48dc9686}">
+        <p14:section name="1 · GAM" id="{2986b8f3-f90e-9993-80ad-728ee08089db}">
           <p14:sldIdLst>
             <p14:sldId id="264"/>
             <p14:sldId id="265"/>
@@ -144,14 +144,14 @@
             <p14:sldId id="267"/>
           </p14:sldIdLst>
         </p14:section>
-        <p14:section name="2–3 · DV and GA4" id="{9f7f6d8b-8403-588a-cf38-38462b4bc743}">
+        <p14:section name="2–3 · DV and GA4" id="{ccbdb58a-80fd-1079-568a-010c45614db3}">
           <p14:sldIdLst>
             <p14:sldId id="268"/>
             <p14:sldId id="269"/>
             <p14:sldId id="270"/>
           </p14:sldIdLst>
         </p14:section>
-        <p14:section name="4–5 · Math and deck" id="{c5b29312-b4c8-ea56-fb87-17b0d5cbfe8d}">
+        <p14:section name="4–5 · Math and deck" id="{3e4d09a1-0f0d-3994-97af-2cd1d2458af1}">
           <p14:sldIdLst>
             <p14:sldId id="271"/>
             <p14:sldId id="272"/>
@@ -895,7 +895,7 @@
         <a:lstStyle/>
         <a:p>
           <a:pPr>
-            <a:defRPr sz="1100">
+            <a:defRPr sz="1000">
               <a:solidFill>
                 <a:srgbClr val="1F1E19"/>
               </a:solidFill>
@@ -949,7 +949,7 @@
                 </a:solidFill>
                 <a:latin typeface="+mn-lt"/>
               </a:rPr>
-              <a:t>Discrepancy rate by month, 2026 YTD (Jan–Sep, October excluded)</a:t>
+              <a:t>Display discrepancy %</a:t>
             </a:r>
           </a:p>
         </c:rich>
@@ -971,7 +971,7 @@
               <c:strCache>
                 <c:ptCount val="1"/>
                 <c:pt idx="0">
-                  <c:v>Discrepancy %</c:v>
+                  <c:v>Display discrepancy %</c:v>
                 </c:pt>
               </c:strCache>
             </c:strRef>
@@ -997,7 +997,7 @@
               <a:lstStyle/>
               <a:p>
                 <a:pPr>
-                  <a:defRPr b="1" i="0" strike="noStrike" sz="1100" u="none">
+                  <a:defRPr b="1" i="0" strike="noStrike" sz="900" u="none">
                     <a:solidFill>
                       <a:srgbClr val="1F1E19"/>
                     </a:solidFill>
@@ -1114,7 +1114,7 @@
             <a:lstStyle/>
             <a:p>
               <a:pPr>
-                <a:defRPr b="1" i="0" strike="noStrike" sz="1100" u="none">
+                <a:defRPr b="1" i="0" strike="noStrike" sz="900" u="none">
                   <a:solidFill>
                     <a:srgbClr val="1F1E19"/>
                   </a:solidFill>
@@ -1160,7 +1160,7 @@
           <a:lstStyle/>
           <a:p>
             <a:pPr>
-              <a:defRPr sz="1100" b="0" i="0" u="none" strike="noStrike">
+              <a:defRPr sz="900" b="0" i="0" u="none" strike="noStrike">
                 <a:solidFill>
                   <a:srgbClr val="57564F"/>
                 </a:solidFill>
@@ -1180,7 +1180,7 @@
         <c:axId val="2094734552"/>
         <c:scaling>
           <c:orientation val="minMax"/>
-          <c:max val="13"/>
+          <c:max val="20"/>
           <c:min val="0"/>
         </c:scaling>
         <c:delete val="1"/>
@@ -1265,7 +1265,7 @@
                 </a:solidFill>
                 <a:latin typeface="+mn-lt"/>
               </a:rPr>
-              <a:t>Volumes, millions</a:t>
+              <a:t>Display, millions</a:t>
             </a:r>
           </a:p>
         </c:rich>
@@ -1289,7 +1289,7 @@
               <c:strCache>
                 <c:ptCount val="1"/>
                 <c:pt idx="0">
-                  <c:v>GAM total (display)</c:v>
+                  <c:v>GAM total</c:v>
                 </c:pt>
               </c:strCache>
             </c:strRef>
@@ -1408,7 +1408,7 @@
               <c:strCache>
                 <c:ptCount val="1"/>
                 <c:pt idx="0">
-                  <c:v>DV post-bid (display)</c:v>
+                  <c:v>DV post-bid</c:v>
                 </c:pt>
               </c:strCache>
             </c:strRef>
@@ -1571,7 +1571,7 @@
           <a:lstStyle/>
           <a:p>
             <a:pPr>
-              <a:defRPr sz="1100" b="0" i="0" u="none" strike="noStrike">
+              <a:defRPr sz="900" b="0" i="0" u="none" strike="noStrike">
                 <a:solidFill>
                   <a:srgbClr val="57564F"/>
                 </a:solidFill>
@@ -1651,7 +1651,7 @@
         <a:lstStyle/>
         <a:p>
           <a:pPr>
-            <a:defRPr sz="1100">
+            <a:defRPr sz="1000">
               <a:solidFill>
                 <a:srgbClr val="1F1E19"/>
               </a:solidFill>
@@ -1680,6 +1680,762 @@
 </file>
 
 <file path=ppt/charts/chart5.xml><?xml version="1.0" encoding="utf-8"?>
+<c:chartSpace xmlns:c="http://schemas.openxmlformats.org/drawingml/2006/chart" xmlns:a="http://schemas.openxmlformats.org/drawingml/2006/main" xmlns:r="http://schemas.openxmlformats.org/officeDocument/2006/relationships">
+  <c:date1904 val="0"/>
+  <c:roundedCorners val="1"/>
+  <c:chart>
+    <c:title>
+      <c:tx>
+        <c:rich>
+          <a:bodyPr/>
+          <a:lstStyle/>
+          <a:p>
+            <a:pPr>
+              <a:defRPr sz="1200" b="0" i="0" u="none" strike="noStrike">
+                <a:solidFill>
+                  <a:srgbClr val="1F1E19"/>
+                </a:solidFill>
+                <a:latin typeface="+mn-lt"/>
+              </a:defRPr>
+            </a:pPr>
+            <a:r>
+              <a:rPr sz="1200" b="0" i="0" u="none" strike="noStrike">
+                <a:solidFill>
+                  <a:srgbClr val="1F1E19"/>
+                </a:solidFill>
+                <a:latin typeface="+mn-lt"/>
+              </a:rPr>
+              <a:t>Video discrepancy %</a:t>
+            </a:r>
+          </a:p>
+        </c:rich>
+      </c:tx>
+      <c:layout/>
+      <c:overlay val="0"/>
+    </c:title>
+    <c:autoTitleDeleted val="0"/>
+    <c:plotArea>
+      <c:layout/>
+      <c:lineChart>
+        <c:varyColors val="0"/>
+        <c:ser>
+          <c:idx val="0"/>
+          <c:order val="0"/>
+          <c:tx>
+            <c:strRef>
+              <c:f>Sheet1!$B$1</c:f>
+              <c:strCache>
+                <c:ptCount val="1"/>
+                <c:pt idx="0">
+                  <c:v>Video discrepancy %</c:v>
+                </c:pt>
+              </c:strCache>
+            </c:strRef>
+          </c:tx>
+          <c:spPr>
+            <a:solidFill>
+              <a:srgbClr val="1F1E19"/>
+            </a:solidFill>
+            <a:ln w="31750" cap="flat">
+              <a:solidFill>
+                <a:srgbClr val="1F1E19"/>
+              </a:solidFill>
+              <a:prstDash val="solid"/>
+              <a:round/>
+            </a:ln>
+            <a:effectLst/>
+          </c:spPr>
+          <c:invertIfNegative val="0"/>
+          <c:dLbls>
+            <c:numFmt formatCode="0.0&quot;%&quot;" sourceLinked="0"/>
+            <c:txPr>
+              <a:bodyPr/>
+              <a:lstStyle/>
+              <a:p>
+                <a:pPr>
+                  <a:defRPr b="1" i="0" strike="noStrike" sz="900" u="none">
+                    <a:solidFill>
+                      <a:srgbClr val="1F1E19"/>
+                    </a:solidFill>
+                    <a:latin typeface="+mn-lt"/>
+                  </a:defRPr>
+                </a:pPr>
+              </a:p>
+            </c:txPr>
+            <c:dLblPos val="t"/>
+            <c:showLegendKey val="0"/>
+            <c:showVal val="1"/>
+            <c:showCatName val="0"/>
+            <c:showSerName val="0"/>
+            <c:showPercent val="0"/>
+            <c:showBubbleSize val="0"/>
+            <c:showLeaderLines val="0"/>
+          </c:dLbls>
+          <c:marker>
+            <c:symbol val="circle"/>
+            <c:size val="7"/>
+            <c:spPr>
+              <a:solidFill>
+                <a:srgbClr val="1F1E19"/>
+              </a:solidFill>
+              <a:ln w="9525" cap="flat">
+                <a:solidFill>
+                  <a:srgbClr val="1F1E19"/>
+                </a:solidFill>
+                <a:prstDash val="solid"/>
+                <a:round/>
+              </a:ln>
+              <a:effectLst/>
+            </c:spPr>
+          </c:marker>
+          <c:cat>
+            <c:multiLvlStrRef>
+              <c:f>Sheet1!$A$2:$A$10</c:f>
+              <c:multiLvlStrCache>
+                <c:ptCount val="9"/>
+                <c:lvl>
+                  <c:pt idx="0">
+                    <c:v>Jan</c:v>
+                  </c:pt>
+                  <c:pt idx="1">
+                    <c:v>Feb</c:v>
+                  </c:pt>
+                  <c:pt idx="2">
+                    <c:v>Mar</c:v>
+                  </c:pt>
+                  <c:pt idx="3">
+                    <c:v>Apr</c:v>
+                  </c:pt>
+                  <c:pt idx="4">
+                    <c:v>May</c:v>
+                  </c:pt>
+                  <c:pt idx="5">
+                    <c:v>Jun</c:v>
+                  </c:pt>
+                  <c:pt idx="6">
+                    <c:v>Jul</c:v>
+                  </c:pt>
+                  <c:pt idx="7">
+                    <c:v>Aug</c:v>
+                  </c:pt>
+                  <c:pt idx="8">
+                    <c:v>Sep</c:v>
+                  </c:pt>
+                </c:lvl>
+              </c:multiLvlStrCache>
+            </c:multiLvlStrRef>
+          </c:cat>
+          <c:val>
+            <c:numRef>
+              <c:f>Sheet1!$B$2:$B$10</c:f>
+              <c:numCache>
+                <c:formatCode>General</c:formatCode>
+                <c:ptCount val="9"/>
+                <c:pt idx="0">
+                  <c:v>12.5</c:v>
+                </c:pt>
+                <c:pt idx="1">
+                  <c:v>15.1</c:v>
+                </c:pt>
+                <c:pt idx="2">
+                  <c:v>14</c:v>
+                </c:pt>
+                <c:pt idx="3">
+                  <c:v>16.4</c:v>
+                </c:pt>
+                <c:pt idx="4">
+                  <c:v>14.3</c:v>
+                </c:pt>
+                <c:pt idx="5">
+                  <c:v>11.2</c:v>
+                </c:pt>
+                <c:pt idx="6">
+                  <c:v>11.7</c:v>
+                </c:pt>
+                <c:pt idx="7">
+                  <c:v>12.8</c:v>
+                </c:pt>
+                <c:pt idx="8">
+                  <c:v>11.4</c:v>
+                </c:pt>
+              </c:numCache>
+            </c:numRef>
+          </c:val>
+          <c:smooth val="0"/>
+        </c:ser>
+        <c:dLbls>
+          <c:numFmt formatCode="0.0&quot;%&quot;" sourceLinked="0"/>
+          <c:txPr>
+            <a:bodyPr/>
+            <a:lstStyle/>
+            <a:p>
+              <a:pPr>
+                <a:defRPr b="1" i="0" strike="noStrike" sz="900" u="none">
+                  <a:solidFill>
+                    <a:srgbClr val="1F1E19"/>
+                  </a:solidFill>
+                  <a:latin typeface="+mn-lt"/>
+                </a:defRPr>
+              </a:pPr>
+            </a:p>
+          </c:txPr>
+          <c:dLblPos val="t"/>
+          <c:showLegendKey val="0"/>
+          <c:showVal val="1"/>
+          <c:showCatName val="0"/>
+          <c:showSerName val="0"/>
+          <c:showPercent val="0"/>
+          <c:showBubbleSize val="0"/>
+          <c:showLeaderLines val="0"/>
+        </c:dLbls>
+        <c:marker val="1"/>
+        <c:axId val="2094734554"/>
+        <c:axId val="2094734552"/>
+        <c:axId val="2094734556"/>
+      </c:lineChart>
+      <c:catAx>
+        <c:axId val="2094734554"/>
+        <c:scaling>
+          <c:orientation val="minMax"/>
+        </c:scaling>
+        <c:delete val="0"/>
+        <c:axPos val="b"/>
+        <c:numFmt formatCode="General" sourceLinked="1"/>
+        <c:majorTickMark val="out"/>
+        <c:minorTickMark val="none"/>
+        <c:tickLblPos val="low"/>
+        <c:spPr>
+          <a:ln w="12700" cap="flat">
+            <a:noFill/>
+            <a:prstDash val="solid"/>
+            <a:round/>
+          </a:ln>
+        </c:spPr>
+        <c:txPr>
+          <a:bodyPr/>
+          <a:lstStyle/>
+          <a:p>
+            <a:pPr>
+              <a:defRPr sz="900" b="0" i="0" u="none" strike="noStrike">
+                <a:solidFill>
+                  <a:srgbClr val="57564F"/>
+                </a:solidFill>
+                <a:latin typeface="+mn-lt"/>
+              </a:defRPr>
+            </a:pPr>
+            <a:endParaRPr lang="en-US"/>
+          </a:p>
+        </c:txPr>
+        <c:crossAx val="2094734552"/>
+        <c:crosses val="autoZero"/>
+        <c:auto val="1"/>
+        <c:lblAlgn val="ctr"/>
+        <c:noMultiLvlLbl val="1"/>
+      </c:catAx>
+      <c:valAx>
+        <c:axId val="2094734552"/>
+        <c:scaling>
+          <c:orientation val="minMax"/>
+          <c:max val="20"/>
+          <c:min val="0"/>
+        </c:scaling>
+        <c:delete val="1"/>
+        <c:axPos val="l"/>
+        <c:numFmt formatCode="General" sourceLinked="0"/>
+        <c:majorTickMark val="out"/>
+        <c:minorTickMark val="none"/>
+        <c:tickLblPos val="nextTo"/>
+        <c:spPr>
+          <a:ln w="12700" cap="flat">
+            <a:noFill/>
+            <a:prstDash val="solid"/>
+            <a:round/>
+          </a:ln>
+        </c:spPr>
+        <c:txPr>
+          <a:bodyPr/>
+          <a:lstStyle/>
+          <a:p>
+            <a:pPr>
+              <a:defRPr sz="1000" b="0" i="0" u="none" strike="noStrike">
+                <a:solidFill>
+                  <a:srgbClr val="57564F"/>
+                </a:solidFill>
+                <a:latin typeface="+mn-lt"/>
+              </a:defRPr>
+            </a:pPr>
+            <a:endParaRPr lang="en-US"/>
+          </a:p>
+        </c:txPr>
+        <c:crossAx val="2094734554"/>
+        <c:crosses val="autoZero"/>
+        <c:crossBetween val="between"/>
+      </c:valAx>
+      <c:spPr>
+        <a:noFill/>
+        <a:ln>
+          <a:noFill/>
+        </a:ln>
+        <a:effectLst/>
+      </c:spPr>
+    </c:plotArea>
+    <c:plotVisOnly val="1"/>
+    <c:dispBlanksAs val="span"/>
+  </c:chart>
+  <c:spPr>
+    <a:noFill/>
+    <a:ln>
+      <a:noFill/>
+    </a:ln>
+    <a:effectLst/>
+  </c:spPr>
+  <c:externalData r:id="rId1">
+    <c:autoUpdate val="0"/>
+  </c:externalData>
+</c:chartSpace>
+</file>
+
+<file path=ppt/charts/chart6.xml><?xml version="1.0" encoding="utf-8"?>
+<c:chartSpace xmlns:c="http://schemas.openxmlformats.org/drawingml/2006/chart" xmlns:a="http://schemas.openxmlformats.org/drawingml/2006/main" xmlns:r="http://schemas.openxmlformats.org/officeDocument/2006/relationships">
+  <c:date1904 val="0"/>
+  <c:roundedCorners val="1"/>
+  <c:chart>
+    <c:title>
+      <c:tx>
+        <c:rich>
+          <a:bodyPr/>
+          <a:lstStyle/>
+          <a:p>
+            <a:pPr>
+              <a:defRPr sz="1200" b="0" i="0" u="none" strike="noStrike">
+                <a:solidFill>
+                  <a:srgbClr val="57564F"/>
+                </a:solidFill>
+                <a:latin typeface="+mn-lt"/>
+              </a:defRPr>
+            </a:pPr>
+            <a:r>
+              <a:rPr sz="1200" b="0" i="0" u="none" strike="noStrike">
+                <a:solidFill>
+                  <a:srgbClr val="57564F"/>
+                </a:solidFill>
+                <a:latin typeface="+mn-lt"/>
+              </a:rPr>
+              <a:t>Video, millions</a:t>
+            </a:r>
+          </a:p>
+        </c:rich>
+      </c:tx>
+      <c:layout/>
+      <c:overlay val="0"/>
+    </c:title>
+    <c:autoTitleDeleted val="0"/>
+    <c:plotArea>
+      <c:layout/>
+      <c:barChart>
+        <c:barDir val="col"/>
+        <c:grouping val="clustered"/>
+        <c:varyColors val="0"/>
+        <c:ser>
+          <c:idx val="0"/>
+          <c:order val="0"/>
+          <c:tx>
+            <c:strRef>
+              <c:f>Sheet1!$B$1</c:f>
+              <c:strCache>
+                <c:ptCount val="1"/>
+                <c:pt idx="0">
+                  <c:v>GAM total</c:v>
+                </c:pt>
+              </c:strCache>
+            </c:strRef>
+          </c:tx>
+          <c:spPr>
+            <a:solidFill>
+              <a:srgbClr val="4B62E0"/>
+            </a:solidFill>
+            <a:effectLst/>
+          </c:spPr>
+          <c:invertIfNegative val="0"/>
+          <c:dLbls>
+            <c:numFmt formatCode="#,##0" sourceLinked="0"/>
+            <c:txPr>
+              <a:bodyPr/>
+              <a:lstStyle/>
+              <a:p>
+                <a:pPr>
+                  <a:defRPr b="0" i="0" strike="noStrike" sz="1200" u="none">
+                    <a:solidFill>
+                      <a:srgbClr val="000000"/>
+                    </a:solidFill>
+                    <a:latin typeface="Arial"/>
+                  </a:defRPr>
+                </a:pPr>
+              </a:p>
+            </c:txPr>
+            <c:showLegendKey val="0"/>
+            <c:showVal val="0"/>
+            <c:showCatName val="0"/>
+            <c:showSerName val="0"/>
+            <c:showPercent val="0"/>
+            <c:showBubbleSize val="0"/>
+            <c:showLeaderLines val="0"/>
+          </c:dLbls>
+          <c:cat>
+            <c:multiLvlStrRef>
+              <c:f>Sheet1!$A$2:$A$10</c:f>
+              <c:multiLvlStrCache>
+                <c:ptCount val="9"/>
+                <c:lvl>
+                  <c:pt idx="0">
+                    <c:v>Jan</c:v>
+                  </c:pt>
+                  <c:pt idx="1">
+                    <c:v>Feb</c:v>
+                  </c:pt>
+                  <c:pt idx="2">
+                    <c:v>Mar</c:v>
+                  </c:pt>
+                  <c:pt idx="3">
+                    <c:v>Apr</c:v>
+                  </c:pt>
+                  <c:pt idx="4">
+                    <c:v>May</c:v>
+                  </c:pt>
+                  <c:pt idx="5">
+                    <c:v>Jun</c:v>
+                  </c:pt>
+                  <c:pt idx="6">
+                    <c:v>Jul</c:v>
+                  </c:pt>
+                  <c:pt idx="7">
+                    <c:v>Aug</c:v>
+                  </c:pt>
+                  <c:pt idx="8">
+                    <c:v>Sep</c:v>
+                  </c:pt>
+                </c:lvl>
+              </c:multiLvlStrCache>
+            </c:multiLvlStrRef>
+          </c:cat>
+          <c:val>
+            <c:numRef>
+              <c:f>Sheet1!$B$2:$B$10</c:f>
+              <c:numCache>
+                <c:formatCode>General</c:formatCode>
+                <c:ptCount val="9"/>
+                <c:pt idx="0">
+                  <c:v>46.7</c:v>
+                </c:pt>
+                <c:pt idx="1">
+                  <c:v>43.3</c:v>
+                </c:pt>
+                <c:pt idx="2">
+                  <c:v>47.1</c:v>
+                </c:pt>
+                <c:pt idx="3">
+                  <c:v>25.7</c:v>
+                </c:pt>
+                <c:pt idx="4">
+                  <c:v>23.9</c:v>
+                </c:pt>
+                <c:pt idx="5">
+                  <c:v>27.2</c:v>
+                </c:pt>
+                <c:pt idx="6">
+                  <c:v>28.9</c:v>
+                </c:pt>
+                <c:pt idx="7">
+                  <c:v>26.5</c:v>
+                </c:pt>
+                <c:pt idx="8">
+                  <c:v>32.9</c:v>
+                </c:pt>
+              </c:numCache>
+            </c:numRef>
+          </c:val>
+        </c:ser>
+        <c:ser>
+          <c:idx val="1"/>
+          <c:order val="1"/>
+          <c:tx>
+            <c:strRef>
+              <c:f>Sheet1!$C$1</c:f>
+              <c:strCache>
+                <c:ptCount val="1"/>
+                <c:pt idx="0">
+                  <c:v>DV post-bid</c:v>
+                </c:pt>
+              </c:strCache>
+            </c:strRef>
+          </c:tx>
+          <c:spPr>
+            <a:solidFill>
+              <a:srgbClr val="2D8D92"/>
+            </a:solidFill>
+            <a:effectLst/>
+          </c:spPr>
+          <c:invertIfNegative val="0"/>
+          <c:dLbls>
+            <c:numFmt formatCode="#,##0" sourceLinked="0"/>
+            <c:txPr>
+              <a:bodyPr/>
+              <a:lstStyle/>
+              <a:p>
+                <a:pPr>
+                  <a:defRPr b="0" i="0" strike="noStrike" sz="1200" u="none">
+                    <a:solidFill>
+                      <a:srgbClr val="000000"/>
+                    </a:solidFill>
+                    <a:latin typeface="Arial"/>
+                  </a:defRPr>
+                </a:pPr>
+              </a:p>
+            </c:txPr>
+            <c:showLegendKey val="0"/>
+            <c:showVal val="0"/>
+            <c:showCatName val="0"/>
+            <c:showSerName val="0"/>
+            <c:showPercent val="0"/>
+            <c:showBubbleSize val="0"/>
+            <c:showLeaderLines val="0"/>
+          </c:dLbls>
+          <c:cat>
+            <c:multiLvlStrRef>
+              <c:f>Sheet1!$A$2:$A$10</c:f>
+              <c:multiLvlStrCache>
+                <c:ptCount val="9"/>
+                <c:lvl>
+                  <c:pt idx="0">
+                    <c:v>Jan</c:v>
+                  </c:pt>
+                  <c:pt idx="1">
+                    <c:v>Feb</c:v>
+                  </c:pt>
+                  <c:pt idx="2">
+                    <c:v>Mar</c:v>
+                  </c:pt>
+                  <c:pt idx="3">
+                    <c:v>Apr</c:v>
+                  </c:pt>
+                  <c:pt idx="4">
+                    <c:v>May</c:v>
+                  </c:pt>
+                  <c:pt idx="5">
+                    <c:v>Jun</c:v>
+                  </c:pt>
+                  <c:pt idx="6">
+                    <c:v>Jul</c:v>
+                  </c:pt>
+                  <c:pt idx="7">
+                    <c:v>Aug</c:v>
+                  </c:pt>
+                  <c:pt idx="8">
+                    <c:v>Sep</c:v>
+                  </c:pt>
+                </c:lvl>
+              </c:multiLvlStrCache>
+            </c:multiLvlStrRef>
+          </c:cat>
+          <c:val>
+            <c:numRef>
+              <c:f>Sheet1!$C$2:$C$10</c:f>
+              <c:numCache>
+                <c:formatCode>General</c:formatCode>
+                <c:ptCount val="9"/>
+                <c:pt idx="0">
+                  <c:v>40.9</c:v>
+                </c:pt>
+                <c:pt idx="1">
+                  <c:v>36.8</c:v>
+                </c:pt>
+                <c:pt idx="2">
+                  <c:v>40.5</c:v>
+                </c:pt>
+                <c:pt idx="3">
+                  <c:v>21.5</c:v>
+                </c:pt>
+                <c:pt idx="4">
+                  <c:v>20.5</c:v>
+                </c:pt>
+                <c:pt idx="5">
+                  <c:v>24.2</c:v>
+                </c:pt>
+                <c:pt idx="6">
+                  <c:v>25.5</c:v>
+                </c:pt>
+                <c:pt idx="7">
+                  <c:v>23.1</c:v>
+                </c:pt>
+                <c:pt idx="8">
+                  <c:v>29.1</c:v>
+                </c:pt>
+              </c:numCache>
+            </c:numRef>
+          </c:val>
+        </c:ser>
+        <c:dLbls>
+          <c:numFmt formatCode="#,##0" sourceLinked="0"/>
+          <c:txPr>
+            <a:bodyPr/>
+            <a:lstStyle/>
+            <a:p>
+              <a:pPr>
+                <a:defRPr b="0" i="0" strike="noStrike" sz="1200" u="none">
+                  <a:solidFill>
+                    <a:srgbClr val="000000"/>
+                  </a:solidFill>
+                  <a:latin typeface="Arial"/>
+                </a:defRPr>
+              </a:pPr>
+            </a:p>
+          </c:txPr>
+          <c:showLegendKey val="0"/>
+          <c:showVal val="0"/>
+          <c:showCatName val="0"/>
+          <c:showSerName val="0"/>
+          <c:showPercent val="0"/>
+          <c:showBubbleSize val="0"/>
+          <c:showLeaderLines val="0"/>
+        </c:dLbls>
+        <c:gapWidth val="55"/>
+        <c:overlap val="0"/>
+        <c:axId val="2094734554"/>
+        <c:axId val="2094734552"/>
+        <c:axId val="2094734556"/>
+      </c:barChart>
+      <c:catAx>
+        <c:axId val="2094734554"/>
+        <c:scaling>
+          <c:orientation val="minMax"/>
+        </c:scaling>
+        <c:delete val="0"/>
+        <c:axPos val="b"/>
+        <c:numFmt formatCode="General" sourceLinked="1"/>
+        <c:majorTickMark val="out"/>
+        <c:minorTickMark val="none"/>
+        <c:tickLblPos val="low"/>
+        <c:spPr>
+          <a:ln w="12700" cap="flat">
+            <a:noFill/>
+            <a:prstDash val="solid"/>
+            <a:round/>
+          </a:ln>
+        </c:spPr>
+        <c:txPr>
+          <a:bodyPr/>
+          <a:lstStyle/>
+          <a:p>
+            <a:pPr>
+              <a:defRPr sz="900" b="0" i="0" u="none" strike="noStrike">
+                <a:solidFill>
+                  <a:srgbClr val="57564F"/>
+                </a:solidFill>
+                <a:latin typeface="+mn-lt"/>
+              </a:defRPr>
+            </a:pPr>
+            <a:endParaRPr lang="en-US"/>
+          </a:p>
+        </c:txPr>
+        <c:crossAx val="2094734552"/>
+        <c:crosses val="autoZero"/>
+        <c:auto val="1"/>
+        <c:lblAlgn val="ctr"/>
+        <c:noMultiLvlLbl val="1"/>
+      </c:catAx>
+      <c:valAx>
+        <c:axId val="2094734552"/>
+        <c:scaling>
+          <c:orientation val="minMax"/>
+        </c:scaling>
+        <c:delete val="0"/>
+        <c:axPos val="l"/>
+        <c:majorGridlines>
+          <c:spPr>
+            <a:ln w="9525" cap="flat">
+              <a:solidFill>
+                <a:srgbClr val="E7E0C9"/>
+              </a:solidFill>
+              <a:prstDash val="solid"/>
+              <a:round/>
+            </a:ln>
+          </c:spPr>
+        </c:majorGridlines>
+        <c:numFmt formatCode="0" sourceLinked="0"/>
+        <c:majorTickMark val="out"/>
+        <c:minorTickMark val="none"/>
+        <c:tickLblPos val="nextTo"/>
+        <c:spPr>
+          <a:ln w="12700" cap="flat">
+            <a:noFill/>
+            <a:prstDash val="solid"/>
+            <a:round/>
+          </a:ln>
+        </c:spPr>
+        <c:txPr>
+          <a:bodyPr/>
+          <a:lstStyle/>
+          <a:p>
+            <a:pPr>
+              <a:defRPr sz="1000" b="0" i="0" u="none" strike="noStrike">
+                <a:solidFill>
+                  <a:srgbClr val="57564F"/>
+                </a:solidFill>
+                <a:latin typeface="+mn-lt"/>
+              </a:defRPr>
+            </a:pPr>
+            <a:endParaRPr lang="en-US"/>
+          </a:p>
+        </c:txPr>
+        <c:crossAx val="2094734554"/>
+        <c:crosses val="autoZero"/>
+        <c:crossBetween val="between"/>
+      </c:valAx>
+      <c:spPr>
+        <a:noFill/>
+        <a:ln>
+          <a:noFill/>
+        </a:ln>
+        <a:effectLst/>
+      </c:spPr>
+    </c:plotArea>
+    <c:legend>
+      <c:legendPos val="t"/>
+      <c:overlay val="0"/>
+      <c:txPr>
+        <a:bodyPr/>
+        <a:lstStyle/>
+        <a:p>
+          <a:pPr>
+            <a:defRPr sz="1000">
+              <a:solidFill>
+                <a:srgbClr val="1F1E19"/>
+              </a:solidFill>
+              <a:latin typeface="+mn-lt"/>
+              <a:cs typeface="+mn-lt"/>
+            </a:defRPr>
+          </a:pPr>
+          <a:endParaRPr lang="en-US"/>
+        </a:p>
+      </c:txPr>
+    </c:legend>
+    <c:plotVisOnly val="1"/>
+    <c:dispBlanksAs val="span"/>
+  </c:chart>
+  <c:spPr>
+    <a:noFill/>
+    <a:ln>
+      <a:noFill/>
+    </a:ln>
+    <a:effectLst/>
+  </c:spPr>
+  <c:externalData r:id="rId1">
+    <c:autoUpdate val="0"/>
+  </c:externalData>
+</c:chartSpace>
+</file>
+
+<file path=ppt/charts/chart7.xml><?xml version="1.0" encoding="utf-8"?>
 <c:chartSpace xmlns:c="http://schemas.openxmlformats.org/drawingml/2006/chart" xmlns:a="http://schemas.openxmlformats.org/drawingml/2006/main" xmlns:r="http://schemas.openxmlformats.org/officeDocument/2006/relationships">
   <c:date1904 val="0"/>
   <c:roundedCorners val="1"/>
@@ -13400,7 +14156,7 @@
       </p:sp>
       <p:graphicFrame>
         <p:nvGraphicFramePr>
-          <p:cNvPr id="4" name="Pre-bid monitoring · what it shows discrepancy chart" descr=""/>
+          <p:cNvPr id="4" name="Pre-bid monitoring · what it shows discrepancy chart 1" descr=""/>
           <p:cNvGraphicFramePr/>
           <p:nvPr/>
         </p:nvGraphicFramePr>
@@ -13416,7 +14172,7 @@
       </p:graphicFrame>
       <p:graphicFrame>
         <p:nvGraphicFramePr>
-          <p:cNvPr id="5" name="Pre-bid monitoring · what it shows volume chart" descr=""/>
+          <p:cNvPr id="5" name="Pre-bid monitoring · what it shows volume chart 1" descr=""/>
           <p:cNvGraphicFramePr/>
           <p:nvPr/>
         </p:nvGraphicFramePr>
@@ -16277,13 +17033,13 @@
       </p:sp>
       <p:graphicFrame>
         <p:nvGraphicFramePr>
-          <p:cNvPr id="4" name="Post-bid monitoring · what it shows discrepancy chart" descr=""/>
+          <p:cNvPr id="4" name="Post-bid monitoring · what it shows discrepancy chart 1" descr=""/>
           <p:cNvGraphicFramePr/>
           <p:nvPr/>
         </p:nvGraphicFramePr>
         <p:xfrm>
           <a:off x="548640" y="1828800"/>
-          <a:ext cx="7406640" cy="1600200"/>
+          <a:ext cx="3543300" cy="1600200"/>
         </p:xfrm>
         <a:graphic xmlns:a="http://schemas.openxmlformats.org/drawingml/2006/main">
           <a:graphicData uri="http://schemas.openxmlformats.org/drawingml/2006/chart">
@@ -16293,13 +17049,13 @@
       </p:graphicFrame>
       <p:graphicFrame>
         <p:nvGraphicFramePr>
-          <p:cNvPr id="5" name="Post-bid monitoring · what it shows volume chart" descr=""/>
+          <p:cNvPr id="5" name="Post-bid monitoring · what it shows volume chart 1" descr=""/>
           <p:cNvGraphicFramePr/>
           <p:nvPr/>
         </p:nvGraphicFramePr>
         <p:xfrm>
           <a:off x="548640" y="3474720"/>
-          <a:ext cx="7406640" cy="2606040"/>
+          <a:ext cx="3543300" cy="2606040"/>
         </p:xfrm>
         <a:graphic xmlns:a="http://schemas.openxmlformats.org/drawingml/2006/main">
           <a:graphicData uri="http://schemas.openxmlformats.org/drawingml/2006/chart">
@@ -16307,9 +17063,41 @@
           </a:graphicData>
         </a:graphic>
       </p:graphicFrame>
-      <p:sp>
-        <p:nvSpPr>
-          <p:cNvPr id="6" name="stat 1"/>
+      <p:graphicFrame>
+        <p:nvGraphicFramePr>
+          <p:cNvPr id="6" name="Post-bid monitoring · what it shows discrepancy chart 2" descr=""/>
+          <p:cNvGraphicFramePr/>
+          <p:nvPr/>
+        </p:nvGraphicFramePr>
+        <p:xfrm>
+          <a:off x="4411980" y="1828800"/>
+          <a:ext cx="3543300" cy="1600200"/>
+        </p:xfrm>
+        <a:graphic xmlns:a="http://schemas.openxmlformats.org/drawingml/2006/main">
+          <a:graphicData uri="http://schemas.openxmlformats.org/drawingml/2006/chart">
+            <c:chart xmlns:c="http://schemas.openxmlformats.org/drawingml/2006/chart" r:id="rId3"/>
+          </a:graphicData>
+        </a:graphic>
+      </p:graphicFrame>
+      <p:graphicFrame>
+        <p:nvGraphicFramePr>
+          <p:cNvPr id="7" name="Post-bid monitoring · what it shows volume chart 2" descr=""/>
+          <p:cNvGraphicFramePr/>
+          <p:nvPr/>
+        </p:nvGraphicFramePr>
+        <p:xfrm>
+          <a:off x="4411980" y="3474720"/>
+          <a:ext cx="3543300" cy="2606040"/>
+        </p:xfrm>
+        <a:graphic xmlns:a="http://schemas.openxmlformats.org/drawingml/2006/main">
+          <a:graphicData uri="http://schemas.openxmlformats.org/drawingml/2006/chart">
+            <c:chart xmlns:c="http://schemas.openxmlformats.org/drawingml/2006/chart" r:id="rId4"/>
+          </a:graphicData>
+        </a:graphic>
+      </p:graphicFrame>
+      <p:sp>
+        <p:nvSpPr>
+          <p:cNvPr id="8" name="stat 1"/>
           <p:cNvSpPr/>
           <p:nvPr/>
         </p:nvSpPr>
@@ -16334,7 +17122,7 @@
       </p:sp>
       <p:sp>
         <p:nvSpPr>
-          <p:cNvPr id="7" name="Text 3"/>
+          <p:cNvPr id="9" name="Text 3"/>
           <p:cNvSpPr txBox="1"/>
           <p:nvPr/>
         </p:nvSpPr>
@@ -16370,7 +17158,7 @@
       </p:sp>
       <p:sp>
         <p:nvSpPr>
-          <p:cNvPr id="8" name="Text 4"/>
+          <p:cNvPr id="10" name="Text 4"/>
           <p:cNvSpPr txBox="1"/>
           <p:nvPr/>
         </p:nvSpPr>
@@ -16409,7 +17197,7 @@
       </p:sp>
       <p:sp>
         <p:nvSpPr>
-          <p:cNvPr id="9" name="Text 5"/>
+          <p:cNvPr id="11" name="Text 5"/>
           <p:cNvSpPr txBox="1"/>
           <p:nvPr/>
         </p:nvSpPr>
@@ -16445,7 +17233,7 @@
       </p:sp>
       <p:sp>
         <p:nvSpPr>
-          <p:cNvPr id="10" name="stat 2"/>
+          <p:cNvPr id="12" name="stat 2"/>
           <p:cNvSpPr/>
           <p:nvPr/>
         </p:nvSpPr>
@@ -16470,7 +17258,7 @@
       </p:sp>
       <p:sp>
         <p:nvSpPr>
-          <p:cNvPr id="11" name="Text 7"/>
+          <p:cNvPr id="13" name="Text 7"/>
           <p:cNvSpPr txBox="1"/>
           <p:nvPr/>
         </p:nvSpPr>
@@ -16506,7 +17294,7 @@
       </p:sp>
       <p:sp>
         <p:nvSpPr>
-          <p:cNvPr id="12" name="Text 8"/>
+          <p:cNvPr id="14" name="Text 8"/>
           <p:cNvSpPr txBox="1"/>
           <p:nvPr/>
         </p:nvSpPr>
@@ -16545,7 +17333,7 @@
       </p:sp>
       <p:sp>
         <p:nvSpPr>
-          <p:cNvPr id="13" name="Text 9"/>
+          <p:cNvPr id="15" name="Text 9"/>
           <p:cNvSpPr txBox="1"/>
           <p:nvPr/>
         </p:nvSpPr>
@@ -16581,7 +17369,7 @@
       </p:sp>
       <p:sp>
         <p:nvSpPr>
-          <p:cNvPr id="14" name="Text 10"/>
+          <p:cNvPr id="16" name="Text 10"/>
           <p:cNvSpPr txBox="1"/>
           <p:nvPr/>
         </p:nvSpPr>
@@ -16609,7 +17397,7 @@
                   <a:schemeClr val="tx2"/>
                 </a:solidFill>
               </a:rPr>
-              <a:t>Source: DV-GAM workbook 2026, display sheet. Discrepancy = 1 − DV ÷ GAM total.</a:t>
+              <a:t>Source: DV-GAM workbook, 2026 YTD Jan–Sep (October excluded). Discrepancy = 1 − DV ÷ GAM total.</a:t>
             </a:r>
             <a:endParaRPr lang="en-US" sz="1100" dirty="0"/>
           </a:p>

</xml_diff>

<commit_message>
docs: drop slide-number references from the TAG IVT guide
Co-Authored-By: Claude Opus 5.5 <noreply@anthropic.com>
Claude-Session: https://claude.ai/code/session_014udSfWkctWaSTKdEZUW1Gh
</commit_message>
<xml_diff>
--- a/docs/TAG_IVT_Report_Update_Guide.pptx
+++ b/docs/TAG_IVT_Report_Update_Guide.pptx
@@ -126,7 +126,7 @@
   <p:extLst>
     <p:ext uri="{521415D9-36F7-43E2-AB2F-B90AF26B5E84}">
       <p14:sectionLst xmlns:p14="http://schemas.microsoft.com/office/powerpoint/2010/main">
-        <p14:section name="Overview" id="{d40b1d84-3ffc-19fd-9c27-9786ef8eb3e0}">
+        <p14:section name="Overview" id="{70fde943-71cc-8fd5-1f38-872407ea5627}">
           <p14:sldIdLst>
             <p14:sldId id="256"/>
             <p14:sldId id="257"/>
@@ -140,7 +140,7 @@
             <p14:sldId id="265"/>
           </p14:sldIdLst>
         </p14:section>
-        <p14:section name="1 · GAM" id="{bf5585b1-3b1c-dee6-45f5-3274a33b9f55}">
+        <p14:section name="1 · GAM" id="{d0858fcc-a574-75d5-d35b-60d467fc9c72}">
           <p14:sldIdLst>
             <p14:sldId id="266"/>
             <p14:sldId id="267"/>
@@ -148,14 +148,14 @@
             <p14:sldId id="269"/>
           </p14:sldIdLst>
         </p14:section>
-        <p14:section name="2–3 · DV and GA4" id="{391aa39b-67b4-2556-adb9-88f56f2c9c58}">
+        <p14:section name="2–3 · DV and GA4" id="{bfe2f7fd-0974-b289-f22b-bb9f058cee51}">
           <p14:sldIdLst>
             <p14:sldId id="270"/>
             <p14:sldId id="271"/>
             <p14:sldId id="272"/>
           </p14:sldIdLst>
         </p14:section>
-        <p14:section name="4–5 · Math and deck" id="{36e01409-39d1-c8d4-293f-9a890d612d72}">
+        <p14:section name="4–5 · Math and deck" id="{55ba5356-3026-6f9c-6e67-1741e43891ac}">
           <p14:sldIdLst>
             <p14:sldId id="273"/>
             <p14:sldId id="274"/>
@@ -6646,7 +6646,7 @@
                   <a:schemeClr val="tx2"/>
                 </a:solidFill>
               </a:rPr>
-              <a:t>The DV-GA workbook's own formula. Slide 4 uses it too.</a:t>
+              <a:t>The DV-GA workbook's own formula. The report uses it too.</a:t>
             </a:r>
             <a:endParaRPr lang="en-US" sz="1400" dirty="0"/>
           </a:p>
@@ -12725,7 +12725,7 @@
                   <a:schemeClr val="tx1"/>
                 </a:solidFill>
               </a:rPr>
-              <a:t>FEEDS SLIDE 4</a:t>
+              <a:t>FEEDS THE REPORT'S PRE-BID SLIDE</a:t>
             </a:r>
             <a:endParaRPr lang="en-US" sz="1100" dirty="0"/>
           </a:p>
@@ -12917,7 +12917,7 @@
                   <a:schemeClr val="tx1"/>
                 </a:solidFill>
               </a:rPr>
-              <a:t>FEEDS SLIDE 10</a:t>
+              <a:t>FEEDS THE REPORT'S SIVT SLIDE</a:t>
             </a:r>
             <a:endParaRPr lang="en-US" sz="1100" dirty="0"/>
           </a:p>
@@ -13300,7 +13300,7 @@
         </p:nvSpPr>
         <p:spPr>
           <a:xfrm>
-            <a:off x="822960" y="2286000"/>
+            <a:off x="822960" y="2331720"/>
             <a:ext cx="1097280" cy="274320"/>
           </a:xfrm>
           <a:prstGeom prst="rect">
@@ -13317,59 +13317,20 @@
               <a:buNone/>
             </a:pPr>
             <a:r>
-              <a:rPr lang="en-US" sz="1000" b="1" spc="200" kern="0" dirty="0">
+              <a:rPr lang="en-US" sz="1100" b="1" spc="200" kern="0" dirty="0">
                 <a:solidFill>
                   <a:schemeClr val="tx2"/>
                 </a:solidFill>
               </a:rPr>
-              <a:t>SLIDE</a:t>
+              <a:t>COVER</a:t>
             </a:r>
-            <a:endParaRPr lang="en-US" sz="1000" dirty="0"/>
+            <a:endParaRPr lang="en-US" sz="1100" dirty="0"/>
           </a:p>
         </p:txBody>
       </p:sp>
       <p:sp>
         <p:nvSpPr>
           <p:cNvPr id="6" name="Text 4"/>
-          <p:cNvSpPr txBox="1"/>
-          <p:nvPr/>
-        </p:nvSpPr>
-        <p:spPr>
-          <a:xfrm>
-            <a:off x="822960" y="2514600"/>
-            <a:ext cx="1097280" cy="822960"/>
-          </a:xfrm>
-          <a:prstGeom prst="rect">
-            <a:avLst/>
-          </a:prstGeom>
-          <a:noFill/>
-          <a:ln/>
-        </p:spPr>
-        <p:txBody>
-          <a:bodyPr wrap="square" lIns="0" tIns="0" rIns="0" bIns="0" rtlCol="0" anchor="t"/>
-          <a:lstStyle/>
-          <a:p>
-            <a:pPr indent="0" marL="0">
-              <a:buNone/>
-            </a:pPr>
-            <a:r>
-              <a:rPr lang="en-US" sz="4400" dirty="0">
-                <a:solidFill>
-                  <a:schemeClr val="tx1"/>
-                </a:solidFill>
-                <a:latin typeface="Georgia" pitchFamily="34" charset="0"/>
-                <a:ea typeface="Georgia" pitchFamily="34" charset="-122"/>
-                <a:cs typeface="Georgia" pitchFamily="34" charset="-120"/>
-              </a:rPr>
-              <a:t>1</a:t>
-            </a:r>
-            <a:endParaRPr lang="en-US" sz="4400" dirty="0"/>
-          </a:p>
-        </p:txBody>
-      </p:sp>
-      <p:sp>
-        <p:nvSpPr>
-          <p:cNvPr id="7" name="Text 5"/>
           <p:cNvSpPr txBox="1"/>
           <p:nvPr/>
         </p:nvSpPr>
@@ -13408,7 +13369,7 @@
       </p:sp>
       <p:sp>
         <p:nvSpPr>
-          <p:cNvPr id="8" name="Text 6"/>
+          <p:cNvPr id="7" name="Text 5"/>
           <p:cNvSpPr txBox="1"/>
           <p:nvPr/>
         </p:nvSpPr>
@@ -13444,7 +13405,7 @@
       </p:sp>
       <p:sp>
         <p:nvSpPr>
-          <p:cNvPr id="9" name="check 2"/>
+          <p:cNvPr id="8" name="check 2"/>
           <p:cNvSpPr/>
           <p:nvPr/>
         </p:nvSpPr>
@@ -13469,13 +13430,13 @@
       </p:sp>
       <p:sp>
         <p:nvSpPr>
-          <p:cNvPr id="10" name="Text 8"/>
+          <p:cNvPr id="9" name="Text 7"/>
           <p:cNvSpPr txBox="1"/>
           <p:nvPr/>
         </p:nvSpPr>
         <p:spPr>
           <a:xfrm>
-            <a:off x="6553048" y="2286000"/>
+            <a:off x="6553048" y="2331720"/>
             <a:ext cx="1097280" cy="274320"/>
           </a:xfrm>
           <a:prstGeom prst="rect">
@@ -13492,59 +13453,20 @@
               <a:buNone/>
             </a:pPr>
             <a:r>
-              <a:rPr lang="en-US" sz="1000" b="1" spc="200" kern="0" dirty="0">
+              <a:rPr lang="en-US" sz="1100" b="1" spc="200" kern="0" dirty="0">
                 <a:solidFill>
                   <a:schemeClr val="tx2"/>
                 </a:solidFill>
               </a:rPr>
-              <a:t>SLIDE</a:t>
+              <a:t>PRE-BID</a:t>
             </a:r>
-            <a:endParaRPr lang="en-US" sz="1000" dirty="0"/>
-          </a:p>
-        </p:txBody>
-      </p:sp>
-      <p:sp>
-        <p:nvSpPr>
-          <p:cNvPr id="11" name="Text 9"/>
-          <p:cNvSpPr txBox="1"/>
-          <p:nvPr/>
-        </p:nvSpPr>
-        <p:spPr>
-          <a:xfrm>
-            <a:off x="6553048" y="2514600"/>
-            <a:ext cx="1097280" cy="822960"/>
-          </a:xfrm>
-          <a:prstGeom prst="rect">
-            <a:avLst/>
-          </a:prstGeom>
-          <a:noFill/>
-          <a:ln/>
-        </p:spPr>
-        <p:txBody>
-          <a:bodyPr wrap="square" lIns="0" tIns="0" rIns="0" bIns="0" rtlCol="0" anchor="t"/>
-          <a:lstStyle/>
-          <a:p>
-            <a:pPr indent="0" marL="0">
-              <a:buNone/>
-            </a:pPr>
-            <a:r>
-              <a:rPr lang="en-US" sz="4400" dirty="0">
-                <a:solidFill>
-                  <a:schemeClr val="tx1"/>
-                </a:solidFill>
-                <a:latin typeface="Georgia" pitchFamily="34" charset="0"/>
-                <a:ea typeface="Georgia" pitchFamily="34" charset="-122"/>
-                <a:cs typeface="Georgia" pitchFamily="34" charset="-120"/>
-              </a:rPr>
-              <a:t>4</a:t>
-            </a:r>
-            <a:endParaRPr lang="en-US" sz="4400" dirty="0"/>
-          </a:p>
-        </p:txBody>
-      </p:sp>
-      <p:sp>
-        <p:nvSpPr>
-          <p:cNvPr id="12" name="Text 10"/>
+            <a:endParaRPr lang="en-US" sz="1100" dirty="0"/>
+          </a:p>
+        </p:txBody>
+      </p:sp>
+      <p:sp>
+        <p:nvSpPr>
+          <p:cNvPr id="10" name="Text 8"/>
           <p:cNvSpPr txBox="1"/>
           <p:nvPr/>
         </p:nvSpPr>
@@ -13583,7 +13505,7 @@
       </p:sp>
       <p:sp>
         <p:nvSpPr>
-          <p:cNvPr id="13" name="Text 11"/>
+          <p:cNvPr id="11" name="Text 9"/>
           <p:cNvSpPr txBox="1"/>
           <p:nvPr/>
         </p:nvSpPr>
@@ -13619,7 +13541,7 @@
       </p:sp>
       <p:sp>
         <p:nvSpPr>
-          <p:cNvPr id="14" name="check 3"/>
+          <p:cNvPr id="12" name="check 3"/>
           <p:cNvSpPr/>
           <p:nvPr/>
         </p:nvSpPr>
@@ -13644,13 +13566,13 @@
       </p:sp>
       <p:sp>
         <p:nvSpPr>
-          <p:cNvPr id="15" name="Text 13"/>
+          <p:cNvPr id="13" name="Text 11"/>
           <p:cNvSpPr txBox="1"/>
           <p:nvPr/>
         </p:nvSpPr>
         <p:spPr>
           <a:xfrm>
-            <a:off x="822960" y="4160520"/>
+            <a:off x="822960" y="4206240"/>
             <a:ext cx="1097280" cy="274320"/>
           </a:xfrm>
           <a:prstGeom prst="rect">
@@ -13667,59 +13589,20 @@
               <a:buNone/>
             </a:pPr>
             <a:r>
-              <a:rPr lang="en-US" sz="1000" b="1" spc="200" kern="0" dirty="0">
+              <a:rPr lang="en-US" sz="1100" b="1" spc="200" kern="0" dirty="0">
                 <a:solidFill>
                   <a:schemeClr val="tx2"/>
                 </a:solidFill>
               </a:rPr>
-              <a:t>SLIDE</a:t>
+              <a:t>CHANGES</a:t>
             </a:r>
-            <a:endParaRPr lang="en-US" sz="1000" dirty="0"/>
-          </a:p>
-        </p:txBody>
-      </p:sp>
-      <p:sp>
-        <p:nvSpPr>
-          <p:cNvPr id="16" name="Text 14"/>
-          <p:cNvSpPr txBox="1"/>
-          <p:nvPr/>
-        </p:nvSpPr>
-        <p:spPr>
-          <a:xfrm>
-            <a:off x="822960" y="4389120"/>
-            <a:ext cx="1097280" cy="822960"/>
-          </a:xfrm>
-          <a:prstGeom prst="rect">
-            <a:avLst/>
-          </a:prstGeom>
-          <a:noFill/>
-          <a:ln/>
-        </p:spPr>
-        <p:txBody>
-          <a:bodyPr wrap="square" lIns="0" tIns="0" rIns="0" bIns="0" rtlCol="0" anchor="t"/>
-          <a:lstStyle/>
-          <a:p>
-            <a:pPr indent="0" marL="0">
-              <a:buNone/>
-            </a:pPr>
-            <a:r>
-              <a:rPr lang="en-US" sz="4400" dirty="0">
-                <a:solidFill>
-                  <a:schemeClr val="tx1"/>
-                </a:solidFill>
-                <a:latin typeface="Georgia" pitchFamily="34" charset="0"/>
-                <a:ea typeface="Georgia" pitchFamily="34" charset="-122"/>
-                <a:cs typeface="Georgia" pitchFamily="34" charset="-120"/>
-              </a:rPr>
-              <a:t>9</a:t>
-            </a:r>
-            <a:endParaRPr lang="en-US" sz="4400" dirty="0"/>
-          </a:p>
-        </p:txBody>
-      </p:sp>
-      <p:sp>
-        <p:nvSpPr>
-          <p:cNvPr id="17" name="Text 15"/>
+            <a:endParaRPr lang="en-US" sz="1100" dirty="0"/>
+          </a:p>
+        </p:txBody>
+      </p:sp>
+      <p:sp>
+        <p:nvSpPr>
+          <p:cNvPr id="14" name="Text 12"/>
           <p:cNvSpPr txBox="1"/>
           <p:nvPr/>
         </p:nvSpPr>
@@ -13758,7 +13641,7 @@
       </p:sp>
       <p:sp>
         <p:nvSpPr>
-          <p:cNvPr id="18" name="Text 16"/>
+          <p:cNvPr id="15" name="Text 13"/>
           <p:cNvSpPr txBox="1"/>
           <p:nvPr/>
         </p:nvSpPr>
@@ -13794,7 +13677,7 @@
       </p:sp>
       <p:sp>
         <p:nvSpPr>
-          <p:cNvPr id="19" name="check 4"/>
+          <p:cNvPr id="16" name="check 4"/>
           <p:cNvSpPr/>
           <p:nvPr/>
         </p:nvSpPr>
@@ -13819,13 +13702,13 @@
       </p:sp>
       <p:sp>
         <p:nvSpPr>
-          <p:cNvPr id="20" name="Text 18"/>
+          <p:cNvPr id="17" name="Text 15"/>
           <p:cNvSpPr txBox="1"/>
           <p:nvPr/>
         </p:nvSpPr>
         <p:spPr>
           <a:xfrm>
-            <a:off x="6553048" y="4160520"/>
+            <a:off x="6553048" y="4206240"/>
             <a:ext cx="1097280" cy="274320"/>
           </a:xfrm>
           <a:prstGeom prst="rect">
@@ -13842,59 +13725,20 @@
               <a:buNone/>
             </a:pPr>
             <a:r>
-              <a:rPr lang="en-US" sz="1000" b="1" spc="200" kern="0" dirty="0">
+              <a:rPr lang="en-US" sz="1100" b="1" spc="200" kern="0" dirty="0">
                 <a:solidFill>
                   <a:schemeClr val="tx2"/>
                 </a:solidFill>
               </a:rPr>
-              <a:t>SLIDE</a:t>
+              <a:t>SIVT</a:t>
             </a:r>
-            <a:endParaRPr lang="en-US" sz="1000" dirty="0"/>
-          </a:p>
-        </p:txBody>
-      </p:sp>
-      <p:sp>
-        <p:nvSpPr>
-          <p:cNvPr id="21" name="Text 19"/>
-          <p:cNvSpPr txBox="1"/>
-          <p:nvPr/>
-        </p:nvSpPr>
-        <p:spPr>
-          <a:xfrm>
-            <a:off x="6553048" y="4389120"/>
-            <a:ext cx="1097280" cy="822960"/>
-          </a:xfrm>
-          <a:prstGeom prst="rect">
-            <a:avLst/>
-          </a:prstGeom>
-          <a:noFill/>
-          <a:ln/>
-        </p:spPr>
-        <p:txBody>
-          <a:bodyPr wrap="square" lIns="0" tIns="0" rIns="0" bIns="0" rtlCol="0" anchor="t"/>
-          <a:lstStyle/>
-          <a:p>
-            <a:pPr indent="0" marL="0">
-              <a:buNone/>
-            </a:pPr>
-            <a:r>
-              <a:rPr lang="en-US" sz="4400" dirty="0">
-                <a:solidFill>
-                  <a:schemeClr val="tx1"/>
-                </a:solidFill>
-                <a:latin typeface="Georgia" pitchFamily="34" charset="0"/>
-                <a:ea typeface="Georgia" pitchFamily="34" charset="-122"/>
-                <a:cs typeface="Georgia" pitchFamily="34" charset="-120"/>
-              </a:rPr>
-              <a:t>10</a:t>
-            </a:r>
-            <a:endParaRPr lang="en-US" sz="4400" dirty="0"/>
-          </a:p>
-        </p:txBody>
-      </p:sp>
-      <p:sp>
-        <p:nvSpPr>
-          <p:cNvPr id="22" name="Text 20"/>
+            <a:endParaRPr lang="en-US" sz="1100" dirty="0"/>
+          </a:p>
+        </p:txBody>
+      </p:sp>
+      <p:sp>
+        <p:nvSpPr>
+          <p:cNvPr id="18" name="Text 16"/>
           <p:cNvSpPr txBox="1"/>
           <p:nvPr/>
         </p:nvSpPr>
@@ -13933,7 +13777,7 @@
       </p:sp>
       <p:sp>
         <p:nvSpPr>
-          <p:cNvPr id="23" name="Text 21"/>
+          <p:cNvPr id="19" name="Text 17"/>
           <p:cNvSpPr txBox="1"/>
           <p:nvPr/>
         </p:nvSpPr>
@@ -14185,7 +14029,7 @@
                   <a:schemeClr val="tx2"/>
                 </a:solidFill>
               </a:rPr>
-              <a:t>One sheet (Y&lt;year&gt;), one row per month grouped Q1–Q4, Totals row at the bottom. Feeds slide 4 of the report.</a:t>
+              <a:t>One sheet (Y&lt;year&gt;), one row per month grouped Q1–Q4, Totals row at the bottom. Feeds the report's pre-bid slide.</a:t>
             </a:r>
             <a:endParaRPr lang="en-US" sz="1400" dirty="0"/>
           </a:p>
@@ -16032,7 +15876,7 @@
                   <a:schemeClr val="tx2"/>
                 </a:solidFill>
               </a:rPr>
-              <a:t>Two sheets, same columns: inpage display (ad unit newsweek) and instream video (vid.newsweek). Feeds slide 10.</a:t>
+              <a:t>Two sheets, same columns: inpage display (ad unit newsweek) and instream video (vid.newsweek). Feeds the report's SIVT slide.</a:t>
             </a:r>
             <a:endParaRPr lang="en-US" sz="1400" dirty="0"/>
           </a:p>
@@ -19122,7 +18966,7 @@
                   <a:schemeClr val="tx2"/>
                 </a:solidFill>
               </a:rPr>
-              <a:t>REPORT SLIDE 4 · PRE-BID MONITORING</a:t>
+              <a:t>REPORT · PRE-BID MONITORING</a:t>
             </a:r>
             <a:endParaRPr lang="en-US" sz="1000" dirty="0"/>
           </a:p>
@@ -20458,7 +20302,7 @@
                   <a:schemeClr val="tx2"/>
                 </a:solidFill>
               </a:rPr>
-              <a:t>REPORT SLIDE 10 · SIVT</a:t>
+              <a:t>REPORT · SIVT</a:t>
             </a:r>
             <a:endParaRPr lang="en-US" sz="1000" dirty="0"/>
           </a:p>
@@ -23216,7 +23060,7 @@
                   <a:schemeClr val="tx2"/>
                 </a:solidFill>
               </a:rPr>
-              <a:t>Slides 1, 4, 9 and 10</a:t>
+              <a:t>Cover, pre-bid, key changes, SIVT</a:t>
             </a:r>
             <a:endParaRPr lang="en-US" sz="1400" dirty="0"/>
           </a:p>

</xml_diff>

<commit_message>
docs: how to apply the Media Type filter in DV's Inventory Quality report
Also flags that the July 2026 Fraud/SIVT rate in the DV UI (~0.38%) is
about 10x the workbook's SIVT Rate (0.04%).

Co-Authored-By: Claude Opus 5.5 <noreply@anthropic.com>
Claude-Session: https://claude.ai/code/session_014udSfWkctWaSTKdEZUW1Gh
</commit_message>
<xml_diff>
--- a/docs/TAG_IVT_Report_Update_Guide.pptx
+++ b/docs/TAG_IVT_Report_Update_Guide.pptx
@@ -26,9 +26,10 @@
     <p:sldId id="274" r:id="rId20"/>
     <p:sldId id="275" r:id="rId21"/>
     <p:sldId id="276" r:id="rId22"/>
+    <p:sldId id="277" r:id="rId23"/>
   </p:sldIdLst>
   <p:notesMasterIdLst>
-    <p:notesMasterId r:id="rId23"/>
+    <p:notesMasterId r:id="rId24"/>
   </p:notesMasterIdLst>
   <p:sldSz cx="12192000" cy="6858000"/>
   <p:notesSz cx="6858000" cy="12192000"/>
@@ -127,7 +128,7 @@
   <p:extLst>
     <p:ext uri="{521415D9-36F7-43E2-AB2F-B90AF26B5E84}">
       <p14:sectionLst xmlns:p14="http://schemas.microsoft.com/office/powerpoint/2010/main">
-        <p14:section name="Overview" id="{71d29785-d45a-8293-aaa9-98424dce8ea1}">
+        <p14:section name="Overview" id="{511c0740-0ad8-a2b6-06d4-2862ec8032cc}">
           <p14:sldIdLst>
             <p14:sldId id="256"/>
             <p14:sldId id="257"/>
@@ -142,7 +143,7 @@
             <p14:sldId id="266"/>
           </p14:sldIdLst>
         </p14:section>
-        <p14:section name="1 · GAM" id="{29b4b13b-142f-fc44-4142-e10fc741a815}">
+        <p14:section name="1 · GAM" id="{01fef463-e30d-6862-f299-c5b17e0ea3cb}">
           <p14:sldIdLst>
             <p14:sldId id="267"/>
             <p14:sldId id="268"/>
@@ -150,18 +151,19 @@
             <p14:sldId id="270"/>
           </p14:sldIdLst>
         </p14:section>
-        <p14:section name="2–3 · DV and GA4" id="{502ecca0-7c34-ab77-ef57-9beb2504cdd2}">
+        <p14:section name="2–3 · DV and GA4" id="{e8db03b0-bbfe-e5af-3391-507446752f30}">
           <p14:sldIdLst>
             <p14:sldId id="271"/>
             <p14:sldId id="272"/>
             <p14:sldId id="273"/>
+            <p14:sldId id="274"/>
           </p14:sldIdLst>
         </p14:section>
-        <p14:section name="4–5 · Math and deck" id="{aa02fecb-e5f8-525f-85d2-290925325704}">
+        <p14:section name="4–5 · Math and deck" id="{bcd8d555-8720-a3b8-07f1-46d060da4e1a}">
           <p14:sldIdLst>
-            <p14:sldId id="274"/>
             <p14:sldId id="275"/>
             <p14:sldId id="276"/>
+            <p14:sldId id="277"/>
           </p14:sldIdLst>
         </p14:section>
       </p14:sectionLst>
@@ -4750,6 +4752,94 @@
 </p:notes>
 </file>
 
+<file path=ppt/notesSlides/notesSlide22.xml><?xml version="1.0" encoding="utf-8"?>
+<p:notes xmlns:a="http://schemas.openxmlformats.org/drawingml/2006/main" xmlns:r="http://schemas.openxmlformats.org/officeDocument/2006/relationships" xmlns:p="http://schemas.openxmlformats.org/presentationml/2006/main">
+  <p:cSld>
+    <p:spTree>
+      <p:nvGrpSpPr>
+        <p:cNvPr id="1" name=""/>
+        <p:cNvGrpSpPr/>
+        <p:nvPr/>
+      </p:nvGrpSpPr>
+      <p:grpSpPr>
+        <a:xfrm>
+          <a:off x="0" y="0"/>
+          <a:ext cx="0" cy="0"/>
+          <a:chOff x="0" y="0"/>
+          <a:chExt cx="0" cy="0"/>
+        </a:xfrm>
+      </p:grpSpPr>
+      <p:sp>
+        <p:nvSpPr>
+          <p:cNvPr id="2" name="Slide Image Placeholder 1"/>
+          <p:cNvSpPr>
+            <a:spLocks noGrp="1" noRot="1" noChangeAspect="1"/>
+          </p:cNvSpPr>
+          <p:nvPr>
+            <p:ph type="sldImg"/>
+          </p:nvPr>
+        </p:nvSpPr>
+        <p:spPr/>
+      </p:sp>
+      <p:sp>
+        <p:nvSpPr>
+          <p:cNvPr id="3" name="Notes Placeholder 2"/>
+          <p:cNvSpPr>
+            <a:spLocks noGrp="1"/>
+          </p:cNvSpPr>
+          <p:nvPr>
+            <p:ph type="body" idx="1"/>
+          </p:nvPr>
+        </p:nvSpPr>
+        <p:spPr/>
+        <p:txBody>
+          <a:bodyPr/>
+          <a:lstStyle/>
+          <a:p>
+            <a:r>
+              <a:rPr lang="en-US" dirty="0"/>
+              <a:t/>
+            </a:r>
+            <a:endParaRPr lang="en-US" dirty="0"/>
+          </a:p>
+        </p:txBody>
+      </p:sp>
+      <p:sp>
+        <p:nvSpPr>
+          <p:cNvPr id="4" name="Slide Number Placeholder 3"/>
+          <p:cNvSpPr>
+            <a:spLocks noGrp="1"/>
+          </p:cNvSpPr>
+          <p:nvPr>
+            <p:ph type="sldNum" sz="quarter" idx="10"/>
+          </p:nvPr>
+        </p:nvSpPr>
+        <p:spPr/>
+        <p:txBody>
+          <a:bodyPr/>
+          <a:lstStyle/>
+          <a:p>
+            <a:fld id="{F7021451-1387-4CA6-816F-3879F97B5CBC}" type="slidenum">
+              <a:rPr lang="en-US"/>
+              <a:t>22</a:t>
+            </a:fld>
+            <a:endParaRPr lang="en-US"/>
+          </a:p>
+        </p:txBody>
+      </p:sp>
+    </p:spTree>
+    <p:extLst>
+      <p:ext uri="{BB962C8B-B14F-4D97-AF65-F5344CB8AC3E}">
+        <p14:creationId xmlns:p14="http://schemas.microsoft.com/office/powerpoint/2010/main" val="1024086991"/>
+      </p:ext>
+    </p:extLst>
+  </p:cSld>
+  <p:clrMapOvr>
+    <a:masterClrMapping/>
+  </p:clrMapOvr>
+</p:notes>
+</file>
+
 <file path=ppt/notesSlides/notesSlide3.xml><?xml version="1.0" encoding="utf-8"?>
 <p:notes xmlns:a="http://schemas.openxmlformats.org/drawingml/2006/main" xmlns:r="http://schemas.openxmlformats.org/officeDocument/2006/relationships" xmlns:p="http://schemas.openxmlformats.org/presentationml/2006/main">
   <p:cSld>
@@ -12384,7 +12474,7 @@
                   <a:schemeClr val="tx2"/>
                 </a:solidFill>
               </a:rPr>
-              <a:t>STEP 3 · GA4 AND DV PRE-BID</a:t>
+              <a:t>STEP 2 · IN THE DV UI</a:t>
             </a:r>
             <a:endParaRPr lang="en-US" sz="1200" dirty="0"/>
           </a:p>
@@ -12425,7 +12515,7 @@
                 <a:ea typeface="Georgia" pitchFamily="34" charset="-122"/>
                 <a:cs typeface="Georgia" pitchFamily="34" charset="-120"/>
               </a:rPr>
-              <a:t>Pageviews against pre-bid requests</a:t>
+              <a:t>Filter the Inventory Quality report by media type</a:t>
             </a:r>
             <a:endParaRPr lang="en-US" sz="3400" dirty="0"/>
           </a:p>
@@ -12439,8 +12529,8 @@
         </p:nvSpPr>
         <p:spPr>
           <a:xfrm>
-            <a:off x="548640" y="2057400"/>
-            <a:ext cx="731520" cy="731520"/>
+            <a:off x="548640" y="1920240"/>
+            <a:ext cx="548640" cy="640080"/>
           </a:xfrm>
           <a:prstGeom prst="rect">
             <a:avLst/>
@@ -12456,7 +12546,7 @@
               <a:buNone/>
             </a:pPr>
             <a:r>
-              <a:rPr lang="en-US" sz="4000" dirty="0">
+              <a:rPr lang="en-US" sz="3000" dirty="0">
                 <a:solidFill>
                   <a:schemeClr val="tx1"/>
                 </a:solidFill>
@@ -12466,7 +12556,7 @@
               </a:rPr>
               <a:t>1</a:t>
             </a:r>
-            <a:endParaRPr lang="en-US" sz="4000" dirty="0"/>
+            <a:endParaRPr lang="en-US" sz="3000" dirty="0"/>
           </a:p>
         </p:txBody>
       </p:sp>
@@ -12478,8 +12568,8 @@
         </p:nvSpPr>
         <p:spPr>
           <a:xfrm>
-            <a:off x="1463040" y="2103120"/>
-            <a:ext cx="5486400" cy="365760"/>
+            <a:off x="1234440" y="1938528"/>
+            <a:ext cx="6035040" cy="347472"/>
           </a:xfrm>
           <a:prstGeom prst="rect">
             <a:avLst/>
@@ -12495,7 +12585,7 @@
               <a:buNone/>
             </a:pPr>
             <a:r>
-              <a:rPr lang="en-US" sz="1900" dirty="0">
+              <a:rPr lang="en-US" sz="1800" dirty="0">
                 <a:solidFill>
                   <a:schemeClr val="tx1"/>
                 </a:solidFill>
@@ -12503,9 +12593,9 @@
                 <a:ea typeface="Georgia" pitchFamily="34" charset="-122"/>
                 <a:cs typeface="Georgia" pitchFamily="34" charset="-120"/>
               </a:rPr>
-              <a:t>Pageviews</a:t>
+              <a:t>Open the report</a:t>
             </a:r>
-            <a:endParaRPr lang="en-US" sz="1900" dirty="0"/>
+            <a:endParaRPr lang="en-US" sz="1800" dirty="0"/>
           </a:p>
         </p:txBody>
       </p:sp>
@@ -12517,8 +12607,8 @@
         </p:nvSpPr>
         <p:spPr>
           <a:xfrm>
-            <a:off x="1463040" y="2496312"/>
-            <a:ext cx="5486400" cy="548640"/>
+            <a:off x="1234440" y="2304288"/>
+            <a:ext cx="6035040" cy="411480"/>
           </a:xfrm>
           <a:prstGeom prst="rect">
             <a:avLst/>
@@ -12534,14 +12624,14 @@
               <a:buNone/>
             </a:pPr>
             <a:r>
-              <a:rPr lang="en-US" sz="1400" dirty="0">
+              <a:rPr lang="en-US" sz="1300" dirty="0">
                 <a:solidFill>
                   <a:schemeClr val="tx2"/>
                 </a:solidFill>
               </a:rPr>
-              <a:t>GA4 saved exploration: Year month × Platform, metric Views, Platform = web</a:t>
+              <a:t>DV Pinnacle → Publisher Suite → Inventory Quality → Inventory</a:t>
             </a:r>
-            <a:endParaRPr lang="en-US" sz="1400" dirty="0"/>
+            <a:endParaRPr lang="en-US" sz="1300" dirty="0"/>
           </a:p>
         </p:txBody>
       </p:sp>
@@ -12553,8 +12643,8 @@
         </p:nvSpPr>
         <p:spPr>
           <a:xfrm>
-            <a:off x="548640" y="3154680"/>
-            <a:ext cx="731520" cy="731520"/>
+            <a:off x="548640" y="2743200"/>
+            <a:ext cx="548640" cy="640080"/>
           </a:xfrm>
           <a:prstGeom prst="rect">
             <a:avLst/>
@@ -12570,7 +12660,7 @@
               <a:buNone/>
             </a:pPr>
             <a:r>
-              <a:rPr lang="en-US" sz="4000" dirty="0">
+              <a:rPr lang="en-US" sz="3000" dirty="0">
                 <a:solidFill>
                   <a:schemeClr val="tx1"/>
                 </a:solidFill>
@@ -12580,7 +12670,7 @@
               </a:rPr>
               <a:t>2</a:t>
             </a:r>
-            <a:endParaRPr lang="en-US" sz="4000" dirty="0"/>
+            <a:endParaRPr lang="en-US" sz="3000" dirty="0"/>
           </a:p>
         </p:txBody>
       </p:sp>
@@ -12592,8 +12682,8 @@
         </p:nvSpPr>
         <p:spPr>
           <a:xfrm>
-            <a:off x="1463040" y="3200400"/>
-            <a:ext cx="5486400" cy="365760"/>
+            <a:off x="1234440" y="2761488"/>
+            <a:ext cx="6035040" cy="347472"/>
           </a:xfrm>
           <a:prstGeom prst="rect">
             <a:avLst/>
@@ -12609,7 +12699,7 @@
               <a:buNone/>
             </a:pPr>
             <a:r>
-              <a:rPr lang="en-US" sz="1900" dirty="0">
+              <a:rPr lang="en-US" sz="1800" dirty="0">
                 <a:solidFill>
                   <a:schemeClr val="tx1"/>
                 </a:solidFill>
@@ -12617,9 +12707,9 @@
                 <a:ea typeface="Georgia" pitchFamily="34" charset="-122"/>
                 <a:cs typeface="Georgia" pitchFamily="34" charset="-120"/>
               </a:rPr>
-              <a:t>Prebid Reqs</a:t>
+              <a:t>Set one month</a:t>
             </a:r>
-            <a:endParaRPr lang="en-US" sz="1900" dirty="0"/>
+            <a:endParaRPr lang="en-US" sz="1800" dirty="0"/>
           </a:p>
         </p:txBody>
       </p:sp>
@@ -12631,8 +12721,8 @@
         </p:nvSpPr>
         <p:spPr>
           <a:xfrm>
-            <a:off x="1463040" y="3593592"/>
-            <a:ext cx="5486400" cy="548640"/>
+            <a:off x="1234440" y="3127248"/>
+            <a:ext cx="6035040" cy="411480"/>
           </a:xfrm>
           <a:prstGeom prst="rect">
             <a:avLst/>
@@ -12648,14 +12738,14 @@
               <a:buNone/>
             </a:pPr>
             <a:r>
-              <a:rPr lang="en-US" sz="1400" dirty="0">
+              <a:rPr lang="en-US" sz="1300" dirty="0">
                 <a:solidFill>
                   <a:schemeClr val="tx2"/>
                 </a:solidFill>
               </a:rPr>
-              <a:t>DV pre-bid page-level requests for the month</a:t>
+              <a:t>Date picker: the first to the last day of the month, e.g. 7/1/2026 – 7/31/2026</a:t>
             </a:r>
-            <a:endParaRPr lang="en-US" sz="1400" dirty="0"/>
+            <a:endParaRPr lang="en-US" sz="1300" dirty="0"/>
           </a:p>
         </p:txBody>
       </p:sp>
@@ -12667,8 +12757,8 @@
         </p:nvSpPr>
         <p:spPr>
           <a:xfrm>
-            <a:off x="548640" y="4251960"/>
-            <a:ext cx="731520" cy="731520"/>
+            <a:off x="548640" y="3566160"/>
+            <a:ext cx="548640" cy="640080"/>
           </a:xfrm>
           <a:prstGeom prst="rect">
             <a:avLst/>
@@ -12684,7 +12774,7 @@
               <a:buNone/>
             </a:pPr>
             <a:r>
-              <a:rPr lang="en-US" sz="4000" dirty="0">
+              <a:rPr lang="en-US" sz="3000" dirty="0">
                 <a:solidFill>
                   <a:schemeClr val="tx1"/>
                 </a:solidFill>
@@ -12694,7 +12784,7 @@
               </a:rPr>
               <a:t>3</a:t>
             </a:r>
-            <a:endParaRPr lang="en-US" sz="4000" dirty="0"/>
+            <a:endParaRPr lang="en-US" sz="3000" dirty="0"/>
           </a:p>
         </p:txBody>
       </p:sp>
@@ -12706,8 +12796,8 @@
         </p:nvSpPr>
         <p:spPr>
           <a:xfrm>
-            <a:off x="1463040" y="4297680"/>
-            <a:ext cx="5486400" cy="365760"/>
+            <a:off x="1234440" y="3584448"/>
+            <a:ext cx="6035040" cy="347472"/>
           </a:xfrm>
           <a:prstGeom prst="rect">
             <a:avLst/>
@@ -12723,7 +12813,7 @@
               <a:buNone/>
             </a:pPr>
             <a:r>
-              <a:rPr lang="en-US" sz="1900" dirty="0">
+              <a:rPr lang="en-US" sz="1800" dirty="0">
                 <a:solidFill>
                   <a:schemeClr val="tx1"/>
                 </a:solidFill>
@@ -12731,9 +12821,9 @@
                 <a:ea typeface="Georgia" pitchFamily="34" charset="-122"/>
                 <a:cs typeface="Georgia" pitchFamily="34" charset="-120"/>
               </a:rPr>
-              <a:t>Discrepancy</a:t>
+              <a:t>Add Filters → Media Type</a:t>
             </a:r>
-            <a:endParaRPr lang="en-US" sz="1900" dirty="0"/>
+            <a:endParaRPr lang="en-US" sz="1800" dirty="0"/>
           </a:p>
         </p:txBody>
       </p:sp>
@@ -12745,8 +12835,8 @@
         </p:nvSpPr>
         <p:spPr>
           <a:xfrm>
-            <a:off x="1463040" y="4690872"/>
-            <a:ext cx="5486400" cy="548640"/>
+            <a:off x="1234440" y="3950208"/>
+            <a:ext cx="6035040" cy="411480"/>
           </a:xfrm>
           <a:prstGeom prst="rect">
             <a:avLst/>
@@ -12762,27 +12852,255 @@
               <a:buNone/>
             </a:pPr>
             <a:r>
-              <a:rPr lang="en-US" sz="1400" dirty="0">
+              <a:rPr lang="en-US" sz="1300" dirty="0">
                 <a:solidFill>
                   <a:schemeClr val="tx2"/>
                 </a:solidFill>
               </a:rPr>
-              <a:t>Formula already in the sheet. Don't overwrite it</a:t>
+              <a:t>Tick Display (or Video) only; leave null unticked. Click Apply</a:t>
             </a:r>
-            <a:endParaRPr lang="en-US" sz="1400" dirty="0"/>
+            <a:endParaRPr lang="en-US" sz="1300" dirty="0"/>
           </a:p>
         </p:txBody>
       </p:sp>
       <p:sp>
         <p:nvSpPr>
-          <p:cNvPr id="13" name="ga4 card"/>
+          <p:cNvPr id="13" name="Text 11"/>
+          <p:cNvSpPr txBox="1"/>
+          <p:nvPr/>
+        </p:nvSpPr>
+        <p:spPr>
+          <a:xfrm>
+            <a:off x="548640" y="4389120"/>
+            <a:ext cx="548640" cy="640080"/>
+          </a:xfrm>
+          <a:prstGeom prst="rect">
+            <a:avLst/>
+          </a:prstGeom>
+          <a:noFill/>
+          <a:ln/>
+        </p:spPr>
+        <p:txBody>
+          <a:bodyPr wrap="square" lIns="0" tIns="0" rIns="0" bIns="0" rtlCol="0" anchor="t"/>
+          <a:lstStyle/>
+          <a:p>
+            <a:pPr indent="0" marL="0">
+              <a:buNone/>
+            </a:pPr>
+            <a:r>
+              <a:rPr lang="en-US" sz="3000" dirty="0">
+                <a:solidFill>
+                  <a:schemeClr val="tx1"/>
+                </a:solidFill>
+                <a:latin typeface="Georgia" pitchFamily="34" charset="0"/>
+                <a:ea typeface="Georgia" pitchFamily="34" charset="-122"/>
+                <a:cs typeface="Georgia" pitchFamily="34" charset="-120"/>
+              </a:rPr>
+              <a:t>4</a:t>
+            </a:r>
+            <a:endParaRPr lang="en-US" sz="3000" dirty="0"/>
+          </a:p>
+        </p:txBody>
+      </p:sp>
+      <p:sp>
+        <p:nvSpPr>
+          <p:cNvPr id="14" name="Text 12"/>
+          <p:cNvSpPr txBox="1"/>
+          <p:nvPr/>
+        </p:nvSpPr>
+        <p:spPr>
+          <a:xfrm>
+            <a:off x="1234440" y="4407408"/>
+            <a:ext cx="6035040" cy="347472"/>
+          </a:xfrm>
+          <a:prstGeom prst="rect">
+            <a:avLst/>
+          </a:prstGeom>
+          <a:noFill/>
+          <a:ln/>
+        </p:spPr>
+        <p:txBody>
+          <a:bodyPr wrap="square" lIns="0" tIns="0" rIns="0" bIns="0" rtlCol="0" anchor="t"/>
+          <a:lstStyle/>
+          <a:p>
+            <a:pPr indent="0" marL="0">
+              <a:buNone/>
+            </a:pPr>
+            <a:r>
+              <a:rPr lang="en-US" sz="1800" dirty="0">
+                <a:solidFill>
+                  <a:schemeClr val="tx1"/>
+                </a:solidFill>
+                <a:latin typeface="Georgia" pitchFamily="34" charset="0"/>
+                <a:ea typeface="Georgia" pitchFamily="34" charset="-122"/>
+                <a:cs typeface="Georgia" pitchFamily="34" charset="-120"/>
+              </a:rPr>
+              <a:t>Read the tiles</a:t>
+            </a:r>
+            <a:endParaRPr lang="en-US" sz="1800" dirty="0"/>
+          </a:p>
+        </p:txBody>
+      </p:sp>
+      <p:sp>
+        <p:nvSpPr>
+          <p:cNvPr id="15" name="Text 13"/>
+          <p:cNvSpPr txBox="1"/>
+          <p:nvPr/>
+        </p:nvSpPr>
+        <p:spPr>
+          <a:xfrm>
+            <a:off x="1234440" y="4773168"/>
+            <a:ext cx="6035040" cy="411480"/>
+          </a:xfrm>
+          <a:prstGeom prst="rect">
+            <a:avLst/>
+          </a:prstGeom>
+          <a:noFill/>
+          <a:ln/>
+        </p:spPr>
+        <p:txBody>
+          <a:bodyPr wrap="square" lIns="0" tIns="0" rIns="0" bIns="0" rtlCol="0" anchor="t"/>
+          <a:lstStyle/>
+          <a:p>
+            <a:pPr indent="0" marL="0">
+              <a:buNone/>
+            </a:pPr>
+            <a:r>
+              <a:rPr lang="en-US" sz="1300" dirty="0">
+                <a:solidFill>
+                  <a:schemeClr val="tx2"/>
+                </a:solidFill>
+              </a:rPr>
+              <a:t>Monitored Impressions → DV post-bid impressions; Fraud/SIVT ÷ Monitored → SIVT Rate</a:t>
+            </a:r>
+            <a:endParaRPr lang="en-US" sz="1300" dirty="0"/>
+          </a:p>
+        </p:txBody>
+      </p:sp>
+      <p:sp>
+        <p:nvSpPr>
+          <p:cNvPr id="16" name="Text 14"/>
+          <p:cNvSpPr txBox="1"/>
+          <p:nvPr/>
+        </p:nvSpPr>
+        <p:spPr>
+          <a:xfrm>
+            <a:off x="548640" y="5212080"/>
+            <a:ext cx="548640" cy="640080"/>
+          </a:xfrm>
+          <a:prstGeom prst="rect">
+            <a:avLst/>
+          </a:prstGeom>
+          <a:noFill/>
+          <a:ln/>
+        </p:spPr>
+        <p:txBody>
+          <a:bodyPr wrap="square" lIns="0" tIns="0" rIns="0" bIns="0" rtlCol="0" anchor="t"/>
+          <a:lstStyle/>
+          <a:p>
+            <a:pPr indent="0" marL="0">
+              <a:buNone/>
+            </a:pPr>
+            <a:r>
+              <a:rPr lang="en-US" sz="3000" dirty="0">
+                <a:solidFill>
+                  <a:schemeClr val="tx1"/>
+                </a:solidFill>
+                <a:latin typeface="Georgia" pitchFamily="34" charset="0"/>
+                <a:ea typeface="Georgia" pitchFamily="34" charset="-122"/>
+                <a:cs typeface="Georgia" pitchFamily="34" charset="-120"/>
+              </a:rPr>
+              <a:t>5</a:t>
+            </a:r>
+            <a:endParaRPr lang="en-US" sz="3000" dirty="0"/>
+          </a:p>
+        </p:txBody>
+      </p:sp>
+      <p:sp>
+        <p:nvSpPr>
+          <p:cNvPr id="17" name="Text 15"/>
+          <p:cNvSpPr txBox="1"/>
+          <p:nvPr/>
+        </p:nvSpPr>
+        <p:spPr>
+          <a:xfrm>
+            <a:off x="1234440" y="5230368"/>
+            <a:ext cx="6035040" cy="347472"/>
+          </a:xfrm>
+          <a:prstGeom prst="rect">
+            <a:avLst/>
+          </a:prstGeom>
+          <a:noFill/>
+          <a:ln/>
+        </p:spPr>
+        <p:txBody>
+          <a:bodyPr wrap="square" lIns="0" tIns="0" rIns="0" bIns="0" rtlCol="0" anchor="t"/>
+          <a:lstStyle/>
+          <a:p>
+            <a:pPr indent="0" marL="0">
+              <a:buNone/>
+            </a:pPr>
+            <a:r>
+              <a:rPr lang="en-US" sz="1800" dirty="0">
+                <a:solidFill>
+                  <a:schemeClr val="tx1"/>
+                </a:solidFill>
+                <a:latin typeface="Georgia" pitchFamily="34" charset="0"/>
+                <a:ea typeface="Georgia" pitchFamily="34" charset="-122"/>
+                <a:cs typeface="Georgia" pitchFamily="34" charset="-120"/>
+              </a:rPr>
+              <a:t>Repeat</a:t>
+            </a:r>
+            <a:endParaRPr lang="en-US" sz="1800" dirty="0"/>
+          </a:p>
+        </p:txBody>
+      </p:sp>
+      <p:sp>
+        <p:nvSpPr>
+          <p:cNvPr id="18" name="Text 16"/>
+          <p:cNvSpPr txBox="1"/>
+          <p:nvPr/>
+        </p:nvSpPr>
+        <p:spPr>
+          <a:xfrm>
+            <a:off x="1234440" y="5596128"/>
+            <a:ext cx="6035040" cy="411480"/>
+          </a:xfrm>
+          <a:prstGeom prst="rect">
+            <a:avLst/>
+          </a:prstGeom>
+          <a:noFill/>
+          <a:ln/>
+        </p:spPr>
+        <p:txBody>
+          <a:bodyPr wrap="square" lIns="0" tIns="0" rIns="0" bIns="0" rtlCol="0" anchor="t"/>
+          <a:lstStyle/>
+          <a:p>
+            <a:pPr indent="0" marL="0">
+              <a:buNone/>
+            </a:pPr>
+            <a:r>
+              <a:rPr lang="en-US" sz="1300" dirty="0">
+                <a:solidFill>
+                  <a:schemeClr val="tx2"/>
+                </a:solidFill>
+              </a:rPr>
+              <a:t>Switch the filter to Video, then move to the next month</a:t>
+            </a:r>
+            <a:endParaRPr lang="en-US" sz="1300" dirty="0"/>
+          </a:p>
+        </p:txBody>
+      </p:sp>
+      <p:sp>
+        <p:nvSpPr>
+          <p:cNvPr id="19" name="dv filter example"/>
           <p:cNvSpPr/>
           <p:nvPr/>
         </p:nvSpPr>
         <p:spPr>
           <a:xfrm>
-            <a:off x="7040880" y="2057400"/>
-            <a:ext cx="4602175" cy="3108960"/>
+            <a:off x="7680960" y="2057400"/>
+            <a:ext cx="3962095" cy="3657600"/>
           </a:xfrm>
           <a:prstGeom prst="rect">
             <a:avLst/>
@@ -12800,14 +13118,14 @@
       </p:sp>
       <p:sp>
         <p:nvSpPr>
-          <p:cNvPr id="14" name="Text 12"/>
+          <p:cNvPr id="20" name="Text 18"/>
           <p:cNvSpPr txBox="1"/>
           <p:nvPr/>
         </p:nvSpPr>
         <p:spPr>
           <a:xfrm>
-            <a:off x="7360920" y="2331720"/>
-            <a:ext cx="4114800" cy="320040"/>
+            <a:off x="8001000" y="2331720"/>
+            <a:ext cx="3291840" cy="274320"/>
           </a:xfrm>
           <a:prstGeom prst="rect">
             <a:avLst/>
@@ -12823,27 +13141,27 @@
               <a:buNone/>
             </a:pPr>
             <a:r>
-              <a:rPr lang="en-US" sz="1200" b="1" spc="200" kern="0" dirty="0">
+              <a:rPr lang="en-US" sz="1100" b="1" spc="200" kern="0" dirty="0">
                 <a:solidFill>
                   <a:schemeClr val="tx2"/>
                 </a:solidFill>
               </a:rPr>
-              <a:t>GA4 SOURCE OF RECORD</a:t>
+              <a:t>EXAMPLE · JULY 2026</a:t>
             </a:r>
-            <a:endParaRPr lang="en-US" sz="1200" dirty="0"/>
+            <a:endParaRPr lang="en-US" sz="1100" dirty="0"/>
           </a:p>
         </p:txBody>
       </p:sp>
       <p:sp>
         <p:nvSpPr>
-          <p:cNvPr id="15" name="Text 13"/>
+          <p:cNvPr id="21" name="Text 19"/>
           <p:cNvSpPr txBox="1"/>
           <p:nvPr/>
         </p:nvSpPr>
         <p:spPr>
           <a:xfrm>
-            <a:off x="7360920" y="2788920"/>
-            <a:ext cx="4023360" cy="731520"/>
+            <a:off x="8001000" y="2743200"/>
+            <a:ext cx="3291840" cy="1280160"/>
           </a:xfrm>
           <a:prstGeom prst="rect">
             <a:avLst/>
@@ -12854,6 +13172,20 @@
         <p:txBody>
           <a:bodyPr wrap="square" lIns="0" tIns="0" rIns="0" bIns="0" rtlCol="0" anchor="t"/>
           <a:lstStyle/>
+          <a:p>
+            <a:pPr indent="0" marL="0">
+              <a:buNone/>
+            </a:pPr>
+            <a:r>
+              <a:rPr lang="en-US" sz="1500" b="1" dirty="0">
+                <a:solidFill>
+                  <a:schemeClr val="tx1"/>
+                </a:solidFill>
+              </a:rPr>
+              <a:t>Media Type</a:t>
+            </a:r>
+            <a:endParaRPr lang="en-US" sz="1500" dirty="0"/>
+          </a:p>
           <a:p>
             <a:pPr indent="0" marL="0">
               <a:buNone/>
@@ -12864,7 +13196,7 @@
                   <a:schemeClr val="tx1"/>
                 </a:solidFill>
               </a:rPr>
-              <a:t>Account 131632414 · property 359317277</a:t>
+              <a:t>■ Display   193.4M</a:t>
             </a:r>
             <a:endParaRPr lang="en-US" sz="1500" dirty="0"/>
           </a:p>
@@ -12873,57 +13205,64 @@
               <a:buNone/>
             </a:pPr>
             <a:r>
-              <a:rPr lang="en-US" sz="1500" u="sng" dirty="0">
+              <a:rPr lang="en-US" sz="1500" dirty="0">
                 <a:solidFill>
                   <a:schemeClr val="tx1"/>
                 </a:solidFill>
-                <a:hlinkClick r:id="rId1" invalidUrl="" action="" tgtFrame="" tooltip="" history="1" highlightClick="0" endSnd="0">
-                  <a:extLst>
-                    <a:ext uri="{A12FA001-AC4F-418D-AE19-62706E023703}">
-                      <ahyp:hlinkClr xmlns:ahyp="http://schemas.microsoft.com/office/drawing/2018/hyperlinkcolor" val="tx"/>
-                    </a:ext>
-                  </a:extLst>
-                </a:hlinkClick>
               </a:rPr>
-              <a:t>Open saved exploration</a:t>
+              <a:t>□ Video        25.5M</a:t>
             </a:r>
             <a:endParaRPr lang="en-US" sz="1500" dirty="0"/>
           </a:p>
-        </p:txBody>
-      </p:sp>
-      <p:sp>
-        <p:nvSpPr>
-          <p:cNvPr id="16" name="Text 14"/>
-          <p:cNvSpPr txBox="1"/>
-          <p:nvPr/>
-        </p:nvSpPr>
-        <p:spPr>
-          <a:xfrm>
-            <a:off x="7360920" y="3657600"/>
-            <a:ext cx="4023360" cy="1280160"/>
-          </a:xfrm>
-          <a:prstGeom prst="rect">
-            <a:avLst/>
-          </a:prstGeom>
-          <a:noFill/>
-          <a:ln/>
-        </p:spPr>
-        <p:txBody>
-          <a:bodyPr wrap="square" lIns="0" tIns="0" rIns="0" bIns="0" rtlCol="0" anchor="t"/>
-          <a:lstStyle/>
           <a:p>
             <a:pPr indent="0" marL="0">
               <a:buNone/>
             </a:pPr>
             <a:r>
-              <a:rPr lang="en-US" sz="1400" dirty="0">
+              <a:rPr lang="en-US" sz="1500" dirty="0">
+                <a:solidFill>
+                  <a:schemeClr val="tx1"/>
+                </a:solidFill>
+              </a:rPr>
+              <a:t>□ null              131</a:t>
+            </a:r>
+            <a:endParaRPr lang="en-US" sz="1500" dirty="0"/>
+          </a:p>
+        </p:txBody>
+      </p:sp>
+      <p:sp>
+        <p:nvSpPr>
+          <p:cNvPr id="22" name="Text 20"/>
+          <p:cNvSpPr txBox="1"/>
+          <p:nvPr/>
+        </p:nvSpPr>
+        <p:spPr>
+          <a:xfrm>
+            <a:off x="8001000" y="4206240"/>
+            <a:ext cx="3291840" cy="1280160"/>
+          </a:xfrm>
+          <a:prstGeom prst="rect">
+            <a:avLst/>
+          </a:prstGeom>
+          <a:noFill/>
+          <a:ln/>
+        </p:spPr>
+        <p:txBody>
+          <a:bodyPr wrap="square" lIns="0" tIns="0" rIns="0" bIns="0" rtlCol="0" anchor="t"/>
+          <a:lstStyle/>
+          <a:p>
+            <a:pPr indent="0" marL="0">
+              <a:buNone/>
+            </a:pPr>
+            <a:r>
+              <a:rPr lang="en-US" sz="1300" dirty="0">
                 <a:solidFill>
                   <a:schemeClr val="tx2"/>
                 </a:solidFill>
               </a:rPr>
-              <a:t>Set the date range to the quarter and copy web Views per month. Save a copy under a shared account so the link survives staff changes.</a:t>
+              <a:t>193.4M is the display figure in the workbook for July. The tile rounds to 0.1M; export the report for exact counts.</a:t>
             </a:r>
-            <a:endParaRPr lang="en-US" sz="1400" dirty="0"/>
+            <a:endParaRPr lang="en-US" sz="1300" dirty="0"/>
           </a:p>
         </p:txBody>
       </p:sp>
@@ -13002,16 +13341,16 @@
       </p:grpSpPr>
       <p:sp>
         <p:nvSpPr>
-          <p:cNvPr id="2" name="Text 0"/>
+          <p:cNvPr id="2" name="Text 1"/>
           <p:cNvSpPr/>
           <p:nvPr>
-            <p:ph idx="100" type="body" hasCustomPrompt="1"/>
+            <p:ph idx="101" type="body" hasCustomPrompt="1"/>
           </p:nvPr>
         </p:nvSpPr>
         <p:spPr>
           <a:xfrm>
-            <a:off x="548640" y="1463040"/>
-            <a:ext cx="3657600" cy="1828800"/>
+            <a:off x="749808" y="457200"/>
+            <a:ext cx="8229600" cy="329184"/>
           </a:xfrm>
           <a:prstGeom prst="rect">
             <a:avLst/>
@@ -13020,39 +13359,75 @@
           <a:ln/>
         </p:spPr>
         <p:txBody>
-          <a:bodyPr wrap="square" lIns="0" tIns="0" rIns="0" bIns="0" rtlCol="0"/>
+          <a:bodyPr wrap="square" lIns="0" tIns="0" rIns="0" bIns="0" rtlCol="0" anchor="ctr"/>
           <a:lstStyle/>
           <a:p>
             <a:pPr indent="0" marL="0">
               <a:buNone/>
             </a:pPr>
             <a:r>
-              <a:rPr lang="en-US" sz="12000" dirty="0">
+              <a:rPr lang="en-US" sz="1200" b="1" spc="300" kern="0" dirty="0">
                 <a:solidFill>
-                  <a:schemeClr val="accent1"/>
+                  <a:schemeClr val="tx2"/>
+                </a:solidFill>
+              </a:rPr>
+              <a:t>STEP 3 · GA4 AND DV PRE-BID</a:t>
+            </a:r>
+            <a:endParaRPr lang="en-US" sz="1200" dirty="0"/>
+          </a:p>
+        </p:txBody>
+      </p:sp>
+      <p:sp>
+        <p:nvSpPr>
+          <p:cNvPr id="3" name="Text 1"/>
+          <p:cNvSpPr/>
+          <p:nvPr>
+            <p:ph idx="102" type="title" hasCustomPrompt="1"/>
+          </p:nvPr>
+        </p:nvSpPr>
+        <p:spPr>
+          <a:xfrm>
+            <a:off x="548640" y="868680"/>
+            <a:ext cx="11094415" cy="868680"/>
+          </a:xfrm>
+          <a:prstGeom prst="rect">
+            <a:avLst/>
+          </a:prstGeom>
+          <a:noFill/>
+          <a:ln/>
+        </p:spPr>
+        <p:txBody>
+          <a:bodyPr wrap="square" lIns="0" tIns="0" rIns="0" bIns="0" rtlCol="0" anchor="t"/>
+          <a:lstStyle/>
+          <a:p>
+            <a:pPr algn="l" indent="0" marL="0">
+              <a:buNone/>
+            </a:pPr>
+            <a:r>
+              <a:rPr lang="en-US" sz="3400" dirty="0">
+                <a:solidFill>
+                  <a:schemeClr val="tx1"/>
                 </a:solidFill>
                 <a:latin typeface="Georgia" pitchFamily="34" charset="0"/>
                 <a:ea typeface="Georgia" pitchFamily="34" charset="-122"/>
                 <a:cs typeface="Georgia" pitchFamily="34" charset="-120"/>
               </a:rPr>
-              <a:t>03</a:t>
+              <a:t>Pageviews against pre-bid requests</a:t>
             </a:r>
-            <a:endParaRPr lang="en-US" sz="12000" dirty="0"/>
+            <a:endParaRPr lang="en-US" sz="3400" dirty="0"/>
           </a:p>
         </p:txBody>
       </p:sp>
       <p:sp>
         <p:nvSpPr>
-          <p:cNvPr id="3" name="Text 0"/>
-          <p:cNvSpPr/>
-          <p:nvPr>
-            <p:ph idx="101" type="title" hasCustomPrompt="1"/>
-          </p:nvPr>
-        </p:nvSpPr>
-        <p:spPr>
-          <a:xfrm>
-            <a:off x="548640" y="3474720"/>
-            <a:ext cx="10515600" cy="1188720"/>
+          <p:cNvPr id="4" name="Text 2"/>
+          <p:cNvSpPr txBox="1"/>
+          <p:nvPr/>
+        </p:nvSpPr>
+        <p:spPr>
+          <a:xfrm>
+            <a:off x="548640" y="2057400"/>
+            <a:ext cx="731520" cy="731520"/>
           </a:xfrm>
           <a:prstGeom prst="rect">
             <a:avLst/>
@@ -13064,36 +13439,34 @@
           <a:bodyPr wrap="square" lIns="0" tIns="0" rIns="0" bIns="0" rtlCol="0" anchor="t"/>
           <a:lstStyle/>
           <a:p>
-            <a:pPr algn="l" indent="0" marL="0">
+            <a:pPr indent="0" marL="0">
               <a:buNone/>
             </a:pPr>
             <a:r>
-              <a:rPr lang="en-US" sz="4400" dirty="0">
+              <a:rPr lang="en-US" sz="4000" dirty="0">
                 <a:solidFill>
-                  <a:schemeClr val="bg1"/>
+                  <a:schemeClr val="tx1"/>
                 </a:solidFill>
                 <a:latin typeface="Georgia" pitchFamily="34" charset="0"/>
                 <a:ea typeface="Georgia" pitchFamily="34" charset="-122"/>
                 <a:cs typeface="Georgia" pitchFamily="34" charset="-120"/>
               </a:rPr>
-              <a:t>Quarter math and the deck</a:t>
+              <a:t>1</a:t>
             </a:r>
-            <a:endParaRPr lang="en-US" sz="4400" dirty="0"/>
+            <a:endParaRPr lang="en-US" sz="4000" dirty="0"/>
           </a:p>
         </p:txBody>
       </p:sp>
       <p:sp>
         <p:nvSpPr>
-          <p:cNvPr id="4" name="Text 0"/>
-          <p:cNvSpPr/>
-          <p:nvPr>
-            <p:ph idx="102" type="body" hasCustomPrompt="1"/>
-          </p:nvPr>
-        </p:nvSpPr>
-        <p:spPr>
-          <a:xfrm>
-            <a:off x="548640" y="4709160"/>
-            <a:ext cx="9601200" cy="1097280"/>
+          <p:cNvPr id="5" name="Text 3"/>
+          <p:cNvSpPr txBox="1"/>
+          <p:nvPr/>
+        </p:nvSpPr>
+        <p:spPr>
+          <a:xfrm>
+            <a:off x="1463040" y="2103120"/>
+            <a:ext cx="5486400" cy="365760"/>
           </a:xfrm>
           <a:prstGeom prst="rect">
             <a:avLst/>
@@ -13109,14 +13482,483 @@
               <a:buNone/>
             </a:pPr>
             <a:r>
-              <a:rPr lang="en-US" sz="1800" dirty="0">
+              <a:rPr lang="en-US" sz="1900" dirty="0">
                 <a:solidFill>
-                  <a:schemeClr val="bg2"/>
+                  <a:schemeClr val="tx1"/>
+                </a:solidFill>
+                <a:latin typeface="Georgia" pitchFamily="34" charset="0"/>
+                <a:ea typeface="Georgia" pitchFamily="34" charset="-122"/>
+                <a:cs typeface="Georgia" pitchFamily="34" charset="-120"/>
+              </a:rPr>
+              <a:t>Pageviews</a:t>
+            </a:r>
+            <a:endParaRPr lang="en-US" sz="1900" dirty="0"/>
+          </a:p>
+        </p:txBody>
+      </p:sp>
+      <p:sp>
+        <p:nvSpPr>
+          <p:cNvPr id="6" name="Text 4"/>
+          <p:cNvSpPr txBox="1"/>
+          <p:nvPr/>
+        </p:nvSpPr>
+        <p:spPr>
+          <a:xfrm>
+            <a:off x="1463040" y="2496312"/>
+            <a:ext cx="5486400" cy="548640"/>
+          </a:xfrm>
+          <a:prstGeom prst="rect">
+            <a:avLst/>
+          </a:prstGeom>
+          <a:noFill/>
+          <a:ln/>
+        </p:spPr>
+        <p:txBody>
+          <a:bodyPr wrap="square" lIns="0" tIns="0" rIns="0" bIns="0" rtlCol="0" anchor="t"/>
+          <a:lstStyle/>
+          <a:p>
+            <a:pPr indent="0" marL="0">
+              <a:buNone/>
+            </a:pPr>
+            <a:r>
+              <a:rPr lang="en-US" sz="1400" dirty="0">
+                <a:solidFill>
+                  <a:schemeClr val="tx2"/>
                 </a:solidFill>
               </a:rPr>
-              <a:t>Months become quarters, quarters become slides</a:t>
+              <a:t>GA4 saved exploration: Year month × Platform, metric Views, Platform = web</a:t>
             </a:r>
-            <a:endParaRPr lang="en-US" sz="1800" dirty="0"/>
+            <a:endParaRPr lang="en-US" sz="1400" dirty="0"/>
+          </a:p>
+        </p:txBody>
+      </p:sp>
+      <p:sp>
+        <p:nvSpPr>
+          <p:cNvPr id="7" name="Text 5"/>
+          <p:cNvSpPr txBox="1"/>
+          <p:nvPr/>
+        </p:nvSpPr>
+        <p:spPr>
+          <a:xfrm>
+            <a:off x="548640" y="3154680"/>
+            <a:ext cx="731520" cy="731520"/>
+          </a:xfrm>
+          <a:prstGeom prst="rect">
+            <a:avLst/>
+          </a:prstGeom>
+          <a:noFill/>
+          <a:ln/>
+        </p:spPr>
+        <p:txBody>
+          <a:bodyPr wrap="square" lIns="0" tIns="0" rIns="0" bIns="0" rtlCol="0" anchor="t"/>
+          <a:lstStyle/>
+          <a:p>
+            <a:pPr indent="0" marL="0">
+              <a:buNone/>
+            </a:pPr>
+            <a:r>
+              <a:rPr lang="en-US" sz="4000" dirty="0">
+                <a:solidFill>
+                  <a:schemeClr val="tx1"/>
+                </a:solidFill>
+                <a:latin typeface="Georgia" pitchFamily="34" charset="0"/>
+                <a:ea typeface="Georgia" pitchFamily="34" charset="-122"/>
+                <a:cs typeface="Georgia" pitchFamily="34" charset="-120"/>
+              </a:rPr>
+              <a:t>2</a:t>
+            </a:r>
+            <a:endParaRPr lang="en-US" sz="4000" dirty="0"/>
+          </a:p>
+        </p:txBody>
+      </p:sp>
+      <p:sp>
+        <p:nvSpPr>
+          <p:cNvPr id="8" name="Text 6"/>
+          <p:cNvSpPr txBox="1"/>
+          <p:nvPr/>
+        </p:nvSpPr>
+        <p:spPr>
+          <a:xfrm>
+            <a:off x="1463040" y="3200400"/>
+            <a:ext cx="5486400" cy="365760"/>
+          </a:xfrm>
+          <a:prstGeom prst="rect">
+            <a:avLst/>
+          </a:prstGeom>
+          <a:noFill/>
+          <a:ln/>
+        </p:spPr>
+        <p:txBody>
+          <a:bodyPr wrap="square" lIns="0" tIns="0" rIns="0" bIns="0" rtlCol="0" anchor="t"/>
+          <a:lstStyle/>
+          <a:p>
+            <a:pPr indent="0" marL="0">
+              <a:buNone/>
+            </a:pPr>
+            <a:r>
+              <a:rPr lang="en-US" sz="1900" dirty="0">
+                <a:solidFill>
+                  <a:schemeClr val="tx1"/>
+                </a:solidFill>
+                <a:latin typeface="Georgia" pitchFamily="34" charset="0"/>
+                <a:ea typeface="Georgia" pitchFamily="34" charset="-122"/>
+                <a:cs typeface="Georgia" pitchFamily="34" charset="-120"/>
+              </a:rPr>
+              <a:t>Prebid Reqs</a:t>
+            </a:r>
+            <a:endParaRPr lang="en-US" sz="1900" dirty="0"/>
+          </a:p>
+        </p:txBody>
+      </p:sp>
+      <p:sp>
+        <p:nvSpPr>
+          <p:cNvPr id="9" name="Text 7"/>
+          <p:cNvSpPr txBox="1"/>
+          <p:nvPr/>
+        </p:nvSpPr>
+        <p:spPr>
+          <a:xfrm>
+            <a:off x="1463040" y="3593592"/>
+            <a:ext cx="5486400" cy="548640"/>
+          </a:xfrm>
+          <a:prstGeom prst="rect">
+            <a:avLst/>
+          </a:prstGeom>
+          <a:noFill/>
+          <a:ln/>
+        </p:spPr>
+        <p:txBody>
+          <a:bodyPr wrap="square" lIns="0" tIns="0" rIns="0" bIns="0" rtlCol="0" anchor="t"/>
+          <a:lstStyle/>
+          <a:p>
+            <a:pPr indent="0" marL="0">
+              <a:buNone/>
+            </a:pPr>
+            <a:r>
+              <a:rPr lang="en-US" sz="1400" dirty="0">
+                <a:solidFill>
+                  <a:schemeClr val="tx2"/>
+                </a:solidFill>
+              </a:rPr>
+              <a:t>DV pre-bid page-level requests for the month</a:t>
+            </a:r>
+            <a:endParaRPr lang="en-US" sz="1400" dirty="0"/>
+          </a:p>
+        </p:txBody>
+      </p:sp>
+      <p:sp>
+        <p:nvSpPr>
+          <p:cNvPr id="10" name="Text 8"/>
+          <p:cNvSpPr txBox="1"/>
+          <p:nvPr/>
+        </p:nvSpPr>
+        <p:spPr>
+          <a:xfrm>
+            <a:off x="548640" y="4251960"/>
+            <a:ext cx="731520" cy="731520"/>
+          </a:xfrm>
+          <a:prstGeom prst="rect">
+            <a:avLst/>
+          </a:prstGeom>
+          <a:noFill/>
+          <a:ln/>
+        </p:spPr>
+        <p:txBody>
+          <a:bodyPr wrap="square" lIns="0" tIns="0" rIns="0" bIns="0" rtlCol="0" anchor="t"/>
+          <a:lstStyle/>
+          <a:p>
+            <a:pPr indent="0" marL="0">
+              <a:buNone/>
+            </a:pPr>
+            <a:r>
+              <a:rPr lang="en-US" sz="4000" dirty="0">
+                <a:solidFill>
+                  <a:schemeClr val="tx1"/>
+                </a:solidFill>
+                <a:latin typeface="Georgia" pitchFamily="34" charset="0"/>
+                <a:ea typeface="Georgia" pitchFamily="34" charset="-122"/>
+                <a:cs typeface="Georgia" pitchFamily="34" charset="-120"/>
+              </a:rPr>
+              <a:t>3</a:t>
+            </a:r>
+            <a:endParaRPr lang="en-US" sz="4000" dirty="0"/>
+          </a:p>
+        </p:txBody>
+      </p:sp>
+      <p:sp>
+        <p:nvSpPr>
+          <p:cNvPr id="11" name="Text 9"/>
+          <p:cNvSpPr txBox="1"/>
+          <p:nvPr/>
+        </p:nvSpPr>
+        <p:spPr>
+          <a:xfrm>
+            <a:off x="1463040" y="4297680"/>
+            <a:ext cx="5486400" cy="365760"/>
+          </a:xfrm>
+          <a:prstGeom prst="rect">
+            <a:avLst/>
+          </a:prstGeom>
+          <a:noFill/>
+          <a:ln/>
+        </p:spPr>
+        <p:txBody>
+          <a:bodyPr wrap="square" lIns="0" tIns="0" rIns="0" bIns="0" rtlCol="0" anchor="t"/>
+          <a:lstStyle/>
+          <a:p>
+            <a:pPr indent="0" marL="0">
+              <a:buNone/>
+            </a:pPr>
+            <a:r>
+              <a:rPr lang="en-US" sz="1900" dirty="0">
+                <a:solidFill>
+                  <a:schemeClr val="tx1"/>
+                </a:solidFill>
+                <a:latin typeface="Georgia" pitchFamily="34" charset="0"/>
+                <a:ea typeface="Georgia" pitchFamily="34" charset="-122"/>
+                <a:cs typeface="Georgia" pitchFamily="34" charset="-120"/>
+              </a:rPr>
+              <a:t>Discrepancy</a:t>
+            </a:r>
+            <a:endParaRPr lang="en-US" sz="1900" dirty="0"/>
+          </a:p>
+        </p:txBody>
+      </p:sp>
+      <p:sp>
+        <p:nvSpPr>
+          <p:cNvPr id="12" name="Text 10"/>
+          <p:cNvSpPr txBox="1"/>
+          <p:nvPr/>
+        </p:nvSpPr>
+        <p:spPr>
+          <a:xfrm>
+            <a:off x="1463040" y="4690872"/>
+            <a:ext cx="5486400" cy="548640"/>
+          </a:xfrm>
+          <a:prstGeom prst="rect">
+            <a:avLst/>
+          </a:prstGeom>
+          <a:noFill/>
+          <a:ln/>
+        </p:spPr>
+        <p:txBody>
+          <a:bodyPr wrap="square" lIns="0" tIns="0" rIns="0" bIns="0" rtlCol="0" anchor="t"/>
+          <a:lstStyle/>
+          <a:p>
+            <a:pPr indent="0" marL="0">
+              <a:buNone/>
+            </a:pPr>
+            <a:r>
+              <a:rPr lang="en-US" sz="1400" dirty="0">
+                <a:solidFill>
+                  <a:schemeClr val="tx2"/>
+                </a:solidFill>
+              </a:rPr>
+              <a:t>Formula already in the sheet. Don't overwrite it</a:t>
+            </a:r>
+            <a:endParaRPr lang="en-US" sz="1400" dirty="0"/>
+          </a:p>
+        </p:txBody>
+      </p:sp>
+      <p:sp>
+        <p:nvSpPr>
+          <p:cNvPr id="13" name="ga4 card"/>
+          <p:cNvSpPr/>
+          <p:nvPr/>
+        </p:nvSpPr>
+        <p:spPr>
+          <a:xfrm>
+            <a:off x="7040880" y="2057400"/>
+            <a:ext cx="4602175" cy="3108960"/>
+          </a:xfrm>
+          <a:prstGeom prst="rect">
+            <a:avLst/>
+          </a:prstGeom>
+          <a:solidFill>
+            <a:schemeClr val="bg2"/>
+          </a:solidFill>
+          <a:ln w="9525">
+            <a:solidFill>
+              <a:srgbClr val="E7E0C9"/>
+            </a:solidFill>
+            <a:prstDash val="solid"/>
+          </a:ln>
+        </p:spPr>
+      </p:sp>
+      <p:sp>
+        <p:nvSpPr>
+          <p:cNvPr id="14" name="Text 12"/>
+          <p:cNvSpPr txBox="1"/>
+          <p:nvPr/>
+        </p:nvSpPr>
+        <p:spPr>
+          <a:xfrm>
+            <a:off x="7360920" y="2331720"/>
+            <a:ext cx="4114800" cy="320040"/>
+          </a:xfrm>
+          <a:prstGeom prst="rect">
+            <a:avLst/>
+          </a:prstGeom>
+          <a:noFill/>
+          <a:ln/>
+        </p:spPr>
+        <p:txBody>
+          <a:bodyPr wrap="square" lIns="0" tIns="0" rIns="0" bIns="0" rtlCol="0" anchor="t"/>
+          <a:lstStyle/>
+          <a:p>
+            <a:pPr indent="0" marL="0">
+              <a:buNone/>
+            </a:pPr>
+            <a:r>
+              <a:rPr lang="en-US" sz="1200" b="1" spc="200" kern="0" dirty="0">
+                <a:solidFill>
+                  <a:schemeClr val="tx2"/>
+                </a:solidFill>
+              </a:rPr>
+              <a:t>GA4 SOURCE OF RECORD</a:t>
+            </a:r>
+            <a:endParaRPr lang="en-US" sz="1200" dirty="0"/>
+          </a:p>
+        </p:txBody>
+      </p:sp>
+      <p:sp>
+        <p:nvSpPr>
+          <p:cNvPr id="15" name="Text 13"/>
+          <p:cNvSpPr txBox="1"/>
+          <p:nvPr/>
+        </p:nvSpPr>
+        <p:spPr>
+          <a:xfrm>
+            <a:off x="7360920" y="2788920"/>
+            <a:ext cx="4023360" cy="731520"/>
+          </a:xfrm>
+          <a:prstGeom prst="rect">
+            <a:avLst/>
+          </a:prstGeom>
+          <a:noFill/>
+          <a:ln/>
+        </p:spPr>
+        <p:txBody>
+          <a:bodyPr wrap="square" lIns="0" tIns="0" rIns="0" bIns="0" rtlCol="0" anchor="t"/>
+          <a:lstStyle/>
+          <a:p>
+            <a:pPr indent="0" marL="0">
+              <a:buNone/>
+            </a:pPr>
+            <a:r>
+              <a:rPr lang="en-US" sz="1500" dirty="0">
+                <a:solidFill>
+                  <a:schemeClr val="tx1"/>
+                </a:solidFill>
+              </a:rPr>
+              <a:t>Account 131632414 · property 359317277</a:t>
+            </a:r>
+            <a:endParaRPr lang="en-US" sz="1500" dirty="0"/>
+          </a:p>
+          <a:p>
+            <a:pPr indent="0" marL="0">
+              <a:buNone/>
+            </a:pPr>
+            <a:r>
+              <a:rPr lang="en-US" sz="1500" u="sng" dirty="0">
+                <a:solidFill>
+                  <a:schemeClr val="tx1"/>
+                </a:solidFill>
+                <a:hlinkClick r:id="rId1" invalidUrl="" action="" tgtFrame="" tooltip="" history="1" highlightClick="0" endSnd="0">
+                  <a:extLst>
+                    <a:ext uri="{A12FA001-AC4F-418D-AE19-62706E023703}">
+                      <ahyp:hlinkClr xmlns:ahyp="http://schemas.microsoft.com/office/drawing/2018/hyperlinkcolor" val="tx"/>
+                    </a:ext>
+                  </a:extLst>
+                </a:hlinkClick>
+              </a:rPr>
+              <a:t>Open saved exploration</a:t>
+            </a:r>
+            <a:endParaRPr lang="en-US" sz="1500" dirty="0"/>
+          </a:p>
+        </p:txBody>
+      </p:sp>
+      <p:sp>
+        <p:nvSpPr>
+          <p:cNvPr id="16" name="Text 14"/>
+          <p:cNvSpPr txBox="1"/>
+          <p:nvPr/>
+        </p:nvSpPr>
+        <p:spPr>
+          <a:xfrm>
+            <a:off x="7360920" y="3657600"/>
+            <a:ext cx="4023360" cy="1280160"/>
+          </a:xfrm>
+          <a:prstGeom prst="rect">
+            <a:avLst/>
+          </a:prstGeom>
+          <a:noFill/>
+          <a:ln/>
+        </p:spPr>
+        <p:txBody>
+          <a:bodyPr wrap="square" lIns="0" tIns="0" rIns="0" bIns="0" rtlCol="0" anchor="t"/>
+          <a:lstStyle/>
+          <a:p>
+            <a:pPr indent="0" marL="0">
+              <a:buNone/>
+            </a:pPr>
+            <a:r>
+              <a:rPr lang="en-US" sz="1400" dirty="0">
+                <a:solidFill>
+                  <a:schemeClr val="tx2"/>
+                </a:solidFill>
+              </a:rPr>
+              <a:t>Set the date range to the quarter and copy web Views per month. Save a copy under a shared account so the link survives staff changes.</a:t>
+            </a:r>
+            <a:endParaRPr lang="en-US" sz="1400" dirty="0"/>
+          </a:p>
+        </p:txBody>
+      </p:sp>
+      <p:sp>
+        <p:nvSpPr>
+          <p:cNvPr id="25" name="Slide Number Placeholder 0"/>
+          <p:cNvSpPr>
+            <a:spLocks noGrp="1"/>
+          </p:cNvSpPr>
+          <p:nvPr>
+            <p:ph type="sldNum" sz="quarter" idx="4294967295"/>
+          </p:nvPr>
+        </p:nvSpPr>
+        <p:spPr>
+          <a:xfrm>
+            <a:off x="548640" y="6400800"/>
+            <a:ext cx="914400" cy="274320"/>
+          </a:xfrm>
+          <a:prstGeom prst="rect">
+            <a:avLst/>
+          </a:prstGeom>
+          <a:extLst>
+            <a:ext uri="{C572A759-6A51-4108-AA02-DFA0A04FC94B}">
+              <ma14:wrappingTextBoxFlag xmlns:ma14="http://schemas.microsoft.com/office/mac/drawingml/2011/main" val="0"/>
+            </a:ext>
+          </a:extLst>
+        </p:spPr>
+        <p:txBody>
+          <a:bodyPr/>
+          <a:lstStyle>
+            <a:lvl1pPr>
+              <a:defRPr sz="1000">
+                <a:solidFill>
+                  <a:srgbClr val="8C887B"/>
+                </a:solidFill>
+                <a:latin typeface="Arial"/>
+                <a:ea typeface="Arial"/>
+                <a:cs typeface="Arial"/>
+              </a:defRPr>
+            </a:lvl1pPr>
+          </a:lstStyle>
+          <a:p>
+            <a:pPr algn="l"/>
+            <a:fld id="{F7021451-1387-4CA6-816F-3879F97B5CBC}" type="slidenum">
+              <a:rPr b="0" lang="en-US"/>
+              <a:t>19</a:t>
+            </a:fld>
+            <a:endParaRPr lang="en-US"/>
           </a:p>
         </p:txBody>
       </p:sp>
@@ -13875,16 +14717,16 @@
       </p:grpSpPr>
       <p:sp>
         <p:nvSpPr>
-          <p:cNvPr id="2" name="Text 1"/>
+          <p:cNvPr id="2" name="Text 0"/>
           <p:cNvSpPr/>
           <p:nvPr>
-            <p:ph idx="101" type="body" hasCustomPrompt="1"/>
+            <p:ph idx="100" type="body" hasCustomPrompt="1"/>
           </p:nvPr>
         </p:nvSpPr>
         <p:spPr>
           <a:xfrm>
-            <a:off x="749808" y="457200"/>
-            <a:ext cx="8229600" cy="329184"/>
+            <a:off x="548640" y="1463040"/>
+            <a:ext cx="3657600" cy="1828800"/>
           </a:xfrm>
           <a:prstGeom prst="rect">
             <a:avLst/>
@@ -13893,100 +14735,39 @@
           <a:ln/>
         </p:spPr>
         <p:txBody>
-          <a:bodyPr wrap="square" lIns="0" tIns="0" rIns="0" bIns="0" rtlCol="0" anchor="ctr"/>
+          <a:bodyPr wrap="square" lIns="0" tIns="0" rIns="0" bIns="0" rtlCol="0"/>
           <a:lstStyle/>
           <a:p>
             <a:pPr indent="0" marL="0">
               <a:buNone/>
             </a:pPr>
             <a:r>
-              <a:rPr lang="en-US" sz="1200" b="1" spc="300" kern="0" dirty="0">
+              <a:rPr lang="en-US" sz="12000" dirty="0">
                 <a:solidFill>
-                  <a:schemeClr val="tx2"/>
-                </a:solidFill>
-              </a:rPr>
-              <a:t>STEP 4 · ROLL MONTHS INTO QUARTERS</a:t>
-            </a:r>
-            <a:endParaRPr lang="en-US" sz="1200" dirty="0"/>
-          </a:p>
-        </p:txBody>
-      </p:sp>
-      <p:sp>
-        <p:nvSpPr>
-          <p:cNvPr id="3" name="Text 1"/>
-          <p:cNvSpPr/>
-          <p:nvPr>
-            <p:ph idx="102" type="title" hasCustomPrompt="1"/>
-          </p:nvPr>
-        </p:nvSpPr>
-        <p:spPr>
-          <a:xfrm>
-            <a:off x="548640" y="868680"/>
-            <a:ext cx="11094415" cy="868680"/>
-          </a:xfrm>
-          <a:prstGeom prst="rect">
-            <a:avLst/>
-          </a:prstGeom>
-          <a:noFill/>
-          <a:ln/>
-        </p:spPr>
-        <p:txBody>
-          <a:bodyPr wrap="square" lIns="0" tIns="0" rIns="0" bIns="0" rtlCol="0" anchor="t"/>
-          <a:lstStyle/>
-          <a:p>
-            <a:pPr algn="l" indent="0" marL="0">
-              <a:buNone/>
-            </a:pPr>
-            <a:r>
-              <a:rPr lang="en-US" sz="3400" dirty="0">
-                <a:solidFill>
-                  <a:schemeClr val="tx1"/>
+                  <a:schemeClr val="accent1"/>
                 </a:solidFill>
                 <a:latin typeface="Georgia" pitchFamily="34" charset="0"/>
                 <a:ea typeface="Georgia" pitchFamily="34" charset="-122"/>
                 <a:cs typeface="Georgia" pitchFamily="34" charset="-120"/>
               </a:rPr>
-              <a:t>Weight SIVT by impressions, never average</a:t>
+              <a:t>03</a:t>
             </a:r>
-            <a:endParaRPr lang="en-US" sz="3400" dirty="0"/>
+            <a:endParaRPr lang="en-US" sz="12000" dirty="0"/>
           </a:p>
         </p:txBody>
       </p:sp>
       <p:sp>
         <p:nvSpPr>
-          <p:cNvPr id="4" name="formula 1"/>
+          <p:cNvPr id="3" name="Text 0"/>
           <p:cNvSpPr/>
-          <p:nvPr/>
-        </p:nvSpPr>
-        <p:spPr>
-          <a:xfrm>
-            <a:off x="548640" y="2057400"/>
-            <a:ext cx="5669280" cy="960120"/>
-          </a:xfrm>
-          <a:prstGeom prst="rect">
-            <a:avLst/>
-          </a:prstGeom>
-          <a:solidFill>
-            <a:schemeClr val="bg1"/>
-          </a:solidFill>
-          <a:ln w="9525">
-            <a:solidFill>
-              <a:srgbClr val="E7E0C9"/>
-            </a:solidFill>
-            <a:prstDash val="solid"/>
-          </a:ln>
-        </p:spPr>
-      </p:sp>
-      <p:sp>
-        <p:nvSpPr>
-          <p:cNvPr id="5" name="Text 3"/>
-          <p:cNvSpPr txBox="1"/>
-          <p:nvPr/>
-        </p:nvSpPr>
-        <p:spPr>
-          <a:xfrm>
-            <a:off x="822960" y="2194560"/>
-            <a:ext cx="5120640" cy="274320"/>
+          <p:nvPr>
+            <p:ph idx="101" type="title" hasCustomPrompt="1"/>
+          </p:nvPr>
+        </p:nvSpPr>
+        <p:spPr>
+          <a:xfrm>
+            <a:off x="548640" y="3474720"/>
+            <a:ext cx="10515600" cy="1188720"/>
           </a:xfrm>
           <a:prstGeom prst="rect">
             <a:avLst/>
@@ -13998,95 +14779,36 @@
           <a:bodyPr wrap="square" lIns="0" tIns="0" rIns="0" bIns="0" rtlCol="0" anchor="t"/>
           <a:lstStyle/>
           <a:p>
-            <a:pPr indent="0" marL="0">
+            <a:pPr algn="l" indent="0" marL="0">
               <a:buNone/>
             </a:pPr>
             <a:r>
-              <a:rPr lang="en-US" sz="1100" b="1" spc="200" kern="0" dirty="0">
+              <a:rPr lang="en-US" sz="4400" dirty="0">
                 <a:solidFill>
-                  <a:schemeClr val="tx2"/>
-                </a:solidFill>
-              </a:rPr>
-              <a:t>QUARTER SIVT</a:t>
-            </a:r>
-            <a:endParaRPr lang="en-US" sz="1100" dirty="0"/>
-          </a:p>
-        </p:txBody>
-      </p:sp>
-      <p:sp>
-        <p:nvSpPr>
-          <p:cNvPr id="6" name="Text 4"/>
-          <p:cNvSpPr txBox="1"/>
-          <p:nvPr/>
-        </p:nvSpPr>
-        <p:spPr>
-          <a:xfrm>
-            <a:off x="822960" y="2441448"/>
-            <a:ext cx="5212080" cy="502920"/>
-          </a:xfrm>
-          <a:prstGeom prst="rect">
-            <a:avLst/>
-          </a:prstGeom>
-          <a:noFill/>
-          <a:ln/>
-        </p:spPr>
-        <p:txBody>
-          <a:bodyPr wrap="square" lIns="0" tIns="0" rIns="0" bIns="0" rtlCol="0" anchor="t"/>
-          <a:lstStyle/>
-          <a:p>
-            <a:pPr indent="0" marL="0">
-              <a:buNone/>
-            </a:pPr>
-            <a:r>
-              <a:rPr lang="en-US" sz="1400" dirty="0">
-                <a:solidFill>
-                  <a:schemeClr val="tx1"/>
+                  <a:schemeClr val="bg1"/>
                 </a:solidFill>
                 <a:latin typeface="Georgia" pitchFamily="34" charset="0"/>
                 <a:ea typeface="Georgia" pitchFamily="34" charset="-122"/>
                 <a:cs typeface="Georgia" pitchFamily="34" charset="-120"/>
               </a:rPr>
-              <a:t>Σ(DV post-bid impressions × SIVT Rate) ÷ Σ DV post-bid impressions</a:t>
+              <a:t>Quarter math and the deck</a:t>
             </a:r>
-            <a:endParaRPr lang="en-US" sz="1400" dirty="0"/>
+            <a:endParaRPr lang="en-US" sz="4400" dirty="0"/>
           </a:p>
         </p:txBody>
       </p:sp>
       <p:sp>
         <p:nvSpPr>
-          <p:cNvPr id="7" name="formula 2"/>
+          <p:cNvPr id="4" name="Text 0"/>
           <p:cNvSpPr/>
-          <p:nvPr/>
-        </p:nvSpPr>
-        <p:spPr>
-          <a:xfrm>
-            <a:off x="548640" y="3200400"/>
-            <a:ext cx="5669280" cy="960120"/>
-          </a:xfrm>
-          <a:prstGeom prst="rect">
-            <a:avLst/>
-          </a:prstGeom>
-          <a:solidFill>
-            <a:schemeClr val="bg1"/>
-          </a:solidFill>
-          <a:ln w="9525">
-            <a:solidFill>
-              <a:srgbClr val="E7E0C9"/>
-            </a:solidFill>
-            <a:prstDash val="solid"/>
-          </a:ln>
-        </p:spPr>
-      </p:sp>
-      <p:sp>
-        <p:nvSpPr>
-          <p:cNvPr id="8" name="Text 6"/>
-          <p:cNvSpPr txBox="1"/>
-          <p:nvPr/>
-        </p:nvSpPr>
-        <p:spPr>
-          <a:xfrm>
-            <a:off x="822960" y="3337560"/>
-            <a:ext cx="5120640" cy="274320"/>
+          <p:nvPr>
+            <p:ph idx="102" type="body" hasCustomPrompt="1"/>
+          </p:nvPr>
+        </p:nvSpPr>
+        <p:spPr>
+          <a:xfrm>
+            <a:off x="548640" y="4709160"/>
+            <a:ext cx="9601200" cy="1097280"/>
           </a:xfrm>
           <a:prstGeom prst="rect">
             <a:avLst/>
@@ -14102,217 +14824,14 @@
               <a:buNone/>
             </a:pPr>
             <a:r>
-              <a:rPr lang="en-US" sz="1100" b="1" spc="200" kern="0" dirty="0">
+              <a:rPr lang="en-US" sz="1800" dirty="0">
                 <a:solidFill>
-                  <a:schemeClr val="tx2"/>
+                  <a:schemeClr val="bg2"/>
                 </a:solidFill>
               </a:rPr>
-              <a:t>OVERALL SIVT</a:t>
+              <a:t>Months become quarters, quarters become slides</a:t>
             </a:r>
-            <a:endParaRPr lang="en-US" sz="1100" dirty="0"/>
-          </a:p>
-        </p:txBody>
-      </p:sp>
-      <p:sp>
-        <p:nvSpPr>
-          <p:cNvPr id="9" name="Text 7"/>
-          <p:cNvSpPr txBox="1"/>
-          <p:nvPr/>
-        </p:nvSpPr>
-        <p:spPr>
-          <a:xfrm>
-            <a:off x="822960" y="3584448"/>
-            <a:ext cx="5212080" cy="502920"/>
-          </a:xfrm>
-          <a:prstGeom prst="rect">
-            <a:avLst/>
-          </a:prstGeom>
-          <a:noFill/>
-          <a:ln/>
-        </p:spPr>
-        <p:txBody>
-          <a:bodyPr wrap="square" lIns="0" tIns="0" rIns="0" bIns="0" rtlCol="0" anchor="t"/>
-          <a:lstStyle/>
-          <a:p>
-            <a:pPr indent="0" marL="0">
-              <a:buNone/>
-            </a:pPr>
-            <a:r>
-              <a:rPr lang="en-US" sz="1400" dirty="0">
-                <a:solidFill>
-                  <a:schemeClr val="tx1"/>
-                </a:solidFill>
-                <a:latin typeface="Georgia" pitchFamily="34" charset="0"/>
-                <a:ea typeface="Georgia" pitchFamily="34" charset="-122"/>
-                <a:cs typeface="Georgia" pitchFamily="34" charset="-120"/>
-              </a:rPr>
-              <a:t>The same, with display and video summed together</a:t>
-            </a:r>
-            <a:endParaRPr lang="en-US" sz="1400" dirty="0"/>
-          </a:p>
-        </p:txBody>
-      </p:sp>
-      <p:sp>
-        <p:nvSpPr>
-          <p:cNvPr id="10" name="formula 3"/>
-          <p:cNvSpPr/>
-          <p:nvPr/>
-        </p:nvSpPr>
-        <p:spPr>
-          <a:xfrm>
-            <a:off x="548640" y="4343400"/>
-            <a:ext cx="5669280" cy="960120"/>
-          </a:xfrm>
-          <a:prstGeom prst="rect">
-            <a:avLst/>
-          </a:prstGeom>
-          <a:solidFill>
-            <a:schemeClr val="bg1"/>
-          </a:solidFill>
-          <a:ln w="9525">
-            <a:solidFill>
-              <a:srgbClr val="E7E0C9"/>
-            </a:solidFill>
-            <a:prstDash val="solid"/>
-          </a:ln>
-        </p:spPr>
-      </p:sp>
-      <p:sp>
-        <p:nvSpPr>
-          <p:cNvPr id="11" name="Text 9"/>
-          <p:cNvSpPr txBox="1"/>
-          <p:nvPr/>
-        </p:nvSpPr>
-        <p:spPr>
-          <a:xfrm>
-            <a:off x="822960" y="4480560"/>
-            <a:ext cx="5120640" cy="274320"/>
-          </a:xfrm>
-          <a:prstGeom prst="rect">
-            <a:avLst/>
-          </a:prstGeom>
-          <a:noFill/>
-          <a:ln/>
-        </p:spPr>
-        <p:txBody>
-          <a:bodyPr wrap="square" lIns="0" tIns="0" rIns="0" bIns="0" rtlCol="0" anchor="t"/>
-          <a:lstStyle/>
-          <a:p>
-            <a:pPr indent="0" marL="0">
-              <a:buNone/>
-            </a:pPr>
-            <a:r>
-              <a:rPr lang="en-US" sz="1100" b="1" spc="200" kern="0" dirty="0">
-                <a:solidFill>
-                  <a:schemeClr val="tx2"/>
-                </a:solidFill>
-              </a:rPr>
-              <a:t>DISCREPANCY</a:t>
-            </a:r>
-            <a:endParaRPr lang="en-US" sz="1100" dirty="0"/>
-          </a:p>
-        </p:txBody>
-      </p:sp>
-      <p:sp>
-        <p:nvSpPr>
-          <p:cNvPr id="12" name="Text 10"/>
-          <p:cNvSpPr txBox="1"/>
-          <p:nvPr/>
-        </p:nvSpPr>
-        <p:spPr>
-          <a:xfrm>
-            <a:off x="822960" y="4727448"/>
-            <a:ext cx="5212080" cy="502920"/>
-          </a:xfrm>
-          <a:prstGeom prst="rect">
-            <a:avLst/>
-          </a:prstGeom>
-          <a:noFill/>
-          <a:ln/>
-        </p:spPr>
-        <p:txBody>
-          <a:bodyPr wrap="square" lIns="0" tIns="0" rIns="0" bIns="0" rtlCol="0" anchor="t"/>
-          <a:lstStyle/>
-          <a:p>
-            <a:pPr indent="0" marL="0">
-              <a:buNone/>
-            </a:pPr>
-            <a:r>
-              <a:rPr lang="en-US" sz="1400" dirty="0">
-                <a:solidFill>
-                  <a:schemeClr val="tx1"/>
-                </a:solidFill>
-                <a:latin typeface="Georgia" pitchFamily="34" charset="0"/>
-                <a:ea typeface="Georgia" pitchFamily="34" charset="-122"/>
-                <a:cs typeface="Georgia" pitchFamily="34" charset="-120"/>
-              </a:rPr>
-              <a:t>(Σ pageviews − Σ pre-bid) ÷ Σ pageviews</a:t>
-            </a:r>
-            <a:endParaRPr lang="en-US" sz="1400" dirty="0"/>
-          </a:p>
-        </p:txBody>
-      </p:sp>
-      <p:graphicFrame>
-        <p:nvGraphicFramePr>
-          <p:cNvPr id="13" name="discrepancy chart" descr=""/>
-          <p:cNvGraphicFramePr/>
-          <p:nvPr/>
-        </p:nvGraphicFramePr>
-        <p:xfrm>
-          <a:off x="6675120" y="1965960"/>
-          <a:ext cx="4967935" cy="3749040"/>
-        </p:xfrm>
-        <a:graphic xmlns:a="http://schemas.openxmlformats.org/drawingml/2006/main">
-          <a:graphicData uri="http://schemas.openxmlformats.org/drawingml/2006/chart">
-            <c:chart xmlns:c="http://schemas.openxmlformats.org/drawingml/2006/chart" r:id="rId1"/>
-          </a:graphicData>
-        </a:graphic>
-      </p:graphicFrame>
-      <p:sp>
-        <p:nvSpPr>
-          <p:cNvPr id="25" name="Slide Number Placeholder 0"/>
-          <p:cNvSpPr>
-            <a:spLocks noGrp="1"/>
-          </p:cNvSpPr>
-          <p:nvPr>
-            <p:ph type="sldNum" sz="quarter" idx="4294967295"/>
-          </p:nvPr>
-        </p:nvSpPr>
-        <p:spPr>
-          <a:xfrm>
-            <a:off x="548640" y="6400800"/>
-            <a:ext cx="914400" cy="274320"/>
-          </a:xfrm>
-          <a:prstGeom prst="rect">
-            <a:avLst/>
-          </a:prstGeom>
-          <a:extLst>
-            <a:ext uri="{C572A759-6A51-4108-AA02-DFA0A04FC94B}">
-              <ma14:wrappingTextBoxFlag xmlns:ma14="http://schemas.microsoft.com/office/mac/drawingml/2011/main" val="0"/>
-            </a:ext>
-          </a:extLst>
-        </p:spPr>
-        <p:txBody>
-          <a:bodyPr/>
-          <a:lstStyle>
-            <a:lvl1pPr>
-              <a:defRPr sz="1000">
-                <a:solidFill>
-                  <a:srgbClr val="8C887B"/>
-                </a:solidFill>
-                <a:latin typeface="Arial"/>
-                <a:ea typeface="Arial"/>
-                <a:cs typeface="Arial"/>
-              </a:defRPr>
-            </a:lvl1pPr>
-          </a:lstStyle>
-          <a:p>
-            <a:pPr algn="l"/>
-            <a:fld id="{F7021451-1387-4CA6-816F-3879F97B5CBC}" type="slidenum">
-              <a:rPr b="0" lang="en-US"/>
-              <a:t>20</a:t>
-            </a:fld>
-            <a:endParaRPr lang="en-US"/>
+            <a:endParaRPr lang="en-US" sz="1800" dirty="0"/>
           </a:p>
         </p:txBody>
       </p:sp>
@@ -14373,6 +14892,474 @@
                   <a:schemeClr val="tx2"/>
                 </a:solidFill>
               </a:rPr>
+              <a:t>STEP 4 · ROLL MONTHS INTO QUARTERS</a:t>
+            </a:r>
+            <a:endParaRPr lang="en-US" sz="1200" dirty="0"/>
+          </a:p>
+        </p:txBody>
+      </p:sp>
+      <p:sp>
+        <p:nvSpPr>
+          <p:cNvPr id="3" name="Text 1"/>
+          <p:cNvSpPr/>
+          <p:nvPr>
+            <p:ph idx="102" type="title" hasCustomPrompt="1"/>
+          </p:nvPr>
+        </p:nvSpPr>
+        <p:spPr>
+          <a:xfrm>
+            <a:off x="548640" y="868680"/>
+            <a:ext cx="11094415" cy="868680"/>
+          </a:xfrm>
+          <a:prstGeom prst="rect">
+            <a:avLst/>
+          </a:prstGeom>
+          <a:noFill/>
+          <a:ln/>
+        </p:spPr>
+        <p:txBody>
+          <a:bodyPr wrap="square" lIns="0" tIns="0" rIns="0" bIns="0" rtlCol="0" anchor="t"/>
+          <a:lstStyle/>
+          <a:p>
+            <a:pPr algn="l" indent="0" marL="0">
+              <a:buNone/>
+            </a:pPr>
+            <a:r>
+              <a:rPr lang="en-US" sz="3400" dirty="0">
+                <a:solidFill>
+                  <a:schemeClr val="tx1"/>
+                </a:solidFill>
+                <a:latin typeface="Georgia" pitchFamily="34" charset="0"/>
+                <a:ea typeface="Georgia" pitchFamily="34" charset="-122"/>
+                <a:cs typeface="Georgia" pitchFamily="34" charset="-120"/>
+              </a:rPr>
+              <a:t>Weight SIVT by impressions, never average</a:t>
+            </a:r>
+            <a:endParaRPr lang="en-US" sz="3400" dirty="0"/>
+          </a:p>
+        </p:txBody>
+      </p:sp>
+      <p:sp>
+        <p:nvSpPr>
+          <p:cNvPr id="4" name="formula 1"/>
+          <p:cNvSpPr/>
+          <p:nvPr/>
+        </p:nvSpPr>
+        <p:spPr>
+          <a:xfrm>
+            <a:off x="548640" y="2057400"/>
+            <a:ext cx="5669280" cy="960120"/>
+          </a:xfrm>
+          <a:prstGeom prst="rect">
+            <a:avLst/>
+          </a:prstGeom>
+          <a:solidFill>
+            <a:schemeClr val="bg1"/>
+          </a:solidFill>
+          <a:ln w="9525">
+            <a:solidFill>
+              <a:srgbClr val="E7E0C9"/>
+            </a:solidFill>
+            <a:prstDash val="solid"/>
+          </a:ln>
+        </p:spPr>
+      </p:sp>
+      <p:sp>
+        <p:nvSpPr>
+          <p:cNvPr id="5" name="Text 3"/>
+          <p:cNvSpPr txBox="1"/>
+          <p:nvPr/>
+        </p:nvSpPr>
+        <p:spPr>
+          <a:xfrm>
+            <a:off x="822960" y="2194560"/>
+            <a:ext cx="5120640" cy="274320"/>
+          </a:xfrm>
+          <a:prstGeom prst="rect">
+            <a:avLst/>
+          </a:prstGeom>
+          <a:noFill/>
+          <a:ln/>
+        </p:spPr>
+        <p:txBody>
+          <a:bodyPr wrap="square" lIns="0" tIns="0" rIns="0" bIns="0" rtlCol="0" anchor="t"/>
+          <a:lstStyle/>
+          <a:p>
+            <a:pPr indent="0" marL="0">
+              <a:buNone/>
+            </a:pPr>
+            <a:r>
+              <a:rPr lang="en-US" sz="1100" b="1" spc="200" kern="0" dirty="0">
+                <a:solidFill>
+                  <a:schemeClr val="tx2"/>
+                </a:solidFill>
+              </a:rPr>
+              <a:t>QUARTER SIVT</a:t>
+            </a:r>
+            <a:endParaRPr lang="en-US" sz="1100" dirty="0"/>
+          </a:p>
+        </p:txBody>
+      </p:sp>
+      <p:sp>
+        <p:nvSpPr>
+          <p:cNvPr id="6" name="Text 4"/>
+          <p:cNvSpPr txBox="1"/>
+          <p:nvPr/>
+        </p:nvSpPr>
+        <p:spPr>
+          <a:xfrm>
+            <a:off x="822960" y="2441448"/>
+            <a:ext cx="5212080" cy="502920"/>
+          </a:xfrm>
+          <a:prstGeom prst="rect">
+            <a:avLst/>
+          </a:prstGeom>
+          <a:noFill/>
+          <a:ln/>
+        </p:spPr>
+        <p:txBody>
+          <a:bodyPr wrap="square" lIns="0" tIns="0" rIns="0" bIns="0" rtlCol="0" anchor="t"/>
+          <a:lstStyle/>
+          <a:p>
+            <a:pPr indent="0" marL="0">
+              <a:buNone/>
+            </a:pPr>
+            <a:r>
+              <a:rPr lang="en-US" sz="1400" dirty="0">
+                <a:solidFill>
+                  <a:schemeClr val="tx1"/>
+                </a:solidFill>
+                <a:latin typeface="Georgia" pitchFamily="34" charset="0"/>
+                <a:ea typeface="Georgia" pitchFamily="34" charset="-122"/>
+                <a:cs typeface="Georgia" pitchFamily="34" charset="-120"/>
+              </a:rPr>
+              <a:t>Σ(DV post-bid impressions × SIVT Rate) ÷ Σ DV post-bid impressions</a:t>
+            </a:r>
+            <a:endParaRPr lang="en-US" sz="1400" dirty="0"/>
+          </a:p>
+        </p:txBody>
+      </p:sp>
+      <p:sp>
+        <p:nvSpPr>
+          <p:cNvPr id="7" name="formula 2"/>
+          <p:cNvSpPr/>
+          <p:nvPr/>
+        </p:nvSpPr>
+        <p:spPr>
+          <a:xfrm>
+            <a:off x="548640" y="3200400"/>
+            <a:ext cx="5669280" cy="960120"/>
+          </a:xfrm>
+          <a:prstGeom prst="rect">
+            <a:avLst/>
+          </a:prstGeom>
+          <a:solidFill>
+            <a:schemeClr val="bg1"/>
+          </a:solidFill>
+          <a:ln w="9525">
+            <a:solidFill>
+              <a:srgbClr val="E7E0C9"/>
+            </a:solidFill>
+            <a:prstDash val="solid"/>
+          </a:ln>
+        </p:spPr>
+      </p:sp>
+      <p:sp>
+        <p:nvSpPr>
+          <p:cNvPr id="8" name="Text 6"/>
+          <p:cNvSpPr txBox="1"/>
+          <p:nvPr/>
+        </p:nvSpPr>
+        <p:spPr>
+          <a:xfrm>
+            <a:off x="822960" y="3337560"/>
+            <a:ext cx="5120640" cy="274320"/>
+          </a:xfrm>
+          <a:prstGeom prst="rect">
+            <a:avLst/>
+          </a:prstGeom>
+          <a:noFill/>
+          <a:ln/>
+        </p:spPr>
+        <p:txBody>
+          <a:bodyPr wrap="square" lIns="0" tIns="0" rIns="0" bIns="0" rtlCol="0" anchor="t"/>
+          <a:lstStyle/>
+          <a:p>
+            <a:pPr indent="0" marL="0">
+              <a:buNone/>
+            </a:pPr>
+            <a:r>
+              <a:rPr lang="en-US" sz="1100" b="1" spc="200" kern="0" dirty="0">
+                <a:solidFill>
+                  <a:schemeClr val="tx2"/>
+                </a:solidFill>
+              </a:rPr>
+              <a:t>OVERALL SIVT</a:t>
+            </a:r>
+            <a:endParaRPr lang="en-US" sz="1100" dirty="0"/>
+          </a:p>
+        </p:txBody>
+      </p:sp>
+      <p:sp>
+        <p:nvSpPr>
+          <p:cNvPr id="9" name="Text 7"/>
+          <p:cNvSpPr txBox="1"/>
+          <p:nvPr/>
+        </p:nvSpPr>
+        <p:spPr>
+          <a:xfrm>
+            <a:off x="822960" y="3584448"/>
+            <a:ext cx="5212080" cy="502920"/>
+          </a:xfrm>
+          <a:prstGeom prst="rect">
+            <a:avLst/>
+          </a:prstGeom>
+          <a:noFill/>
+          <a:ln/>
+        </p:spPr>
+        <p:txBody>
+          <a:bodyPr wrap="square" lIns="0" tIns="0" rIns="0" bIns="0" rtlCol="0" anchor="t"/>
+          <a:lstStyle/>
+          <a:p>
+            <a:pPr indent="0" marL="0">
+              <a:buNone/>
+            </a:pPr>
+            <a:r>
+              <a:rPr lang="en-US" sz="1400" dirty="0">
+                <a:solidFill>
+                  <a:schemeClr val="tx1"/>
+                </a:solidFill>
+                <a:latin typeface="Georgia" pitchFamily="34" charset="0"/>
+                <a:ea typeface="Georgia" pitchFamily="34" charset="-122"/>
+                <a:cs typeface="Georgia" pitchFamily="34" charset="-120"/>
+              </a:rPr>
+              <a:t>The same, with display and video summed together</a:t>
+            </a:r>
+            <a:endParaRPr lang="en-US" sz="1400" dirty="0"/>
+          </a:p>
+        </p:txBody>
+      </p:sp>
+      <p:sp>
+        <p:nvSpPr>
+          <p:cNvPr id="10" name="formula 3"/>
+          <p:cNvSpPr/>
+          <p:nvPr/>
+        </p:nvSpPr>
+        <p:spPr>
+          <a:xfrm>
+            <a:off x="548640" y="4343400"/>
+            <a:ext cx="5669280" cy="960120"/>
+          </a:xfrm>
+          <a:prstGeom prst="rect">
+            <a:avLst/>
+          </a:prstGeom>
+          <a:solidFill>
+            <a:schemeClr val="bg1"/>
+          </a:solidFill>
+          <a:ln w="9525">
+            <a:solidFill>
+              <a:srgbClr val="E7E0C9"/>
+            </a:solidFill>
+            <a:prstDash val="solid"/>
+          </a:ln>
+        </p:spPr>
+      </p:sp>
+      <p:sp>
+        <p:nvSpPr>
+          <p:cNvPr id="11" name="Text 9"/>
+          <p:cNvSpPr txBox="1"/>
+          <p:nvPr/>
+        </p:nvSpPr>
+        <p:spPr>
+          <a:xfrm>
+            <a:off x="822960" y="4480560"/>
+            <a:ext cx="5120640" cy="274320"/>
+          </a:xfrm>
+          <a:prstGeom prst="rect">
+            <a:avLst/>
+          </a:prstGeom>
+          <a:noFill/>
+          <a:ln/>
+        </p:spPr>
+        <p:txBody>
+          <a:bodyPr wrap="square" lIns="0" tIns="0" rIns="0" bIns="0" rtlCol="0" anchor="t"/>
+          <a:lstStyle/>
+          <a:p>
+            <a:pPr indent="0" marL="0">
+              <a:buNone/>
+            </a:pPr>
+            <a:r>
+              <a:rPr lang="en-US" sz="1100" b="1" spc="200" kern="0" dirty="0">
+                <a:solidFill>
+                  <a:schemeClr val="tx2"/>
+                </a:solidFill>
+              </a:rPr>
+              <a:t>DISCREPANCY</a:t>
+            </a:r>
+            <a:endParaRPr lang="en-US" sz="1100" dirty="0"/>
+          </a:p>
+        </p:txBody>
+      </p:sp>
+      <p:sp>
+        <p:nvSpPr>
+          <p:cNvPr id="12" name="Text 10"/>
+          <p:cNvSpPr txBox="1"/>
+          <p:nvPr/>
+        </p:nvSpPr>
+        <p:spPr>
+          <a:xfrm>
+            <a:off x="822960" y="4727448"/>
+            <a:ext cx="5212080" cy="502920"/>
+          </a:xfrm>
+          <a:prstGeom prst="rect">
+            <a:avLst/>
+          </a:prstGeom>
+          <a:noFill/>
+          <a:ln/>
+        </p:spPr>
+        <p:txBody>
+          <a:bodyPr wrap="square" lIns="0" tIns="0" rIns="0" bIns="0" rtlCol="0" anchor="t"/>
+          <a:lstStyle/>
+          <a:p>
+            <a:pPr indent="0" marL="0">
+              <a:buNone/>
+            </a:pPr>
+            <a:r>
+              <a:rPr lang="en-US" sz="1400" dirty="0">
+                <a:solidFill>
+                  <a:schemeClr val="tx1"/>
+                </a:solidFill>
+                <a:latin typeface="Georgia" pitchFamily="34" charset="0"/>
+                <a:ea typeface="Georgia" pitchFamily="34" charset="-122"/>
+                <a:cs typeface="Georgia" pitchFamily="34" charset="-120"/>
+              </a:rPr>
+              <a:t>(Σ pageviews − Σ pre-bid) ÷ Σ pageviews</a:t>
+            </a:r>
+            <a:endParaRPr lang="en-US" sz="1400" dirty="0"/>
+          </a:p>
+        </p:txBody>
+      </p:sp>
+      <p:graphicFrame>
+        <p:nvGraphicFramePr>
+          <p:cNvPr id="13" name="discrepancy chart" descr=""/>
+          <p:cNvGraphicFramePr/>
+          <p:nvPr/>
+        </p:nvGraphicFramePr>
+        <p:xfrm>
+          <a:off x="6675120" y="1965960"/>
+          <a:ext cx="4967935" cy="3749040"/>
+        </p:xfrm>
+        <a:graphic xmlns:a="http://schemas.openxmlformats.org/drawingml/2006/main">
+          <a:graphicData uri="http://schemas.openxmlformats.org/drawingml/2006/chart">
+            <c:chart xmlns:c="http://schemas.openxmlformats.org/drawingml/2006/chart" r:id="rId1"/>
+          </a:graphicData>
+        </a:graphic>
+      </p:graphicFrame>
+      <p:sp>
+        <p:nvSpPr>
+          <p:cNvPr id="25" name="Slide Number Placeholder 0"/>
+          <p:cNvSpPr>
+            <a:spLocks noGrp="1"/>
+          </p:cNvSpPr>
+          <p:nvPr>
+            <p:ph type="sldNum" sz="quarter" idx="4294967295"/>
+          </p:nvPr>
+        </p:nvSpPr>
+        <p:spPr>
+          <a:xfrm>
+            <a:off x="548640" y="6400800"/>
+            <a:ext cx="914400" cy="274320"/>
+          </a:xfrm>
+          <a:prstGeom prst="rect">
+            <a:avLst/>
+          </a:prstGeom>
+          <a:extLst>
+            <a:ext uri="{C572A759-6A51-4108-AA02-DFA0A04FC94B}">
+              <ma14:wrappingTextBoxFlag xmlns:ma14="http://schemas.microsoft.com/office/mac/drawingml/2011/main" val="0"/>
+            </a:ext>
+          </a:extLst>
+        </p:spPr>
+        <p:txBody>
+          <a:bodyPr/>
+          <a:lstStyle>
+            <a:lvl1pPr>
+              <a:defRPr sz="1000">
+                <a:solidFill>
+                  <a:srgbClr val="8C887B"/>
+                </a:solidFill>
+                <a:latin typeface="Arial"/>
+                <a:ea typeface="Arial"/>
+                <a:cs typeface="Arial"/>
+              </a:defRPr>
+            </a:lvl1pPr>
+          </a:lstStyle>
+          <a:p>
+            <a:pPr algn="l"/>
+            <a:fld id="{F7021451-1387-4CA6-816F-3879F97B5CBC}" type="slidenum">
+              <a:rPr b="0" lang="en-US"/>
+              <a:t>21</a:t>
+            </a:fld>
+            <a:endParaRPr lang="en-US"/>
+          </a:p>
+        </p:txBody>
+      </p:sp>
+    </p:spTree>
+  </p:cSld>
+  <p:clrMapOvr>
+    <a:masterClrMapping/>
+  </p:clrMapOvr>
+</p:sld>
+</file>
+
+<file path=ppt/slides/slide22.xml><?xml version="1.0" encoding="utf-8"?>
+<p:sld xmlns:a="http://schemas.openxmlformats.org/drawingml/2006/main" xmlns:r="http://schemas.openxmlformats.org/officeDocument/2006/relationships" xmlns:p="http://schemas.openxmlformats.org/presentationml/2006/main">
+  <p:cSld name="Slide 22">
+    <p:spTree>
+      <p:nvGrpSpPr>
+        <p:cNvPr id="1" name=""/>
+        <p:cNvGrpSpPr/>
+        <p:nvPr/>
+      </p:nvGrpSpPr>
+      <p:grpSpPr>
+        <a:xfrm>
+          <a:off x="0" y="0"/>
+          <a:ext cx="0" cy="0"/>
+          <a:chOff x="0" y="0"/>
+          <a:chExt cx="0" cy="0"/>
+        </a:xfrm>
+      </p:grpSpPr>
+      <p:sp>
+        <p:nvSpPr>
+          <p:cNvPr id="2" name="Text 1"/>
+          <p:cNvSpPr/>
+          <p:nvPr>
+            <p:ph idx="101" type="body" hasCustomPrompt="1"/>
+          </p:nvPr>
+        </p:nvSpPr>
+        <p:spPr>
+          <a:xfrm>
+            <a:off x="749808" y="457200"/>
+            <a:ext cx="8229600" cy="329184"/>
+          </a:xfrm>
+          <a:prstGeom prst="rect">
+            <a:avLst/>
+          </a:prstGeom>
+          <a:noFill/>
+          <a:ln/>
+        </p:spPr>
+        <p:txBody>
+          <a:bodyPr wrap="square" lIns="0" tIns="0" rIns="0" bIns="0" rtlCol="0" anchor="ctr"/>
+          <a:lstStyle/>
+          <a:p>
+            <a:pPr indent="0" marL="0">
+              <a:buNone/>
+            </a:pPr>
+            <a:r>
+              <a:rPr lang="en-US" sz="1200" b="1" spc="300" kern="0" dirty="0">
+                <a:solidFill>
+                  <a:schemeClr val="tx2"/>
+                </a:solidFill>
+              </a:rPr>
               <a:t>STEP 5 · UPDATE THE DECK</a:t>
             </a:r>
             <a:endParaRPr lang="en-US" sz="1200" dirty="0"/>
@@ -15006,7 +15993,7 @@
             <a:pPr algn="l"/>
             <a:fld id="{F7021451-1387-4CA6-816F-3879F97B5CBC}" type="slidenum">
               <a:rPr b="0" lang="en-US"/>
-              <a:t>21</a:t>
+              <a:t>22</a:t>
             </a:fld>
             <a:endParaRPr lang="en-US"/>
           </a:p>

</xml_diff>

<commit_message>
docs: drop the 'Newsweek design' label from the guide's source notes
Co-Authored-By: Claude Opus 5.5 <noreply@anthropic.com>
Claude-Session: https://claude.ai/code/session_014udSfWkctWaSTKdEZUW1Gh
</commit_message>
<xml_diff>
--- a/docs/TAG_IVT_Report_Update_Guide.pptx
+++ b/docs/TAG_IVT_Report_Update_Guide.pptx
@@ -128,7 +128,7 @@
   <p:extLst>
     <p:ext uri="{521415D9-36F7-43E2-AB2F-B90AF26B5E84}">
       <p14:sectionLst xmlns:p14="http://schemas.microsoft.com/office/powerpoint/2010/main">
-        <p14:section name="Overview" id="{511c0740-0ad8-a2b6-06d4-2862ec8032cc}">
+        <p14:section name="Overview" id="{1d907725-23ad-01dd-559e-acba5e024381}">
           <p14:sldIdLst>
             <p14:sldId id="256"/>
             <p14:sldId id="257"/>
@@ -143,7 +143,7 @@
             <p14:sldId id="266"/>
           </p14:sldIdLst>
         </p14:section>
-        <p14:section name="1 · GAM" id="{01fef463-e30d-6862-f299-c5b17e0ea3cb}">
+        <p14:section name="1 · GAM" id="{e0d38ab2-a614-d10f-b4bf-8372e87de3da}">
           <p14:sldIdLst>
             <p14:sldId id="267"/>
             <p14:sldId id="268"/>
@@ -151,7 +151,7 @@
             <p14:sldId id="270"/>
           </p14:sldIdLst>
         </p14:section>
-        <p14:section name="2–3 · DV and GA4" id="{e8db03b0-bbfe-e5af-3391-507446752f30}">
+        <p14:section name="2–3 · DV and GA4" id="{86901443-a32c-2a68-39c6-420a91e2a7d4}">
           <p14:sldIdLst>
             <p14:sldId id="271"/>
             <p14:sldId id="272"/>
@@ -159,7 +159,7 @@
             <p14:sldId id="274"/>
           </p14:sldIdLst>
         </p14:section>
-        <p14:section name="4–5 · Math and deck" id="{bcd8d555-8720-a3b8-07f1-46d060da4e1a}">
+        <p14:section name="4–5 · Math and deck" id="{8467ae4f-d3b9-28af-5872-072c1e0baa57}">
           <p14:sldIdLst>
             <p14:sldId id="275"/>
             <p14:sldId id="276"/>
@@ -24463,7 +24463,7 @@
                   <a:schemeClr val="tx2"/>
                 </a:solidFill>
               </a:rPr>
-              <a:t>Newsweek design · 2026 YTD Jan–Sep from the DV-GA workbook · discrepancy = (pageviews − DV pre-bid) ÷ pageviews. Q4 fills in after December closes.</a:t>
+              <a:t>2026 YTD Jan–Sep from the DV-GA workbook · discrepancy = (pageviews − DV pre-bid) ÷ pageviews. Q4 fills in after December closes.</a:t>
             </a:r>
             <a:endParaRPr lang="en-US" sz="1100" dirty="0"/>
           </a:p>
@@ -28089,7 +28089,7 @@
                   <a:schemeClr val="tx2"/>
                 </a:solidFill>
               </a:rPr>
-              <a:t>Newsweek design · 2026 YTD Jan–Sep from the DV-GAM workbook · overall and quarters weighted by DV post-bid impressions. Q4 fills in after December closes.</a:t>
+              <a:t>2026 YTD Jan–Sep from the DV-GAM workbook · overall and quarters weighted by DV post-bid impressions. Q4 fills in after December closes.</a:t>
             </a:r>
             <a:endParaRPr lang="en-US" sz="1100" dirty="0"/>
           </a:p>

</xml_diff>

<commit_message>
TAG IVT: full Ad Exchange for display January; drop the PA card from the guide
Co-Authored-By: Claude Opus 5.5 <noreply@anthropic.com>
Claude-Session: https://claude.ai/code/session_014udSfWkctWaSTKdEZUW1Gh
</commit_message>
<xml_diff>
--- a/docs/TAG_IVT_Report_Update_Guide.pptx
+++ b/docs/TAG_IVT_Report_Update_Guide.pptx
@@ -128,7 +128,7 @@
   <p:extLst>
     <p:ext uri="{521415D9-36F7-43E2-AB2F-B90AF26B5E84}">
       <p14:sectionLst xmlns:p14="http://schemas.microsoft.com/office/powerpoint/2010/main">
-        <p14:section name="Overview" id="{1d907725-23ad-01dd-559e-acba5e024381}">
+        <p14:section name="Overview" id="{f9f30aaf-f8c4-6727-3cd4-d1db2e174e90}">
           <p14:sldIdLst>
             <p14:sldId id="256"/>
             <p14:sldId id="257"/>
@@ -143,7 +143,7 @@
             <p14:sldId id="266"/>
           </p14:sldIdLst>
         </p14:section>
-        <p14:section name="1 · GAM" id="{e0d38ab2-a614-d10f-b4bf-8372e87de3da}">
+        <p14:section name="1 · GAM" id="{ae453b02-5647-bffd-e309-890a6a22eafe}">
           <p14:sldIdLst>
             <p14:sldId id="267"/>
             <p14:sldId id="268"/>
@@ -151,7 +151,7 @@
             <p14:sldId id="270"/>
           </p14:sldIdLst>
         </p14:section>
-        <p14:section name="2–3 · DV and GA4" id="{86901443-a32c-2a68-39c6-420a91e2a7d4}">
+        <p14:section name="2–3 · DV and GA4" id="{6a4747da-f5f0-87a0-8905-dd6ac7b936ca}">
           <p14:sldIdLst>
             <p14:sldId id="271"/>
             <p14:sldId id="272"/>
@@ -159,7 +159,7 @@
             <p14:sldId id="274"/>
           </p14:sldIdLst>
         </p14:section>
-        <p14:section name="4–5 · Math and deck" id="{8467ae4f-d3b9-28af-5872-072c1e0baa57}">
+        <p14:section name="4–5 · Math and deck" id="{5b20602c-7b49-5fc5-b6c5-8edd79c5f263}">
           <p14:sldIdLst>
             <p14:sldId id="275"/>
             <p14:sldId id="276"/>
@@ -11097,7 +11097,7 @@
                 <a:ea typeface="Georgia" pitchFamily="34" charset="-122"/>
                 <a:cs typeface="Georgia" pitchFamily="34" charset="-120"/>
               </a:rPr>
-              <a:t>Three dimension traps, and one fact to remember</a:t>
+              <a:t>Three dimension traps</a:t>
             </a:r>
             <a:endParaRPr lang="en-US" sz="3400" dirty="0"/>
           </a:p>
@@ -11112,7 +11112,7 @@
         <p:spPr>
           <a:xfrm>
             <a:off x="548640" y="2057400"/>
-            <a:ext cx="6035040" cy="1005840"/>
+            <a:ext cx="11094415" cy="1005840"/>
           </a:xfrm>
           <a:prstGeom prst="rect">
             <a:avLst/>
@@ -11198,7 +11198,7 @@
         <p:spPr>
           <a:xfrm>
             <a:off x="1463040" y="2194560"/>
-            <a:ext cx="4937760" cy="731520"/>
+            <a:ext cx="9905695" cy="731520"/>
           </a:xfrm>
           <a:prstGeom prst="rect">
             <a:avLst/>
@@ -11214,14 +11214,14 @@
               <a:buNone/>
             </a:pPr>
             <a:r>
-              <a:rPr lang="en-US" sz="1600" b="1" dirty="0">
+              <a:rPr lang="en-US" sz="1800" b="1" dirty="0">
                 <a:solidFill>
                   <a:schemeClr val="tx1"/>
                 </a:solidFill>
               </a:rPr>
               <a:t>Use Ad unit (top level), not Ad unit</a:t>
             </a:r>
-            <a:endParaRPr lang="en-US" sz="1600" dirty="0"/>
+            <a:endParaRPr lang="en-US" sz="1800" dirty="0"/>
           </a:p>
         </p:txBody>
       </p:sp>
@@ -11234,7 +11234,7 @@
         <p:spPr>
           <a:xfrm>
             <a:off x="548640" y="3246120"/>
-            <a:ext cx="6035040" cy="1005840"/>
+            <a:ext cx="11094415" cy="1005840"/>
           </a:xfrm>
           <a:prstGeom prst="rect">
             <a:avLst/>
@@ -11320,7 +11320,7 @@
         <p:spPr>
           <a:xfrm>
             <a:off x="1463040" y="3383280"/>
-            <a:ext cx="4937760" cy="731520"/>
+            <a:ext cx="9905695" cy="731520"/>
           </a:xfrm>
           <a:prstGeom prst="rect">
             <a:avLst/>
@@ -11336,14 +11336,14 @@
               <a:buNone/>
             </a:pPr>
             <a:r>
-              <a:rPr lang="en-US" sz="1600" b="1" dirty="0">
+              <a:rPr lang="en-US" sz="1800" b="1" dirty="0">
                 <a:solidFill>
                   <a:schemeClr val="tx1"/>
                 </a:solidFill>
               </a:rPr>
               <a:t>Video Ad Exchange: In-stream video + In-stream video or audio</a:t>
             </a:r>
-            <a:endParaRPr lang="en-US" sz="1600" dirty="0"/>
+            <a:endParaRPr lang="en-US" sz="1800" dirty="0"/>
           </a:p>
         </p:txBody>
       </p:sp>
@@ -11356,7 +11356,7 @@
         <p:spPr>
           <a:xfrm>
             <a:off x="548640" y="4434840"/>
-            <a:ext cx="6035040" cy="1005840"/>
+            <a:ext cx="11094415" cy="1005840"/>
           </a:xfrm>
           <a:prstGeom prst="rect">
             <a:avLst/>
@@ -11442,7 +11442,7 @@
         <p:spPr>
           <a:xfrm>
             <a:off x="1463040" y="4572000"/>
-            <a:ext cx="4937760" cy="731520"/>
+            <a:ext cx="9905695" cy="731520"/>
           </a:xfrm>
           <a:prstGeom prst="rect">
             <a:avLst/>
@@ -11458,167 +11458,14 @@
               <a:buNone/>
             </a:pPr>
             <a:r>
-              <a:rPr lang="en-US" sz="1600" b="1" dirty="0">
+              <a:rPr lang="en-US" sz="1800" b="1" dirty="0">
                 <a:solidFill>
                   <a:schemeClr val="tx1"/>
                 </a:solidFill>
               </a:rPr>
               <a:t>Never filter Programmatic channel = Open Auction</a:t>
             </a:r>
-            <a:endParaRPr lang="en-US" sz="1600" dirty="0"/>
-          </a:p>
-        </p:txBody>
-      </p:sp>
-      <p:sp>
-        <p:nvSpPr>
-          <p:cNvPr id="16" name="fact card"/>
-          <p:cNvSpPr/>
-          <p:nvPr/>
-        </p:nvSpPr>
-        <p:spPr>
-          <a:xfrm>
-            <a:off x="7040880" y="2057400"/>
-            <a:ext cx="4602175" cy="3383280"/>
-          </a:xfrm>
-          <a:prstGeom prst="rect">
-            <a:avLst/>
-          </a:prstGeom>
-          <a:solidFill>
-            <a:schemeClr val="bg2"/>
-          </a:solidFill>
-          <a:ln w="9525">
-            <a:solidFill>
-              <a:srgbClr val="E7E0C9"/>
-            </a:solidFill>
-            <a:prstDash val="solid"/>
-          </a:ln>
-        </p:spPr>
-      </p:sp>
-      <p:sp>
-        <p:nvSpPr>
-          <p:cNvPr id="17" name="Text 15"/>
-          <p:cNvSpPr txBox="1"/>
-          <p:nvPr/>
-        </p:nvSpPr>
-        <p:spPr>
-          <a:xfrm>
-            <a:off x="7360920" y="2331720"/>
-            <a:ext cx="4114800" cy="320040"/>
-          </a:xfrm>
-          <a:prstGeom prst="rect">
-            <a:avLst/>
-          </a:prstGeom>
-          <a:noFill/>
-          <a:ln/>
-        </p:spPr>
-        <p:txBody>
-          <a:bodyPr wrap="square" lIns="0" tIns="0" rIns="0" bIns="0" rtlCol="0" anchor="t"/>
-          <a:lstStyle/>
-          <a:p>
-            <a:pPr indent="0" marL="0">
-              <a:buNone/>
-            </a:pPr>
-            <a:r>
-              <a:rPr lang="en-US" sz="1200" b="1" spc="200" kern="0" dirty="0">
-                <a:solidFill>
-                  <a:schemeClr val="tx2"/>
-                </a:solidFill>
-              </a:rPr>
-              <a:t>AD EXCHANGE INCLUDES PRIVATE AUCTION</a:t>
-            </a:r>
-            <a:endParaRPr lang="en-US" sz="1200" dirty="0"/>
-          </a:p>
-        </p:txBody>
-      </p:sp>
-      <p:sp>
-        <p:nvSpPr>
-          <p:cNvPr id="18" name="Text 16"/>
-          <p:cNvSpPr txBox="1"/>
-          <p:nvPr/>
-        </p:nvSpPr>
-        <p:spPr>
-          <a:xfrm>
-            <a:off x="7360920" y="2834640"/>
-            <a:ext cx="4114800" cy="1097280"/>
-          </a:xfrm>
-          <a:prstGeom prst="rect">
-            <a:avLst/>
-          </a:prstGeom>
-          <a:noFill/>
-          <a:ln/>
-        </p:spPr>
-        <p:txBody>
-          <a:bodyPr wrap="square" lIns="0" tIns="0" rIns="0" bIns="0" rtlCol="0" anchor="t"/>
-          <a:lstStyle/>
-          <a:p>
-            <a:pPr indent="0" marL="0">
-              <a:buNone/>
-            </a:pPr>
-            <a:r>
-              <a:rPr lang="en-US" sz="2600" dirty="0">
-                <a:solidFill>
-                  <a:schemeClr val="tx1"/>
-                </a:solidFill>
-                <a:latin typeface="Georgia" pitchFamily="34" charset="0"/>
-                <a:ea typeface="Georgia" pitchFamily="34" charset="-122"/>
-                <a:cs typeface="Georgia" pitchFamily="34" charset="-120"/>
-              </a:rPr>
-              <a:t>48,732,896 + 681,691</a:t>
-            </a:r>
-            <a:endParaRPr lang="en-US" sz="2600" dirty="0"/>
-          </a:p>
-          <a:p>
-            <a:pPr indent="0" marL="0">
-              <a:buNone/>
-            </a:pPr>
-            <a:r>
-              <a:rPr lang="en-US" sz="2600" dirty="0">
-                <a:solidFill>
-                  <a:schemeClr val="tx1"/>
-                </a:solidFill>
-                <a:latin typeface="Georgia" pitchFamily="34" charset="0"/>
-                <a:ea typeface="Georgia" pitchFamily="34" charset="-122"/>
-                <a:cs typeface="Georgia" pitchFamily="34" charset="-120"/>
-              </a:rPr>
-              <a:t>= 49,414,587</a:t>
-            </a:r>
-            <a:endParaRPr lang="en-US" sz="2600" dirty="0"/>
-          </a:p>
-        </p:txBody>
-      </p:sp>
-      <p:sp>
-        <p:nvSpPr>
-          <p:cNvPr id="19" name="Text 17"/>
-          <p:cNvSpPr txBox="1"/>
-          <p:nvPr/>
-        </p:nvSpPr>
-        <p:spPr>
-          <a:xfrm>
-            <a:off x="7360920" y="4069080"/>
-            <a:ext cx="4023360" cy="1188720"/>
-          </a:xfrm>
-          <a:prstGeom prst="rect">
-            <a:avLst/>
-          </a:prstGeom>
-          <a:noFill/>
-          <a:ln/>
-        </p:spPr>
-        <p:txBody>
-          <a:bodyPr wrap="square" lIns="0" tIns="0" rIns="0" bIns="0" rtlCol="0" anchor="t"/>
-          <a:lstStyle/>
-          <a:p>
-            <a:pPr indent="0" marL="0">
-              <a:buNone/>
-            </a:pPr>
-            <a:r>
-              <a:rPr lang="en-US" sz="1400" dirty="0">
-                <a:solidFill>
-                  <a:schemeClr val="tx2"/>
-                </a:solidFill>
-              </a:rPr>
-              <a:t>Open Auction + PA = Ad Exchange, every month (Feb display shown). Never add PA on top of Ad Exchange as a separate source.</a:t>
-            </a:r>
-            <a:endParaRPr lang="en-US" sz="1400" dirty="0"/>
+            <a:endParaRPr lang="en-US" sz="1800" dirty="0"/>
           </a:p>
         </p:txBody>
       </p:sp>

</xml_diff>

<commit_message>
docs: drop IAS from the TAG IVT report guide
Newsweek no longer uses IAS. The report outline now lists GAM filtering
and two pathways (DV + GAM); the final checklist and runbook say to
remove IAS from the coverage slides.

Co-Authored-By: Claude Opus 5.5 <noreply@anthropic.com>
Claude-Session: https://claude.ai/code/session_014udSfWkctWaSTKdEZUW1Gh
</commit_message>
<xml_diff>
--- a/docs/TAG_IVT_Report_Update_Guide.pptx
+++ b/docs/TAG_IVT_Report_Update_Guide.pptx
@@ -138,7 +138,7 @@
   <p:extLst>
     <p:ext uri="{521415D9-36F7-43E2-AB2F-B90AF26B5E84}">
       <p14:sectionLst xmlns:p14="http://schemas.microsoft.com/office/powerpoint/2010/main">
-        <p14:section name="Overview" id="{bedfb6b6-2c9e-8bd4-6c79-96ed5c942a51}">
+        <p14:section name="Overview" id="{20b3f463-b0d5-27ec-9aa5-1f3f63a84f6d}">
           <p14:sldIdLst>
             <p14:sldId id="256"/>
             <p14:sldId id="257"/>
@@ -154,7 +154,7 @@
             <p14:sldId id="267"/>
           </p14:sldIdLst>
         </p14:section>
-        <p14:section name="Step 1 · GAM" id="{e4f7f021-73e2-6bed-c6f0-c2dda3b434d2}">
+        <p14:section name="Step 1 · GAM" id="{575ec512-36eb-4bbd-8cad-8ce8072e2550}">
           <p14:sldIdLst>
             <p14:sldId id="268"/>
             <p14:sldId id="269"/>
@@ -164,33 +164,33 @@
             <p14:sldId id="273"/>
           </p14:sldIdLst>
         </p14:section>
-        <p14:section name="Step 2 · DV" id="{6a4e5997-e455-42e8-5cfe-7206d0fb14c5}">
+        <p14:section name="Step 2 · DV" id="{f06eea11-dc7e-c821-eb6b-3779b712b033}">
           <p14:sldIdLst>
             <p14:sldId id="274"/>
             <p14:sldId id="275"/>
             <p14:sldId id="276"/>
           </p14:sldIdLst>
         </p14:section>
-        <p14:section name="Step 3 · GA4 + pre-bid" id="{e3fed79e-f1c8-abdd-22a3-c23c1303ba2a}">
+        <p14:section name="Step 3 · GA4 + pre-bid" id="{d043862b-039b-df7e-1dde-b50da0d80b8c}">
           <p14:sldIdLst>
             <p14:sldId id="277"/>
             <p14:sldId id="278"/>
           </p14:sldIdLst>
         </p14:section>
-        <p14:section name="Step 4 · Quarter math" id="{fa2c9900-56bc-2a49-930f-3d8a9fd8a67d}">
+        <p14:section name="Step 4 · Quarter math" id="{64b7410f-5bad-1eae-81d2-a77645d0ea65}">
           <p14:sldIdLst>
             <p14:sldId id="279"/>
             <p14:sldId id="280"/>
           </p14:sldIdLst>
         </p14:section>
-        <p14:section name="Step 5 · Build the deck" id="{86cf179b-9bac-3f5f-9188-96092d873376}">
+        <p14:section name="Step 5 · Build the deck" id="{fa9e561e-7f7e-4f0a-f4e4-124447313a4b}">
           <p14:sldIdLst>
             <p14:sldId id="281"/>
             <p14:sldId id="282"/>
             <p14:sldId id="283"/>
           </p14:sldIdLst>
         </p14:section>
-        <p14:section name="Appendix" id="{d0314779-0f70-c354-af1b-685dcc689fb0}">
+        <p14:section name="Appendix" id="{2408af79-33eb-5036-8608-6198625a884d}">
           <p14:sldIdLst>
             <p14:sldId id="284"/>
             <p14:sldId id="285"/>
@@ -30374,7 +30374,7 @@
         <p:spPr>
           <a:xfrm>
             <a:off x="548640" y="1874520"/>
-            <a:ext cx="11094415" cy="585216"/>
+            <a:ext cx="11094415" cy="530352"/>
           </a:xfrm>
           <a:prstGeom prst="rect">
             <a:avLst/>
@@ -30398,7 +30398,7 @@
         </p:nvSpPr>
         <p:spPr>
           <a:xfrm>
-            <a:off x="777240" y="2057400"/>
+            <a:off x="777240" y="2029968"/>
             <a:ext cx="219456" cy="219456"/>
           </a:xfrm>
           <a:prstGeom prst="rect">
@@ -30423,7 +30423,7 @@
         </p:nvSpPr>
         <p:spPr>
           <a:xfrm>
-            <a:off x="1234440" y="1965960"/>
+            <a:off x="1234440" y="1929384"/>
             <a:ext cx="10058400" cy="420624"/>
           </a:xfrm>
           <a:prstGeom prst="rect">
@@ -30459,8 +30459,8 @@
         </p:nvSpPr>
         <p:spPr>
           <a:xfrm>
-            <a:off x="548640" y="2560320"/>
-            <a:ext cx="11094415" cy="585216"/>
+            <a:off x="548640" y="2496312"/>
+            <a:ext cx="11094415" cy="530352"/>
           </a:xfrm>
           <a:prstGeom prst="rect">
             <a:avLst/>
@@ -30484,7 +30484,7 @@
         </p:nvSpPr>
         <p:spPr>
           <a:xfrm>
-            <a:off x="777240" y="2743200"/>
+            <a:off x="777240" y="2651760"/>
             <a:ext cx="219456" cy="219456"/>
           </a:xfrm>
           <a:prstGeom prst="rect">
@@ -30509,7 +30509,7 @@
         </p:nvSpPr>
         <p:spPr>
           <a:xfrm>
-            <a:off x="1234440" y="2651760"/>
+            <a:off x="1234440" y="2551176"/>
             <a:ext cx="10058400" cy="420624"/>
           </a:xfrm>
           <a:prstGeom prst="rect">
@@ -30545,8 +30545,8 @@
         </p:nvSpPr>
         <p:spPr>
           <a:xfrm>
-            <a:off x="548640" y="3246120"/>
-            <a:ext cx="11094415" cy="585216"/>
+            <a:off x="548640" y="3118104"/>
+            <a:ext cx="11094415" cy="530352"/>
           </a:xfrm>
           <a:prstGeom prst="rect">
             <a:avLst/>
@@ -30570,7 +30570,7 @@
         </p:nvSpPr>
         <p:spPr>
           <a:xfrm>
-            <a:off x="777240" y="3429000"/>
+            <a:off x="777240" y="3273552"/>
             <a:ext cx="219456" cy="219456"/>
           </a:xfrm>
           <a:prstGeom prst="rect">
@@ -30595,7 +30595,7 @@
         </p:nvSpPr>
         <p:spPr>
           <a:xfrm>
-            <a:off x="1234440" y="3337560"/>
+            <a:off x="1234440" y="3172968"/>
             <a:ext cx="10058400" cy="420624"/>
           </a:xfrm>
           <a:prstGeom prst="rect">
@@ -30631,8 +30631,8 @@
         </p:nvSpPr>
         <p:spPr>
           <a:xfrm>
-            <a:off x="548640" y="3931920"/>
-            <a:ext cx="11094415" cy="585216"/>
+            <a:off x="548640" y="3739896"/>
+            <a:ext cx="11094415" cy="530352"/>
           </a:xfrm>
           <a:prstGeom prst="rect">
             <a:avLst/>
@@ -30656,7 +30656,7 @@
         </p:nvSpPr>
         <p:spPr>
           <a:xfrm>
-            <a:off x="777240" y="4114800"/>
+            <a:off x="777240" y="3895344"/>
             <a:ext cx="219456" cy="219456"/>
           </a:xfrm>
           <a:prstGeom prst="rect">
@@ -30681,7 +30681,7 @@
         </p:nvSpPr>
         <p:spPr>
           <a:xfrm>
-            <a:off x="1234440" y="4023360"/>
+            <a:off x="1234440" y="3794760"/>
             <a:ext cx="6949440" cy="420624"/>
           </a:xfrm>
           <a:prstGeom prst="rect">
@@ -30717,7 +30717,7 @@
         </p:nvSpPr>
         <p:spPr>
           <a:xfrm>
-            <a:off x="8321040" y="4023360"/>
+            <a:off x="8321040" y="3794760"/>
             <a:ext cx="3200400" cy="420624"/>
           </a:xfrm>
           <a:prstGeom prst="rect">
@@ -30764,8 +30764,8 @@
         </p:nvSpPr>
         <p:spPr>
           <a:xfrm>
-            <a:off x="548640" y="4617720"/>
-            <a:ext cx="11094415" cy="585216"/>
+            <a:off x="548640" y="4361688"/>
+            <a:ext cx="11094415" cy="530352"/>
           </a:xfrm>
           <a:prstGeom prst="rect">
             <a:avLst/>
@@ -30789,7 +30789,7 @@
         </p:nvSpPr>
         <p:spPr>
           <a:xfrm>
-            <a:off x="777240" y="4800600"/>
+            <a:off x="777240" y="4517136"/>
             <a:ext cx="219456" cy="219456"/>
           </a:xfrm>
           <a:prstGeom prst="rect">
@@ -30814,7 +30814,7 @@
         </p:nvSpPr>
         <p:spPr>
           <a:xfrm>
-            <a:off x="1234440" y="4709160"/>
+            <a:off x="1234440" y="4416552"/>
             <a:ext cx="10058400" cy="420624"/>
           </a:xfrm>
           <a:prstGeom prst="rect">
@@ -30850,8 +30850,8 @@
         </p:nvSpPr>
         <p:spPr>
           <a:xfrm>
-            <a:off x="548640" y="5303520"/>
-            <a:ext cx="11094415" cy="585216"/>
+            <a:off x="548640" y="4983480"/>
+            <a:ext cx="11094415" cy="530352"/>
           </a:xfrm>
           <a:prstGeom prst="rect">
             <a:avLst/>
@@ -30875,7 +30875,7 @@
         </p:nvSpPr>
         <p:spPr>
           <a:xfrm>
-            <a:off x="777240" y="5486400"/>
+            <a:off x="777240" y="5138928"/>
             <a:ext cx="219456" cy="219456"/>
           </a:xfrm>
           <a:prstGeom prst="rect">
@@ -30900,7 +30900,93 @@
         </p:nvSpPr>
         <p:spPr>
           <a:xfrm>
-            <a:off x="1234440" y="5394960"/>
+            <a:off x="1234440" y="5038344"/>
+            <a:ext cx="10058400" cy="420624"/>
+          </a:xfrm>
+          <a:prstGeom prst="rect">
+            <a:avLst/>
+          </a:prstGeom>
+          <a:noFill/>
+          <a:ln/>
+        </p:spPr>
+        <p:txBody>
+          <a:bodyPr wrap="square" lIns="0" tIns="0" rIns="0" bIns="0" rtlCol="0" anchor="ctr"/>
+          <a:lstStyle/>
+          <a:p>
+            <a:pPr indent="0" marL="0">
+              <a:buNone/>
+            </a:pPr>
+            <a:r>
+              <a:rPr lang="en-US" sz="1400" dirty="0">
+                <a:solidFill>
+                  <a:schemeClr val="tx1"/>
+                </a:solidFill>
+              </a:rPr>
+              <a:t>IAS appears nowhere: we no longer use it, so the coverage slides name only DV and GAM</a:t>
+            </a:r>
+            <a:endParaRPr lang="en-US" sz="1400" dirty="0"/>
+          </a:p>
+        </p:txBody>
+      </p:sp>
+      <p:sp>
+        <p:nvSpPr>
+          <p:cNvPr id="23" name="final 7"/>
+          <p:cNvSpPr/>
+          <p:nvPr/>
+        </p:nvSpPr>
+        <p:spPr>
+          <a:xfrm>
+            <a:off x="548640" y="5605272"/>
+            <a:ext cx="11094415" cy="530352"/>
+          </a:xfrm>
+          <a:prstGeom prst="rect">
+            <a:avLst/>
+          </a:prstGeom>
+          <a:solidFill>
+            <a:schemeClr val="bg1"/>
+          </a:solidFill>
+          <a:ln w="9525">
+            <a:solidFill>
+              <a:srgbClr val="E7E0C9"/>
+            </a:solidFill>
+            <a:prstDash val="solid"/>
+          </a:ln>
+        </p:spPr>
+      </p:sp>
+      <p:sp>
+        <p:nvSpPr>
+          <p:cNvPr id="24" name="box 7"/>
+          <p:cNvSpPr/>
+          <p:nvPr/>
+        </p:nvSpPr>
+        <p:spPr>
+          <a:xfrm>
+            <a:off x="777240" y="5760720"/>
+            <a:ext cx="219456" cy="219456"/>
+          </a:xfrm>
+          <a:prstGeom prst="rect">
+            <a:avLst/>
+          </a:prstGeom>
+          <a:solidFill>
+            <a:schemeClr val="bg1"/>
+          </a:solidFill>
+          <a:ln w="15875">
+            <a:solidFill>
+              <a:srgbClr val="1F1E19"/>
+            </a:solidFill>
+            <a:prstDash val="solid"/>
+          </a:ln>
+        </p:spPr>
+      </p:sp>
+      <p:sp>
+        <p:nvSpPr>
+          <p:cNvPr id="25" name="Text 23"/>
+          <p:cNvSpPr txBox="1"/>
+          <p:nvPr/>
+        </p:nvSpPr>
+        <p:spPr>
+          <a:xfrm>
+            <a:off x="1234440" y="5660136"/>
             <a:ext cx="6949440" cy="420624"/>
           </a:xfrm>
           <a:prstGeom prst="rect">
@@ -30930,13 +31016,13 @@
       </p:sp>
       <p:sp>
         <p:nvSpPr>
-          <p:cNvPr id="23" name="Text 21"/>
+          <p:cNvPr id="26" name="Text 24"/>
           <p:cNvSpPr txBox="1"/>
           <p:nvPr/>
         </p:nvSpPr>
         <p:spPr>
           <a:xfrm>
-            <a:off x="8321040" y="5394960"/>
+            <a:off x="8321040" y="5660136"/>
             <a:ext cx="3200400" cy="420624"/>
           </a:xfrm>
           <a:prstGeom prst="rect">
@@ -36521,7 +36607,7 @@
                   <a:schemeClr val="tx1"/>
                 </a:solidFill>
               </a:rPr>
-              <a:t>IAS and GAM filtering</a:t>
+              <a:t>GAM filtering</a:t>
             </a:r>
             <a:endParaRPr lang="en-US" sz="1500" dirty="0"/>
           </a:p>
@@ -36557,7 +36643,7 @@
                   <a:schemeClr val="tx2"/>
                 </a:solidFill>
               </a:rPr>
-              <a:t>The other two layers of protection</a:t>
+              <a:t>The second layer of protection, after DV</a:t>
             </a:r>
             <a:endParaRPr lang="en-US" sz="1200" dirty="0"/>
           </a:p>
@@ -36657,7 +36743,7 @@
                   <a:schemeClr val="tx1"/>
                 </a:solidFill>
               </a:rPr>
-              <a:t>Three pathways to ad quality</a:t>
+              <a:t>Two pathways to ad quality</a:t>
             </a:r>
             <a:endParaRPr lang="en-US" sz="1500" dirty="0"/>
           </a:p>
@@ -36693,7 +36779,7 @@
                   <a:schemeClr val="tx2"/>
                 </a:solidFill>
               </a:rPr>
-              <a:t>DV, IAS and GAM together</a:t>
+              <a:t>DV and GAM together</a:t>
             </a:r>
             <a:endParaRPr lang="en-US" sz="1200" dirty="0"/>
           </a:p>

</xml_diff>

<commit_message>
docs: TAG IVT guide — resolve open questions
Deadline near year end; reviewers Michael (CTO) and Kelly Liu (SVP
Yield & AdOps); DV numbers read off the UI tiles (no export); SIVT goal
under 1%; video Ad Exchange Jan/Jul-Sep now include In-stream video or
audio (Aug video discrepancy 12.8% -> 13.1%, Sep 11.4% -> 11.6%; YTD
unchanged at 13.3%). Only the post-bid video gap explanation remains open.

Co-Authored-By: Claude Opus 5.5 <noreply@anthropic.com>
Claude-Session: https://claude.ai/code/session_014udSfWkctWaSTKdEZUW1Gh
</commit_message>
<xml_diff>
--- a/docs/TAG_IVT_Report_Update_Guide.pptx
+++ b/docs/TAG_IVT_Report_Update_Guide.pptx
@@ -138,7 +138,7 @@
   <p:extLst>
     <p:ext uri="{521415D9-36F7-43E2-AB2F-B90AF26B5E84}">
       <p14:sectionLst xmlns:p14="http://schemas.microsoft.com/office/powerpoint/2010/main">
-        <p14:section name="Overview" id="{20b3f463-b0d5-27ec-9aa5-1f3f63a84f6d}">
+        <p14:section name="Overview" id="{612ca653-5141-ac22-4a13-d860da3499f5}">
           <p14:sldIdLst>
             <p14:sldId id="256"/>
             <p14:sldId id="257"/>
@@ -154,7 +154,7 @@
             <p14:sldId id="267"/>
           </p14:sldIdLst>
         </p14:section>
-        <p14:section name="Step 1 · GAM" id="{575ec512-36eb-4bbd-8cad-8ce8072e2550}">
+        <p14:section name="Step 1 · GAM" id="{ad637459-3f80-5d7e-f5aa-bc2d08e1e8e2}">
           <p14:sldIdLst>
             <p14:sldId id="268"/>
             <p14:sldId id="269"/>
@@ -164,33 +164,33 @@
             <p14:sldId id="273"/>
           </p14:sldIdLst>
         </p14:section>
-        <p14:section name="Step 2 · DV" id="{f06eea11-dc7e-c821-eb6b-3779b712b033}">
+        <p14:section name="Step 2 · DV" id="{6eaf53ef-ac52-1c99-1e98-d6adfb6dad48}">
           <p14:sldIdLst>
             <p14:sldId id="274"/>
             <p14:sldId id="275"/>
             <p14:sldId id="276"/>
           </p14:sldIdLst>
         </p14:section>
-        <p14:section name="Step 3 · GA4 + pre-bid" id="{d043862b-039b-df7e-1dde-b50da0d80b8c}">
+        <p14:section name="Step 3 · GA4 + pre-bid" id="{cd615adf-736e-5aeb-6864-9d3e4fe24395}">
           <p14:sldIdLst>
             <p14:sldId id="277"/>
             <p14:sldId id="278"/>
           </p14:sldIdLst>
         </p14:section>
-        <p14:section name="Step 4 · Quarter math" id="{64b7410f-5bad-1eae-81d2-a77645d0ea65}">
+        <p14:section name="Step 4 · Quarter math" id="{64bb3379-6c88-da90-0749-d763a69dfa8d}">
           <p14:sldIdLst>
             <p14:sldId id="279"/>
             <p14:sldId id="280"/>
           </p14:sldIdLst>
         </p14:section>
-        <p14:section name="Step 5 · Build the deck" id="{fa9e561e-7f7e-4f0a-f4e4-124447313a4b}">
+        <p14:section name="Step 5 · Build the deck" id="{66830082-04c8-4c17-18e0-0cc7ddda58cb}">
           <p14:sldIdLst>
             <p14:sldId id="281"/>
             <p14:sldId id="282"/>
             <p14:sldId id="283"/>
           </p14:sldIdLst>
         </p14:section>
-        <p14:section name="Appendix" id="{2408af79-33eb-5036-8608-6198625a884d}">
+        <p14:section name="Appendix" id="{fd3c60bc-f930-31be-b0ea-6cd4702a676a}">
           <p14:sldIdLst>
             <p14:sldId id="284"/>
             <p14:sldId id="285"/>
@@ -1893,10 +1893,10 @@
                   <c:v>11.7</c:v>
                 </c:pt>
                 <c:pt idx="7">
-                  <c:v>12.8</c:v>
+                  <c:v>13.1</c:v>
                 </c:pt>
                 <c:pt idx="8">
-                  <c:v>11.4</c:v>
+                  <c:v>11.6</c:v>
                 </c:pt>
               </c:numCache>
             </c:numRef>
@@ -2186,7 +2186,7 @@
                   <c:v>28.9</c:v>
                 </c:pt>
                 <c:pt idx="7">
-                  <c:v>26.5</c:v>
+                  <c:v>26.6</c:v>
                 </c:pt>
                 <c:pt idx="8">
                   <c:v>32.9</c:v>
@@ -20840,7 +20840,7 @@
                           <a:ea typeface="Arial" pitchFamily="34" charset="-122"/>
                           <a:cs typeface="Arial" pitchFamily="34" charset="-120"/>
                         </a:rPr>
-                        <a:t>3,236,962</a:t>
+                        <a:t>3,236,963</a:t>
                       </a:r>
                       <a:endParaRPr lang="en-US" sz="1000" dirty="0">
                         <a:latin typeface="Arial" charset="0"/>
@@ -21090,7 +21090,7 @@
                           <a:ea typeface="Arial" pitchFamily="34" charset="-122"/>
                           <a:cs typeface="Arial" pitchFamily="34" charset="-120"/>
                         </a:rPr>
-                        <a:t>46,725,758</a:t>
+                        <a:t>46,725,759</a:t>
                       </a:r>
                       <a:endParaRPr lang="en-US" sz="1000" dirty="0">
                         <a:latin typeface="Arial" charset="0"/>
@@ -23552,7 +23552,7 @@
                           <a:ea typeface="Arial" pitchFamily="34" charset="-122"/>
                           <a:cs typeface="Arial" pitchFamily="34" charset="-120"/>
                         </a:rPr>
-                        <a:t>1,332,484</a:t>
+                        <a:t>1,332,567</a:t>
                       </a:r>
                       <a:endParaRPr lang="en-US" sz="1000" dirty="0">
                         <a:latin typeface="Arial" charset="0"/>
@@ -23802,7 +23802,7 @@
                           <a:ea typeface="Arial" pitchFamily="34" charset="-122"/>
                           <a:cs typeface="Arial" pitchFamily="34" charset="-120"/>
                         </a:rPr>
-                        <a:t>28,890,902</a:t>
+                        <a:t>28,890,985</a:t>
                       </a:r>
                       <a:endParaRPr lang="en-US" sz="1000" dirty="0">
                         <a:latin typeface="Arial" charset="0"/>
@@ -24004,7 +24004,7 @@
                           <a:ea typeface="Arial" pitchFamily="34" charset="-122"/>
                           <a:cs typeface="Arial" pitchFamily="34" charset="-120"/>
                         </a:rPr>
-                        <a:t>1,634,651</a:t>
+                        <a:t>1,716,850</a:t>
                       </a:r>
                       <a:endParaRPr lang="en-US" sz="1000" dirty="0">
                         <a:latin typeface="Arial" charset="0"/>
@@ -24254,7 +24254,7 @@
                           <a:ea typeface="Arial" pitchFamily="34" charset="-122"/>
                           <a:cs typeface="Arial" pitchFamily="34" charset="-120"/>
                         </a:rPr>
-                        <a:t>26,490,184</a:t>
+                        <a:t>26,572,383</a:t>
                       </a:r>
                       <a:endParaRPr lang="en-US" sz="1000" dirty="0">
                         <a:latin typeface="Arial" charset="0"/>
@@ -24354,7 +24354,7 @@
                           <a:ea typeface="Arial" pitchFamily="34" charset="-122"/>
                           <a:cs typeface="Arial" pitchFamily="34" charset="-120"/>
                         </a:rPr>
-                        <a:t>12.8%</a:t>
+                        <a:t>13.1%</a:t>
                       </a:r>
                       <a:endParaRPr lang="en-US" sz="1000" dirty="0">
                         <a:latin typeface="Arial" charset="0"/>
@@ -24456,7 +24456,7 @@
                           <a:ea typeface="Arial" pitchFamily="34" charset="-122"/>
                           <a:cs typeface="Arial" pitchFamily="34" charset="-120"/>
                         </a:rPr>
-                        <a:t>2,327,827</a:t>
+                        <a:t>2,370,358</a:t>
                       </a:r>
                       <a:endParaRPr lang="en-US" sz="1000" dirty="0">
                         <a:latin typeface="Arial" charset="0"/>
@@ -24706,7 +24706,7 @@
                           <a:ea typeface="Arial" pitchFamily="34" charset="-122"/>
                           <a:cs typeface="Arial" pitchFamily="34" charset="-120"/>
                         </a:rPr>
-                        <a:t>32,860,875</a:t>
+                        <a:t>32,903,406</a:t>
                       </a:r>
                       <a:endParaRPr lang="en-US" sz="1000" dirty="0">
                         <a:latin typeface="Arial" charset="0"/>
@@ -24806,7 +24806,7 @@
                           <a:ea typeface="Arial" pitchFamily="34" charset="-122"/>
                           <a:cs typeface="Arial" pitchFamily="34" charset="-120"/>
                         </a:rPr>
-                        <a:t>11.4%</a:t>
+                        <a:t>11.6%</a:t>
                       </a:r>
                       <a:endParaRPr lang="en-US" sz="1000" dirty="0">
                         <a:latin typeface="Arial" charset="0"/>
@@ -24908,7 +24908,7 @@
                           <a:ea typeface="Arial" pitchFamily="34" charset="-122"/>
                           <a:cs typeface="Arial" pitchFamily="34" charset="-120"/>
                         </a:rPr>
-                        <a:t>23,752,294</a:t>
+                        <a:t>23,877,108</a:t>
                       </a:r>
                       <a:endParaRPr lang="en-US" sz="1000" dirty="0">
                         <a:latin typeface="Arial" charset="0"/>
@@ -25158,7 +25158,7 @@
                           <a:ea typeface="Arial" pitchFamily="34" charset="-122"/>
                           <a:cs typeface="Arial" pitchFamily="34" charset="-120"/>
                         </a:rPr>
-                        <a:t>302,255,362</a:t>
+                        <a:t>302,380,176</a:t>
                       </a:r>
                       <a:endParaRPr lang="en-US" sz="1000" dirty="0">
                         <a:latin typeface="Arial" charset="0"/>
@@ -25326,7 +25326,7 @@
                   <a:schemeClr val="tx2"/>
                 </a:solidFill>
               </a:rPr>
-              <a:t>Instream video sheet (ad unit vid.newsweek), 2026 YTD Jan–Sep. GAM total = Ad Exchange + PMP – PA + Ad server (the sheet's formula). Discrepancy = 1 − DV post-bid ÷ GAM total. TO CONFIRM: Jan and Jul–Sep Ad Exchange still exclude In-stream video or audio.</a:t>
+              <a:t>Instream video sheet (ad unit vid.newsweek), 2026 YTD Jan–Sep. GAM total = Ad Exchange + PMP – PA + Ad server (the sheet's formula). Discrepancy = 1 − DV post-bid ÷ GAM total. Ad Exchange includes In-stream video or audio every month.</a:t>
             </a:r>
             <a:endParaRPr lang="en-US" sz="1100" dirty="0"/>
           </a:p>
@@ -26605,7 +26605,7 @@
                   <a:schemeClr val="tx2"/>
                 </a:solidFill>
               </a:rPr>
-              <a:t>Fraud/SIVT ÷ Monitored, entered as a decimal (0.0004 = 0.04%). TO CONFIRM the scale: the UI shows ~0.4% for July.</a:t>
+              <a:t>Fraud/SIVT ÷ Monitored, entered as a decimal (0.0004 = 0.04%). Goal: under 1%.</a:t>
             </a:r>
             <a:endParaRPr lang="en-US" sz="1400" dirty="0"/>
           </a:p>
@@ -26741,7 +26741,7 @@
                   <a:schemeClr val="tx2"/>
                 </a:solidFill>
               </a:rPr>
-              <a:t>A tile reading 370.0M goes into the workbook as 370,000,000, which is how the 2026 sheet was filled. Exact counts need an export: TO CONFIRM the export steps.</a:t>
+              <a:t>A tile reading 370.0M goes into the workbook as 370,000,000, which is how the 2026 sheet was filled. No export needed: read the tiles in the UI.</a:t>
             </a:r>
             <a:endParaRPr lang="en-US" sz="1400" dirty="0"/>
           </a:p>
@@ -30682,7 +30682,7 @@
         <p:spPr>
           <a:xfrm>
             <a:off x="1234440" y="3794760"/>
-            <a:ext cx="6949440" cy="420624"/>
+            <a:ext cx="10058400" cy="420624"/>
           </a:xfrm>
           <a:prstGeom prst="rect">
             <a:avLst/>
@@ -30703,7 +30703,7 @@
                   <a:schemeClr val="tx1"/>
                 </a:solidFill>
               </a:rPr>
-              <a:t>SIVT is impression-weighted and on the same scale as the DV UI</a:t>
+              <a:t>SIVT is impression-weighted and under the 1% goal</a:t>
             </a:r>
             <a:endParaRPr lang="en-US" sz="1400" dirty="0"/>
           </a:p>
@@ -30711,54 +30711,7 @@
       </p:sp>
       <p:sp>
         <p:nvSpPr>
-          <p:cNvPr id="16" name="Text 14"/>
-          <p:cNvSpPr txBox="1"/>
-          <p:nvPr/>
-        </p:nvSpPr>
-        <p:spPr>
-          <a:xfrm>
-            <a:off x="8321040" y="3794760"/>
-            <a:ext cx="3200400" cy="420624"/>
-          </a:xfrm>
-          <a:prstGeom prst="rect">
-            <a:avLst/>
-          </a:prstGeom>
-          <a:noFill/>
-          <a:ln/>
-        </p:spPr>
-        <p:txBody>
-          <a:bodyPr wrap="square" lIns="0" tIns="0" rIns="0" bIns="0" rtlCol="0" anchor="ctr"/>
-          <a:lstStyle/>
-          <a:p>
-            <a:pPr indent="0" marL="0">
-              <a:buNone/>
-            </a:pPr>
-            <a:r>
-              <a:rPr lang="en-US" sz="1200" b="1" dirty="0">
-                <a:solidFill>
-                  <a:srgbClr val="8A6D00"/>
-                </a:solidFill>
-              </a:rPr>
-              <a:t>TO CONFIRM  </a:t>
-            </a:r>
-            <a:pPr indent="0" marL="0">
-              <a:buNone/>
-            </a:pPr>
-            <a:r>
-              <a:rPr lang="en-US" sz="1200" dirty="0">
-                <a:solidFill>
-                  <a:srgbClr val="8A6D00"/>
-                </a:solidFill>
-              </a:rPr>
-              <a:t>the 0.04% vs ~0.4% question</a:t>
-            </a:r>
-            <a:endParaRPr lang="en-US" sz="1200" dirty="0"/>
-          </a:p>
-        </p:txBody>
-      </p:sp>
-      <p:sp>
-        <p:nvSpPr>
-          <p:cNvPr id="17" name="final 5"/>
+          <p:cNvPr id="16" name="final 5"/>
           <p:cNvSpPr/>
           <p:nvPr/>
         </p:nvSpPr>
@@ -30783,7 +30736,7 @@
       </p:sp>
       <p:sp>
         <p:nvSpPr>
-          <p:cNvPr id="18" name="box 5"/>
+          <p:cNvPr id="17" name="box 5"/>
           <p:cNvSpPr/>
           <p:nvPr/>
         </p:nvSpPr>
@@ -30808,7 +30761,7 @@
       </p:sp>
       <p:sp>
         <p:nvSpPr>
-          <p:cNvPr id="19" name="Text 17"/>
+          <p:cNvPr id="18" name="Text 16"/>
           <p:cNvSpPr txBox="1"/>
           <p:nvPr/>
         </p:nvSpPr>
@@ -30844,7 +30797,7 @@
       </p:sp>
       <p:sp>
         <p:nvSpPr>
-          <p:cNvPr id="20" name="final 6"/>
+          <p:cNvPr id="19" name="final 6"/>
           <p:cNvSpPr/>
           <p:nvPr/>
         </p:nvSpPr>
@@ -30869,7 +30822,7 @@
       </p:sp>
       <p:sp>
         <p:nvSpPr>
-          <p:cNvPr id="21" name="box 6"/>
+          <p:cNvPr id="20" name="box 6"/>
           <p:cNvSpPr/>
           <p:nvPr/>
         </p:nvSpPr>
@@ -30894,7 +30847,7 @@
       </p:sp>
       <p:sp>
         <p:nvSpPr>
-          <p:cNvPr id="22" name="Text 20"/>
+          <p:cNvPr id="21" name="Text 19"/>
           <p:cNvSpPr txBox="1"/>
           <p:nvPr/>
         </p:nvSpPr>
@@ -30930,7 +30883,7 @@
       </p:sp>
       <p:sp>
         <p:nvSpPr>
-          <p:cNvPr id="23" name="final 7"/>
+          <p:cNvPr id="22" name="final 7"/>
           <p:cNvSpPr/>
           <p:nvPr/>
         </p:nvSpPr>
@@ -30955,7 +30908,7 @@
       </p:sp>
       <p:sp>
         <p:nvSpPr>
-          <p:cNvPr id="24" name="box 7"/>
+          <p:cNvPr id="23" name="box 7"/>
           <p:cNvSpPr/>
           <p:nvPr/>
         </p:nvSpPr>
@@ -30980,14 +30933,14 @@
       </p:sp>
       <p:sp>
         <p:nvSpPr>
-          <p:cNvPr id="25" name="Text 23"/>
+          <p:cNvPr id="24" name="Text 22"/>
           <p:cNvSpPr txBox="1"/>
           <p:nvPr/>
         </p:nvSpPr>
         <p:spPr>
           <a:xfrm>
             <a:off x="1234440" y="5660136"/>
-            <a:ext cx="6949440" cy="420624"/>
+            <a:ext cx="10058400" cy="420624"/>
           </a:xfrm>
           <a:prstGeom prst="rect">
             <a:avLst/>
@@ -31008,56 +30961,9 @@
                   <a:schemeClr val="tx1"/>
                 </a:solidFill>
               </a:rPr>
-              <a:t>Someone else reviews the deck before it goes to TAG</a:t>
+              <a:t>Michael (CTO) and Kelly Liu (SVP Yield &amp; AdOps) review the deck before it goes to TAG</a:t>
             </a:r>
             <a:endParaRPr lang="en-US" sz="1400" dirty="0"/>
-          </a:p>
-        </p:txBody>
-      </p:sp>
-      <p:sp>
-        <p:nvSpPr>
-          <p:cNvPr id="26" name="Text 24"/>
-          <p:cNvSpPr txBox="1"/>
-          <p:nvPr/>
-        </p:nvSpPr>
-        <p:spPr>
-          <a:xfrm>
-            <a:off x="8321040" y="5660136"/>
-            <a:ext cx="3200400" cy="420624"/>
-          </a:xfrm>
-          <a:prstGeom prst="rect">
-            <a:avLst/>
-          </a:prstGeom>
-          <a:noFill/>
-          <a:ln/>
-        </p:spPr>
-        <p:txBody>
-          <a:bodyPr wrap="square" lIns="0" tIns="0" rIns="0" bIns="0" rtlCol="0" anchor="ctr"/>
-          <a:lstStyle/>
-          <a:p>
-            <a:pPr indent="0" marL="0">
-              <a:buNone/>
-            </a:pPr>
-            <a:r>
-              <a:rPr lang="en-US" sz="1200" b="1" dirty="0">
-                <a:solidFill>
-                  <a:srgbClr val="8A6D00"/>
-                </a:solidFill>
-              </a:rPr>
-              <a:t>TO CONFIRM  </a:t>
-            </a:r>
-            <a:pPr indent="0" marL="0">
-              <a:buNone/>
-            </a:pPr>
-            <a:r>
-              <a:rPr lang="en-US" sz="1200" dirty="0">
-                <a:solidFill>
-                  <a:srgbClr val="8A6D00"/>
-                </a:solidFill>
-              </a:rPr>
-              <a:t>who reviews and who sends</a:t>
-            </a:r>
-            <a:endParaRPr lang="en-US" sz="1200" dirty="0"/>
           </a:p>
         </p:txBody>
       </p:sp>
@@ -34376,7 +34282,7 @@
                 <a:ea typeface="Georgia" pitchFamily="34" charset="-122"/>
                 <a:cs typeface="Georgia" pitchFamily="34" charset="-120"/>
               </a:rPr>
-              <a:t>SIVT stays near 0.04% every quarter</a:t>
+              <a:t>SIVT stays well under the 1% goal</a:t>
             </a:r>
             <a:endParaRPr lang="en-US" sz="3400" dirty="0"/>
           </a:p>
@@ -35373,58 +35279,29 @@
             </a:r>
             <a:endParaRPr lang="en-US" sz="1300" dirty="0"/>
           </a:p>
-        </p:txBody>
-      </p:sp>
-      <p:sp>
-        <p:nvSpPr>
-          <p:cNvPr id="17" name="Text 15"/>
-          <p:cNvSpPr txBox="1"/>
-          <p:nvPr/>
-        </p:nvSpPr>
-        <p:spPr>
-          <a:xfrm>
-            <a:off x="822960" y="5486400"/>
-            <a:ext cx="4861408" cy="320040"/>
-          </a:xfrm>
-          <a:prstGeom prst="rect">
-            <a:avLst/>
-          </a:prstGeom>
-          <a:noFill/>
-          <a:ln/>
-        </p:spPr>
-        <p:txBody>
-          <a:bodyPr wrap="square" lIns="0" tIns="0" rIns="0" bIns="0" rtlCol="0" anchor="t"/>
-          <a:lstStyle/>
           <a:p>
-            <a:pPr indent="0" marL="0">
-              <a:buNone/>
+            <a:pPr marL="342900" indent="-342900">
+              <a:spcAft>
+                <a:spcPts val="200"/>
+              </a:spcAft>
+              <a:buSzPct val="100000"/>
+              <a:buChar char="•"/>
             </a:pPr>
             <a:r>
-              <a:rPr lang="en-US" sz="1200" b="1" dirty="0">
+              <a:rPr lang="en-US" sz="1300" dirty="0">
                 <a:solidFill>
-                  <a:srgbClr val="8A6D00"/>
+                  <a:schemeClr val="tx1"/>
                 </a:solidFill>
               </a:rPr>
-              <a:t>TO CONFIRM  </a:t>
+              <a:t>TAG's deadline falls close to the end of the year</a:t>
             </a:r>
-            <a:pPr indent="0" marL="0">
-              <a:buNone/>
-            </a:pPr>
-            <a:r>
-              <a:rPr lang="en-US" sz="1200" dirty="0">
-                <a:solidFill>
-                  <a:srgbClr val="8A6D00"/>
-                </a:solidFill>
-              </a:rPr>
-              <a:t>TAG's deadline for the report</a:t>
-            </a:r>
-            <a:endParaRPr lang="en-US" sz="1200" dirty="0"/>
+            <a:endParaRPr lang="en-US" sz="1300" dirty="0"/>
           </a:p>
         </p:txBody>
       </p:sp>
       <p:sp>
         <p:nvSpPr>
-          <p:cNvPr id="18" name="prep 4"/>
+          <p:cNvPr id="17" name="prep 4"/>
           <p:cNvSpPr/>
           <p:nvPr/>
         </p:nvSpPr>
@@ -35449,7 +35326,7 @@
       </p:sp>
       <p:sp>
         <p:nvSpPr>
-          <p:cNvPr id="19" name="Text 17"/>
+          <p:cNvPr id="18" name="Text 16"/>
           <p:cNvSpPr txBox="1"/>
           <p:nvPr/>
         </p:nvSpPr>
@@ -35485,7 +35362,7 @@
       </p:sp>
       <p:sp>
         <p:nvSpPr>
-          <p:cNvPr id="20" name="Text 18"/>
+          <p:cNvPr id="19" name="Text 17"/>
           <p:cNvSpPr txBox="1"/>
           <p:nvPr/>
         </p:nvSpPr>
@@ -35516,7 +35393,7 @@
                 <a:ea typeface="Georgia" pitchFamily="34" charset="-122"/>
                 <a:cs typeface="Georgia" pitchFamily="34" charset="-120"/>
               </a:rPr>
-              <a:t>Who to ask</a:t>
+              <a:t>Who reviews it</a:t>
             </a:r>
             <a:endParaRPr lang="en-US" sz="1800" dirty="0"/>
           </a:p>
@@ -35524,7 +35401,7 @@
       </p:sp>
       <p:sp>
         <p:nvSpPr>
-          <p:cNvPr id="21" name="Text 19"/>
+          <p:cNvPr id="20" name="Text 18"/>
           <p:cNvSpPr txBox="1"/>
           <p:nvPr/>
         </p:nvSpPr>
@@ -35556,56 +35433,27 @@
                   <a:schemeClr val="tx1"/>
                 </a:solidFill>
               </a:rPr>
-              <a:t>Questions about the numbers: RevOps</a:t>
+              <a:t>Michael, CTO</a:t>
             </a:r>
             <a:endParaRPr lang="en-US" sz="1300" dirty="0"/>
           </a:p>
-        </p:txBody>
-      </p:sp>
-      <p:sp>
-        <p:nvSpPr>
-          <p:cNvPr id="22" name="Text 20"/>
-          <p:cNvSpPr txBox="1"/>
-          <p:nvPr/>
-        </p:nvSpPr>
-        <p:spPr>
-          <a:xfrm>
-            <a:off x="6507328" y="5486400"/>
-            <a:ext cx="4861408" cy="320040"/>
-          </a:xfrm>
-          <a:prstGeom prst="rect">
-            <a:avLst/>
-          </a:prstGeom>
-          <a:noFill/>
-          <a:ln/>
-        </p:spPr>
-        <p:txBody>
-          <a:bodyPr wrap="square" lIns="0" tIns="0" rIns="0" bIns="0" rtlCol="0" anchor="t"/>
-          <a:lstStyle/>
           <a:p>
-            <a:pPr indent="0" marL="0">
-              <a:buNone/>
+            <a:pPr marL="342900" indent="-342900">
+              <a:spcAft>
+                <a:spcPts val="200"/>
+              </a:spcAft>
+              <a:buSzPct val="100000"/>
+              <a:buChar char="•"/>
             </a:pPr>
             <a:r>
-              <a:rPr lang="en-US" sz="1200" b="1" dirty="0">
+              <a:rPr lang="en-US" sz="1300" dirty="0">
                 <a:solidFill>
-                  <a:srgbClr val="8A6D00"/>
+                  <a:schemeClr val="tx1"/>
                 </a:solidFill>
               </a:rPr>
-              <a:t>TO CONFIRM  </a:t>
+              <a:t>Kelly Liu, SVP Yield &amp; AdOps</a:t>
             </a:r>
-            <a:pPr indent="0" marL="0">
-              <a:buNone/>
-            </a:pPr>
-            <a:r>
-              <a:rPr lang="en-US" sz="1200" dirty="0">
-                <a:solidFill>
-                  <a:srgbClr val="8A6D00"/>
-                </a:solidFill>
-              </a:rPr>
-              <a:t>Who reviews, approves and sends the report; DV contact</a:t>
-            </a:r>
-            <a:endParaRPr lang="en-US" sz="1200" dirty="0"/>
+            <a:endParaRPr lang="en-US" sz="1300" dirty="0"/>
           </a:p>
         </p:txBody>
       </p:sp>
@@ -41109,7 +40957,7 @@
                   <a:schemeClr val="tx1"/>
                 </a:solidFill>
               </a:rPr>
-              <a:t>Goal: show TAG auditors that SIVT stays low, month after month.</a:t>
+              <a:t>Goal: show TAG auditors that SIVT stays under 1%, month after month.</a:t>
             </a:r>
             <a:endParaRPr lang="en-US" sz="1500" dirty="0"/>
           </a:p>

</xml_diff>

<commit_message>
docs: TAG IVT data is refreshed monthly, not quarterly
Guide, runbook and CLAUDE.md now say to update the workbooks and the
report's data slides every month (~3 days after month close), recomputing
the current quarter-to-date and YTD each time.

Co-Authored-By: Claude Opus 5.5 <noreply@anthropic.com>
Claude-Session: https://claude.ai/code/session_014udSfWkctWaSTKdEZUW1Gh
</commit_message>
<xml_diff>
--- a/docs/TAG_IVT_Report_Update_Guide.pptx
+++ b/docs/TAG_IVT_Report_Update_Guide.pptx
@@ -138,7 +138,7 @@
   <p:extLst>
     <p:ext uri="{521415D9-36F7-43E2-AB2F-B90AF26B5E84}">
       <p14:sectionLst xmlns:p14="http://schemas.microsoft.com/office/powerpoint/2010/main">
-        <p14:section name="Overview" id="{612ca653-5141-ac22-4a13-d860da3499f5}">
+        <p14:section name="Overview" id="{e9294b11-86c2-caab-416a-51d9db43885d}">
           <p14:sldIdLst>
             <p14:sldId id="256"/>
             <p14:sldId id="257"/>
@@ -154,7 +154,7 @@
             <p14:sldId id="267"/>
           </p14:sldIdLst>
         </p14:section>
-        <p14:section name="Step 1 · GAM" id="{ad637459-3f80-5d7e-f5aa-bc2d08e1e8e2}">
+        <p14:section name="Step 1 · GAM" id="{684f06ef-868a-1db8-c14a-b5b7edf1e879}">
           <p14:sldIdLst>
             <p14:sldId id="268"/>
             <p14:sldId id="269"/>
@@ -164,33 +164,33 @@
             <p14:sldId id="273"/>
           </p14:sldIdLst>
         </p14:section>
-        <p14:section name="Step 2 · DV" id="{6eaf53ef-ac52-1c99-1e98-d6adfb6dad48}">
+        <p14:section name="Step 2 · DV" id="{868a033d-57e9-b76a-7089-d0e562c27d45}">
           <p14:sldIdLst>
             <p14:sldId id="274"/>
             <p14:sldId id="275"/>
             <p14:sldId id="276"/>
           </p14:sldIdLst>
         </p14:section>
-        <p14:section name="Step 3 · GA4 + pre-bid" id="{cd615adf-736e-5aeb-6864-9d3e4fe24395}">
+        <p14:section name="Step 3 · GA4 + pre-bid" id="{55ed1216-d2db-e8d0-bd70-cada02cd7b88}">
           <p14:sldIdLst>
             <p14:sldId id="277"/>
             <p14:sldId id="278"/>
           </p14:sldIdLst>
         </p14:section>
-        <p14:section name="Step 4 · Quarter math" id="{64bb3379-6c88-da90-0749-d763a69dfa8d}">
+        <p14:section name="Step 4 · Quarter math" id="{2cfb939f-47c0-2206-3e1a-8a51a4a17164}">
           <p14:sldIdLst>
             <p14:sldId id="279"/>
             <p14:sldId id="280"/>
           </p14:sldIdLst>
         </p14:section>
-        <p14:section name="Step 5 · Build the deck" id="{66830082-04c8-4c17-18e0-0cc7ddda58cb}">
+        <p14:section name="Step 5 · Build the deck" id="{57e7feb3-b7b8-e32b-20b1-f1772eb049de}">
           <p14:sldIdLst>
             <p14:sldId id="281"/>
             <p14:sldId id="282"/>
             <p14:sldId id="283"/>
           </p14:sldIdLst>
         </p14:section>
-        <p14:section name="Appendix" id="{fd3c60bc-f930-31be-b0ea-6cd4702a676a}">
+        <p14:section name="Appendix" id="{37d2cf68-09ba-c88e-00cf-c81a093d8232}">
           <p14:sldIdLst>
             <p14:sldId id="284"/>
             <p14:sldId id="285"/>
@@ -3332,7 +3332,7 @@
           <a:p>
             <a:r>
               <a:rPr lang="en-US" dirty="0"/>
-              <a:t>Guide for the quarterly refresh of the Newsweek IVT Monitoring Report, the TAG CAF evidence pack. Everything here is done in the Ad Manager, DoubleVerify Pinnacle and GA4 interfaces.</a:t>
+              <a:t>Guide for the monthly refresh of the Newsweek IVT Monitoring Report, the TAG CAF evidence pack. Everything here is done in the Ad Manager, DoubleVerify Pinnacle and GA4 interfaces.</a:t>
             </a:r>
             <a:endParaRPr lang="en-US" dirty="0"/>
           </a:p>
@@ -12843,7 +12843,7 @@
                   <a:schemeClr val="bg2"/>
                 </a:solidFill>
               </a:rPr>
-              <a:t>Save each with date range This year. Next quarter: open it, run it, and copy only the new months.</a:t>
+              <a:t>Save each with date range This year. Next month: open it, run it, and copy only the new month.</a:t>
             </a:r>
             <a:endParaRPr lang="en-US" sz="1400" dirty="0"/>
           </a:p>
@@ -25659,7 +25659,7 @@
                   <a:schemeClr val="tx1"/>
                 </a:solidFill>
               </a:rPr>
-              <a:t>TAG (the Trustworthy Accountability Group) is an ad-industry body. Its Certified Against Fraud (CAF) seal lets Newsweek show buyers that we prevent and remove invalid traffic, not just measure it. To keep the seal, TAG's auditors ask for evidence. The IVT Monitoring Report is that evidence, and this guide refreshes it every quarter.</a:t>
+              <a:t>TAG (the Trustworthy Accountability Group) is an ad-industry body. Its Certified Against Fraud (CAF) seal lets Newsweek show buyers that we prevent and remove invalid traffic, not just measure it. To keep the seal, TAG's auditors ask for evidence. The IVT Monitoring Report is that evidence, and this guide refreshes it every month.</a:t>
             </a:r>
             <a:endParaRPr lang="en-US" sz="1500" dirty="0"/>
           </a:p>
@@ -28467,7 +28467,7 @@
                   <a:schemeClr val="tx2"/>
                 </a:solidFill>
               </a:rPr>
-              <a:t>Set the date range to the quarter and copy web Views per month.</a:t>
+              <a:t>Set the date range to the new month and copy its web Views.</a:t>
             </a:r>
             <a:endParaRPr lang="en-US" sz="1300" dirty="0"/>
           </a:p>
@@ -29374,6 +29374,42 @@
       </p:sp>
       <p:sp>
         <p:nvSpPr>
+          <p:cNvPr id="17" name="Text 15"/>
+          <p:cNvSpPr txBox="1"/>
+          <p:nvPr/>
+        </p:nvSpPr>
+        <p:spPr>
+          <a:xfrm>
+            <a:off x="548640" y="5669280"/>
+            <a:ext cx="11094415" cy="365760"/>
+          </a:xfrm>
+          <a:prstGeom prst="rect">
+            <a:avLst/>
+          </a:prstGeom>
+          <a:noFill/>
+          <a:ln/>
+        </p:spPr>
+        <p:txBody>
+          <a:bodyPr wrap="square" lIns="0" tIns="0" rIns="0" bIns="0" rtlCol="0" anchor="t"/>
+          <a:lstStyle/>
+          <a:p>
+            <a:pPr indent="0" marL="0">
+              <a:buNone/>
+            </a:pPr>
+            <a:r>
+              <a:rPr lang="en-US" sz="1300" i="1" dirty="0">
+                <a:solidFill>
+                  <a:schemeClr val="tx2"/>
+                </a:solidFill>
+              </a:rPr>
+              <a:t>Every month, recompute the current quarter (quarter-to-date until its third month is in) and the YTD row.</a:t>
+            </a:r>
+            <a:endParaRPr lang="en-US" sz="1300" dirty="0"/>
+          </a:p>
+        </p:txBody>
+      </p:sp>
+      <p:sp>
+        <p:nvSpPr>
           <p:cNvPr id="25" name="Slide Number Placeholder 0"/>
           <p:cNvSpPr>
             <a:spLocks noGrp="1"/>
@@ -29663,7 +29699,7 @@
                 <a:ea typeface="Georgia" pitchFamily="34" charset="-122"/>
                 <a:cs typeface="Georgia" pitchFamily="34" charset="-120"/>
               </a:rPr>
-              <a:t>Four slides change every quarter</a:t>
+              <a:t>Four slides change every month</a:t>
             </a:r>
             <a:endParaRPr lang="en-US" sz="3400" dirty="0"/>
           </a:p>
@@ -30071,7 +30107,7 @@
                   <a:schemeClr val="tx2"/>
                 </a:solidFill>
               </a:rPr>
-              <a:t>Anything that moved traffic or measurement this quarter: replatforming, a new video player, a vendor or threshold change.</a:t>
+              <a:t>Anything that moved traffic or measurement this month: replatforming, a new video player, a vendor or threshold change.</a:t>
             </a:r>
             <a:endParaRPr lang="en-US" sz="1300" dirty="0"/>
           </a:p>
@@ -30445,7 +30481,7 @@
                   <a:schemeClr val="tx1"/>
                 </a:solidFill>
               </a:rPr>
-              <a:t>Both workbooks have every month of the quarter, display and video, and the Totals rows recalculate</a:t>
+              <a:t>Both workbooks have the new month, display and video, and the Totals rows recalculate</a:t>
             </a:r>
             <a:endParaRPr lang="en-US" sz="1400" dirty="0"/>
           </a:p>
@@ -30617,7 +30653,7 @@
                   <a:schemeClr val="tx1"/>
                 </a:solidFill>
               </a:rPr>
-              <a:t>Discrepancies look like last quarter's. A jump of more than a few points gets an explanation on the Key changes slide</a:t>
+              <a:t>Discrepancies look like last month's. A jump of more than a few points gets an explanation on the Key changes slide</a:t>
             </a:r>
             <a:endParaRPr lang="en-US" sz="1400" dirty="0"/>
           </a:p>
@@ -31154,7 +31190,7 @@
                   <a:schemeClr val="bg2"/>
                 </a:solidFill>
               </a:rPr>
-              <a:t>Charts to sanity-check a quarter before it goes out</a:t>
+              <a:t>Charts to sanity-check the numbers each month</a:t>
             </a:r>
             <a:endParaRPr lang="en-US" sz="1800" dirty="0"/>
           </a:p>
@@ -35275,7 +35311,7 @@
                   <a:schemeClr val="tx1"/>
                 </a:solidFill>
               </a:rPr>
-              <a:t>After the quarter closes; wait ~3 days so DV data is complete</a:t>
+              <a:t>Every month, ~3 days after it closes, so DV data is complete</a:t>
             </a:r>
             <a:endParaRPr lang="en-US" sz="1300" dirty="0"/>
           </a:p>
@@ -35775,7 +35811,7 @@
                   <a:schemeClr val="tx1"/>
                 </a:solidFill>
               </a:rPr>
-              <a:t>UPDATE EACH QUARTER</a:t>
+              <a:t>UPDATE EACH MONTH</a:t>
             </a:r>
             <a:endParaRPr lang="en-US" sz="900" dirty="0"/>
           </a:p>
@@ -36219,7 +36255,7 @@
                   <a:schemeClr val="tx1"/>
                 </a:solidFill>
               </a:rPr>
-              <a:t>UPDATE EACH QUARTER</a:t>
+              <a:t>UPDATE EACH MONTH</a:t>
             </a:r>
             <a:endParaRPr lang="en-US" sz="900" dirty="0"/>
           </a:p>
@@ -36799,7 +36835,7 @@
                   <a:schemeClr val="tx1"/>
                 </a:solidFill>
               </a:rPr>
-              <a:t>UPDATE EACH QUARTER</a:t>
+              <a:t>UPDATE EACH MONTH</a:t>
             </a:r>
             <a:endParaRPr lang="en-US" sz="900" dirty="0"/>
           </a:p>
@@ -36971,7 +37007,7 @@
                   <a:schemeClr val="tx1"/>
                 </a:solidFill>
               </a:rPr>
-              <a:t>UPDATE EACH QUARTER</a:t>
+              <a:t>UPDATE EACH MONTH</a:t>
             </a:r>
             <a:endParaRPr lang="en-US" sz="900" dirty="0"/>
           </a:p>
@@ -37143,7 +37179,7 @@
                   <a:schemeClr val="tx2"/>
                 </a:solidFill>
               </a:rPr>
-              <a:t>Shaded slides change every quarter (Step 5). The rest stay as they are unless the setup changes. The next two slides show the finished data slides.</a:t>
+              <a:t>Shaded slides change every month (Step 5). The rest stay as they are unless the setup changes. The next two slides show the finished data slides.</a:t>
             </a:r>
             <a:endParaRPr lang="en-US" sz="1200" dirty="0"/>
           </a:p>
@@ -44547,7 +44583,7 @@
                 <a:ea typeface="Georgia" pitchFamily="34" charset="-122"/>
                 <a:cs typeface="Georgia" pitchFamily="34" charset="-120"/>
               </a:rPr>
-              <a:t>Three files, refreshed once a quarter</a:t>
+              <a:t>Three files, refreshed every month</a:t>
             </a:r>
             <a:endParaRPr lang="en-US" sz="3400" dirty="0"/>
           </a:p>

</xml_diff>

<commit_message>
docs: TAG IVT guide names the recipient (Katrina Eddy, AAM)
Co-Authored-By: Claude Opus 5.5 <noreply@anthropic.com>
Claude-Session: https://claude.ai/code/session_014udSfWkctWaSTKdEZUW1Gh
</commit_message>
<xml_diff>
--- a/docs/TAG_IVT_Report_Update_Guide.pptx
+++ b/docs/TAG_IVT_Report_Update_Guide.pptx
@@ -138,7 +138,7 @@
   <p:extLst>
     <p:ext uri="{521415D9-36F7-43E2-AB2F-B90AF26B5E84}">
       <p14:sectionLst xmlns:p14="http://schemas.microsoft.com/office/powerpoint/2010/main">
-        <p14:section name="Overview" id="{e9294b11-86c2-caab-416a-51d9db43885d}">
+        <p14:section name="Overview" id="{3cb92171-c300-b514-726c-47e68a469399}">
           <p14:sldIdLst>
             <p14:sldId id="256"/>
             <p14:sldId id="257"/>
@@ -154,7 +154,7 @@
             <p14:sldId id="267"/>
           </p14:sldIdLst>
         </p14:section>
-        <p14:section name="Step 1 · GAM" id="{684f06ef-868a-1db8-c14a-b5b7edf1e879}">
+        <p14:section name="Step 1 · GAM" id="{b27cdb5a-bcb8-dbce-2bc0-2a0a5c051b8d}">
           <p14:sldIdLst>
             <p14:sldId id="268"/>
             <p14:sldId id="269"/>
@@ -164,33 +164,33 @@
             <p14:sldId id="273"/>
           </p14:sldIdLst>
         </p14:section>
-        <p14:section name="Step 2 · DV" id="{868a033d-57e9-b76a-7089-d0e562c27d45}">
+        <p14:section name="Step 2 · DV" id="{117a360c-0756-6e14-f180-dcb675d8cbb7}">
           <p14:sldIdLst>
             <p14:sldId id="274"/>
             <p14:sldId id="275"/>
             <p14:sldId id="276"/>
           </p14:sldIdLst>
         </p14:section>
-        <p14:section name="Step 3 · GA4 + pre-bid" id="{55ed1216-d2db-e8d0-bd70-cada02cd7b88}">
+        <p14:section name="Step 3 · GA4 + pre-bid" id="{5b6772e1-fdcb-86c3-d8b9-40c2a46647ff}">
           <p14:sldIdLst>
             <p14:sldId id="277"/>
             <p14:sldId id="278"/>
           </p14:sldIdLst>
         </p14:section>
-        <p14:section name="Step 4 · Quarter math" id="{2cfb939f-47c0-2206-3e1a-8a51a4a17164}">
+        <p14:section name="Step 4 · Quarter math" id="{25f44bd3-a279-6777-8d40-705597a3d239}">
           <p14:sldIdLst>
             <p14:sldId id="279"/>
             <p14:sldId id="280"/>
           </p14:sldIdLst>
         </p14:section>
-        <p14:section name="Step 5 · Build the deck" id="{57e7feb3-b7b8-e32b-20b1-f1772eb049de}">
+        <p14:section name="Step 5 · Build the deck" id="{3eb83376-4569-77c0-d201-87d728953298}">
           <p14:sldIdLst>
             <p14:sldId id="281"/>
             <p14:sldId id="282"/>
             <p14:sldId id="283"/>
           </p14:sldIdLst>
         </p14:section>
-        <p14:section name="Appendix" id="{37d2cf68-09ba-c88e-00cf-c81a093d8232}">
+        <p14:section name="Appendix" id="{5b0121e8-dc04-b043-2505-ac6fcca07b28}">
           <p14:sldIdLst>
             <p14:sldId id="284"/>
             <p14:sldId id="285"/>
@@ -30997,7 +30997,7 @@
                   <a:schemeClr val="tx1"/>
                 </a:solidFill>
               </a:rPr>
-              <a:t>Michael (CTO) and Kelly Liu (SVP Yield &amp; AdOps) review the deck before it goes to TAG</a:t>
+              <a:t>Michael (CTO) and Kelly Liu (SVP Yield &amp; AdOps) review it, then send it to Katrina Eddy (katrina.eddy@auditedmedia.com)</a:t>
             </a:r>
             <a:endParaRPr lang="en-US" sz="1400" dirty="0"/>
           </a:p>
@@ -35429,7 +35429,7 @@
                 <a:ea typeface="Georgia" pitchFamily="34" charset="-122"/>
                 <a:cs typeface="Georgia" pitchFamily="34" charset="-120"/>
               </a:rPr>
-              <a:t>Who reviews it</a:t>
+              <a:t>Who reviews and receives it</a:t>
             </a:r>
             <a:endParaRPr lang="en-US" sz="1800" dirty="0"/>
           </a:p>
@@ -35469,7 +35469,7 @@
                   <a:schemeClr val="tx1"/>
                 </a:solidFill>
               </a:rPr>
-              <a:t>Michael, CTO</a:t>
+              <a:t>Review: Michael (CTO), Kelly Liu (SVP Yield &amp; AdOps)</a:t>
             </a:r>
             <a:endParaRPr lang="en-US" sz="1300" dirty="0"/>
           </a:p>
@@ -35487,7 +35487,43 @@
                   <a:schemeClr val="tx1"/>
                 </a:solidFill>
               </a:rPr>
-              <a:t>Kelly Liu, SVP Yield &amp; AdOps</a:t>
+              <a:t>Send to: Katrina Eddy, VP Tech Assurance, AAM</a:t>
+            </a:r>
+            <a:endParaRPr lang="en-US" sz="1300" dirty="0"/>
+          </a:p>
+          <a:p>
+            <a:pPr marL="342900" indent="-342900">
+              <a:spcAft>
+                <a:spcPts val="200"/>
+              </a:spcAft>
+              <a:buSzPct val="100000"/>
+              <a:buChar char="•"/>
+            </a:pPr>
+            <a:r>
+              <a:rPr lang="en-US" sz="1300" dirty="0">
+                <a:solidFill>
+                  <a:schemeClr val="tx1"/>
+                </a:solidFill>
+              </a:rPr>
+              <a:t>katrina.eddy@auditedmedia.com</a:t>
+            </a:r>
+            <a:endParaRPr lang="en-US" sz="1300" dirty="0"/>
+          </a:p>
+          <a:p>
+            <a:pPr marL="342900" indent="-342900">
+              <a:spcAft>
+                <a:spcPts val="200"/>
+              </a:spcAft>
+              <a:buSzPct val="100000"/>
+              <a:buChar char="•"/>
+            </a:pPr>
+            <a:r>
+              <a:rPr lang="en-US" sz="1300" dirty="0">
+                <a:solidFill>
+                  <a:schemeClr val="tx1"/>
+                </a:solidFill>
+              </a:rPr>
+              <a:t>O 203-447-2883 · M 203-675-5652</a:t>
             </a:r>
             <a:endParaRPr lang="en-US" sz="1300" dirty="0"/>
           </a:p>

</xml_diff>

<commit_message>
docs: add the yearly AAM review to the TAG IVT guide
Two appendix slides and a runbook section: the evidence AAM asks for
after the January review call, and the questions it asks with last
year's answers (sampling, lists, AdX, methodology link, sellers.json,
fraud response). Timing now mentions the January call, the recipient
card adds Jonathan Reid and TechAssurance@ on cc, and the video DV-GAM
gap is explained (mostly AdX, which DV can't scan post-bid).

Co-Authored-By: Claude Opus 5.5 <noreply@anthropic.com>
Claude-Session: https://claude.ai/code/session_014udSfWkctWaSTKdEZUW1Gh
</commit_message>
<xml_diff>
--- a/docs/TAG_IVT_Report_Update_Guide.pptx
+++ b/docs/TAG_IVT_Report_Update_Guide.pptx
@@ -37,9 +37,11 @@
     <p:sldId id="285" r:id="rId31"/>
     <p:sldId id="286" r:id="rId32"/>
     <p:sldId id="287" r:id="rId33"/>
+    <p:sldId id="288" r:id="rId34"/>
+    <p:sldId id="289" r:id="rId35"/>
   </p:sldIdLst>
   <p:notesMasterIdLst>
-    <p:notesMasterId r:id="rId34"/>
+    <p:notesMasterId r:id="rId36"/>
   </p:notesMasterIdLst>
   <p:sldSz cx="12192000" cy="6858000"/>
   <p:notesSz cx="6858000" cy="12192000"/>
@@ -138,7 +140,7 @@
   <p:extLst>
     <p:ext uri="{521415D9-36F7-43E2-AB2F-B90AF26B5E84}">
       <p14:sectionLst xmlns:p14="http://schemas.microsoft.com/office/powerpoint/2010/main">
-        <p14:section name="Overview" id="{3cb92171-c300-b514-726c-47e68a469399}">
+        <p14:section name="Overview" id="{612a0bb7-0cc6-541a-f1dd-eb7f6c93159f}">
           <p14:sldIdLst>
             <p14:sldId id="256"/>
             <p14:sldId id="257"/>
@@ -154,7 +156,7 @@
             <p14:sldId id="267"/>
           </p14:sldIdLst>
         </p14:section>
-        <p14:section name="Step 1 · GAM" id="{b27cdb5a-bcb8-dbce-2bc0-2a0a5c051b8d}">
+        <p14:section name="Step 1 · GAM" id="{df5b372e-6b54-2874-5afa-62d5334c505d}">
           <p14:sldIdLst>
             <p14:sldId id="268"/>
             <p14:sldId id="269"/>
@@ -164,38 +166,40 @@
             <p14:sldId id="273"/>
           </p14:sldIdLst>
         </p14:section>
-        <p14:section name="Step 2 · DV" id="{117a360c-0756-6e14-f180-dcb675d8cbb7}">
+        <p14:section name="Step 2 · DV" id="{10901d52-7efa-ba85-f6fe-01bfce1b95ad}">
           <p14:sldIdLst>
             <p14:sldId id="274"/>
             <p14:sldId id="275"/>
             <p14:sldId id="276"/>
           </p14:sldIdLst>
         </p14:section>
-        <p14:section name="Step 3 · GA4 + pre-bid" id="{5b6772e1-fdcb-86c3-d8b9-40c2a46647ff}">
+        <p14:section name="Step 3 · GA4 + pre-bid" id="{0b75761b-68a0-f733-e16a-f5c947622051}">
           <p14:sldIdLst>
             <p14:sldId id="277"/>
             <p14:sldId id="278"/>
           </p14:sldIdLst>
         </p14:section>
-        <p14:section name="Step 4 · Quarter math" id="{25f44bd3-a279-6777-8d40-705597a3d239}">
+        <p14:section name="Step 4 · Quarter math" id="{0ad1d3ca-a643-c9fa-699a-3cb734f0cb0e}">
           <p14:sldIdLst>
             <p14:sldId id="279"/>
             <p14:sldId id="280"/>
           </p14:sldIdLst>
         </p14:section>
-        <p14:section name="Step 5 · Build the deck" id="{3eb83376-4569-77c0-d201-87d728953298}">
+        <p14:section name="Step 5 · Build the deck" id="{f1f449c2-af33-10ef-b60d-fbc3cc52b196}">
           <p14:sldIdLst>
             <p14:sldId id="281"/>
             <p14:sldId id="282"/>
             <p14:sldId id="283"/>
           </p14:sldIdLst>
         </p14:section>
-        <p14:section name="Appendix" id="{5b0121e8-dc04-b043-2505-ac6fcca07b28}">
+        <p14:section name="Appendix" id="{a45da84d-2e02-ccf2-a87c-6bae46657484}">
           <p14:sldIdLst>
             <p14:sldId id="284"/>
             <p14:sldId id="285"/>
             <p14:sldId id="286"/>
             <p14:sldId id="287"/>
+            <p14:sldId id="288"/>
+            <p14:sldId id="289"/>
           </p14:sldIdLst>
         </p14:section>
       </p14:sectionLst>
@@ -5574,6 +5578,182 @@
 </p:notes>
 </file>
 
+<file path=ppt/notesSlides/notesSlide33.xml><?xml version="1.0" encoding="utf-8"?>
+<p:notes xmlns:a="http://schemas.openxmlformats.org/drawingml/2006/main" xmlns:r="http://schemas.openxmlformats.org/officeDocument/2006/relationships" xmlns:p="http://schemas.openxmlformats.org/presentationml/2006/main">
+  <p:cSld>
+    <p:spTree>
+      <p:nvGrpSpPr>
+        <p:cNvPr id="1" name=""/>
+        <p:cNvGrpSpPr/>
+        <p:nvPr/>
+      </p:nvGrpSpPr>
+      <p:grpSpPr>
+        <a:xfrm>
+          <a:off x="0" y="0"/>
+          <a:ext cx="0" cy="0"/>
+          <a:chOff x="0" y="0"/>
+          <a:chExt cx="0" cy="0"/>
+        </a:xfrm>
+      </p:grpSpPr>
+      <p:sp>
+        <p:nvSpPr>
+          <p:cNvPr id="2" name="Slide Image Placeholder 1"/>
+          <p:cNvSpPr>
+            <a:spLocks noGrp="1" noRot="1" noChangeAspect="1"/>
+          </p:cNvSpPr>
+          <p:nvPr>
+            <p:ph type="sldImg"/>
+          </p:nvPr>
+        </p:nvSpPr>
+        <p:spPr/>
+      </p:sp>
+      <p:sp>
+        <p:nvSpPr>
+          <p:cNvPr id="3" name="Notes Placeholder 2"/>
+          <p:cNvSpPr>
+            <a:spLocks noGrp="1"/>
+          </p:cNvSpPr>
+          <p:nvPr>
+            <p:ph type="body" idx="1"/>
+          </p:nvPr>
+        </p:nvSpPr>
+        <p:spPr/>
+        <p:txBody>
+          <a:bodyPr/>
+          <a:lstStyle/>
+          <a:p>
+            <a:r>
+              <a:rPr lang="en-US" dirty="0"/>
+              <a:t/>
+            </a:r>
+            <a:endParaRPr lang="en-US" dirty="0"/>
+          </a:p>
+        </p:txBody>
+      </p:sp>
+      <p:sp>
+        <p:nvSpPr>
+          <p:cNvPr id="4" name="Slide Number Placeholder 3"/>
+          <p:cNvSpPr>
+            <a:spLocks noGrp="1"/>
+          </p:cNvSpPr>
+          <p:nvPr>
+            <p:ph type="sldNum" sz="quarter" idx="10"/>
+          </p:nvPr>
+        </p:nvSpPr>
+        <p:spPr/>
+        <p:txBody>
+          <a:bodyPr/>
+          <a:lstStyle/>
+          <a:p>
+            <a:fld id="{F7021451-1387-4CA6-816F-3879F97B5CBC}" type="slidenum">
+              <a:rPr lang="en-US"/>
+              <a:t>33</a:t>
+            </a:fld>
+            <a:endParaRPr lang="en-US"/>
+          </a:p>
+        </p:txBody>
+      </p:sp>
+    </p:spTree>
+    <p:extLst>
+      <p:ext uri="{BB962C8B-B14F-4D97-AF65-F5344CB8AC3E}">
+        <p14:creationId xmlns:p14="http://schemas.microsoft.com/office/powerpoint/2010/main" val="1024086991"/>
+      </p:ext>
+    </p:extLst>
+  </p:cSld>
+  <p:clrMapOvr>
+    <a:masterClrMapping/>
+  </p:clrMapOvr>
+</p:notes>
+</file>
+
+<file path=ppt/notesSlides/notesSlide34.xml><?xml version="1.0" encoding="utf-8"?>
+<p:notes xmlns:a="http://schemas.openxmlformats.org/drawingml/2006/main" xmlns:r="http://schemas.openxmlformats.org/officeDocument/2006/relationships" xmlns:p="http://schemas.openxmlformats.org/presentationml/2006/main">
+  <p:cSld>
+    <p:spTree>
+      <p:nvGrpSpPr>
+        <p:cNvPr id="1" name=""/>
+        <p:cNvGrpSpPr/>
+        <p:nvPr/>
+      </p:nvGrpSpPr>
+      <p:grpSpPr>
+        <a:xfrm>
+          <a:off x="0" y="0"/>
+          <a:ext cx="0" cy="0"/>
+          <a:chOff x="0" y="0"/>
+          <a:chExt cx="0" cy="0"/>
+        </a:xfrm>
+      </p:grpSpPr>
+      <p:sp>
+        <p:nvSpPr>
+          <p:cNvPr id="2" name="Slide Image Placeholder 1"/>
+          <p:cNvSpPr>
+            <a:spLocks noGrp="1" noRot="1" noChangeAspect="1"/>
+          </p:cNvSpPr>
+          <p:nvPr>
+            <p:ph type="sldImg"/>
+          </p:nvPr>
+        </p:nvSpPr>
+        <p:spPr/>
+      </p:sp>
+      <p:sp>
+        <p:nvSpPr>
+          <p:cNvPr id="3" name="Notes Placeholder 2"/>
+          <p:cNvSpPr>
+            <a:spLocks noGrp="1"/>
+          </p:cNvSpPr>
+          <p:nvPr>
+            <p:ph type="body" idx="1"/>
+          </p:nvPr>
+        </p:nvSpPr>
+        <p:spPr/>
+        <p:txBody>
+          <a:bodyPr/>
+          <a:lstStyle/>
+          <a:p>
+            <a:r>
+              <a:rPr lang="en-US" dirty="0"/>
+              <a:t/>
+            </a:r>
+            <a:endParaRPr lang="en-US" dirty="0"/>
+          </a:p>
+        </p:txBody>
+      </p:sp>
+      <p:sp>
+        <p:nvSpPr>
+          <p:cNvPr id="4" name="Slide Number Placeholder 3"/>
+          <p:cNvSpPr>
+            <a:spLocks noGrp="1"/>
+          </p:cNvSpPr>
+          <p:nvPr>
+            <p:ph type="sldNum" sz="quarter" idx="10"/>
+          </p:nvPr>
+        </p:nvSpPr>
+        <p:spPr/>
+        <p:txBody>
+          <a:bodyPr/>
+          <a:lstStyle/>
+          <a:p>
+            <a:fld id="{F7021451-1387-4CA6-816F-3879F97B5CBC}" type="slidenum">
+              <a:rPr lang="en-US"/>
+              <a:t>34</a:t>
+            </a:fld>
+            <a:endParaRPr lang="en-US"/>
+          </a:p>
+        </p:txBody>
+      </p:sp>
+    </p:spTree>
+    <p:extLst>
+      <p:ext uri="{BB962C8B-B14F-4D97-AF65-F5344CB8AC3E}">
+        <p14:creationId xmlns:p14="http://schemas.microsoft.com/office/powerpoint/2010/main" val="1024086991"/>
+      </p:ext>
+    </p:extLst>
+  </p:cSld>
+  <p:clrMapOvr>
+    <a:masterClrMapping/>
+  </p:clrMapOvr>
+</p:notes>
+</file>
+
 <file path=ppt/notesSlides/notesSlide4.xml><?xml version="1.0" encoding="utf-8"?>
 <p:notes xmlns:a="http://schemas.openxmlformats.org/drawingml/2006/main" xmlns:r="http://schemas.openxmlformats.org/officeDocument/2006/relationships" xmlns:p="http://schemas.openxmlformats.org/presentationml/2006/main">
   <p:cSld>
@@ -31190,7 +31370,7 @@
                   <a:schemeClr val="bg2"/>
                 </a:solidFill>
               </a:rPr>
-              <a:t>Charts to sanity-check the numbers each month</a:t>
+              <a:t>Sanity-check charts and the yearly AAM review</a:t>
             </a:r>
             <a:endParaRPr lang="en-US" sz="1800" dirty="0"/>
           </a:p>
@@ -34130,7 +34310,7 @@
                   <a:schemeClr val="tx2"/>
                 </a:solidFill>
               </a:rPr>
-              <a:t>86.7% measured. Why the gap: TO CONFIRM with DV.</a:t>
+              <a:t>86.7% measured. Mostly Google AdX, which DV can't scan post-bid.</a:t>
             </a:r>
             <a:endParaRPr lang="en-US" sz="1300" dirty="0"/>
           </a:p>
@@ -34691,6 +34871,2589 @@
             <a:fld id="{F7021451-1387-4CA6-816F-3879F97B5CBC}" type="slidenum">
               <a:rPr b="0" lang="en-US"/>
               <a:t>32</a:t>
+            </a:fld>
+            <a:endParaRPr lang="en-US"/>
+          </a:p>
+        </p:txBody>
+      </p:sp>
+    </p:spTree>
+  </p:cSld>
+  <p:clrMapOvr>
+    <a:masterClrMapping/>
+  </p:clrMapOvr>
+</p:sld>
+</file>
+
+<file path=ppt/slides/slide33.xml><?xml version="1.0" encoding="utf-8"?>
+<p:sld xmlns:a="http://schemas.openxmlformats.org/drawingml/2006/main" xmlns:r="http://schemas.openxmlformats.org/officeDocument/2006/relationships" xmlns:p="http://schemas.openxmlformats.org/presentationml/2006/main">
+  <p:cSld name="Slide 33">
+    <p:spTree>
+      <p:nvGrpSpPr>
+        <p:cNvPr id="1" name=""/>
+        <p:cNvGrpSpPr/>
+        <p:nvPr/>
+      </p:nvGrpSpPr>
+      <p:grpSpPr>
+        <a:xfrm>
+          <a:off x="0" y="0"/>
+          <a:ext cx="0" cy="0"/>
+          <a:chOff x="0" y="0"/>
+          <a:chExt cx="0" cy="0"/>
+        </a:xfrm>
+      </p:grpSpPr>
+      <p:sp>
+        <p:nvSpPr>
+          <p:cNvPr id="2" name="Text 1"/>
+          <p:cNvSpPr/>
+          <p:nvPr>
+            <p:ph idx="101" type="body" hasCustomPrompt="1"/>
+          </p:nvPr>
+        </p:nvSpPr>
+        <p:spPr>
+          <a:xfrm>
+            <a:off x="749808" y="457200"/>
+            <a:ext cx="8229600" cy="329184"/>
+          </a:xfrm>
+          <a:prstGeom prst="rect">
+            <a:avLst/>
+          </a:prstGeom>
+          <a:noFill/>
+          <a:ln/>
+        </p:spPr>
+        <p:txBody>
+          <a:bodyPr wrap="square" lIns="0" tIns="0" rIns="0" bIns="0" rtlCol="0" anchor="ctr"/>
+          <a:lstStyle/>
+          <a:p>
+            <a:pPr indent="0" marL="0">
+              <a:buNone/>
+            </a:pPr>
+            <a:r>
+              <a:rPr lang="en-US" sz="1200" b="1" spc="300" kern="0" dirty="0">
+                <a:solidFill>
+                  <a:schemeClr val="tx2"/>
+                </a:solidFill>
+              </a:rPr>
+              <a:t>APPENDIX · YEARLY AAM REVIEW</a:t>
+            </a:r>
+            <a:endParaRPr lang="en-US" sz="1200" dirty="0"/>
+          </a:p>
+        </p:txBody>
+      </p:sp>
+      <p:sp>
+        <p:nvSpPr>
+          <p:cNvPr id="3" name="Text 1"/>
+          <p:cNvSpPr/>
+          <p:nvPr>
+            <p:ph idx="102" type="title" hasCustomPrompt="1"/>
+          </p:nvPr>
+        </p:nvSpPr>
+        <p:spPr>
+          <a:xfrm>
+            <a:off x="548640" y="868680"/>
+            <a:ext cx="11094415" cy="868680"/>
+          </a:xfrm>
+          <a:prstGeom prst="rect">
+            <a:avLst/>
+          </a:prstGeom>
+          <a:noFill/>
+          <a:ln/>
+        </p:spPr>
+        <p:txBody>
+          <a:bodyPr wrap="square" lIns="0" tIns="0" rIns="0" bIns="0" rtlCol="0" anchor="t"/>
+          <a:lstStyle/>
+          <a:p>
+            <a:pPr algn="l" indent="0" marL="0">
+              <a:buNone/>
+            </a:pPr>
+            <a:r>
+              <a:rPr lang="en-US" sz="3400" dirty="0">
+                <a:solidFill>
+                  <a:schemeClr val="tx1"/>
+                </a:solidFill>
+                <a:latin typeface="Georgia" pitchFamily="34" charset="0"/>
+                <a:ea typeface="Georgia" pitchFamily="34" charset="-122"/>
+                <a:cs typeface="Georgia" pitchFamily="34" charset="-120"/>
+              </a:rPr>
+              <a:t>What AAM asks for in January</a:t>
+            </a:r>
+            <a:endParaRPr lang="en-US" sz="3400" dirty="0"/>
+          </a:p>
+        </p:txBody>
+      </p:sp>
+      <p:sp>
+        <p:nvSpPr>
+          <p:cNvPr id="4" name="Text 2"/>
+          <p:cNvSpPr txBox="1"/>
+          <p:nvPr/>
+        </p:nvSpPr>
+        <p:spPr>
+          <a:xfrm>
+            <a:off x="548640" y="1828800"/>
+            <a:ext cx="11094415" cy="457200"/>
+          </a:xfrm>
+          <a:prstGeom prst="rect">
+            <a:avLst/>
+          </a:prstGeom>
+          <a:noFill/>
+          <a:ln/>
+        </p:spPr>
+        <p:txBody>
+          <a:bodyPr wrap="square" lIns="0" tIns="0" rIns="0" bIns="0" rtlCol="0" anchor="t"/>
+          <a:lstStyle/>
+          <a:p>
+            <a:pPr indent="0" marL="0">
+              <a:buNone/>
+            </a:pPr>
+            <a:r>
+              <a:rPr lang="en-US" sz="1300" dirty="0">
+                <a:solidFill>
+                  <a:schemeClr val="tx2"/>
+                </a:solidFill>
+              </a:rPr>
+              <a:t>AAM (the Alliance for Audited Media) audits our TAG CAF seal once a year. After the review call, Jonathan Reid sends a list of evidence to drop in the shared folder. Last year's list:</a:t>
+            </a:r>
+            <a:endParaRPr lang="en-US" sz="1300" dirty="0"/>
+          </a:p>
+        </p:txBody>
+      </p:sp>
+      <p:sp>
+        <p:nvSpPr>
+          <p:cNvPr id="5" name="evidence 1"/>
+          <p:cNvSpPr/>
+          <p:nvPr/>
+        </p:nvSpPr>
+        <p:spPr>
+          <a:xfrm>
+            <a:off x="548640" y="2423160"/>
+            <a:ext cx="5410048" cy="621792"/>
+          </a:xfrm>
+          <a:prstGeom prst="rect">
+            <a:avLst/>
+          </a:prstGeom>
+          <a:solidFill>
+            <a:schemeClr val="bg1"/>
+          </a:solidFill>
+          <a:ln w="9525">
+            <a:solidFill>
+              <a:srgbClr val="E7E0C9"/>
+            </a:solidFill>
+            <a:prstDash val="solid"/>
+          </a:ln>
+        </p:spPr>
+      </p:sp>
+      <p:sp>
+        <p:nvSpPr>
+          <p:cNvPr id="6" name="evbox 1"/>
+          <p:cNvSpPr/>
+          <p:nvPr/>
+        </p:nvSpPr>
+        <p:spPr>
+          <a:xfrm>
+            <a:off x="777240" y="2624328"/>
+            <a:ext cx="219456" cy="219456"/>
+          </a:xfrm>
+          <a:prstGeom prst="rect">
+            <a:avLst/>
+          </a:prstGeom>
+          <a:solidFill>
+            <a:schemeClr val="bg1"/>
+          </a:solidFill>
+          <a:ln w="15875">
+            <a:solidFill>
+              <a:srgbClr val="1F1E19"/>
+            </a:solidFill>
+            <a:prstDash val="solid"/>
+          </a:ln>
+        </p:spPr>
+      </p:sp>
+      <p:sp>
+        <p:nvSpPr>
+          <p:cNvPr id="7" name="Text 5"/>
+          <p:cNvSpPr txBox="1"/>
+          <p:nvPr/>
+        </p:nvSpPr>
+        <p:spPr>
+          <a:xfrm>
+            <a:off x="1188720" y="2487168"/>
+            <a:ext cx="4587088" cy="274320"/>
+          </a:xfrm>
+          <a:prstGeom prst="rect">
+            <a:avLst/>
+          </a:prstGeom>
+          <a:noFill/>
+          <a:ln/>
+        </p:spPr>
+        <p:txBody>
+          <a:bodyPr wrap="square" lIns="0" tIns="0" rIns="0" bIns="0" rtlCol="0" anchor="t"/>
+          <a:lstStyle/>
+          <a:p>
+            <a:pPr indent="0" marL="0">
+              <a:buNone/>
+            </a:pPr>
+            <a:r>
+              <a:rPr lang="en-US" sz="1400" b="1" dirty="0">
+                <a:solidFill>
+                  <a:schemeClr val="tx1"/>
+                </a:solidFill>
+              </a:rPr>
+              <a:t>The report deck</a:t>
+            </a:r>
+            <a:endParaRPr lang="en-US" sz="1400" dirty="0"/>
+          </a:p>
+        </p:txBody>
+      </p:sp>
+      <p:sp>
+        <p:nvSpPr>
+          <p:cNvPr id="8" name="Text 6"/>
+          <p:cNvSpPr txBox="1"/>
+          <p:nvPr/>
+        </p:nvSpPr>
+        <p:spPr>
+          <a:xfrm>
+            <a:off x="1188720" y="2761488"/>
+            <a:ext cx="4587088" cy="246888"/>
+          </a:xfrm>
+          <a:prstGeom prst="rect">
+            <a:avLst/>
+          </a:prstGeom>
+          <a:noFill/>
+          <a:ln/>
+        </p:spPr>
+        <p:txBody>
+          <a:bodyPr wrap="square" lIns="0" tIns="0" rIns="0" bIns="0" rtlCol="0" anchor="t"/>
+          <a:lstStyle/>
+          <a:p>
+            <a:pPr indent="0" marL="0">
+              <a:buNone/>
+            </a:pPr>
+            <a:r>
+              <a:rPr lang="en-US" sz="1200" dirty="0">
+                <a:solidFill>
+                  <a:schemeClr val="tx2"/>
+                </a:solidFill>
+              </a:rPr>
+              <a:t>This deck, as presented on the call</a:t>
+            </a:r>
+            <a:endParaRPr lang="en-US" sz="1200" dirty="0"/>
+          </a:p>
+        </p:txBody>
+      </p:sp>
+      <p:sp>
+        <p:nvSpPr>
+          <p:cNvPr id="9" name="evidence 2"/>
+          <p:cNvSpPr/>
+          <p:nvPr/>
+        </p:nvSpPr>
+        <p:spPr>
+          <a:xfrm>
+            <a:off x="548640" y="3154680"/>
+            <a:ext cx="5410048" cy="621792"/>
+          </a:xfrm>
+          <a:prstGeom prst="rect">
+            <a:avLst/>
+          </a:prstGeom>
+          <a:solidFill>
+            <a:schemeClr val="bg1"/>
+          </a:solidFill>
+          <a:ln w="9525">
+            <a:solidFill>
+              <a:srgbClr val="E7E0C9"/>
+            </a:solidFill>
+            <a:prstDash val="solid"/>
+          </a:ln>
+        </p:spPr>
+      </p:sp>
+      <p:sp>
+        <p:nvSpPr>
+          <p:cNvPr id="10" name="evbox 2"/>
+          <p:cNvSpPr/>
+          <p:nvPr/>
+        </p:nvSpPr>
+        <p:spPr>
+          <a:xfrm>
+            <a:off x="777240" y="3355848"/>
+            <a:ext cx="219456" cy="219456"/>
+          </a:xfrm>
+          <a:prstGeom prst="rect">
+            <a:avLst/>
+          </a:prstGeom>
+          <a:solidFill>
+            <a:schemeClr val="bg1"/>
+          </a:solidFill>
+          <a:ln w="15875">
+            <a:solidFill>
+              <a:srgbClr val="1F1E19"/>
+            </a:solidFill>
+            <a:prstDash val="solid"/>
+          </a:ln>
+        </p:spPr>
+      </p:sp>
+      <p:sp>
+        <p:nvSpPr>
+          <p:cNvPr id="11" name="Text 9"/>
+          <p:cNvSpPr txBox="1"/>
+          <p:nvPr/>
+        </p:nvSpPr>
+        <p:spPr>
+          <a:xfrm>
+            <a:off x="1188720" y="3218688"/>
+            <a:ext cx="4587088" cy="274320"/>
+          </a:xfrm>
+          <a:prstGeom prst="rect">
+            <a:avLst/>
+          </a:prstGeom>
+          <a:noFill/>
+          <a:ln/>
+        </p:spPr>
+        <p:txBody>
+          <a:bodyPr wrap="square" lIns="0" tIns="0" rIns="0" bIns="0" rtlCol="0" anchor="t"/>
+          <a:lstStyle/>
+          <a:p>
+            <a:pPr indent="0" marL="0">
+              <a:buNone/>
+            </a:pPr>
+            <a:r>
+              <a:rPr lang="en-US" sz="1400" b="1" dirty="0">
+                <a:solidFill>
+                  <a:schemeClr val="tx1"/>
+                </a:solidFill>
+              </a:rPr>
+              <a:t>DV IVT screenshots</a:t>
+            </a:r>
+            <a:endParaRPr lang="en-US" sz="1400" dirty="0"/>
+          </a:p>
+        </p:txBody>
+      </p:sp>
+      <p:sp>
+        <p:nvSpPr>
+          <p:cNvPr id="12" name="Text 10"/>
+          <p:cNvSpPr txBox="1"/>
+          <p:nvPr/>
+        </p:nvSpPr>
+        <p:spPr>
+          <a:xfrm>
+            <a:off x="1188720" y="3493008"/>
+            <a:ext cx="4587088" cy="246888"/>
+          </a:xfrm>
+          <a:prstGeom prst="rect">
+            <a:avLst/>
+          </a:prstGeom>
+          <a:noFill/>
+          <a:ln/>
+        </p:spPr>
+        <p:txBody>
+          <a:bodyPr wrap="square" lIns="0" tIns="0" rIns="0" bIns="0" rtlCol="0" anchor="t"/>
+          <a:lstStyle/>
+          <a:p>
+            <a:pPr indent="0" marL="0">
+              <a:buNone/>
+            </a:pPr>
+            <a:r>
+              <a:rPr lang="en-US" sz="1200" dirty="0">
+                <a:solidFill>
+                  <a:schemeClr val="tx2"/>
+                </a:solidFill>
+              </a:rPr>
+              <a:t>IVT rates from the DV UI</a:t>
+            </a:r>
+            <a:endParaRPr lang="en-US" sz="1200" dirty="0"/>
+          </a:p>
+        </p:txBody>
+      </p:sp>
+      <p:sp>
+        <p:nvSpPr>
+          <p:cNvPr id="13" name="evidence 3"/>
+          <p:cNvSpPr/>
+          <p:nvPr/>
+        </p:nvSpPr>
+        <p:spPr>
+          <a:xfrm>
+            <a:off x="548640" y="3886200"/>
+            <a:ext cx="5410048" cy="621792"/>
+          </a:xfrm>
+          <a:prstGeom prst="rect">
+            <a:avLst/>
+          </a:prstGeom>
+          <a:solidFill>
+            <a:schemeClr val="bg1"/>
+          </a:solidFill>
+          <a:ln w="9525">
+            <a:solidFill>
+              <a:srgbClr val="E7E0C9"/>
+            </a:solidFill>
+            <a:prstDash val="solid"/>
+          </a:ln>
+        </p:spPr>
+      </p:sp>
+      <p:sp>
+        <p:nvSpPr>
+          <p:cNvPr id="14" name="evbox 3"/>
+          <p:cNvSpPr/>
+          <p:nvPr/>
+        </p:nvSpPr>
+        <p:spPr>
+          <a:xfrm>
+            <a:off x="777240" y="4087368"/>
+            <a:ext cx="219456" cy="219456"/>
+          </a:xfrm>
+          <a:prstGeom prst="rect">
+            <a:avLst/>
+          </a:prstGeom>
+          <a:solidFill>
+            <a:schemeClr val="bg1"/>
+          </a:solidFill>
+          <a:ln w="15875">
+            <a:solidFill>
+              <a:srgbClr val="1F1E19"/>
+            </a:solidFill>
+            <a:prstDash val="solid"/>
+          </a:ln>
+        </p:spPr>
+      </p:sp>
+      <p:sp>
+        <p:nvSpPr>
+          <p:cNvPr id="15" name="Text 13"/>
+          <p:cNvSpPr txBox="1"/>
+          <p:nvPr/>
+        </p:nvSpPr>
+        <p:spPr>
+          <a:xfrm>
+            <a:off x="1188720" y="3950208"/>
+            <a:ext cx="4587088" cy="274320"/>
+          </a:xfrm>
+          <a:prstGeom prst="rect">
+            <a:avLst/>
+          </a:prstGeom>
+          <a:noFill/>
+          <a:ln/>
+        </p:spPr>
+        <p:txBody>
+          <a:bodyPr wrap="square" lIns="0" tIns="0" rIns="0" bIns="0" rtlCol="0" anchor="t"/>
+          <a:lstStyle/>
+          <a:p>
+            <a:pPr indent="0" marL="0">
+              <a:buNone/>
+            </a:pPr>
+            <a:r>
+              <a:rPr lang="en-US" sz="1400" b="1" dirty="0">
+                <a:solidFill>
+                  <a:schemeClr val="tx1"/>
+                </a:solidFill>
+              </a:rPr>
+              <a:t>DV raw pre-bid data</a:t>
+            </a:r>
+            <a:endParaRPr lang="en-US" sz="1400" dirty="0"/>
+          </a:p>
+        </p:txBody>
+      </p:sp>
+      <p:sp>
+        <p:nvSpPr>
+          <p:cNvPr id="16" name="Text 14"/>
+          <p:cNvSpPr txBox="1"/>
+          <p:nvPr/>
+        </p:nvSpPr>
+        <p:spPr>
+          <a:xfrm>
+            <a:off x="1188720" y="4224528"/>
+            <a:ext cx="4587088" cy="246888"/>
+          </a:xfrm>
+          <a:prstGeom prst="rect">
+            <a:avLst/>
+          </a:prstGeom>
+          <a:noFill/>
+          <a:ln/>
+        </p:spPr>
+        <p:txBody>
+          <a:bodyPr wrap="square" lIns="0" tIns="0" rIns="0" bIns="0" rtlCol="0" anchor="t"/>
+          <a:lstStyle/>
+          <a:p>
+            <a:pPr indent="0" marL="0">
+              <a:buNone/>
+            </a:pPr>
+            <a:r>
+              <a:rPr lang="en-US" sz="1200" dirty="0">
+                <a:solidFill>
+                  <a:schemeClr val="tx2"/>
+                </a:solidFill>
+              </a:rPr>
+              <a:t>The monthly CSVs, plus DV's emails for months sent by email</a:t>
+            </a:r>
+            <a:endParaRPr lang="en-US" sz="1200" dirty="0"/>
+          </a:p>
+        </p:txBody>
+      </p:sp>
+      <p:sp>
+        <p:nvSpPr>
+          <p:cNvPr id="17" name="evidence 4"/>
+          <p:cNvSpPr/>
+          <p:nvPr/>
+        </p:nvSpPr>
+        <p:spPr>
+          <a:xfrm>
+            <a:off x="548640" y="4617720"/>
+            <a:ext cx="5410048" cy="621792"/>
+          </a:xfrm>
+          <a:prstGeom prst="rect">
+            <a:avLst/>
+          </a:prstGeom>
+          <a:solidFill>
+            <a:schemeClr val="bg1"/>
+          </a:solidFill>
+          <a:ln w="9525">
+            <a:solidFill>
+              <a:srgbClr val="E7E0C9"/>
+            </a:solidFill>
+            <a:prstDash val="solid"/>
+          </a:ln>
+        </p:spPr>
+      </p:sp>
+      <p:sp>
+        <p:nvSpPr>
+          <p:cNvPr id="18" name="evbox 4"/>
+          <p:cNvSpPr/>
+          <p:nvPr/>
+        </p:nvSpPr>
+        <p:spPr>
+          <a:xfrm>
+            <a:off x="777240" y="4818888"/>
+            <a:ext cx="219456" cy="219456"/>
+          </a:xfrm>
+          <a:prstGeom prst="rect">
+            <a:avLst/>
+          </a:prstGeom>
+          <a:solidFill>
+            <a:schemeClr val="bg1"/>
+          </a:solidFill>
+          <a:ln w="15875">
+            <a:solidFill>
+              <a:srgbClr val="1F1E19"/>
+            </a:solidFill>
+            <a:prstDash val="solid"/>
+          </a:ln>
+        </p:spPr>
+      </p:sp>
+      <p:sp>
+        <p:nvSpPr>
+          <p:cNvPr id="19" name="Text 17"/>
+          <p:cNvSpPr txBox="1"/>
+          <p:nvPr/>
+        </p:nvSpPr>
+        <p:spPr>
+          <a:xfrm>
+            <a:off x="1188720" y="4681728"/>
+            <a:ext cx="4587088" cy="274320"/>
+          </a:xfrm>
+          <a:prstGeom prst="rect">
+            <a:avLst/>
+          </a:prstGeom>
+          <a:noFill/>
+          <a:ln/>
+        </p:spPr>
+        <p:txBody>
+          <a:bodyPr wrap="square" lIns="0" tIns="0" rIns="0" bIns="0" rtlCol="0" anchor="t"/>
+          <a:lstStyle/>
+          <a:p>
+            <a:pPr indent="0" marL="0">
+              <a:buNone/>
+            </a:pPr>
+            <a:r>
+              <a:rPr lang="en-US" sz="1400" b="1" dirty="0">
+                <a:solidFill>
+                  <a:schemeClr val="tx1"/>
+                </a:solidFill>
+              </a:rPr>
+              <a:t>GA4 screenshots</a:t>
+            </a:r>
+            <a:endParaRPr lang="en-US" sz="1400" dirty="0"/>
+          </a:p>
+        </p:txBody>
+      </p:sp>
+      <p:sp>
+        <p:nvSpPr>
+          <p:cNvPr id="20" name="Text 18"/>
+          <p:cNvSpPr txBox="1"/>
+          <p:nvPr/>
+        </p:nvSpPr>
+        <p:spPr>
+          <a:xfrm>
+            <a:off x="1188720" y="4956048"/>
+            <a:ext cx="4587088" cy="246888"/>
+          </a:xfrm>
+          <a:prstGeom prst="rect">
+            <a:avLst/>
+          </a:prstGeom>
+          <a:noFill/>
+          <a:ln/>
+        </p:spPr>
+        <p:txBody>
+          <a:bodyPr wrap="square" lIns="0" tIns="0" rIns="0" bIns="0" rtlCol="0" anchor="t"/>
+          <a:lstStyle/>
+          <a:p>
+            <a:pPr indent="0" marL="0">
+              <a:buNone/>
+            </a:pPr>
+            <a:r>
+              <a:rPr lang="en-US" sz="1200" dirty="0">
+                <a:solidFill>
+                  <a:schemeClr val="tx2"/>
+                </a:solidFill>
+              </a:rPr>
+              <a:t>Pageview counts, by month</a:t>
+            </a:r>
+            <a:endParaRPr lang="en-US" sz="1200" dirty="0"/>
+          </a:p>
+        </p:txBody>
+      </p:sp>
+      <p:sp>
+        <p:nvSpPr>
+          <p:cNvPr id="21" name="evidence 5"/>
+          <p:cNvSpPr/>
+          <p:nvPr/>
+        </p:nvSpPr>
+        <p:spPr>
+          <a:xfrm>
+            <a:off x="548640" y="5349240"/>
+            <a:ext cx="5410048" cy="621792"/>
+          </a:xfrm>
+          <a:prstGeom prst="rect">
+            <a:avLst/>
+          </a:prstGeom>
+          <a:solidFill>
+            <a:schemeClr val="bg1"/>
+          </a:solidFill>
+          <a:ln w="9525">
+            <a:solidFill>
+              <a:srgbClr val="E7E0C9"/>
+            </a:solidFill>
+            <a:prstDash val="solid"/>
+          </a:ln>
+        </p:spPr>
+      </p:sp>
+      <p:sp>
+        <p:nvSpPr>
+          <p:cNvPr id="22" name="evbox 5"/>
+          <p:cNvSpPr/>
+          <p:nvPr/>
+        </p:nvSpPr>
+        <p:spPr>
+          <a:xfrm>
+            <a:off x="777240" y="5550408"/>
+            <a:ext cx="219456" cy="219456"/>
+          </a:xfrm>
+          <a:prstGeom prst="rect">
+            <a:avLst/>
+          </a:prstGeom>
+          <a:solidFill>
+            <a:schemeClr val="bg1"/>
+          </a:solidFill>
+          <a:ln w="15875">
+            <a:solidFill>
+              <a:srgbClr val="1F1E19"/>
+            </a:solidFill>
+            <a:prstDash val="solid"/>
+          </a:ln>
+        </p:spPr>
+      </p:sp>
+      <p:sp>
+        <p:nvSpPr>
+          <p:cNvPr id="23" name="Text 21"/>
+          <p:cNvSpPr txBox="1"/>
+          <p:nvPr/>
+        </p:nvSpPr>
+        <p:spPr>
+          <a:xfrm>
+            <a:off x="1188720" y="5413248"/>
+            <a:ext cx="4587088" cy="274320"/>
+          </a:xfrm>
+          <a:prstGeom prst="rect">
+            <a:avLst/>
+          </a:prstGeom>
+          <a:noFill/>
+          <a:ln/>
+        </p:spPr>
+        <p:txBody>
+          <a:bodyPr wrap="square" lIns="0" tIns="0" rIns="0" bIns="0" rtlCol="0" anchor="t"/>
+          <a:lstStyle/>
+          <a:p>
+            <a:pPr indent="0" marL="0">
+              <a:buNone/>
+            </a:pPr>
+            <a:r>
+              <a:rPr lang="en-US" sz="1400" b="1" dirty="0">
+                <a:solidFill>
+                  <a:schemeClr val="tx1"/>
+                </a:solidFill>
+              </a:rPr>
+              <a:t>Discrepancy report</a:t>
+            </a:r>
+            <a:endParaRPr lang="en-US" sz="1400" dirty="0"/>
+          </a:p>
+        </p:txBody>
+      </p:sp>
+      <p:sp>
+        <p:nvSpPr>
+          <p:cNvPr id="24" name="Text 22"/>
+          <p:cNvSpPr txBox="1"/>
+          <p:nvPr/>
+        </p:nvSpPr>
+        <p:spPr>
+          <a:xfrm>
+            <a:off x="1188720" y="5687568"/>
+            <a:ext cx="4587088" cy="246888"/>
+          </a:xfrm>
+          <a:prstGeom prst="rect">
+            <a:avLst/>
+          </a:prstGeom>
+          <a:noFill/>
+          <a:ln/>
+        </p:spPr>
+        <p:txBody>
+          <a:bodyPr wrap="square" lIns="0" tIns="0" rIns="0" bIns="0" rtlCol="0" anchor="t"/>
+          <a:lstStyle/>
+          <a:p>
+            <a:pPr indent="0" marL="0">
+              <a:buNone/>
+            </a:pPr>
+            <a:r>
+              <a:rPr lang="en-US" sz="1200" dirty="0">
+                <a:solidFill>
+                  <a:schemeClr val="tx2"/>
+                </a:solidFill>
+              </a:rPr>
+              <a:t>The DV-GAM workbook, display and video</a:t>
+            </a:r>
+            <a:endParaRPr lang="en-US" sz="1200" dirty="0"/>
+          </a:p>
+        </p:txBody>
+      </p:sp>
+      <p:sp>
+        <p:nvSpPr>
+          <p:cNvPr id="25" name="evidence 6"/>
+          <p:cNvSpPr/>
+          <p:nvPr/>
+        </p:nvSpPr>
+        <p:spPr>
+          <a:xfrm>
+            <a:off x="6233008" y="2423160"/>
+            <a:ext cx="5410048" cy="621792"/>
+          </a:xfrm>
+          <a:prstGeom prst="rect">
+            <a:avLst/>
+          </a:prstGeom>
+          <a:solidFill>
+            <a:schemeClr val="bg1"/>
+          </a:solidFill>
+          <a:ln w="9525">
+            <a:solidFill>
+              <a:srgbClr val="E7E0C9"/>
+            </a:solidFill>
+            <a:prstDash val="solid"/>
+          </a:ln>
+        </p:spPr>
+      </p:sp>
+      <p:sp>
+        <p:nvSpPr>
+          <p:cNvPr id="26" name="evbox 6"/>
+          <p:cNvSpPr/>
+          <p:nvPr/>
+        </p:nvSpPr>
+        <p:spPr>
+          <a:xfrm>
+            <a:off x="6461608" y="2624328"/>
+            <a:ext cx="219456" cy="219456"/>
+          </a:xfrm>
+          <a:prstGeom prst="rect">
+            <a:avLst/>
+          </a:prstGeom>
+          <a:solidFill>
+            <a:schemeClr val="bg1"/>
+          </a:solidFill>
+          <a:ln w="15875">
+            <a:solidFill>
+              <a:srgbClr val="1F1E19"/>
+            </a:solidFill>
+            <a:prstDash val="solid"/>
+          </a:ln>
+        </p:spPr>
+      </p:sp>
+      <p:sp>
+        <p:nvSpPr>
+          <p:cNvPr id="27" name="Text 25"/>
+          <p:cNvSpPr txBox="1"/>
+          <p:nvPr/>
+        </p:nvSpPr>
+        <p:spPr>
+          <a:xfrm>
+            <a:off x="6873088" y="2487168"/>
+            <a:ext cx="4587088" cy="274320"/>
+          </a:xfrm>
+          <a:prstGeom prst="rect">
+            <a:avLst/>
+          </a:prstGeom>
+          <a:noFill/>
+          <a:ln/>
+        </p:spPr>
+        <p:txBody>
+          <a:bodyPr wrap="square" lIns="0" tIns="0" rIns="0" bIns="0" rtlCol="0" anchor="t"/>
+          <a:lstStyle/>
+          <a:p>
+            <a:pPr indent="0" marL="0">
+              <a:buNone/>
+            </a:pPr>
+            <a:r>
+              <a:rPr lang="en-US" sz="1400" b="1" dirty="0">
+                <a:solidFill>
+                  <a:schemeClr val="tx1"/>
+                </a:solidFill>
+              </a:rPr>
+              <a:t>DV post-bid screenshots</a:t>
+            </a:r>
+            <a:endParaRPr lang="en-US" sz="1400" dirty="0"/>
+          </a:p>
+        </p:txBody>
+      </p:sp>
+      <p:sp>
+        <p:nvSpPr>
+          <p:cNvPr id="28" name="Text 26"/>
+          <p:cNvSpPr txBox="1"/>
+          <p:nvPr/>
+        </p:nvSpPr>
+        <p:spPr>
+          <a:xfrm>
+            <a:off x="6873088" y="2761488"/>
+            <a:ext cx="4587088" cy="246888"/>
+          </a:xfrm>
+          <a:prstGeom prst="rect">
+            <a:avLst/>
+          </a:prstGeom>
+          <a:noFill/>
+          <a:ln/>
+        </p:spPr>
+        <p:txBody>
+          <a:bodyPr wrap="square" lIns="0" tIns="0" rIns="0" bIns="0" rtlCol="0" anchor="t"/>
+          <a:lstStyle/>
+          <a:p>
+            <a:pPr indent="0" marL="0">
+              <a:buNone/>
+            </a:pPr>
+            <a:r>
+              <a:rPr lang="en-US" sz="1200" dirty="0">
+                <a:solidFill>
+                  <a:schemeClr val="tx2"/>
+                </a:solidFill>
+              </a:rPr>
+              <a:t>Back up the workbook's DV numbers, display and video</a:t>
+            </a:r>
+            <a:endParaRPr lang="en-US" sz="1200" dirty="0"/>
+          </a:p>
+        </p:txBody>
+      </p:sp>
+      <p:sp>
+        <p:nvSpPr>
+          <p:cNvPr id="29" name="evidence 7"/>
+          <p:cNvSpPr/>
+          <p:nvPr/>
+        </p:nvSpPr>
+        <p:spPr>
+          <a:xfrm>
+            <a:off x="6233008" y="3154680"/>
+            <a:ext cx="5410048" cy="621792"/>
+          </a:xfrm>
+          <a:prstGeom prst="rect">
+            <a:avLst/>
+          </a:prstGeom>
+          <a:solidFill>
+            <a:schemeClr val="bg1"/>
+          </a:solidFill>
+          <a:ln w="9525">
+            <a:solidFill>
+              <a:srgbClr val="E7E0C9"/>
+            </a:solidFill>
+            <a:prstDash val="solid"/>
+          </a:ln>
+        </p:spPr>
+      </p:sp>
+      <p:sp>
+        <p:nvSpPr>
+          <p:cNvPr id="30" name="evbox 7"/>
+          <p:cNvSpPr/>
+          <p:nvPr/>
+        </p:nvSpPr>
+        <p:spPr>
+          <a:xfrm>
+            <a:off x="6461608" y="3355848"/>
+            <a:ext cx="219456" cy="219456"/>
+          </a:xfrm>
+          <a:prstGeom prst="rect">
+            <a:avLst/>
+          </a:prstGeom>
+          <a:solidFill>
+            <a:schemeClr val="bg1"/>
+          </a:solidFill>
+          <a:ln w="15875">
+            <a:solidFill>
+              <a:srgbClr val="1F1E19"/>
+            </a:solidFill>
+            <a:prstDash val="solid"/>
+          </a:ln>
+        </p:spPr>
+      </p:sp>
+      <p:sp>
+        <p:nvSpPr>
+          <p:cNvPr id="31" name="Text 29"/>
+          <p:cNvSpPr txBox="1"/>
+          <p:nvPr/>
+        </p:nvSpPr>
+        <p:spPr>
+          <a:xfrm>
+            <a:off x="6873088" y="3218688"/>
+            <a:ext cx="4587088" cy="274320"/>
+          </a:xfrm>
+          <a:prstGeom prst="rect">
+            <a:avLst/>
+          </a:prstGeom>
+          <a:noFill/>
+          <a:ln/>
+        </p:spPr>
+        <p:txBody>
+          <a:bodyPr wrap="square" lIns="0" tIns="0" rIns="0" bIns="0" rtlCol="0" anchor="t"/>
+          <a:lstStyle/>
+          <a:p>
+            <a:pPr indent="0" marL="0">
+              <a:buNone/>
+            </a:pPr>
+            <a:r>
+              <a:rPr lang="en-US" sz="1400" b="1" dirty="0">
+                <a:solidFill>
+                  <a:schemeClr val="tx1"/>
+                </a:solidFill>
+              </a:rPr>
+              <a:t>ads.txt evidence</a:t>
+            </a:r>
+            <a:endParaRPr lang="en-US" sz="1400" dirty="0"/>
+          </a:p>
+        </p:txBody>
+      </p:sp>
+      <p:sp>
+        <p:nvSpPr>
+          <p:cNvPr id="32" name="Text 30"/>
+          <p:cNvSpPr txBox="1"/>
+          <p:nvPr/>
+        </p:nvSpPr>
+        <p:spPr>
+          <a:xfrm>
+            <a:off x="6873088" y="3493008"/>
+            <a:ext cx="4587088" cy="246888"/>
+          </a:xfrm>
+          <a:prstGeom prst="rect">
+            <a:avLst/>
+          </a:prstGeom>
+          <a:noFill/>
+          <a:ln/>
+        </p:spPr>
+        <p:txBody>
+          <a:bodyPr wrap="square" lIns="0" tIns="0" rIns="0" bIns="0" rtlCol="0" anchor="t"/>
+          <a:lstStyle/>
+          <a:p>
+            <a:pPr indent="0" marL="0">
+              <a:buNone/>
+            </a:pPr>
+            <a:r>
+              <a:rPr lang="en-US" sz="1200" dirty="0">
+                <a:solidFill>
+                  <a:schemeClr val="tx2"/>
+                </a:solidFill>
+              </a:rPr>
+              <a:t>Screenshot of the update log, plus one sample update ticket</a:t>
+            </a:r>
+            <a:endParaRPr lang="en-US" sz="1200" dirty="0"/>
+          </a:p>
+        </p:txBody>
+      </p:sp>
+      <p:sp>
+        <p:nvSpPr>
+          <p:cNvPr id="33" name="evidence 8"/>
+          <p:cNvSpPr/>
+          <p:nvPr/>
+        </p:nvSpPr>
+        <p:spPr>
+          <a:xfrm>
+            <a:off x="6233008" y="3886200"/>
+            <a:ext cx="5410048" cy="621792"/>
+          </a:xfrm>
+          <a:prstGeom prst="rect">
+            <a:avLst/>
+          </a:prstGeom>
+          <a:solidFill>
+            <a:schemeClr val="bg1"/>
+          </a:solidFill>
+          <a:ln w="9525">
+            <a:solidFill>
+              <a:srgbClr val="E7E0C9"/>
+            </a:solidFill>
+            <a:prstDash val="solid"/>
+          </a:ln>
+        </p:spPr>
+      </p:sp>
+      <p:sp>
+        <p:nvSpPr>
+          <p:cNvPr id="34" name="evbox 8"/>
+          <p:cNvSpPr/>
+          <p:nvPr/>
+        </p:nvSpPr>
+        <p:spPr>
+          <a:xfrm>
+            <a:off x="6461608" y="4087368"/>
+            <a:ext cx="219456" cy="219456"/>
+          </a:xfrm>
+          <a:prstGeom prst="rect">
+            <a:avLst/>
+          </a:prstGeom>
+          <a:solidFill>
+            <a:schemeClr val="bg1"/>
+          </a:solidFill>
+          <a:ln w="15875">
+            <a:solidFill>
+              <a:srgbClr val="1F1E19"/>
+            </a:solidFill>
+            <a:prstDash val="solid"/>
+          </a:ln>
+        </p:spPr>
+      </p:sp>
+      <p:sp>
+        <p:nvSpPr>
+          <p:cNvPr id="35" name="Text 33"/>
+          <p:cNvSpPr txBox="1"/>
+          <p:nvPr/>
+        </p:nvSpPr>
+        <p:spPr>
+          <a:xfrm>
+            <a:off x="6873088" y="3950208"/>
+            <a:ext cx="4587088" cy="274320"/>
+          </a:xfrm>
+          <a:prstGeom prst="rect">
+            <a:avLst/>
+          </a:prstGeom>
+          <a:noFill/>
+          <a:ln/>
+        </p:spPr>
+        <p:txBody>
+          <a:bodyPr wrap="square" lIns="0" tIns="0" rIns="0" bIns="0" rtlCol="0" anchor="t"/>
+          <a:lstStyle/>
+          <a:p>
+            <a:pPr indent="0" marL="0">
+              <a:buNone/>
+            </a:pPr>
+            <a:r>
+              <a:rPr lang="en-US" sz="1400" b="1" dirty="0">
+                <a:solidFill>
+                  <a:schemeClr val="tx1"/>
+                </a:solidFill>
+              </a:rPr>
+              <a:t>Complaint process</a:t>
+            </a:r>
+            <a:endParaRPr lang="en-US" sz="1400" dirty="0"/>
+          </a:p>
+        </p:txBody>
+      </p:sp>
+      <p:sp>
+        <p:nvSpPr>
+          <p:cNvPr id="36" name="Text 34"/>
+          <p:cNvSpPr txBox="1"/>
+          <p:nvPr/>
+        </p:nvSpPr>
+        <p:spPr>
+          <a:xfrm>
+            <a:off x="6873088" y="4224528"/>
+            <a:ext cx="4587088" cy="246888"/>
+          </a:xfrm>
+          <a:prstGeom prst="rect">
+            <a:avLst/>
+          </a:prstGeom>
+          <a:noFill/>
+          <a:ln/>
+        </p:spPr>
+        <p:txBody>
+          <a:bodyPr wrap="square" lIns="0" tIns="0" rIns="0" bIns="0" rtlCol="0" anchor="t"/>
+          <a:lstStyle/>
+          <a:p>
+            <a:pPr indent="0" marL="0">
+              <a:buNone/>
+            </a:pPr>
+            <a:r>
+              <a:rPr lang="en-US" sz="1200" dirty="0">
+                <a:solidFill>
+                  <a:schemeClr val="tx2"/>
+                </a:solidFill>
+              </a:rPr>
+              <a:t>Confirm it hasn't changed; an example if one happened</a:t>
+            </a:r>
+            <a:endParaRPr lang="en-US" sz="1200" dirty="0"/>
+          </a:p>
+        </p:txBody>
+      </p:sp>
+      <p:sp>
+        <p:nvSpPr>
+          <p:cNvPr id="37" name="evidence 9"/>
+          <p:cNvSpPr/>
+          <p:nvPr/>
+        </p:nvSpPr>
+        <p:spPr>
+          <a:xfrm>
+            <a:off x="6233008" y="4617720"/>
+            <a:ext cx="5410048" cy="621792"/>
+          </a:xfrm>
+          <a:prstGeom prst="rect">
+            <a:avLst/>
+          </a:prstGeom>
+          <a:solidFill>
+            <a:schemeClr val="bg2"/>
+          </a:solidFill>
+          <a:ln w="9525">
+            <a:solidFill>
+              <a:srgbClr val="E7E0C9"/>
+            </a:solidFill>
+            <a:prstDash val="solid"/>
+          </a:ln>
+        </p:spPr>
+      </p:sp>
+      <p:sp>
+        <p:nvSpPr>
+          <p:cNvPr id="38" name="Text 36"/>
+          <p:cNvSpPr txBox="1"/>
+          <p:nvPr/>
+        </p:nvSpPr>
+        <p:spPr>
+          <a:xfrm>
+            <a:off x="6873088" y="4681728"/>
+            <a:ext cx="4587088" cy="274320"/>
+          </a:xfrm>
+          <a:prstGeom prst="rect">
+            <a:avLst/>
+          </a:prstGeom>
+          <a:noFill/>
+          <a:ln/>
+        </p:spPr>
+        <p:txBody>
+          <a:bodyPr wrap="square" lIns="0" tIns="0" rIns="0" bIns="0" rtlCol="0" anchor="t"/>
+          <a:lstStyle/>
+          <a:p>
+            <a:pPr indent="0" marL="0">
+              <a:buNone/>
+            </a:pPr>
+            <a:r>
+              <a:rPr lang="en-US" sz="1400" b="1" strike="sngStrike" dirty="0">
+                <a:solidFill>
+                  <a:schemeClr val="tx2"/>
+                </a:solidFill>
+              </a:rPr>
+              <a:t>IAS screenshots</a:t>
+            </a:r>
+            <a:endParaRPr lang="en-US" sz="1400" dirty="0"/>
+          </a:p>
+        </p:txBody>
+      </p:sp>
+      <p:sp>
+        <p:nvSpPr>
+          <p:cNvPr id="39" name="Text 37"/>
+          <p:cNvSpPr txBox="1"/>
+          <p:nvPr/>
+        </p:nvSpPr>
+        <p:spPr>
+          <a:xfrm>
+            <a:off x="6873088" y="4956048"/>
+            <a:ext cx="4587088" cy="246888"/>
+          </a:xfrm>
+          <a:prstGeom prst="rect">
+            <a:avLst/>
+          </a:prstGeom>
+          <a:noFill/>
+          <a:ln/>
+        </p:spPr>
+        <p:txBody>
+          <a:bodyPr wrap="square" lIns="0" tIns="0" rIns="0" bIns="0" rtlCol="0" anchor="t"/>
+          <a:lstStyle/>
+          <a:p>
+            <a:pPr indent="0" marL="0">
+              <a:buNone/>
+            </a:pPr>
+            <a:r>
+              <a:rPr lang="en-US" sz="1200" dirty="0">
+                <a:solidFill>
+                  <a:schemeClr val="tx2"/>
+                </a:solidFill>
+              </a:rPr>
+              <a:t>No longer applies: we stopped using IAS</a:t>
+            </a:r>
+            <a:endParaRPr lang="en-US" sz="1200" dirty="0"/>
+          </a:p>
+        </p:txBody>
+      </p:sp>
+      <p:sp>
+        <p:nvSpPr>
+          <p:cNvPr id="25" name="Slide Number Placeholder 0"/>
+          <p:cNvSpPr>
+            <a:spLocks noGrp="1"/>
+          </p:cNvSpPr>
+          <p:nvPr>
+            <p:ph type="sldNum" sz="quarter" idx="4294967295"/>
+          </p:nvPr>
+        </p:nvSpPr>
+        <p:spPr>
+          <a:xfrm>
+            <a:off x="548640" y="6400800"/>
+            <a:ext cx="914400" cy="274320"/>
+          </a:xfrm>
+          <a:prstGeom prst="rect">
+            <a:avLst/>
+          </a:prstGeom>
+          <a:extLst>
+            <a:ext uri="{C572A759-6A51-4108-AA02-DFA0A04FC94B}">
+              <ma14:wrappingTextBoxFlag xmlns:ma14="http://schemas.microsoft.com/office/mac/drawingml/2011/main" val="0"/>
+            </a:ext>
+          </a:extLst>
+        </p:spPr>
+        <p:txBody>
+          <a:bodyPr/>
+          <a:lstStyle>
+            <a:lvl1pPr>
+              <a:defRPr sz="1000">
+                <a:solidFill>
+                  <a:srgbClr val="8C887B"/>
+                </a:solidFill>
+                <a:latin typeface="Arial"/>
+                <a:ea typeface="Arial"/>
+                <a:cs typeface="Arial"/>
+              </a:defRPr>
+            </a:lvl1pPr>
+          </a:lstStyle>
+          <a:p>
+            <a:pPr algn="l"/>
+            <a:fld id="{F7021451-1387-4CA6-816F-3879F97B5CBC}" type="slidenum">
+              <a:rPr b="0" lang="en-US"/>
+              <a:t>33</a:t>
+            </a:fld>
+            <a:endParaRPr lang="en-US"/>
+          </a:p>
+        </p:txBody>
+      </p:sp>
+    </p:spTree>
+  </p:cSld>
+  <p:clrMapOvr>
+    <a:masterClrMapping/>
+  </p:clrMapOvr>
+</p:sld>
+</file>
+
+<file path=ppt/slides/slide34.xml><?xml version="1.0" encoding="utf-8"?>
+<p:sld xmlns:a="http://schemas.openxmlformats.org/drawingml/2006/main" xmlns:r="http://schemas.openxmlformats.org/officeDocument/2006/relationships" xmlns:p="http://schemas.openxmlformats.org/presentationml/2006/main">
+  <p:cSld name="Slide 34">
+    <p:spTree>
+      <p:nvGrpSpPr>
+        <p:cNvPr id="1" name=""/>
+        <p:cNvGrpSpPr/>
+        <p:nvPr/>
+      </p:nvGrpSpPr>
+      <p:grpSpPr>
+        <a:xfrm>
+          <a:off x="0" y="0"/>
+          <a:ext cx="0" cy="0"/>
+          <a:chOff x="0" y="0"/>
+          <a:chExt cx="0" cy="0"/>
+        </a:xfrm>
+      </p:grpSpPr>
+      <p:sp>
+        <p:nvSpPr>
+          <p:cNvPr id="2" name="Text 1"/>
+          <p:cNvSpPr/>
+          <p:nvPr>
+            <p:ph idx="101" type="body" hasCustomPrompt="1"/>
+          </p:nvPr>
+        </p:nvSpPr>
+        <p:spPr>
+          <a:xfrm>
+            <a:off x="749808" y="457200"/>
+            <a:ext cx="8229600" cy="329184"/>
+          </a:xfrm>
+          <a:prstGeom prst="rect">
+            <a:avLst/>
+          </a:prstGeom>
+          <a:noFill/>
+          <a:ln/>
+        </p:spPr>
+        <p:txBody>
+          <a:bodyPr wrap="square" lIns="0" tIns="0" rIns="0" bIns="0" rtlCol="0" anchor="ctr"/>
+          <a:lstStyle/>
+          <a:p>
+            <a:pPr indent="0" marL="0">
+              <a:buNone/>
+            </a:pPr>
+            <a:r>
+              <a:rPr lang="en-US" sz="1200" b="1" spc="300" kern="0" dirty="0">
+                <a:solidFill>
+                  <a:schemeClr val="tx2"/>
+                </a:solidFill>
+              </a:rPr>
+              <a:t>APPENDIX · YEARLY AAM REVIEW</a:t>
+            </a:r>
+            <a:endParaRPr lang="en-US" sz="1200" dirty="0"/>
+          </a:p>
+        </p:txBody>
+      </p:sp>
+      <p:sp>
+        <p:nvSpPr>
+          <p:cNvPr id="3" name="Text 1"/>
+          <p:cNvSpPr/>
+          <p:nvPr>
+            <p:ph idx="102" type="title" hasCustomPrompt="1"/>
+          </p:nvPr>
+        </p:nvSpPr>
+        <p:spPr>
+          <a:xfrm>
+            <a:off x="548640" y="868680"/>
+            <a:ext cx="11094415" cy="868680"/>
+          </a:xfrm>
+          <a:prstGeom prst="rect">
+            <a:avLst/>
+          </a:prstGeom>
+          <a:noFill/>
+          <a:ln/>
+        </p:spPr>
+        <p:txBody>
+          <a:bodyPr wrap="square" lIns="0" tIns="0" rIns="0" bIns="0" rtlCol="0" anchor="t"/>
+          <a:lstStyle/>
+          <a:p>
+            <a:pPr algn="l" indent="0" marL="0">
+              <a:buNone/>
+            </a:pPr>
+            <a:r>
+              <a:rPr lang="en-US" sz="3400" dirty="0">
+                <a:solidFill>
+                  <a:schemeClr val="tx1"/>
+                </a:solidFill>
+                <a:latin typeface="Georgia" pitchFamily="34" charset="0"/>
+                <a:ea typeface="Georgia" pitchFamily="34" charset="-122"/>
+                <a:cs typeface="Georgia" pitchFamily="34" charset="-120"/>
+              </a:rPr>
+              <a:t>Questions they ask, and last year's answers</a:t>
+            </a:r>
+            <a:endParaRPr lang="en-US" sz="3400" dirty="0"/>
+          </a:p>
+        </p:txBody>
+      </p:sp>
+      <p:graphicFrame>
+        <p:nvGraphicFramePr>
+          <p:cNvPr id="35" name="aam questions"/>
+          <p:cNvGraphicFramePr>
+            <a:graphicFrameLocks noGrp="1"/>
+          </p:cNvGraphicFramePr>
+          <p:nvPr>
+            <p:extLst>
+              <p:ext uri="{D42A27DB-BD31-4B8C-83A1-F6EECF244321}">
+                <p14:modId xmlns:p14="http://schemas.microsoft.com/office/powerpoint/2010/main" val="1579011935"/>
+              </p:ext>
+            </p:extLst>
+          </p:nvPr>
+        </p:nvGraphicFramePr>
+        <p:xfrm>
+          <a:off x="548640" y="1874520"/>
+          <a:ext cx="11094415" cy="914400"/>
+        </p:xfrm>
+        <a:graphic>
+          <a:graphicData uri="http://schemas.openxmlformats.org/drawingml/2006/table">
+            <a:tbl>
+              <a:tblPr/>
+              <a:tblGrid>
+                <a:gridCol w="4023360"/>
+                <a:gridCol w="7068312"/>
+              </a:tblGrid>
+              <a:tr h="475488">
+                <a:tc>
+                  <a:txBody>
+                    <a:bodyPr/>
+                    <a:lstStyle/>
+                    <a:p>
+                      <a:pPr indent="0" marL="0">
+                        <a:buNone/>
+                      </a:pPr>
+                      <a:r>
+                        <a:rPr lang="en-US" sz="1300" b="1" dirty="0">
+                          <a:solidFill>
+                            <a:schemeClr val="tx1"/>
+                          </a:solidFill>
+                          <a:latin typeface="Arial" pitchFamily="34" charset="0"/>
+                          <a:ea typeface="Arial" pitchFamily="34" charset="-122"/>
+                          <a:cs typeface="Arial" pitchFamily="34" charset="-120"/>
+                        </a:rPr>
+                        <a:t>They ask</a:t>
+                      </a:r>
+                      <a:endParaRPr lang="en-US" sz="1300" dirty="0">
+                        <a:latin typeface="Arial" charset="0"/>
+                        <a:ea typeface="Arial" charset="0"/>
+                        <a:cs typeface="Arial" charset="0"/>
+                      </a:endParaRPr>
+                    </a:p>
+                  </a:txBody>
+                  <a:tcPr marL="73152" marR="73152" marT="73152" marB="73152" anchor="ctr">
+                    <a:lnL w="9525" cap="flat" cmpd="sng" algn="ctr">
+                      <a:solidFill>
+                        <a:srgbClr val="E7E0C9"/>
+                      </a:solidFill>
+                      <a:prstDash val="solid"/>
+                      <a:round/>
+                      <a:headEnd type="none" w="med" len="med"/>
+                      <a:tailEnd type="none" w="med" len="med"/>
+                    </a:lnL>
+                    <a:lnR w="9525" cap="flat" cmpd="sng" algn="ctr">
+                      <a:solidFill>
+                        <a:srgbClr val="E7E0C9"/>
+                      </a:solidFill>
+                      <a:prstDash val="solid"/>
+                      <a:round/>
+                      <a:headEnd type="none" w="med" len="med"/>
+                      <a:tailEnd type="none" w="med" len="med"/>
+                    </a:lnR>
+                    <a:lnT w="9525" cap="flat" cmpd="sng" algn="ctr">
+                      <a:solidFill>
+                        <a:srgbClr val="E7E0C9"/>
+                      </a:solidFill>
+                      <a:prstDash val="solid"/>
+                      <a:round/>
+                      <a:headEnd type="none" w="med" len="med"/>
+                      <a:tailEnd type="none" w="med" len="med"/>
+                    </a:lnT>
+                    <a:lnB w="9525" cap="flat" cmpd="sng" algn="ctr">
+                      <a:solidFill>
+                        <a:srgbClr val="E7E0C9"/>
+                      </a:solidFill>
+                      <a:prstDash val="solid"/>
+                      <a:round/>
+                      <a:headEnd type="none" w="med" len="med"/>
+                      <a:tailEnd type="none" w="med" len="med"/>
+                    </a:lnB>
+                    <a:solidFill>
+                      <a:schemeClr val="bg2"/>
+                    </a:solidFill>
+                  </a:tcPr>
+                </a:tc>
+                <a:tc>
+                  <a:txBody>
+                    <a:bodyPr/>
+                    <a:lstStyle/>
+                    <a:p>
+                      <a:pPr indent="0" marL="0">
+                        <a:buNone/>
+                      </a:pPr>
+                      <a:r>
+                        <a:rPr lang="en-US" sz="1300" b="1" dirty="0">
+                          <a:solidFill>
+                            <a:schemeClr val="tx1"/>
+                          </a:solidFill>
+                          <a:latin typeface="Arial" pitchFamily="34" charset="0"/>
+                          <a:ea typeface="Arial" pitchFamily="34" charset="-122"/>
+                          <a:cs typeface="Arial" pitchFamily="34" charset="-120"/>
+                        </a:rPr>
+                        <a:t>Last year's answer</a:t>
+                      </a:r>
+                      <a:endParaRPr lang="en-US" sz="1300" dirty="0">
+                        <a:latin typeface="Arial" charset="0"/>
+                        <a:ea typeface="Arial" charset="0"/>
+                        <a:cs typeface="Arial" charset="0"/>
+                      </a:endParaRPr>
+                    </a:p>
+                  </a:txBody>
+                  <a:tcPr marL="73152" marR="73152" marT="73152" marB="73152" anchor="ctr">
+                    <a:lnL w="9525" cap="flat" cmpd="sng" algn="ctr">
+                      <a:solidFill>
+                        <a:srgbClr val="E7E0C9"/>
+                      </a:solidFill>
+                      <a:prstDash val="solid"/>
+                      <a:round/>
+                      <a:headEnd type="none" w="med" len="med"/>
+                      <a:tailEnd type="none" w="med" len="med"/>
+                    </a:lnL>
+                    <a:lnR w="9525" cap="flat" cmpd="sng" algn="ctr">
+                      <a:solidFill>
+                        <a:srgbClr val="E7E0C9"/>
+                      </a:solidFill>
+                      <a:prstDash val="solid"/>
+                      <a:round/>
+                      <a:headEnd type="none" w="med" len="med"/>
+                      <a:tailEnd type="none" w="med" len="med"/>
+                    </a:lnR>
+                    <a:lnT w="9525" cap="flat" cmpd="sng" algn="ctr">
+                      <a:solidFill>
+                        <a:srgbClr val="E7E0C9"/>
+                      </a:solidFill>
+                      <a:prstDash val="solid"/>
+                      <a:round/>
+                      <a:headEnd type="none" w="med" len="med"/>
+                      <a:tailEnd type="none" w="med" len="med"/>
+                    </a:lnT>
+                    <a:lnB w="9525" cap="flat" cmpd="sng" algn="ctr">
+                      <a:solidFill>
+                        <a:srgbClr val="E7E0C9"/>
+                      </a:solidFill>
+                      <a:prstDash val="solid"/>
+                      <a:round/>
+                      <a:headEnd type="none" w="med" len="med"/>
+                      <a:tailEnd type="none" w="med" len="med"/>
+                    </a:lnB>
+                    <a:solidFill>
+                      <a:schemeClr val="bg2"/>
+                    </a:solidFill>
+                  </a:tcPr>
+                </a:tc>
+              </a:tr>
+              <a:tr h="475488">
+                <a:tc>
+                  <a:txBody>
+                    <a:bodyPr/>
+                    <a:lstStyle/>
+                    <a:p>
+                      <a:pPr indent="0" marL="0">
+                        <a:buNone/>
+                      </a:pPr>
+                      <a:r>
+                        <a:rPr lang="en-US" sz="1250" b="1" dirty="0">
+                          <a:solidFill>
+                            <a:schemeClr val="tx1"/>
+                          </a:solidFill>
+                          <a:latin typeface="Arial" pitchFamily="34" charset="0"/>
+                          <a:ea typeface="Arial" pitchFamily="34" charset="-122"/>
+                          <a:cs typeface="Arial" pitchFamily="34" charset="-120"/>
+                        </a:rPr>
+                        <a:t>Any material changes since last year?</a:t>
+                      </a:r>
+                      <a:endParaRPr lang="en-US" sz="1250" dirty="0">
+                        <a:latin typeface="Arial" charset="0"/>
+                        <a:ea typeface="Arial" charset="0"/>
+                        <a:cs typeface="Arial" charset="0"/>
+                      </a:endParaRPr>
+                    </a:p>
+                  </a:txBody>
+                  <a:tcPr marL="73152" marR="73152" marT="73152" marB="73152" anchor="ctr">
+                    <a:lnL w="9525" cap="flat" cmpd="sng" algn="ctr">
+                      <a:solidFill>
+                        <a:srgbClr val="E7E0C9"/>
+                      </a:solidFill>
+                      <a:prstDash val="solid"/>
+                      <a:round/>
+                      <a:headEnd type="none" w="med" len="med"/>
+                      <a:tailEnd type="none" w="med" len="med"/>
+                    </a:lnL>
+                    <a:lnR w="9525" cap="flat" cmpd="sng" algn="ctr">
+                      <a:solidFill>
+                        <a:srgbClr val="E7E0C9"/>
+                      </a:solidFill>
+                      <a:prstDash val="solid"/>
+                      <a:round/>
+                      <a:headEnd type="none" w="med" len="med"/>
+                      <a:tailEnd type="none" w="med" len="med"/>
+                    </a:lnR>
+                    <a:lnT w="9525" cap="flat" cmpd="sng" algn="ctr">
+                      <a:solidFill>
+                        <a:srgbClr val="E7E0C9"/>
+                      </a:solidFill>
+                      <a:prstDash val="solid"/>
+                      <a:round/>
+                      <a:headEnd type="none" w="med" len="med"/>
+                      <a:tailEnd type="none" w="med" len="med"/>
+                    </a:lnT>
+                    <a:lnB w="9525" cap="flat" cmpd="sng" algn="ctr">
+                      <a:solidFill>
+                        <a:srgbClr val="E7E0C9"/>
+                      </a:solidFill>
+                      <a:prstDash val="solid"/>
+                      <a:round/>
+                      <a:headEnd type="none" w="med" len="med"/>
+                      <a:tailEnd type="none" w="med" len="med"/>
+                    </a:lnB>
+                    <a:solidFill>
+                      <a:srgbClr val="FEFCF6"/>
+                    </a:solidFill>
+                  </a:tcPr>
+                </a:tc>
+                <a:tc>
+                  <a:txBody>
+                    <a:bodyPr/>
+                    <a:lstStyle/>
+                    <a:p>
+                      <a:pPr indent="0" marL="0">
+                        <a:buNone/>
+                      </a:pPr>
+                      <a:r>
+                        <a:rPr lang="en-US" sz="1250" dirty="0">
+                          <a:solidFill>
+                            <a:schemeClr val="tx1"/>
+                          </a:solidFill>
+                          <a:latin typeface="Arial" pitchFamily="34" charset="0"/>
+                          <a:ea typeface="Arial" pitchFamily="34" charset="-122"/>
+                          <a:cs typeface="Arial" pitchFamily="34" charset="-120"/>
+                        </a:rPr>
+                        <a:t>Say so, e.g. we dropped IAS in 2026</a:t>
+                      </a:r>
+                      <a:endParaRPr lang="en-US" sz="1250" dirty="0">
+                        <a:latin typeface="Arial" charset="0"/>
+                        <a:ea typeface="Arial" charset="0"/>
+                        <a:cs typeface="Arial" charset="0"/>
+                      </a:endParaRPr>
+                    </a:p>
+                  </a:txBody>
+                  <a:tcPr marL="73152" marR="73152" marT="73152" marB="73152" anchor="ctr">
+                    <a:lnL w="9525" cap="flat" cmpd="sng" algn="ctr">
+                      <a:solidFill>
+                        <a:srgbClr val="E7E0C9"/>
+                      </a:solidFill>
+                      <a:prstDash val="solid"/>
+                      <a:round/>
+                      <a:headEnd type="none" w="med" len="med"/>
+                      <a:tailEnd type="none" w="med" len="med"/>
+                    </a:lnL>
+                    <a:lnR w="9525" cap="flat" cmpd="sng" algn="ctr">
+                      <a:solidFill>
+                        <a:srgbClr val="E7E0C9"/>
+                      </a:solidFill>
+                      <a:prstDash val="solid"/>
+                      <a:round/>
+                      <a:headEnd type="none" w="med" len="med"/>
+                      <a:tailEnd type="none" w="med" len="med"/>
+                    </a:lnR>
+                    <a:lnT w="9525" cap="flat" cmpd="sng" algn="ctr">
+                      <a:solidFill>
+                        <a:srgbClr val="E7E0C9"/>
+                      </a:solidFill>
+                      <a:prstDash val="solid"/>
+                      <a:round/>
+                      <a:headEnd type="none" w="med" len="med"/>
+                      <a:tailEnd type="none" w="med" len="med"/>
+                    </a:lnT>
+                    <a:lnB w="9525" cap="flat" cmpd="sng" algn="ctr">
+                      <a:solidFill>
+                        <a:srgbClr val="E7E0C9"/>
+                      </a:solidFill>
+                      <a:prstDash val="solid"/>
+                      <a:round/>
+                      <a:headEnd type="none" w="med" len="med"/>
+                      <a:tailEnd type="none" w="med" len="med"/>
+                    </a:lnB>
+                    <a:solidFill>
+                      <a:srgbClr val="FEFCF6"/>
+                    </a:solidFill>
+                  </a:tcPr>
+                </a:tc>
+              </a:tr>
+              <a:tr h="475488">
+                <a:tc>
+                  <a:txBody>
+                    <a:bodyPr/>
+                    <a:lstStyle/>
+                    <a:p>
+                      <a:pPr indent="0" marL="0">
+                        <a:buNone/>
+                      </a:pPr>
+                      <a:r>
+                        <a:rPr lang="en-US" sz="1250" b="1" dirty="0">
+                          <a:solidFill>
+                            <a:schemeClr val="tx1"/>
+                          </a:solidFill>
+                          <a:latin typeface="Arial" pitchFamily="34" charset="0"/>
+                          <a:ea typeface="Arial" pitchFamily="34" charset="-122"/>
+                          <a:cs typeface="Arial" pitchFamily="34" charset="-120"/>
+                        </a:rPr>
+                        <a:t>What share of traffic does DV scan?</a:t>
+                      </a:r>
+                      <a:endParaRPr lang="en-US" sz="1250" dirty="0">
+                        <a:latin typeface="Arial" charset="0"/>
+                        <a:ea typeface="Arial" charset="0"/>
+                        <a:cs typeface="Arial" charset="0"/>
+                      </a:endParaRPr>
+                    </a:p>
+                  </a:txBody>
+                  <a:tcPr marL="73152" marR="73152" marT="73152" marB="73152" anchor="ctr">
+                    <a:lnL w="9525" cap="flat" cmpd="sng" algn="ctr">
+                      <a:solidFill>
+                        <a:srgbClr val="E7E0C9"/>
+                      </a:solidFill>
+                      <a:prstDash val="solid"/>
+                      <a:round/>
+                      <a:headEnd type="none" w="med" len="med"/>
+                      <a:tailEnd type="none" w="med" len="med"/>
+                    </a:lnL>
+                    <a:lnR w="9525" cap="flat" cmpd="sng" algn="ctr">
+                      <a:solidFill>
+                        <a:srgbClr val="E7E0C9"/>
+                      </a:solidFill>
+                      <a:prstDash val="solid"/>
+                      <a:round/>
+                      <a:headEnd type="none" w="med" len="med"/>
+                      <a:tailEnd type="none" w="med" len="med"/>
+                    </a:lnR>
+                    <a:lnT w="9525" cap="flat" cmpd="sng" algn="ctr">
+                      <a:solidFill>
+                        <a:srgbClr val="E7E0C9"/>
+                      </a:solidFill>
+                      <a:prstDash val="solid"/>
+                      <a:round/>
+                      <a:headEnd type="none" w="med" len="med"/>
+                      <a:tailEnd type="none" w="med" len="med"/>
+                    </a:lnT>
+                    <a:lnB w="9525" cap="flat" cmpd="sng" algn="ctr">
+                      <a:solidFill>
+                        <a:srgbClr val="E7E0C9"/>
+                      </a:solidFill>
+                      <a:prstDash val="solid"/>
+                      <a:round/>
+                      <a:headEnd type="none" w="med" len="med"/>
+                      <a:tailEnd type="none" w="med" len="med"/>
+                    </a:lnB>
+                    <a:solidFill>
+                      <a:srgbClr val="FEFCF6"/>
+                    </a:solidFill>
+                  </a:tcPr>
+                </a:tc>
+                <a:tc>
+                  <a:txBody>
+                    <a:bodyPr/>
+                    <a:lstStyle/>
+                    <a:p>
+                      <a:pPr indent="0" marL="0">
+                        <a:buNone/>
+                      </a:pPr>
+                      <a:r>
+                        <a:rPr lang="en-US" sz="1250" dirty="0">
+                          <a:solidFill>
+                            <a:schemeClr val="tx1"/>
+                          </a:solidFill>
+                          <a:latin typeface="Arial" pitchFamily="34" charset="0"/>
+                          <a:ea typeface="Arial" pitchFamily="34" charset="-122"/>
+                          <a:cs typeface="Arial" pitchFamily="34" charset="-120"/>
+                        </a:rPr>
+                        <a:t>Display 100%; video 1–5% (sampled)</a:t>
+                      </a:r>
+                      <a:endParaRPr lang="en-US" sz="1250" dirty="0">
+                        <a:latin typeface="Arial" charset="0"/>
+                        <a:ea typeface="Arial" charset="0"/>
+                        <a:cs typeface="Arial" charset="0"/>
+                      </a:endParaRPr>
+                    </a:p>
+                  </a:txBody>
+                  <a:tcPr marL="73152" marR="73152" marT="73152" marB="73152" anchor="ctr">
+                    <a:lnL w="9525" cap="flat" cmpd="sng" algn="ctr">
+                      <a:solidFill>
+                        <a:srgbClr val="E7E0C9"/>
+                      </a:solidFill>
+                      <a:prstDash val="solid"/>
+                      <a:round/>
+                      <a:headEnd type="none" w="med" len="med"/>
+                      <a:tailEnd type="none" w="med" len="med"/>
+                    </a:lnL>
+                    <a:lnR w="9525" cap="flat" cmpd="sng" algn="ctr">
+                      <a:solidFill>
+                        <a:srgbClr val="E7E0C9"/>
+                      </a:solidFill>
+                      <a:prstDash val="solid"/>
+                      <a:round/>
+                      <a:headEnd type="none" w="med" len="med"/>
+                      <a:tailEnd type="none" w="med" len="med"/>
+                    </a:lnR>
+                    <a:lnT w="9525" cap="flat" cmpd="sng" algn="ctr">
+                      <a:solidFill>
+                        <a:srgbClr val="E7E0C9"/>
+                      </a:solidFill>
+                      <a:prstDash val="solid"/>
+                      <a:round/>
+                      <a:headEnd type="none" w="med" len="med"/>
+                      <a:tailEnd type="none" w="med" len="med"/>
+                    </a:lnT>
+                    <a:lnB w="9525" cap="flat" cmpd="sng" algn="ctr">
+                      <a:solidFill>
+                        <a:srgbClr val="E7E0C9"/>
+                      </a:solidFill>
+                      <a:prstDash val="solid"/>
+                      <a:round/>
+                      <a:headEnd type="none" w="med" len="med"/>
+                      <a:tailEnd type="none" w="med" len="med"/>
+                    </a:lnB>
+                    <a:solidFill>
+                      <a:srgbClr val="FEFCF6"/>
+                    </a:solidFill>
+                  </a:tcPr>
+                </a:tc>
+              </a:tr>
+              <a:tr h="475488">
+                <a:tc>
+                  <a:txBody>
+                    <a:bodyPr/>
+                    <a:lstStyle/>
+                    <a:p>
+                      <a:pPr indent="0" marL="0">
+                        <a:buNone/>
+                      </a:pPr>
+                      <a:r>
+                        <a:rPr lang="en-US" sz="1250" b="1" dirty="0">
+                          <a:solidFill>
+                            <a:schemeClr val="tx1"/>
+                          </a:solidFill>
+                          <a:latin typeface="Arial" pitchFamily="34" charset="0"/>
+                          <a:ea typeface="Arial" pitchFamily="34" charset="-122"/>
+                          <a:cs typeface="Arial" pitchFamily="34" charset="-120"/>
+                        </a:rPr>
+                        <a:t>Which DV lists do you ingest pre-bid?</a:t>
+                      </a:r>
+                      <a:endParaRPr lang="en-US" sz="1250" dirty="0">
+                        <a:latin typeface="Arial" charset="0"/>
+                        <a:ea typeface="Arial" charset="0"/>
+                        <a:cs typeface="Arial" charset="0"/>
+                      </a:endParaRPr>
+                    </a:p>
+                  </a:txBody>
+                  <a:tcPr marL="73152" marR="73152" marT="73152" marB="73152" anchor="ctr">
+                    <a:lnL w="9525" cap="flat" cmpd="sng" algn="ctr">
+                      <a:solidFill>
+                        <a:srgbClr val="E7E0C9"/>
+                      </a:solidFill>
+                      <a:prstDash val="solid"/>
+                      <a:round/>
+                      <a:headEnd type="none" w="med" len="med"/>
+                      <a:tailEnd type="none" w="med" len="med"/>
+                    </a:lnL>
+                    <a:lnR w="9525" cap="flat" cmpd="sng" algn="ctr">
+                      <a:solidFill>
+                        <a:srgbClr val="E7E0C9"/>
+                      </a:solidFill>
+                      <a:prstDash val="solid"/>
+                      <a:round/>
+                      <a:headEnd type="none" w="med" len="med"/>
+                      <a:tailEnd type="none" w="med" len="med"/>
+                    </a:lnR>
+                    <a:lnT w="9525" cap="flat" cmpd="sng" algn="ctr">
+                      <a:solidFill>
+                        <a:srgbClr val="E7E0C9"/>
+                      </a:solidFill>
+                      <a:prstDash val="solid"/>
+                      <a:round/>
+                      <a:headEnd type="none" w="med" len="med"/>
+                      <a:tailEnd type="none" w="med" len="med"/>
+                    </a:lnT>
+                    <a:lnB w="9525" cap="flat" cmpd="sng" algn="ctr">
+                      <a:solidFill>
+                        <a:srgbClr val="E7E0C9"/>
+                      </a:solidFill>
+                      <a:prstDash val="solid"/>
+                      <a:round/>
+                      <a:headEnd type="none" w="med" len="med"/>
+                      <a:tailEnd type="none" w="med" len="med"/>
+                    </a:lnB>
+                    <a:solidFill>
+                      <a:srgbClr val="FEFCF6"/>
+                    </a:solidFill>
+                  </a:tcPr>
+                </a:tc>
+                <a:tc>
+                  <a:txBody>
+                    <a:bodyPr/>
+                    <a:lstStyle/>
+                    <a:p>
+                      <a:pPr indent="0" marL="0">
+                        <a:buNone/>
+                      </a:pPr>
+                      <a:r>
+                        <a:rPr lang="en-US" sz="1250" dirty="0">
+                          <a:solidFill>
+                            <a:schemeClr val="tx1"/>
+                          </a:solidFill>
+                          <a:latin typeface="Arial" pitchFamily="34" charset="0"/>
+                          <a:ea typeface="Arial" pitchFamily="34" charset="-122"/>
+                          <a:cs typeface="Arial" pitchFamily="34" charset="-120"/>
+                        </a:rPr>
+                        <a:t>None. DV runs client-side on the page (Michael confirmed, Jan 2026)</a:t>
+                      </a:r>
+                      <a:endParaRPr lang="en-US" sz="1250" dirty="0">
+                        <a:latin typeface="Arial" charset="0"/>
+                        <a:ea typeface="Arial" charset="0"/>
+                        <a:cs typeface="Arial" charset="0"/>
+                      </a:endParaRPr>
+                    </a:p>
+                  </a:txBody>
+                  <a:tcPr marL="73152" marR="73152" marT="73152" marB="73152" anchor="ctr">
+                    <a:lnL w="9525" cap="flat" cmpd="sng" algn="ctr">
+                      <a:solidFill>
+                        <a:srgbClr val="E7E0C9"/>
+                      </a:solidFill>
+                      <a:prstDash val="solid"/>
+                      <a:round/>
+                      <a:headEnd type="none" w="med" len="med"/>
+                      <a:tailEnd type="none" w="med" len="med"/>
+                    </a:lnL>
+                    <a:lnR w="9525" cap="flat" cmpd="sng" algn="ctr">
+                      <a:solidFill>
+                        <a:srgbClr val="E7E0C9"/>
+                      </a:solidFill>
+                      <a:prstDash val="solid"/>
+                      <a:round/>
+                      <a:headEnd type="none" w="med" len="med"/>
+                      <a:tailEnd type="none" w="med" len="med"/>
+                    </a:lnR>
+                    <a:lnT w="9525" cap="flat" cmpd="sng" algn="ctr">
+                      <a:solidFill>
+                        <a:srgbClr val="E7E0C9"/>
+                      </a:solidFill>
+                      <a:prstDash val="solid"/>
+                      <a:round/>
+                      <a:headEnd type="none" w="med" len="med"/>
+                      <a:tailEnd type="none" w="med" len="med"/>
+                    </a:lnT>
+                    <a:lnB w="9525" cap="flat" cmpd="sng" algn="ctr">
+                      <a:solidFill>
+                        <a:srgbClr val="E7E0C9"/>
+                      </a:solidFill>
+                      <a:prstDash val="solid"/>
+                      <a:round/>
+                      <a:headEnd type="none" w="med" len="med"/>
+                      <a:tailEnd type="none" w="med" len="med"/>
+                    </a:lnB>
+                    <a:solidFill>
+                      <a:srgbClr val="FEFCF6"/>
+                    </a:solidFill>
+                  </a:tcPr>
+                </a:tc>
+              </a:tr>
+              <a:tr h="475488">
+                <a:tc>
+                  <a:txBody>
+                    <a:bodyPr/>
+                    <a:lstStyle/>
+                    <a:p>
+                      <a:pPr indent="0" marL="0">
+                        <a:buNone/>
+                      </a:pPr>
+                      <a:r>
+                        <a:rPr lang="en-US" sz="1250" b="1" dirty="0">
+                          <a:solidFill>
+                            <a:schemeClr val="tx1"/>
+                          </a:solidFill>
+                          <a:latin typeface="Arial" pitchFamily="34" charset="0"/>
+                          <a:ea typeface="Arial" pitchFamily="34" charset="-122"/>
+                          <a:cs typeface="Arial" pitchFamily="34" charset="-120"/>
+                        </a:rPr>
+                        <a:t>Any traffic that can't be scanned?</a:t>
+                      </a:r>
+                      <a:endParaRPr lang="en-US" sz="1250" dirty="0">
+                        <a:latin typeface="Arial" charset="0"/>
+                        <a:ea typeface="Arial" charset="0"/>
+                        <a:cs typeface="Arial" charset="0"/>
+                      </a:endParaRPr>
+                    </a:p>
+                  </a:txBody>
+                  <a:tcPr marL="73152" marR="73152" marT="73152" marB="73152" anchor="ctr">
+                    <a:lnL w="9525" cap="flat" cmpd="sng" algn="ctr">
+                      <a:solidFill>
+                        <a:srgbClr val="E7E0C9"/>
+                      </a:solidFill>
+                      <a:prstDash val="solid"/>
+                      <a:round/>
+                      <a:headEnd type="none" w="med" len="med"/>
+                      <a:tailEnd type="none" w="med" len="med"/>
+                    </a:lnL>
+                    <a:lnR w="9525" cap="flat" cmpd="sng" algn="ctr">
+                      <a:solidFill>
+                        <a:srgbClr val="E7E0C9"/>
+                      </a:solidFill>
+                      <a:prstDash val="solid"/>
+                      <a:round/>
+                      <a:headEnd type="none" w="med" len="med"/>
+                      <a:tailEnd type="none" w="med" len="med"/>
+                    </a:lnR>
+                    <a:lnT w="9525" cap="flat" cmpd="sng" algn="ctr">
+                      <a:solidFill>
+                        <a:srgbClr val="E7E0C9"/>
+                      </a:solidFill>
+                      <a:prstDash val="solid"/>
+                      <a:round/>
+                      <a:headEnd type="none" w="med" len="med"/>
+                      <a:tailEnd type="none" w="med" len="med"/>
+                    </a:lnT>
+                    <a:lnB w="9525" cap="flat" cmpd="sng" algn="ctr">
+                      <a:solidFill>
+                        <a:srgbClr val="E7E0C9"/>
+                      </a:solidFill>
+                      <a:prstDash val="solid"/>
+                      <a:round/>
+                      <a:headEnd type="none" w="med" len="med"/>
+                      <a:tailEnd type="none" w="med" len="med"/>
+                    </a:lnB>
+                    <a:solidFill>
+                      <a:srgbClr val="FEFCF6"/>
+                    </a:solidFill>
+                  </a:tcPr>
+                </a:tc>
+                <a:tc>
+                  <a:txBody>
+                    <a:bodyPr/>
+                    <a:lstStyle/>
+                    <a:p>
+                      <a:pPr indent="0" marL="0">
+                        <a:buNone/>
+                      </a:pPr>
+                      <a:r>
+                        <a:rPr lang="en-US" sz="1250" dirty="0">
+                          <a:solidFill>
+                            <a:schemeClr val="tx1"/>
+                          </a:solidFill>
+                          <a:latin typeface="Arial" pitchFamily="34" charset="0"/>
+                          <a:ea typeface="Arial" pitchFamily="34" charset="-122"/>
+                          <a:cs typeface="Arial" pitchFamily="34" charset="-120"/>
+                        </a:rPr>
+                        <a:t>Google AdX: DV's wrapper can't go on exchange tags, so post-bid covers ad-server traffic only</a:t>
+                      </a:r>
+                      <a:endParaRPr lang="en-US" sz="1250" dirty="0">
+                        <a:latin typeface="Arial" charset="0"/>
+                        <a:ea typeface="Arial" charset="0"/>
+                        <a:cs typeface="Arial" charset="0"/>
+                      </a:endParaRPr>
+                    </a:p>
+                  </a:txBody>
+                  <a:tcPr marL="73152" marR="73152" marT="73152" marB="73152" anchor="ctr">
+                    <a:lnL w="9525" cap="flat" cmpd="sng" algn="ctr">
+                      <a:solidFill>
+                        <a:srgbClr val="E7E0C9"/>
+                      </a:solidFill>
+                      <a:prstDash val="solid"/>
+                      <a:round/>
+                      <a:headEnd type="none" w="med" len="med"/>
+                      <a:tailEnd type="none" w="med" len="med"/>
+                    </a:lnL>
+                    <a:lnR w="9525" cap="flat" cmpd="sng" algn="ctr">
+                      <a:solidFill>
+                        <a:srgbClr val="E7E0C9"/>
+                      </a:solidFill>
+                      <a:prstDash val="solid"/>
+                      <a:round/>
+                      <a:headEnd type="none" w="med" len="med"/>
+                      <a:tailEnd type="none" w="med" len="med"/>
+                    </a:lnR>
+                    <a:lnT w="9525" cap="flat" cmpd="sng" algn="ctr">
+                      <a:solidFill>
+                        <a:srgbClr val="E7E0C9"/>
+                      </a:solidFill>
+                      <a:prstDash val="solid"/>
+                      <a:round/>
+                      <a:headEnd type="none" w="med" len="med"/>
+                      <a:tailEnd type="none" w="med" len="med"/>
+                    </a:lnT>
+                    <a:lnB w="9525" cap="flat" cmpd="sng" algn="ctr">
+                      <a:solidFill>
+                        <a:srgbClr val="E7E0C9"/>
+                      </a:solidFill>
+                      <a:prstDash val="solid"/>
+                      <a:round/>
+                      <a:headEnd type="none" w="med" len="med"/>
+                      <a:tailEnd type="none" w="med" len="med"/>
+                    </a:lnB>
+                    <a:solidFill>
+                      <a:srgbClr val="FEFCF6"/>
+                    </a:solidFill>
+                  </a:tcPr>
+                </a:tc>
+              </a:tr>
+              <a:tr h="475488">
+                <a:tc>
+                  <a:txBody>
+                    <a:bodyPr/>
+                    <a:lstStyle/>
+                    <a:p>
+                      <a:pPr indent="0" marL="0">
+                        <a:buNone/>
+                      </a:pPr>
+                      <a:r>
+                        <a:rPr lang="en-US" sz="1250" b="1" dirty="0">
+                          <a:solidFill>
+                            <a:schemeClr val="tx1"/>
+                          </a:solidFill>
+                          <a:latin typeface="Arial" pitchFamily="34" charset="0"/>
+                          <a:ea typeface="Arial" pitchFamily="34" charset="-122"/>
+                          <a:cs typeface="Arial" pitchFamily="34" charset="-120"/>
+                        </a:rPr>
+                        <a:t>Where's the Description of Methodology?</a:t>
+                      </a:r>
+                      <a:endParaRPr lang="en-US" sz="1250" dirty="0">
+                        <a:latin typeface="Arial" charset="0"/>
+                        <a:ea typeface="Arial" charset="0"/>
+                        <a:cs typeface="Arial" charset="0"/>
+                      </a:endParaRPr>
+                    </a:p>
+                  </a:txBody>
+                  <a:tcPr marL="73152" marR="73152" marT="73152" marB="73152" anchor="ctr">
+                    <a:lnL w="9525" cap="flat" cmpd="sng" algn="ctr">
+                      <a:solidFill>
+                        <a:srgbClr val="E7E0C9"/>
+                      </a:solidFill>
+                      <a:prstDash val="solid"/>
+                      <a:round/>
+                      <a:headEnd type="none" w="med" len="med"/>
+                      <a:tailEnd type="none" w="med" len="med"/>
+                    </a:lnL>
+                    <a:lnR w="9525" cap="flat" cmpd="sng" algn="ctr">
+                      <a:solidFill>
+                        <a:srgbClr val="E7E0C9"/>
+                      </a:solidFill>
+                      <a:prstDash val="solid"/>
+                      <a:round/>
+                      <a:headEnd type="none" w="med" len="med"/>
+                      <a:tailEnd type="none" w="med" len="med"/>
+                    </a:lnR>
+                    <a:lnT w="9525" cap="flat" cmpd="sng" algn="ctr">
+                      <a:solidFill>
+                        <a:srgbClr val="E7E0C9"/>
+                      </a:solidFill>
+                      <a:prstDash val="solid"/>
+                      <a:round/>
+                      <a:headEnd type="none" w="med" len="med"/>
+                      <a:tailEnd type="none" w="med" len="med"/>
+                    </a:lnT>
+                    <a:lnB w="9525" cap="flat" cmpd="sng" algn="ctr">
+                      <a:solidFill>
+                        <a:srgbClr val="E7E0C9"/>
+                      </a:solidFill>
+                      <a:prstDash val="solid"/>
+                      <a:round/>
+                      <a:headEnd type="none" w="med" len="med"/>
+                      <a:tailEnd type="none" w="med" len="med"/>
+                    </a:lnB>
+                    <a:solidFill>
+                      <a:srgbClr val="FEFCF6"/>
+                    </a:solidFill>
+                  </a:tcPr>
+                </a:tc>
+                <a:tc>
+                  <a:txBody>
+                    <a:bodyPr/>
+                    <a:lstStyle/>
+                    <a:p>
+                      <a:pPr indent="0" marL="0">
+                        <a:buNone/>
+                      </a:pPr>
+                      <a:r>
+                        <a:rPr lang="en-US" sz="1250" dirty="0">
+                          <a:solidFill>
+                            <a:schemeClr val="tx1"/>
+                          </a:solidFill>
+                          <a:latin typeface="Arial" pitchFamily="34" charset="0"/>
+                          <a:ea typeface="Arial" pitchFamily="34" charset="-122"/>
+                          <a:cs typeface="Arial" pitchFamily="34" charset="-120"/>
+                        </a:rPr>
+                        <a:t>advertising.newsweek.com/#about-section. Check the link still works</a:t>
+                      </a:r>
+                      <a:endParaRPr lang="en-US" sz="1250" dirty="0">
+                        <a:latin typeface="Arial" charset="0"/>
+                        <a:ea typeface="Arial" charset="0"/>
+                        <a:cs typeface="Arial" charset="0"/>
+                      </a:endParaRPr>
+                    </a:p>
+                  </a:txBody>
+                  <a:tcPr marL="73152" marR="73152" marT="73152" marB="73152" anchor="ctr">
+                    <a:lnL w="9525" cap="flat" cmpd="sng" algn="ctr">
+                      <a:solidFill>
+                        <a:srgbClr val="E7E0C9"/>
+                      </a:solidFill>
+                      <a:prstDash val="solid"/>
+                      <a:round/>
+                      <a:headEnd type="none" w="med" len="med"/>
+                      <a:tailEnd type="none" w="med" len="med"/>
+                    </a:lnL>
+                    <a:lnR w="9525" cap="flat" cmpd="sng" algn="ctr">
+                      <a:solidFill>
+                        <a:srgbClr val="E7E0C9"/>
+                      </a:solidFill>
+                      <a:prstDash val="solid"/>
+                      <a:round/>
+                      <a:headEnd type="none" w="med" len="med"/>
+                      <a:tailEnd type="none" w="med" len="med"/>
+                    </a:lnR>
+                    <a:lnT w="9525" cap="flat" cmpd="sng" algn="ctr">
+                      <a:solidFill>
+                        <a:srgbClr val="E7E0C9"/>
+                      </a:solidFill>
+                      <a:prstDash val="solid"/>
+                      <a:round/>
+                      <a:headEnd type="none" w="med" len="med"/>
+                      <a:tailEnd type="none" w="med" len="med"/>
+                    </a:lnT>
+                    <a:lnB w="9525" cap="flat" cmpd="sng" algn="ctr">
+                      <a:solidFill>
+                        <a:srgbClr val="E7E0C9"/>
+                      </a:solidFill>
+                      <a:prstDash val="solid"/>
+                      <a:round/>
+                      <a:headEnd type="none" w="med" len="med"/>
+                      <a:tailEnd type="none" w="med" len="med"/>
+                    </a:lnB>
+                    <a:solidFill>
+                      <a:srgbClr val="FEFCF6"/>
+                    </a:solidFill>
+                  </a:tcPr>
+                </a:tc>
+              </a:tr>
+              <a:tr h="475488">
+                <a:tc>
+                  <a:txBody>
+                    <a:bodyPr/>
+                    <a:lstStyle/>
+                    <a:p>
+                      <a:pPr indent="0" marL="0">
+                        <a:buNone/>
+                      </a:pPr>
+                      <a:r>
+                        <a:rPr lang="en-US" sz="1250" b="1" dirty="0">
+                          <a:solidFill>
+                            <a:schemeClr val="tx1"/>
+                          </a:solidFill>
+                          <a:latin typeface="Arial" pitchFamily="34" charset="0"/>
+                          <a:ea typeface="Arial" pitchFamily="34" charset="-122"/>
+                          <a:cs typeface="Arial" pitchFamily="34" charset="-120"/>
+                        </a:rPr>
+                        <a:t>Do you need a sellers.json?</a:t>
+                      </a:r>
+                      <a:endParaRPr lang="en-US" sz="1250" dirty="0">
+                        <a:latin typeface="Arial" charset="0"/>
+                        <a:ea typeface="Arial" charset="0"/>
+                        <a:cs typeface="Arial" charset="0"/>
+                      </a:endParaRPr>
+                    </a:p>
+                  </a:txBody>
+                  <a:tcPr marL="73152" marR="73152" marT="73152" marB="73152" anchor="ctr">
+                    <a:lnL w="9525" cap="flat" cmpd="sng" algn="ctr">
+                      <a:solidFill>
+                        <a:srgbClr val="E7E0C9"/>
+                      </a:solidFill>
+                      <a:prstDash val="solid"/>
+                      <a:round/>
+                      <a:headEnd type="none" w="med" len="med"/>
+                      <a:tailEnd type="none" w="med" len="med"/>
+                    </a:lnL>
+                    <a:lnR w="9525" cap="flat" cmpd="sng" algn="ctr">
+                      <a:solidFill>
+                        <a:srgbClr val="E7E0C9"/>
+                      </a:solidFill>
+                      <a:prstDash val="solid"/>
+                      <a:round/>
+                      <a:headEnd type="none" w="med" len="med"/>
+                      <a:tailEnd type="none" w="med" len="med"/>
+                    </a:lnR>
+                    <a:lnT w="9525" cap="flat" cmpd="sng" algn="ctr">
+                      <a:solidFill>
+                        <a:srgbClr val="E7E0C9"/>
+                      </a:solidFill>
+                      <a:prstDash val="solid"/>
+                      <a:round/>
+                      <a:headEnd type="none" w="med" len="med"/>
+                      <a:tailEnd type="none" w="med" len="med"/>
+                    </a:lnT>
+                    <a:lnB w="9525" cap="flat" cmpd="sng" algn="ctr">
+                      <a:solidFill>
+                        <a:srgbClr val="E7E0C9"/>
+                      </a:solidFill>
+                      <a:prstDash val="solid"/>
+                      <a:round/>
+                      <a:headEnd type="none" w="med" len="med"/>
+                      <a:tailEnd type="none" w="med" len="med"/>
+                    </a:lnB>
+                    <a:solidFill>
+                      <a:srgbClr val="FEFCF6"/>
+                    </a:solidFill>
+                  </a:tcPr>
+                </a:tc>
+                <a:tc>
+                  <a:txBody>
+                    <a:bodyPr/>
+                    <a:lstStyle/>
+                    <a:p>
+                      <a:pPr indent="0" marL="0">
+                        <a:buNone/>
+                      </a:pPr>
+                      <a:r>
+                        <a:rPr lang="en-US" sz="1250" dirty="0">
+                          <a:solidFill>
+                            <a:schemeClr val="tx1"/>
+                          </a:solidFill>
+                          <a:latin typeface="Arial" pitchFamily="34" charset="0"/>
+                          <a:ea typeface="Arial" pitchFamily="34" charset="-122"/>
+                          <a:cs typeface="Arial" pitchFamily="34" charset="-120"/>
+                        </a:rPr>
+                        <a:t>No: Newsweek is a publisher. Make sure each exchange lists us in its sellers.json</a:t>
+                      </a:r>
+                      <a:endParaRPr lang="en-US" sz="1250" dirty="0">
+                        <a:latin typeface="Arial" charset="0"/>
+                        <a:ea typeface="Arial" charset="0"/>
+                        <a:cs typeface="Arial" charset="0"/>
+                      </a:endParaRPr>
+                    </a:p>
+                  </a:txBody>
+                  <a:tcPr marL="73152" marR="73152" marT="73152" marB="73152" anchor="ctr">
+                    <a:lnL w="9525" cap="flat" cmpd="sng" algn="ctr">
+                      <a:solidFill>
+                        <a:srgbClr val="E7E0C9"/>
+                      </a:solidFill>
+                      <a:prstDash val="solid"/>
+                      <a:round/>
+                      <a:headEnd type="none" w="med" len="med"/>
+                      <a:tailEnd type="none" w="med" len="med"/>
+                    </a:lnL>
+                    <a:lnR w="9525" cap="flat" cmpd="sng" algn="ctr">
+                      <a:solidFill>
+                        <a:srgbClr val="E7E0C9"/>
+                      </a:solidFill>
+                      <a:prstDash val="solid"/>
+                      <a:round/>
+                      <a:headEnd type="none" w="med" len="med"/>
+                      <a:tailEnd type="none" w="med" len="med"/>
+                    </a:lnR>
+                    <a:lnT w="9525" cap="flat" cmpd="sng" algn="ctr">
+                      <a:solidFill>
+                        <a:srgbClr val="E7E0C9"/>
+                      </a:solidFill>
+                      <a:prstDash val="solid"/>
+                      <a:round/>
+                      <a:headEnd type="none" w="med" len="med"/>
+                      <a:tailEnd type="none" w="med" len="med"/>
+                    </a:lnT>
+                    <a:lnB w="9525" cap="flat" cmpd="sng" algn="ctr">
+                      <a:solidFill>
+                        <a:srgbClr val="E7E0C9"/>
+                      </a:solidFill>
+                      <a:prstDash val="solid"/>
+                      <a:round/>
+                      <a:headEnd type="none" w="med" len="med"/>
+                      <a:tailEnd type="none" w="med" len="med"/>
+                    </a:lnB>
+                    <a:solidFill>
+                      <a:srgbClr val="FEFCF6"/>
+                    </a:solidFill>
+                  </a:tcPr>
+                </a:tc>
+              </a:tr>
+              <a:tr h="475488">
+                <a:tc>
+                  <a:txBody>
+                    <a:bodyPr/>
+                    <a:lstStyle/>
+                    <a:p>
+                      <a:pPr indent="0" marL="0">
+                        <a:buNone/>
+                      </a:pPr>
+                      <a:r>
+                        <a:rPr lang="en-US" sz="1250" b="1" dirty="0">
+                          <a:solidFill>
+                            <a:schemeClr val="tx1"/>
+                          </a:solidFill>
+                          <a:latin typeface="Arial" pitchFamily="34" charset="0"/>
+                          <a:ea typeface="Arial" pitchFamily="34" charset="-122"/>
+                          <a:cs typeface="Arial" pitchFamily="34" charset="-120"/>
+                        </a:rPr>
+                        <a:t>Who responds to fraud incidents?</a:t>
+                      </a:r>
+                      <a:endParaRPr lang="en-US" sz="1250" dirty="0">
+                        <a:latin typeface="Arial" charset="0"/>
+                        <a:ea typeface="Arial" charset="0"/>
+                        <a:cs typeface="Arial" charset="0"/>
+                      </a:endParaRPr>
+                    </a:p>
+                  </a:txBody>
+                  <a:tcPr marL="73152" marR="73152" marT="73152" marB="73152" anchor="ctr">
+                    <a:lnL w="9525" cap="flat" cmpd="sng" algn="ctr">
+                      <a:solidFill>
+                        <a:srgbClr val="E7E0C9"/>
+                      </a:solidFill>
+                      <a:prstDash val="solid"/>
+                      <a:round/>
+                      <a:headEnd type="none" w="med" len="med"/>
+                      <a:tailEnd type="none" w="med" len="med"/>
+                    </a:lnL>
+                    <a:lnR w="9525" cap="flat" cmpd="sng" algn="ctr">
+                      <a:solidFill>
+                        <a:srgbClr val="E7E0C9"/>
+                      </a:solidFill>
+                      <a:prstDash val="solid"/>
+                      <a:round/>
+                      <a:headEnd type="none" w="med" len="med"/>
+                      <a:tailEnd type="none" w="med" len="med"/>
+                    </a:lnR>
+                    <a:lnT w="9525" cap="flat" cmpd="sng" algn="ctr">
+                      <a:solidFill>
+                        <a:srgbClr val="E7E0C9"/>
+                      </a:solidFill>
+                      <a:prstDash val="solid"/>
+                      <a:round/>
+                      <a:headEnd type="none" w="med" len="med"/>
+                      <a:tailEnd type="none" w="med" len="med"/>
+                    </a:lnT>
+                    <a:lnB w="9525" cap="flat" cmpd="sng" algn="ctr">
+                      <a:solidFill>
+                        <a:srgbClr val="E7E0C9"/>
+                      </a:solidFill>
+                      <a:prstDash val="solid"/>
+                      <a:round/>
+                      <a:headEnd type="none" w="med" len="med"/>
+                      <a:tailEnd type="none" w="med" len="med"/>
+                    </a:lnB>
+                    <a:solidFill>
+                      <a:srgbClr val="FEFCF6"/>
+                    </a:solidFill>
+                  </a:tcPr>
+                </a:tc>
+                <a:tc>
+                  <a:txBody>
+                    <a:bodyPr/>
+                    <a:lstStyle/>
+                    <a:p>
+                      <a:pPr indent="0" marL="0">
+                        <a:buNone/>
+                      </a:pPr>
+                      <a:r>
+                        <a:rPr lang="en-US" sz="1250" dirty="0">
+                          <a:solidFill>
+                            <a:schemeClr val="tx1"/>
+                          </a:solidFill>
+                          <a:latin typeface="Arial" pitchFamily="34" charset="0"/>
+                          <a:ea typeface="Arial" pitchFamily="34" charset="-122"/>
+                          <a:cs typeface="Arial" pitchFamily="34" charset="-120"/>
+                        </a:rPr>
+                        <a:t>The CTO, supported by the Director of Operations and the VP of Ad Ops</a:t>
+                      </a:r>
+                      <a:endParaRPr lang="en-US" sz="1250" dirty="0">
+                        <a:latin typeface="Arial" charset="0"/>
+                        <a:ea typeface="Arial" charset="0"/>
+                        <a:cs typeface="Arial" charset="0"/>
+                      </a:endParaRPr>
+                    </a:p>
+                  </a:txBody>
+                  <a:tcPr marL="73152" marR="73152" marT="73152" marB="73152" anchor="ctr">
+                    <a:lnL w="9525" cap="flat" cmpd="sng" algn="ctr">
+                      <a:solidFill>
+                        <a:srgbClr val="E7E0C9"/>
+                      </a:solidFill>
+                      <a:prstDash val="solid"/>
+                      <a:round/>
+                      <a:headEnd type="none" w="med" len="med"/>
+                      <a:tailEnd type="none" w="med" len="med"/>
+                    </a:lnL>
+                    <a:lnR w="9525" cap="flat" cmpd="sng" algn="ctr">
+                      <a:solidFill>
+                        <a:srgbClr val="E7E0C9"/>
+                      </a:solidFill>
+                      <a:prstDash val="solid"/>
+                      <a:round/>
+                      <a:headEnd type="none" w="med" len="med"/>
+                      <a:tailEnd type="none" w="med" len="med"/>
+                    </a:lnR>
+                    <a:lnT w="9525" cap="flat" cmpd="sng" algn="ctr">
+                      <a:solidFill>
+                        <a:srgbClr val="E7E0C9"/>
+                      </a:solidFill>
+                      <a:prstDash val="solid"/>
+                      <a:round/>
+                      <a:headEnd type="none" w="med" len="med"/>
+                      <a:tailEnd type="none" w="med" len="med"/>
+                    </a:lnT>
+                    <a:lnB w="9525" cap="flat" cmpd="sng" algn="ctr">
+                      <a:solidFill>
+                        <a:srgbClr val="E7E0C9"/>
+                      </a:solidFill>
+                      <a:prstDash val="solid"/>
+                      <a:round/>
+                      <a:headEnd type="none" w="med" len="med"/>
+                      <a:tailEnd type="none" w="med" len="med"/>
+                    </a:lnB>
+                    <a:solidFill>
+                      <a:srgbClr val="FEFCF6"/>
+                    </a:solidFill>
+                  </a:tcPr>
+                </a:tc>
+              </a:tr>
+            </a:tbl>
+          </a:graphicData>
+        </a:graphic>
+      </p:graphicFrame>
+      <p:sp>
+        <p:nvSpPr>
+          <p:cNvPr id="5" name="Text 2"/>
+          <p:cNvSpPr txBox="1"/>
+          <p:nvPr/>
+        </p:nvSpPr>
+        <p:spPr>
+          <a:xfrm>
+            <a:off x="548640" y="5852160"/>
+            <a:ext cx="11094415" cy="411480"/>
+          </a:xfrm>
+          <a:prstGeom prst="rect">
+            <a:avLst/>
+          </a:prstGeom>
+          <a:noFill/>
+          <a:ln/>
+        </p:spPr>
+        <p:txBody>
+          <a:bodyPr wrap="square" lIns="0" tIns="0" rIns="0" bIns="0" rtlCol="0" anchor="t"/>
+          <a:lstStyle/>
+          <a:p>
+            <a:pPr indent="0" marL="0">
+              <a:buNone/>
+            </a:pPr>
+            <a:r>
+              <a:rPr lang="en-US" sz="1200" i="1" dirty="0">
+                <a:solidFill>
+                  <a:schemeClr val="tx2"/>
+                </a:solidFill>
+              </a:rPr>
+              <a:t>They also re-check ads.txt (newsweek.com/ads.txt) with third-party validators and send back any errors. Source: AAM emails, Jan–Apr 2026.</a:t>
+            </a:r>
+            <a:endParaRPr lang="en-US" sz="1200" dirty="0"/>
+          </a:p>
+        </p:txBody>
+      </p:sp>
+      <p:sp>
+        <p:nvSpPr>
+          <p:cNvPr id="25" name="Slide Number Placeholder 0"/>
+          <p:cNvSpPr>
+            <a:spLocks noGrp="1"/>
+          </p:cNvSpPr>
+          <p:nvPr>
+            <p:ph type="sldNum" sz="quarter" idx="4294967295"/>
+          </p:nvPr>
+        </p:nvSpPr>
+        <p:spPr>
+          <a:xfrm>
+            <a:off x="548640" y="6400800"/>
+            <a:ext cx="914400" cy="274320"/>
+          </a:xfrm>
+          <a:prstGeom prst="rect">
+            <a:avLst/>
+          </a:prstGeom>
+          <a:extLst>
+            <a:ext uri="{C572A759-6A51-4108-AA02-DFA0A04FC94B}">
+              <ma14:wrappingTextBoxFlag xmlns:ma14="http://schemas.microsoft.com/office/mac/drawingml/2011/main" val="0"/>
+            </a:ext>
+          </a:extLst>
+        </p:spPr>
+        <p:txBody>
+          <a:bodyPr/>
+          <a:lstStyle>
+            <a:lvl1pPr>
+              <a:defRPr sz="1000">
+                <a:solidFill>
+                  <a:srgbClr val="8C887B"/>
+                </a:solidFill>
+                <a:latin typeface="Arial"/>
+                <a:ea typeface="Arial"/>
+                <a:cs typeface="Arial"/>
+              </a:defRPr>
+            </a:lvl1pPr>
+          </a:lstStyle>
+          <a:p>
+            <a:pPr algn="l"/>
+            <a:fld id="{F7021451-1387-4CA6-816F-3879F97B5CBC}" type="slidenum">
+              <a:rPr b="0" lang="en-US"/>
+              <a:t>34</a:t>
             </a:fld>
             <a:endParaRPr lang="en-US"/>
           </a:p>
@@ -35333,6 +38096,24 @@
             </a:r>
             <a:endParaRPr lang="en-US" sz="1300" dirty="0"/>
           </a:p>
+          <a:p>
+            <a:pPr marL="342900" indent="-342900">
+              <a:spcAft>
+                <a:spcPts val="200"/>
+              </a:spcAft>
+              <a:buSzPct val="100000"/>
+              <a:buChar char="•"/>
+            </a:pPr>
+            <a:r>
+              <a:rPr lang="en-US" sz="1300" dirty="0">
+                <a:solidFill>
+                  <a:schemeClr val="tx1"/>
+                </a:solidFill>
+              </a:rPr>
+              <a:t>AAM's review call follows in January (Appendix)</a:t>
+            </a:r>
+            <a:endParaRPr lang="en-US" sz="1300" dirty="0"/>
+          </a:p>
         </p:txBody>
       </p:sp>
       <p:sp>
@@ -35505,7 +38286,7 @@
                   <a:schemeClr val="tx1"/>
                 </a:solidFill>
               </a:rPr>
-              <a:t>katrina.eddy@auditedmedia.com</a:t>
+              <a:t>katrina.eddy@auditedmedia.com · O 203-447-2883</a:t>
             </a:r>
             <a:endParaRPr lang="en-US" sz="1300" dirty="0"/>
           </a:p>
@@ -35523,7 +38304,7 @@
                   <a:schemeClr val="tx1"/>
                 </a:solidFill>
               </a:rPr>
-              <a:t>O 203-447-2883 · M 203-675-5652</a:t>
+              <a:t>Cc: Jonathan Reid · TechAssurance@auditedmedia.com</a:t>
             </a:r>
             <a:endParaRPr lang="en-US" sz="1300" dirty="0"/>
           </a:p>

</xml_diff>

<commit_message>
docs: TAG IVT guide — video post-bid 100% via Open Measurement; monthly-ready deck
Video post-bid is measured at 100%: DoubleVerify is the Open Measurement
Viewability Partner in GAM (Roger, 2026-10-21). Replaces the old 1-5%
sampled / AdX explanations, adds the GAM set-up screenshots to the AAM
evidence list, and rewrites Step 5 for the 2026 report deck, which now
carries a row for every month (Oct-Dec show a dash until they close) and
a single DATA THROUGH line on the cover.

Co-Authored-By: Claude Opus 5.5 <noreply@anthropic.com>
Claude-Session: https://claude.ai/code/session_014udSfWkctWaSTKdEZUW1Gh
</commit_message>
<xml_diff>
--- a/docs/TAG_IVT_Report_Update_Guide.pptx
+++ b/docs/TAG_IVT_Report_Update_Guide.pptx
@@ -140,7 +140,7 @@
   <p:extLst>
     <p:ext uri="{521415D9-36F7-43E2-AB2F-B90AF26B5E84}">
       <p14:sectionLst xmlns:p14="http://schemas.microsoft.com/office/powerpoint/2010/main">
-        <p14:section name="Overview" id="{612a0bb7-0cc6-541a-f1dd-eb7f6c93159f}">
+        <p14:section name="Overview" id="{6e856b0d-bad2-827a-e58a-148abf7d2708}">
           <p14:sldIdLst>
             <p14:sldId id="256"/>
             <p14:sldId id="257"/>
@@ -156,7 +156,7 @@
             <p14:sldId id="267"/>
           </p14:sldIdLst>
         </p14:section>
-        <p14:section name="Step 1 · GAM" id="{df5b372e-6b54-2874-5afa-62d5334c505d}">
+        <p14:section name="Step 1 · GAM" id="{576acd0c-cfc5-9878-957c-d85dcddfb6b3}">
           <p14:sldIdLst>
             <p14:sldId id="268"/>
             <p14:sldId id="269"/>
@@ -166,33 +166,33 @@
             <p14:sldId id="273"/>
           </p14:sldIdLst>
         </p14:section>
-        <p14:section name="Step 2 · DV" id="{10901d52-7efa-ba85-f6fe-01bfce1b95ad}">
+        <p14:section name="Step 2 · DV" id="{027598b2-a819-6644-79f6-17f196bac121}">
           <p14:sldIdLst>
             <p14:sldId id="274"/>
             <p14:sldId id="275"/>
             <p14:sldId id="276"/>
           </p14:sldIdLst>
         </p14:section>
-        <p14:section name="Step 3 · GA4 + pre-bid" id="{0b75761b-68a0-f733-e16a-f5c947622051}">
+        <p14:section name="Step 3 · GA4 + pre-bid" id="{c4334358-bcdc-0a85-7878-0d553b2d4014}">
           <p14:sldIdLst>
             <p14:sldId id="277"/>
             <p14:sldId id="278"/>
           </p14:sldIdLst>
         </p14:section>
-        <p14:section name="Step 4 · Quarter math" id="{0ad1d3ca-a643-c9fa-699a-3cb734f0cb0e}">
+        <p14:section name="Step 4 · Quarter math" id="{0e4b6974-e459-8773-b0b3-db3a5e7a5ab8}">
           <p14:sldIdLst>
             <p14:sldId id="279"/>
             <p14:sldId id="280"/>
           </p14:sldIdLst>
         </p14:section>
-        <p14:section name="Step 5 · Build the deck" id="{f1f449c2-af33-10ef-b60d-fbc3cc52b196}">
+        <p14:section name="Step 5 · Build the deck" id="{9873bdd8-7c24-787f-0552-5b8c84c610f8}">
           <p14:sldIdLst>
             <p14:sldId id="281"/>
             <p14:sldId id="282"/>
             <p14:sldId id="283"/>
           </p14:sldIdLst>
         </p14:section>
-        <p14:section name="Appendix" id="{a45da84d-2e02-ccf2-a87c-6bae46657484}">
+        <p14:section name="Appendix" id="{6b636eeb-41c2-da87-4583-4112d376502f}">
           <p14:sldIdLst>
             <p14:sldId id="284"/>
             <p14:sldId id="285"/>
@@ -29979,7 +29979,7 @@
                 <a:ea typeface="Georgia" pitchFamily="34" charset="-122"/>
                 <a:cs typeface="Georgia" pitchFamily="34" charset="-120"/>
               </a:rPr>
-              <a:t>Title year</a:t>
+              <a:t>Data through</a:t>
             </a:r>
             <a:endParaRPr lang="en-US" sz="1800" dirty="0"/>
           </a:p>
@@ -30015,7 +30015,7 @@
                   <a:schemeClr val="tx2"/>
                 </a:solidFill>
               </a:rPr>
-              <a:t>Confirm the year on the cover.</a:t>
+              <a:t>Change DATA THROUGH on the cover, and 'data through' in each data slide's footnote, to the latest closed month.</a:t>
             </a:r>
             <a:endParaRPr lang="en-US" sz="1300" dirty="0"/>
           </a:p>
@@ -30151,7 +30151,7 @@
                   <a:schemeClr val="tx2"/>
                 </a:solidFill>
               </a:rPr>
-              <a:t>Rebuild as the by-month and by-quarter tables shown earlier. Discrepancy = (pageviews − DV pre-bid) ÷ pageviews; the 2026 Q1–Q2 report divided by DV, so restate those.</a:t>
+              <a:t>Replace the — in the new month's row, then update its quarter and the YTD row from the DV-GA workbook. Discrepancy = (pageviews − DV pre-bid) ÷ pageviews.</a:t>
             </a:r>
             <a:endParaRPr lang="en-US" sz="1300" dirty="0"/>
           </a:p>
@@ -30423,7 +30423,7 @@
                   <a:schemeClr val="tx2"/>
                 </a:solidFill>
               </a:rPr>
-              <a:t>Overall, display and video, weighted by DV post-bid impressions (Step 4). Q4 stays blank until December closes.</a:t>
+              <a:t>Copy the new month, its quarter and YTD from the DV-GAM workbook's Quarters sheet. Already impression-weighted.</a:t>
             </a:r>
             <a:endParaRPr lang="en-US" sz="1300" dirty="0"/>
           </a:p>
@@ -34310,7 +34310,7 @@
                   <a:schemeClr val="tx2"/>
                 </a:solidFill>
               </a:rPr>
-              <a:t>86.7% measured. Mostly Google AdX, which DV can't scan post-bid.</a:t>
+              <a:t>86.7% matched by count. Coverage is 100% (Open Measurement).</a:t>
             </a:r>
             <a:endParaRPr lang="en-US" sz="1300" dirty="0"/>
           </a:p>
@@ -36007,6 +36007,128 @@
             <a:avLst/>
           </a:prstGeom>
           <a:solidFill>
+            <a:schemeClr val="bg1"/>
+          </a:solidFill>
+          <a:ln w="9525">
+            <a:solidFill>
+              <a:srgbClr val="E7E0C9"/>
+            </a:solidFill>
+            <a:prstDash val="solid"/>
+          </a:ln>
+        </p:spPr>
+      </p:sp>
+      <p:sp>
+        <p:nvSpPr>
+          <p:cNvPr id="38" name="evbox 9"/>
+          <p:cNvSpPr/>
+          <p:nvPr/>
+        </p:nvSpPr>
+        <p:spPr>
+          <a:xfrm>
+            <a:off x="6461608" y="4818888"/>
+            <a:ext cx="219456" cy="219456"/>
+          </a:xfrm>
+          <a:prstGeom prst="rect">
+            <a:avLst/>
+          </a:prstGeom>
+          <a:solidFill>
+            <a:schemeClr val="bg1"/>
+          </a:solidFill>
+          <a:ln w="15875">
+            <a:solidFill>
+              <a:srgbClr val="1F1E19"/>
+            </a:solidFill>
+            <a:prstDash val="solid"/>
+          </a:ln>
+        </p:spPr>
+      </p:sp>
+      <p:sp>
+        <p:nvSpPr>
+          <p:cNvPr id="39" name="Text 37"/>
+          <p:cNvSpPr txBox="1"/>
+          <p:nvPr/>
+        </p:nvSpPr>
+        <p:spPr>
+          <a:xfrm>
+            <a:off x="6873088" y="4681728"/>
+            <a:ext cx="4587088" cy="274320"/>
+          </a:xfrm>
+          <a:prstGeom prst="rect">
+            <a:avLst/>
+          </a:prstGeom>
+          <a:noFill/>
+          <a:ln/>
+        </p:spPr>
+        <p:txBody>
+          <a:bodyPr wrap="square" lIns="0" tIns="0" rIns="0" bIns="0" rtlCol="0" anchor="t"/>
+          <a:lstStyle/>
+          <a:p>
+            <a:pPr indent="0" marL="0">
+              <a:buNone/>
+            </a:pPr>
+            <a:r>
+              <a:rPr lang="en-US" sz="1400" b="1" dirty="0">
+                <a:solidFill>
+                  <a:schemeClr val="tx1"/>
+                </a:solidFill>
+              </a:rPr>
+              <a:t>Video OM set-up</a:t>
+            </a:r>
+            <a:endParaRPr lang="en-US" sz="1400" dirty="0"/>
+          </a:p>
+        </p:txBody>
+      </p:sp>
+      <p:sp>
+        <p:nvSpPr>
+          <p:cNvPr id="40" name="Text 38"/>
+          <p:cNvSpPr txBox="1"/>
+          <p:nvPr/>
+        </p:nvSpPr>
+        <p:spPr>
+          <a:xfrm>
+            <a:off x="6873088" y="4956048"/>
+            <a:ext cx="4587088" cy="246888"/>
+          </a:xfrm>
+          <a:prstGeom prst="rect">
+            <a:avLst/>
+          </a:prstGeom>
+          <a:noFill/>
+          <a:ln/>
+        </p:spPr>
+        <p:txBody>
+          <a:bodyPr wrap="square" lIns="0" tIns="0" rIns="0" bIns="0" rtlCol="0" anchor="t"/>
+          <a:lstStyle/>
+          <a:p>
+            <a:pPr indent="0" marL="0">
+              <a:buNone/>
+            </a:pPr>
+            <a:r>
+              <a:rPr lang="en-US" sz="1200" dirty="0">
+                <a:solidFill>
+                  <a:schemeClr val="tx2"/>
+                </a:solidFill>
+              </a:rPr>
+              <a:t>GAM: DoubleVerify company + OM Viewability Partner field</a:t>
+            </a:r>
+            <a:endParaRPr lang="en-US" sz="1200" dirty="0"/>
+          </a:p>
+        </p:txBody>
+      </p:sp>
+      <p:sp>
+        <p:nvSpPr>
+          <p:cNvPr id="41" name="evidence 10"/>
+          <p:cNvSpPr/>
+          <p:nvPr/>
+        </p:nvSpPr>
+        <p:spPr>
+          <a:xfrm>
+            <a:off x="6233008" y="5349240"/>
+            <a:ext cx="5410048" cy="621792"/>
+          </a:xfrm>
+          <a:prstGeom prst="rect">
+            <a:avLst/>
+          </a:prstGeom>
+          <a:solidFill>
             <a:schemeClr val="bg2"/>
           </a:solidFill>
           <a:ln w="9525">
@@ -36019,13 +36141,13 @@
       </p:sp>
       <p:sp>
         <p:nvSpPr>
-          <p:cNvPr id="38" name="Text 36"/>
+          <p:cNvPr id="42" name="Text 40"/>
           <p:cNvSpPr txBox="1"/>
           <p:nvPr/>
         </p:nvSpPr>
         <p:spPr>
           <a:xfrm>
-            <a:off x="6873088" y="4681728"/>
+            <a:off x="6873088" y="5413248"/>
             <a:ext cx="4587088" cy="274320"/>
           </a:xfrm>
           <a:prstGeom prst="rect">
@@ -36055,13 +36177,13 @@
       </p:sp>
       <p:sp>
         <p:nvSpPr>
-          <p:cNvPr id="39" name="Text 37"/>
+          <p:cNvPr id="43" name="Text 41"/>
           <p:cNvSpPr txBox="1"/>
           <p:nvPr/>
         </p:nvSpPr>
         <p:spPr>
           <a:xfrm>
-            <a:off x="6873088" y="4956048"/>
+            <a:off x="6873088" y="5687568"/>
             <a:ext cx="4587088" cy="246888"/>
           </a:xfrm>
           <a:prstGeom prst="rect">
@@ -36629,7 +36751,7 @@
                           <a:ea typeface="Arial" pitchFamily="34" charset="-122"/>
                           <a:cs typeface="Arial" pitchFamily="34" charset="-120"/>
                         </a:rPr>
-                        <a:t>Display 100%; video 1–5% (sampled)</a:t>
+                        <a:t>Display 100%. Video now 100%: DV is the Open Measurement Viewability Partner in GAM (last review: 1–5% sampled)</a:t>
                       </a:r>
                       <a:endParaRPr lang="en-US" sz="1250" dirty="0">
                         <a:latin typeface="Arial" charset="0"/>
@@ -36905,7 +37027,7 @@
                           <a:ea typeface="Arial" pitchFamily="34" charset="-122"/>
                           <a:cs typeface="Arial" pitchFamily="34" charset="-120"/>
                         </a:rPr>
-                        <a:t>Google AdX: DV's wrapper can't go on exchange tags, so post-bid covers ad-server traffic only</a:t>
+                        <a:t>Last review: Google AdX, since DV's wrapper can't go on exchange tags. Video is now covered through Open Measurement</a:t>
                       </a:r>
                       <a:endParaRPr lang="en-US" sz="1250" dirty="0">
                         <a:latin typeface="Arial" charset="0"/>

</xml_diff>